<commit_message>
feat(render): apply shape rotation and flipH/flipV as CSS transforms
Wave 1 parsed xfrm rot/flipH/flipV onto Shape/PicShape/TableShape.
This wires them into the renderer — each positioned container div gets
a transform combining flips (scaleX/Y -1) and rotation (deg).
transform-origin is the shape centroid, matching PowerPoint.

Co-Authored-By: Claude Opus 4.7 (1M context) <noreply@anthropic.com>
</commit_message>
<xml_diff>
--- a/tests/render-test/basic/presentation.pptx
+++ b/tests/render-test/basic/presentation.pptx
@@ -12,6 +12,7 @@
     <p:sldId id="260" r:id="rId11"/>
     <p:sldId id="261" r:id="rId12"/>
     <p:sldId id="262" r:id="rId13"/>
+    <p:sldId id="263" r:id="rId14"/>
   </p:sldIdLst>
   <p:sldSz cx="9144000" cy="6858000" type="screen4x3"/>
   <p:notesSz cx="6858000" cy="9144000"/>
@@ -3539,6 +3540,138 @@
 </file>
 
 <file path=ppt/slides/slide7.xml><?xml version="1.0" encoding="utf-8"?>
+<p:sld xmlns:a="http://schemas.openxmlformats.org/drawingml/2006/main" xmlns:p="http://schemas.openxmlformats.org/presentationml/2006/main" xmlns:r="http://schemas.openxmlformats.org/officeDocument/2006/relationships">
+  <p:cSld>
+    <p:spTree>
+      <p:nvGrpSpPr>
+        <p:cNvPr id="1" name=""/>
+        <p:cNvGrpSpPr/>
+        <p:nvPr/>
+      </p:nvGrpSpPr>
+      <p:grpSpPr/>
+      <p:sp>
+        <p:nvSpPr>
+          <p:cNvPr id="2" name="Title 1"/>
+          <p:cNvSpPr>
+            <a:spLocks noGrp="1"/>
+          </p:cNvSpPr>
+          <p:nvPr>
+            <p:ph type="title"/>
+          </p:nvPr>
+        </p:nvSpPr>
+        <p:spPr/>
+        <p:txBody>
+          <a:bodyPr/>
+          <a:lstStyle/>
+          <a:p>
+            <a:r>
+              <a:t>Rotated &amp; flipped</a:t>
+            </a:r>
+          </a:p>
+        </p:txBody>
+      </p:sp>
+      <p:sp>
+        <p:nvSpPr>
+          <p:cNvPr id="3" name="TextBox 2"/>
+          <p:cNvSpPr txBox="1"/>
+          <p:nvPr/>
+        </p:nvSpPr>
+        <p:spPr>
+          <a:xfrm rot="1800000">
+            <a:off x="914400" y="1828800"/>
+            <a:ext cx="2743200" cy="914400"/>
+          </a:xfrm>
+          <a:prstGeom prst="rect">
+            <a:avLst/>
+          </a:prstGeom>
+          <a:noFill/>
+        </p:spPr>
+        <p:txBody>
+          <a:bodyPr wrap="none">
+            <a:spAutoFit/>
+          </a:bodyPr>
+          <a:lstStyle/>
+          <a:p>
+            <a:r>
+              <a:rPr sz="2000"/>
+              <a:t>Rotated 30 degrees</a:t>
+            </a:r>
+          </a:p>
+        </p:txBody>
+      </p:sp>
+      <p:sp>
+        <p:nvSpPr>
+          <p:cNvPr id="4" name="Right Arrow 3"/>
+          <p:cNvSpPr/>
+          <p:nvPr/>
+        </p:nvSpPr>
+        <p:spPr>
+          <a:xfrm flipH="1">
+            <a:off x="4572000" y="1828800"/>
+            <a:ext cx="1828800" cy="914400"/>
+          </a:xfrm>
+          <a:prstGeom prst="rightArrow">
+            <a:avLst/>
+          </a:prstGeom>
+          <a:solidFill>
+            <a:srgbClr val="4F81BD"/>
+          </a:solidFill>
+        </p:spPr>
+        <p:style>
+          <a:lnRef idx="1">
+            <a:schemeClr val="accent1"/>
+          </a:lnRef>
+          <a:fillRef idx="3">
+            <a:schemeClr val="accent1"/>
+          </a:fillRef>
+          <a:effectRef idx="2">
+            <a:schemeClr val="accent1"/>
+          </a:effectRef>
+          <a:fontRef idx="minor">
+            <a:schemeClr val="lt1"/>
+          </a:fontRef>
+        </p:style>
+        <p:txBody>
+          <a:bodyPr rtlCol="0" anchor="ctr"/>
+          <a:lstStyle/>
+          <a:p>
+            <a:pPr algn="ctr"/>
+          </a:p>
+        </p:txBody>
+      </p:sp>
+      <p:pic>
+        <p:nvPicPr>
+          <p:cNvPr id="5" name="Picture 4" descr="python-powered.png"/>
+          <p:cNvPicPr>
+            <a:picLocks noChangeAspect="1"/>
+          </p:cNvPicPr>
+          <p:nvPr/>
+        </p:nvPicPr>
+        <p:blipFill>
+          <a:blip r:embed="rId2"/>
+          <a:stretch>
+            <a:fillRect/>
+          </a:stretch>
+        </p:blipFill>
+        <p:spPr>
+          <a:xfrm rot="2700000">
+            <a:off x="3657600" y="3657600"/>
+            <a:ext cx="1828800" cy="914400"/>
+          </a:xfrm>
+          <a:prstGeom prst="rect">
+            <a:avLst/>
+          </a:prstGeom>
+        </p:spPr>
+      </p:pic>
+    </p:spTree>
+  </p:cSld>
+  <p:clrMapOvr>
+    <a:masterClrMapping/>
+  </p:clrMapOvr>
+</p:sld>
+</file>
+
+<file path=ppt/slides/slide8.xml><?xml version="1.0" encoding="utf-8"?>
 <p:sld xmlns:a="http://schemas.openxmlformats.org/drawingml/2006/main" xmlns:p="http://schemas.openxmlformats.org/presentationml/2006/main" xmlns:r="http://schemas.openxmlformats.org/officeDocument/2006/relationships">
   <p:cSld>
     <p:spTree>

</xml_diff>

<commit_message>
feat(images): crop, grayscale, brightness/contrast, alpha, biLevel
Parses <a:srcRect>, <a:lum>, <a:grayscl>, <a:biLevel>, <a:alphaModFix>,
<a:duotone> from <a:blipFill>. Renderer applies crop via wrapper
overflow + scaled/offset <img>, alpha via opacity, color ops via a
combined CSS filter string. Duotone uses a best-effort mix-blend-mode
fallback; full feColorMatrix support noted as TODO.

Co-Authored-By: Claude Opus 4.7 (1M context) <noreply@anthropic.com>
</commit_message>
<xml_diff>
--- a/tests/render-test/basic/presentation.pptx
+++ b/tests/render-test/basic/presentation.pptx
@@ -12,6 +12,7 @@
     <p:sldId id="260" r:id="rId11"/>
     <p:sldId id="261" r:id="rId12"/>
     <p:sldId id="262" r:id="rId13"/>
+    <p:sldId id="263" r:id="rId14"/>
   </p:sldIdLst>
   <p:sldSz cx="9144000" cy="6858000" type="screen4x3"/>
   <p:notesSz cx="6858000" cy="9144000"/>
@@ -3539,6 +3540,203 @@
 </file>
 
 <file path=ppt/slides/slide7.xml><?xml version="1.0" encoding="utf-8"?>
+<p:sld xmlns:a="http://schemas.openxmlformats.org/drawingml/2006/main" xmlns:p="http://schemas.openxmlformats.org/presentationml/2006/main" xmlns:r="http://schemas.openxmlformats.org/officeDocument/2006/relationships">
+  <p:cSld>
+    <p:spTree>
+      <p:nvGrpSpPr>
+        <p:cNvPr id="1" name=""/>
+        <p:cNvGrpSpPr/>
+        <p:nvPr/>
+      </p:nvGrpSpPr>
+      <p:grpSpPr/>
+      <p:sp>
+        <p:nvSpPr>
+          <p:cNvPr id="2" name="Title 1"/>
+          <p:cNvSpPr>
+            <a:spLocks noGrp="1"/>
+          </p:cNvSpPr>
+          <p:nvPr>
+            <p:ph type="title"/>
+          </p:nvPr>
+        </p:nvSpPr>
+        <p:spPr/>
+        <p:txBody>
+          <a:bodyPr/>
+          <a:lstStyle/>
+          <a:p>
+            <a:r>
+              <a:t>Image adjustments</a:t>
+            </a:r>
+          </a:p>
+        </p:txBody>
+      </p:sp>
+      <p:pic>
+        <p:nvPicPr>
+          <p:cNvPr id="3" name="Picture 2" descr="python-powered.png"/>
+          <p:cNvPicPr>
+            <a:picLocks noChangeAspect="1"/>
+          </p:cNvPicPr>
+          <p:nvPr/>
+        </p:nvPicPr>
+        <p:blipFill>
+          <a:srcRect l="20000" t="10000" r="20000" b="10000"/>
+          <a:blip r:embed="rId2"/>
+          <a:stretch>
+            <a:fillRect/>
+          </a:stretch>
+        </p:blipFill>
+        <p:spPr>
+          <a:xfrm>
+            <a:off x="457200" y="1645920"/>
+            <a:ext cx="2286000" cy="1645920"/>
+          </a:xfrm>
+          <a:prstGeom prst="rect">
+            <a:avLst/>
+          </a:prstGeom>
+        </p:spPr>
+      </p:pic>
+      <p:pic>
+        <p:nvPicPr>
+          <p:cNvPr id="4" name="Picture 3" descr="python-powered.png"/>
+          <p:cNvPicPr>
+            <a:picLocks noChangeAspect="1"/>
+          </p:cNvPicPr>
+          <p:nvPr/>
+        </p:nvPicPr>
+        <p:blipFill>
+          <a:blip r:embed="rId2">
+            <a:grayscl/>
+          </a:blip>
+          <a:stretch>
+            <a:fillRect/>
+          </a:stretch>
+        </p:blipFill>
+        <p:spPr>
+          <a:xfrm>
+            <a:off x="3017520" y="1645920"/>
+            <a:ext cx="2286000" cy="1645920"/>
+          </a:xfrm>
+          <a:prstGeom prst="rect">
+            <a:avLst/>
+          </a:prstGeom>
+        </p:spPr>
+      </p:pic>
+      <p:pic>
+        <p:nvPicPr>
+          <p:cNvPr id="5" name="Picture 4" descr="python-powered.png"/>
+          <p:cNvPicPr>
+            <a:picLocks noChangeAspect="1"/>
+          </p:cNvPicPr>
+          <p:nvPr/>
+        </p:nvPicPr>
+        <p:blipFill>
+          <a:blip r:embed="rId2">
+            <a:lum bright="20000" contrast="30000"/>
+          </a:blip>
+          <a:stretch>
+            <a:fillRect/>
+          </a:stretch>
+        </p:blipFill>
+        <p:spPr>
+          <a:xfrm>
+            <a:off x="5577840" y="1645920"/>
+            <a:ext cx="2286000" cy="1645920"/>
+          </a:xfrm>
+          <a:prstGeom prst="rect">
+            <a:avLst/>
+          </a:prstGeom>
+        </p:spPr>
+      </p:pic>
+      <p:pic>
+        <p:nvPicPr>
+          <p:cNvPr id="6" name="Picture 5" descr="python-powered.png"/>
+          <p:cNvPicPr>
+            <a:picLocks noChangeAspect="1"/>
+          </p:cNvPicPr>
+          <p:nvPr/>
+        </p:nvPicPr>
+        <p:blipFill>
+          <a:blip r:embed="rId2">
+            <a:alphaModFix amt="50000"/>
+          </a:blip>
+          <a:stretch>
+            <a:fillRect/>
+          </a:stretch>
+        </p:blipFill>
+        <p:spPr>
+          <a:xfrm>
+            <a:off x="457200" y="3840480"/>
+            <a:ext cx="2286000" cy="1645920"/>
+          </a:xfrm>
+          <a:prstGeom prst="rect">
+            <a:avLst/>
+          </a:prstGeom>
+        </p:spPr>
+      </p:pic>
+      <p:pic>
+        <p:nvPicPr>
+          <p:cNvPr id="7" name="Picture 6" descr="python-powered.png"/>
+          <p:cNvPicPr>
+            <a:picLocks noChangeAspect="1"/>
+          </p:cNvPicPr>
+          <p:nvPr/>
+        </p:nvPicPr>
+        <p:blipFill>
+          <a:blip r:embed="rId2">
+            <a:biLevel thresh="50000"/>
+          </a:blip>
+          <a:stretch>
+            <a:fillRect/>
+          </a:stretch>
+        </p:blipFill>
+        <p:spPr>
+          <a:xfrm>
+            <a:off x="3017520" y="3840480"/>
+            <a:ext cx="2286000" cy="1645920"/>
+          </a:xfrm>
+          <a:prstGeom prst="rect">
+            <a:avLst/>
+          </a:prstGeom>
+        </p:spPr>
+      </p:pic>
+      <p:pic>
+        <p:nvPicPr>
+          <p:cNvPr id="8" name="Picture 7" descr="python-powered.png"/>
+          <p:cNvPicPr>
+            <a:picLocks noChangeAspect="1"/>
+          </p:cNvPicPr>
+          <p:nvPr/>
+        </p:nvPicPr>
+        <p:blipFill>
+          <a:blip r:embed="rId2">
+            <a:duotone>
+              <a:srgbClr val="1F3A93"/>
+              <a:srgbClr val="FFD9B3"/>
+            </a:duotone>
+          </a:blip>
+          <a:stretch>
+            <a:fillRect/>
+          </a:stretch>
+        </p:blipFill>
+        <p:spPr>
+          <a:xfrm>
+            <a:off x="5577840" y="3840480"/>
+            <a:ext cx="2286000" cy="1645920"/>
+          </a:xfrm>
+          <a:prstGeom prst="rect">
+            <a:avLst/>
+          </a:prstGeom>
+        </p:spPr>
+      </p:pic>
+    </p:spTree>
+  </p:cSld>
+  <p:clrMapOvr>
+    <a:masterClrMapping/>
+  </p:clrMapOvr>
+</p:sld>
+</file>
+
+<file path=ppt/slides/slide8.xml><?xml version="1.0" encoding="utf-8"?>
 <p:sld xmlns:a="http://schemas.openxmlformats.org/drawingml/2006/main" xmlns:p="http://schemas.openxmlformats.org/presentationml/2006/main" xmlns:r="http://schemas.openxmlformats.org/officeDocument/2006/relationships">
   <p:cSld>
     <p:spTree>

</xml_diff>

<commit_message>
feat(effects): parse and render outer/inner shadow, glow, blur, softEdge
New src/effects.ts parses <a:effectLst>. Renderer maps them to CSS
box-shadow and filter chains: outerShdw -> box-shadow, innerShdw ->
inset box-shadow, glow -> drop-shadow, blur -> filter:blur, softEdge
-> approximation via filter:blur, reflection -> -webkit-box-reflect
where supported.

Co-Authored-By: Claude Opus 4.7 (1M context) <noreply@anthropic.com>
</commit_message>
<xml_diff>
--- a/tests/render-test/basic/presentation.pptx
+++ b/tests/render-test/basic/presentation.pptx
@@ -12,6 +12,7 @@
     <p:sldId id="260" r:id="rId11"/>
     <p:sldId id="261" r:id="rId12"/>
     <p:sldId id="262" r:id="rId13"/>
+    <p:sldId id="263" r:id="rId14"/>
   </p:sldIdLst>
   <p:sldSz cx="9144000" cy="6858000" type="screen4x3"/>
   <p:notesSz cx="6858000" cy="9144000"/>
@@ -3539,6 +3540,347 @@
 </file>
 
 <file path=ppt/slides/slide7.xml><?xml version="1.0" encoding="utf-8"?>
+<p:sld xmlns:a="http://schemas.openxmlformats.org/drawingml/2006/main" xmlns:p="http://schemas.openxmlformats.org/presentationml/2006/main" xmlns:r="http://schemas.openxmlformats.org/officeDocument/2006/relationships">
+  <p:cSld>
+    <p:spTree>
+      <p:nvGrpSpPr>
+        <p:cNvPr id="1" name=""/>
+        <p:cNvGrpSpPr/>
+        <p:nvPr/>
+      </p:nvGrpSpPr>
+      <p:grpSpPr/>
+      <p:sp>
+        <p:nvSpPr>
+          <p:cNvPr id="2" name="Title 1"/>
+          <p:cNvSpPr>
+            <a:spLocks noGrp="1"/>
+          </p:cNvSpPr>
+          <p:nvPr>
+            <p:ph type="title"/>
+          </p:nvPr>
+        </p:nvSpPr>
+        <p:spPr/>
+        <p:txBody>
+          <a:bodyPr/>
+          <a:lstStyle/>
+          <a:p>
+            <a:r>
+              <a:t>Effects</a:t>
+            </a:r>
+          </a:p>
+        </p:txBody>
+      </p:sp>
+      <p:sp>
+        <p:nvSpPr>
+          <p:cNvPr id="3" name="Rectangle 2"/>
+          <p:cNvSpPr/>
+          <p:nvPr/>
+        </p:nvSpPr>
+        <p:spPr>
+          <a:xfrm>
+            <a:off x="685800" y="1828800"/>
+            <a:ext cx="2286000" cy="1097280"/>
+          </a:xfrm>
+          <a:prstGeom prst="rect">
+            <a:avLst/>
+          </a:prstGeom>
+          <a:solidFill>
+            <a:srgbClr val="4F81BD"/>
+          </a:solidFill>
+          <a:effectLst>
+            <a:outerShdw blurRad="50800" dist="38100" dir="2700000" algn="tl" rotWithShape="0">
+              <a:srgbClr val="000000">
+                <a:alpha val="50000"/>
+              </a:srgbClr>
+            </a:outerShdw>
+          </a:effectLst>
+        </p:spPr>
+        <p:style>
+          <a:lnRef idx="1">
+            <a:schemeClr val="accent1"/>
+          </a:lnRef>
+          <a:fillRef idx="3">
+            <a:schemeClr val="accent1"/>
+          </a:fillRef>
+          <a:effectRef idx="2">
+            <a:schemeClr val="accent1"/>
+          </a:effectRef>
+          <a:fontRef idx="minor">
+            <a:schemeClr val="lt1"/>
+          </a:fontRef>
+        </p:style>
+        <p:txBody>
+          <a:bodyPr rtlCol="0" anchor="ctr"/>
+          <a:lstStyle/>
+          <a:p>
+            <a:r>
+              <a:rPr>
+                <a:solidFill>
+                  <a:srgbClr val="FFFFFF"/>
+                </a:solidFill>
+              </a:rPr>
+              <a:t>Outer shadow</a:t>
+            </a:r>
+          </a:p>
+        </p:txBody>
+      </p:sp>
+      <p:sp>
+        <p:nvSpPr>
+          <p:cNvPr id="4" name="Rectangle 3"/>
+          <p:cNvSpPr/>
+          <p:nvPr/>
+        </p:nvSpPr>
+        <p:spPr>
+          <a:xfrm>
+            <a:off x="3657600" y="1828800"/>
+            <a:ext cx="2286000" cy="1097280"/>
+          </a:xfrm>
+          <a:prstGeom prst="rect">
+            <a:avLst/>
+          </a:prstGeom>
+          <a:solidFill>
+            <a:srgbClr val="FFFFFF"/>
+          </a:solidFill>
+          <a:ln>
+            <a:solidFill>
+              <a:srgbClr val="009966"/>
+            </a:solidFill>
+          </a:ln>
+          <a:effectLst>
+            <a:glow rad="63500">
+              <a:srgbClr val="00CC66">
+                <a:alpha val="60000"/>
+              </a:srgbClr>
+            </a:glow>
+          </a:effectLst>
+        </p:spPr>
+        <p:style>
+          <a:lnRef idx="1">
+            <a:schemeClr val="accent1"/>
+          </a:lnRef>
+          <a:fillRef idx="3">
+            <a:schemeClr val="accent1"/>
+          </a:fillRef>
+          <a:effectRef idx="2">
+            <a:schemeClr val="accent1"/>
+          </a:effectRef>
+          <a:fontRef idx="minor">
+            <a:schemeClr val="lt1"/>
+          </a:fontRef>
+        </p:style>
+        <p:txBody>
+          <a:bodyPr rtlCol="0" anchor="ctr"/>
+          <a:lstStyle/>
+          <a:p>
+            <a:r>
+              <a:t>Glow</a:t>
+            </a:r>
+          </a:p>
+        </p:txBody>
+      </p:sp>
+      <p:sp>
+        <p:nvSpPr>
+          <p:cNvPr id="5" name="Rectangle 4"/>
+          <p:cNvSpPr/>
+          <p:nvPr/>
+        </p:nvSpPr>
+        <p:spPr>
+          <a:xfrm>
+            <a:off x="6629400" y="1828800"/>
+            <a:ext cx="2286000" cy="1097280"/>
+          </a:xfrm>
+          <a:prstGeom prst="rect">
+            <a:avLst/>
+          </a:prstGeom>
+          <a:solidFill>
+            <a:srgbClr val="D9436E"/>
+          </a:solidFill>
+          <a:effectLst>
+            <a:blur rad="38100" grow="1"/>
+          </a:effectLst>
+        </p:spPr>
+        <p:style>
+          <a:lnRef idx="1">
+            <a:schemeClr val="accent1"/>
+          </a:lnRef>
+          <a:fillRef idx="3">
+            <a:schemeClr val="accent1"/>
+          </a:fillRef>
+          <a:effectRef idx="2">
+            <a:schemeClr val="accent1"/>
+          </a:effectRef>
+          <a:fontRef idx="minor">
+            <a:schemeClr val="lt1"/>
+          </a:fontRef>
+        </p:style>
+        <p:txBody>
+          <a:bodyPr rtlCol="0" anchor="ctr"/>
+          <a:lstStyle/>
+          <a:p>
+            <a:r>
+              <a:rPr>
+                <a:solidFill>
+                  <a:srgbClr val="FFFFFF"/>
+                </a:solidFill>
+              </a:rPr>
+              <a:t>Blur</a:t>
+            </a:r>
+          </a:p>
+        </p:txBody>
+      </p:sp>
+      <p:sp>
+        <p:nvSpPr>
+          <p:cNvPr id="6" name="Rectangle 5"/>
+          <p:cNvSpPr/>
+          <p:nvPr/>
+        </p:nvSpPr>
+        <p:spPr>
+          <a:xfrm>
+            <a:off x="685800" y="3657600"/>
+            <a:ext cx="2286000" cy="1097280"/>
+          </a:xfrm>
+          <a:prstGeom prst="rect">
+            <a:avLst/>
+          </a:prstGeom>
+          <a:solidFill>
+            <a:srgbClr val="F2F2F2"/>
+          </a:solidFill>
+          <a:effectLst>
+            <a:innerShdw blurRad="63500" dist="25400" dir="13500000">
+              <a:srgbClr val="000000">
+                <a:alpha val="60000"/>
+              </a:srgbClr>
+            </a:innerShdw>
+          </a:effectLst>
+        </p:spPr>
+        <p:style>
+          <a:lnRef idx="1">
+            <a:schemeClr val="accent1"/>
+          </a:lnRef>
+          <a:fillRef idx="3">
+            <a:schemeClr val="accent1"/>
+          </a:fillRef>
+          <a:effectRef idx="2">
+            <a:schemeClr val="accent1"/>
+          </a:effectRef>
+          <a:fontRef idx="minor">
+            <a:schemeClr val="lt1"/>
+          </a:fontRef>
+        </p:style>
+        <p:txBody>
+          <a:bodyPr rtlCol="0" anchor="ctr"/>
+          <a:lstStyle/>
+          <a:p>
+            <a:r>
+              <a:t>Inner shadow</a:t>
+            </a:r>
+          </a:p>
+        </p:txBody>
+      </p:sp>
+      <p:sp>
+        <p:nvSpPr>
+          <p:cNvPr id="7" name="Rectangle 6"/>
+          <p:cNvSpPr/>
+          <p:nvPr/>
+        </p:nvSpPr>
+        <p:spPr>
+          <a:xfrm>
+            <a:off x="3657600" y="3657600"/>
+            <a:ext cx="2286000" cy="1097280"/>
+          </a:xfrm>
+          <a:prstGeom prst="rect">
+            <a:avLst/>
+          </a:prstGeom>
+          <a:solidFill>
+            <a:srgbClr val="F79646"/>
+          </a:solidFill>
+          <a:effectLst>
+            <a:softEdge rad="50800"/>
+          </a:effectLst>
+        </p:spPr>
+        <p:style>
+          <a:lnRef idx="1">
+            <a:schemeClr val="accent1"/>
+          </a:lnRef>
+          <a:fillRef idx="3">
+            <a:schemeClr val="accent1"/>
+          </a:fillRef>
+          <a:effectRef idx="2">
+            <a:schemeClr val="accent1"/>
+          </a:effectRef>
+          <a:fontRef idx="minor">
+            <a:schemeClr val="lt1"/>
+          </a:fontRef>
+        </p:style>
+        <p:txBody>
+          <a:bodyPr rtlCol="0" anchor="ctr"/>
+          <a:lstStyle/>
+          <a:p>
+            <a:r>
+              <a:t>Soft edge</a:t>
+            </a:r>
+          </a:p>
+        </p:txBody>
+      </p:sp>
+      <p:sp>
+        <p:nvSpPr>
+          <p:cNvPr id="8" name="Rectangle 7"/>
+          <p:cNvSpPr/>
+          <p:nvPr/>
+        </p:nvSpPr>
+        <p:spPr>
+          <a:xfrm>
+            <a:off x="6629400" y="3657600"/>
+            <a:ext cx="2286000" cy="1097280"/>
+          </a:xfrm>
+          <a:prstGeom prst="rect">
+            <a:avLst/>
+          </a:prstGeom>
+          <a:solidFill>
+            <a:srgbClr val="4F81BD"/>
+          </a:solidFill>
+          <a:effectLst>
+            <a:reflection blurRad="6350" stA="50000" stPos="0" endA="300" endPos="50000" dist="38100" dir="5400000" sy="-100000" algn="bl" rotWithShape="0"/>
+          </a:effectLst>
+        </p:spPr>
+        <p:style>
+          <a:lnRef idx="1">
+            <a:schemeClr val="accent1"/>
+          </a:lnRef>
+          <a:fillRef idx="3">
+            <a:schemeClr val="accent1"/>
+          </a:fillRef>
+          <a:effectRef idx="2">
+            <a:schemeClr val="accent1"/>
+          </a:effectRef>
+          <a:fontRef idx="minor">
+            <a:schemeClr val="lt1"/>
+          </a:fontRef>
+        </p:style>
+        <p:txBody>
+          <a:bodyPr rtlCol="0" anchor="ctr"/>
+          <a:lstStyle/>
+          <a:p>
+            <a:r>
+              <a:rPr>
+                <a:solidFill>
+                  <a:srgbClr val="FFFFFF"/>
+                </a:solidFill>
+              </a:rPr>
+              <a:t>Reflection</a:t>
+            </a:r>
+          </a:p>
+        </p:txBody>
+      </p:sp>
+    </p:spTree>
+  </p:cSld>
+  <p:clrMapOvr>
+    <a:masterClrMapping/>
+  </p:clrMapOvr>
+</p:sld>
+</file>
+
+<file path=ppt/slides/slide8.xml><?xml version="1.0" encoding="utf-8"?>
 <p:sld xmlns:a="http://schemas.openxmlformats.org/drawingml/2006/main" xmlns:p="http://schemas.openxmlformats.org/presentationml/2006/main" xmlns:r="http://schemas.openxmlformats.org/officeDocument/2006/relationships">
   <p:cSld>
     <p:spTree>

</xml_diff>

<commit_message>
feat(text): render underline, strike, super/sub, spacing, rtl, lang
Wires Wave 1 typography fields through the text renderer: underline /
strike combine into text-decoration, baseline produces super/sub with
size scaling, letterSpacing maps to letter-spacing, lineSpacing to
line-height, spaceBef/Aft to margins, rtl to direction. Hyperlink
and field runs get data-* markers for follow-up passes (P9/P10).

Co-Authored-By: Claude Opus 4.7 (1M context) <noreply@anthropic.com>
</commit_message>
<xml_diff>
--- a/tests/render-test/basic/presentation.pptx
+++ b/tests/render-test/basic/presentation.pptx
@@ -12,6 +12,7 @@
     <p:sldId id="260" r:id="rId11"/>
     <p:sldId id="261" r:id="rId12"/>
     <p:sldId id="262" r:id="rId13"/>
+    <p:sldId id="263" r:id="rId14"/>
   </p:sldIdLst>
   <p:sldSz cx="9144000" cy="6858000" type="screen4x3"/>
   <p:notesSz cx="6858000" cy="9144000"/>
@@ -3710,6 +3711,120 @@
           </a:graphicData>
         </a:graphic>
       </p:graphicFrame>
+    </p:spTree>
+  </p:cSld>
+  <p:clrMapOvr>
+    <a:masterClrMapping/>
+  </p:clrMapOvr>
+</p:sld>
+</file>
+
+<file path=ppt/slides/slide8.xml><?xml version="1.0" encoding="utf-8"?>
+<p:sld xmlns:a="http://schemas.openxmlformats.org/drawingml/2006/main" xmlns:p="http://schemas.openxmlformats.org/presentationml/2006/main" xmlns:r="http://schemas.openxmlformats.org/officeDocument/2006/relationships">
+  <p:cSld>
+    <p:spTree>
+      <p:nvGrpSpPr>
+        <p:cNvPr id="1" name=""/>
+        <p:cNvGrpSpPr/>
+        <p:nvPr/>
+      </p:nvGrpSpPr>
+      <p:grpSpPr/>
+      <p:sp>
+        <p:nvSpPr>
+          <p:cNvPr id="2" name="Title 1"/>
+          <p:cNvSpPr>
+            <a:spLocks noGrp="1"/>
+          </p:cNvSpPr>
+          <p:nvPr>
+            <p:ph type="title"/>
+          </p:nvPr>
+        </p:nvSpPr>
+        <p:spPr/>
+        <p:txBody>
+          <a:bodyPr/>
+          <a:lstStyle/>
+          <a:p>
+            <a:r>
+              <a:t>Typography</a:t>
+            </a:r>
+          </a:p>
+        </p:txBody>
+      </p:sp>
+      <p:sp>
+        <p:nvSpPr>
+          <p:cNvPr id="3" name="TextBox 2"/>
+          <p:cNvSpPr txBox="1"/>
+          <p:nvPr/>
+        </p:nvSpPr>
+        <p:spPr>
+          <a:xfrm>
+            <a:off x="914400" y="1371600"/>
+            <a:ext cx="7315200" cy="3657600"/>
+          </a:xfrm>
+          <a:prstGeom prst="rect">
+            <a:avLst/>
+          </a:prstGeom>
+          <a:noFill/>
+        </p:spPr>
+        <p:txBody>
+          <a:bodyPr wrap="square">
+            <a:spAutoFit/>
+          </a:bodyPr>
+          <a:lstStyle/>
+          <a:p>
+            <a:r>
+              <a:t>Plain then </a:t>
+            </a:r>
+            <a:r>
+              <a:rPr u="sng"/>
+              <a:t>underlined</a:t>
+            </a:r>
+            <a:r>
+              <a:t> then </a:t>
+            </a:r>
+            <a:r>
+              <a:rPr strike="sngStrike"/>
+              <a:t>strikethrough</a:t>
+            </a:r>
+            <a:r>
+              <a:t>.</a:t>
+            </a:r>
+          </a:p>
+          <a:p>
+            <a:r>
+              <a:t>E = mc</a:t>
+            </a:r>
+            <a:r>
+              <a:rPr baseline="30000"/>
+              <a:t>2</a:t>
+            </a:r>
+            <a:r>
+              <a:t>, H</a:t>
+            </a:r>
+            <a:r>
+              <a:rPr baseline="-25000"/>
+              <a:t>2</a:t>
+            </a:r>
+            <a:r>
+              <a:t>O, </a:t>
+            </a:r>
+            <a:r>
+              <a:rPr spc="200"/>
+              <a:t>l e t t e r   s p a c e d</a:t>
+            </a:r>
+          </a:p>
+          <a:p>
+            <a:pPr>
+              <a:lnSpc>
+                <a:spcPct val="150000"/>
+              </a:lnSpc>
+            </a:pPr>
+            <a:r>
+              <a:t>This paragraph uses 1.5x line spacing so you can see the extra vertical room between wrapped lines. Quick brown foxes and lazy dogs.</a:t>
+            </a:r>
+          </a:p>
+        </p:txBody>
+      </p:sp>
     </p:spTree>
   </p:cSld>
   <p:clrMapOvr>

</xml_diff>

<commit_message>
feat(notes+comments): load notesSlide and cmLst parts into slide metadata
Adds Slide.notes and Slide.comments; renders them only when the new
`renderNotes` / `renderComments` options are enabled. Author names
are resolved from commentAuthors.xml so comments show who wrote them.

Co-Authored-By: Claude Opus 4.7 (1M context) <noreply@anthropic.com>
</commit_message>
<xml_diff>
--- a/tests/render-test/basic/presentation.pptx
+++ b/tests/render-test/basic/presentation.pptx
@@ -6,12 +6,12 @@
   </p:sldMasterIdLst>
   <p:sldIdLst>
     <p:sldId id="256" r:id="rId7"/>
-    <p:sldId id="257" r:id="rId8"/>
-    <p:sldId id="258" r:id="rId9"/>
-    <p:sldId id="259" r:id="rId10"/>
-    <p:sldId id="260" r:id="rId11"/>
-    <p:sldId id="261" r:id="rId12"/>
-    <p:sldId id="262" r:id="rId13"/>
+    <p:sldId id="257" r:id="rId9"/>
+    <p:sldId id="258" r:id="rId10"/>
+    <p:sldId id="259" r:id="rId11"/>
+    <p:sldId id="260" r:id="rId12"/>
+    <p:sldId id="261" r:id="rId13"/>
+    <p:sldId id="262" r:id="rId14"/>
   </p:sldIdLst>
   <p:sldSz cx="9144000" cy="6858000" type="screen4x3"/>
   <p:notesSz cx="6858000" cy="9144000"/>
@@ -111,6 +111,446 @@
     </a:lvl9pPr>
   </p:defaultTextStyle>
 </p:presentation>
+</file>
+
+<file path=ppt/commentAuthors.xml><?xml version="1.0" encoding="utf-8"?>
+<p:cmAuthorLst xmlns:p="http://schemas.openxmlformats.org/presentationml/2006/main">
+  <p:cmAuthor id="0" name="Fixture Author" initials="FA" lastIdx="1" clrIdx="0"/>
+</p:cmAuthorLst>
+</file>
+
+<file path=ppt/comments/comment1.xml><?xml version="1.0" encoding="utf-8"?>
+<p:cmLst xmlns:p="http://schemas.openxmlformats.org/presentationml/2006/main">
+  <p:cm authorId="0" dt="2024-01-15T10:00:00Z" idx="1">
+    <p:pos x="1828800" y="1143000"/>
+    <p:text>Sample review comment for testing.</p:text>
+  </p:cm>
+</p:cmLst>
+</file>
+
+<file path=ppt/notesMasters/notesMaster1.xml><?xml version="1.0" encoding="utf-8"?>
+<p:notesMaster xmlns:a="http://schemas.openxmlformats.org/drawingml/2006/main" xmlns:p="http://schemas.openxmlformats.org/presentationml/2006/main" xmlns:r="http://schemas.openxmlformats.org/officeDocument/2006/relationships">
+  <p:cSld>
+    <p:bg>
+      <p:bgRef idx="1001">
+        <a:schemeClr val="bg1"/>
+      </p:bgRef>
+    </p:bg>
+    <p:spTree>
+      <p:nvGrpSpPr>
+        <p:cNvPr id="1" name=""/>
+        <p:cNvGrpSpPr/>
+        <p:nvPr/>
+      </p:nvGrpSpPr>
+      <p:grpSpPr>
+        <a:xfrm>
+          <a:off x="0" y="0"/>
+          <a:ext cx="0" cy="0"/>
+          <a:chOff x="0" y="0"/>
+          <a:chExt cx="0" cy="0"/>
+        </a:xfrm>
+      </p:grpSpPr>
+      <p:sp>
+        <p:nvSpPr>
+          <p:cNvPr id="2" name="Header Placeholder 1"/>
+          <p:cNvSpPr>
+            <a:spLocks noGrp="1"/>
+          </p:cNvSpPr>
+          <p:nvPr>
+            <p:ph type="hdr" sz="quarter"/>
+          </p:nvPr>
+        </p:nvSpPr>
+        <p:spPr>
+          <a:xfrm>
+            <a:off x="0" y="0"/>
+            <a:ext cx="2971800" cy="457200"/>
+          </a:xfrm>
+          <a:prstGeom prst="rect">
+            <a:avLst/>
+          </a:prstGeom>
+        </p:spPr>
+        <p:txBody>
+          <a:bodyPr vert="horz" lIns="91440" tIns="45720" rIns="91440" bIns="45720" rtlCol="0"/>
+          <a:lstStyle>
+            <a:lvl1pPr algn="l">
+              <a:defRPr sz="1200"/>
+            </a:lvl1pPr>
+          </a:lstStyle>
+          <a:p>
+            <a:endParaRPr lang="en-US"/>
+          </a:p>
+        </p:txBody>
+      </p:sp>
+      <p:sp>
+        <p:nvSpPr>
+          <p:cNvPr id="3" name="Date Placeholder 2"/>
+          <p:cNvSpPr>
+            <a:spLocks noGrp="1"/>
+          </p:cNvSpPr>
+          <p:nvPr>
+            <p:ph type="dt" idx="1"/>
+          </p:nvPr>
+        </p:nvSpPr>
+        <p:spPr>
+          <a:xfrm>
+            <a:off x="3884613" y="0"/>
+            <a:ext cx="2971800" cy="457200"/>
+          </a:xfrm>
+          <a:prstGeom prst="rect">
+            <a:avLst/>
+          </a:prstGeom>
+        </p:spPr>
+        <p:txBody>
+          <a:bodyPr vert="horz" lIns="91440" tIns="45720" rIns="91440" bIns="45720" rtlCol="0"/>
+          <a:lstStyle>
+            <a:lvl1pPr algn="r">
+              <a:defRPr sz="1200"/>
+            </a:lvl1pPr>
+          </a:lstStyle>
+          <a:p>
+            <a:fld id="{0F89C1C7-3DCD-1040-A9CF-14679D8B5DDD}" type="datetimeFigureOut">
+              <a:rPr lang="en-US" smtClean="0"/>
+              <a:t>10/17/16</a:t>
+            </a:fld>
+            <a:endParaRPr lang="en-US"/>
+          </a:p>
+        </p:txBody>
+      </p:sp>
+      <p:sp>
+        <p:nvSpPr>
+          <p:cNvPr id="4" name="Slide Image Placeholder 3"/>
+          <p:cNvSpPr>
+            <a:spLocks noGrp="1" noRot="1" noChangeAspect="1"/>
+          </p:cNvSpPr>
+          <p:nvPr>
+            <p:ph type="sldImg" idx="2"/>
+          </p:nvPr>
+        </p:nvSpPr>
+        <p:spPr>
+          <a:xfrm>
+            <a:off x="1143000" y="685800"/>
+            <a:ext cx="4572000" cy="3429000"/>
+          </a:xfrm>
+          <a:prstGeom prst="rect">
+            <a:avLst/>
+          </a:prstGeom>
+          <a:noFill/>
+          <a:ln w="12700">
+            <a:solidFill>
+              <a:prstClr val="black"/>
+            </a:solidFill>
+          </a:ln>
+        </p:spPr>
+        <p:txBody>
+          <a:bodyPr vert="horz" lIns="91440" tIns="45720" rIns="91440" bIns="45720" rtlCol="0" anchor="ctr"/>
+          <a:lstStyle/>
+          <a:p>
+            <a:endParaRPr lang="en-US"/>
+          </a:p>
+        </p:txBody>
+      </p:sp>
+      <p:sp>
+        <p:nvSpPr>
+          <p:cNvPr id="5" name="Notes Placeholder 4"/>
+          <p:cNvSpPr>
+            <a:spLocks noGrp="1"/>
+          </p:cNvSpPr>
+          <p:nvPr>
+            <p:ph type="body" sz="quarter" idx="3"/>
+          </p:nvPr>
+        </p:nvSpPr>
+        <p:spPr>
+          <a:xfrm>
+            <a:off x="685800" y="4343400"/>
+            <a:ext cx="5486400" cy="4114800"/>
+          </a:xfrm>
+          <a:prstGeom prst="rect">
+            <a:avLst/>
+          </a:prstGeom>
+        </p:spPr>
+        <p:txBody>
+          <a:bodyPr vert="horz" lIns="91440" tIns="45720" rIns="91440" bIns="45720" rtlCol="0"/>
+          <a:lstStyle/>
+          <a:p>
+            <a:pPr lvl="0"/>
+            <a:r>
+              <a:rPr lang="en-US" smtClean="0"/>
+              <a:t>Click to edit Master text styles</a:t>
+            </a:r>
+          </a:p>
+          <a:p>
+            <a:pPr lvl="1"/>
+            <a:r>
+              <a:rPr lang="en-US" smtClean="0"/>
+              <a:t>Second level</a:t>
+            </a:r>
+          </a:p>
+          <a:p>
+            <a:pPr lvl="2"/>
+            <a:r>
+              <a:rPr lang="en-US" smtClean="0"/>
+              <a:t>Third level</a:t>
+            </a:r>
+          </a:p>
+          <a:p>
+            <a:pPr lvl="3"/>
+            <a:r>
+              <a:rPr lang="en-US" smtClean="0"/>
+              <a:t>Fourth level</a:t>
+            </a:r>
+          </a:p>
+          <a:p>
+            <a:pPr lvl="4"/>
+            <a:r>
+              <a:rPr lang="en-US" smtClean="0"/>
+              <a:t>Fifth level</a:t>
+            </a:r>
+            <a:endParaRPr lang="en-US"/>
+          </a:p>
+        </p:txBody>
+      </p:sp>
+      <p:sp>
+        <p:nvSpPr>
+          <p:cNvPr id="6" name="Footer Placeholder 5"/>
+          <p:cNvSpPr>
+            <a:spLocks noGrp="1"/>
+          </p:cNvSpPr>
+          <p:nvPr>
+            <p:ph type="ftr" sz="quarter" idx="4"/>
+          </p:nvPr>
+        </p:nvSpPr>
+        <p:spPr>
+          <a:xfrm>
+            <a:off x="0" y="8685213"/>
+            <a:ext cx="2971800" cy="457200"/>
+          </a:xfrm>
+          <a:prstGeom prst="rect">
+            <a:avLst/>
+          </a:prstGeom>
+        </p:spPr>
+        <p:txBody>
+          <a:bodyPr vert="horz" lIns="91440" tIns="45720" rIns="91440" bIns="45720" rtlCol="0" anchor="b"/>
+          <a:lstStyle>
+            <a:lvl1pPr algn="l">
+              <a:defRPr sz="1200"/>
+            </a:lvl1pPr>
+          </a:lstStyle>
+          <a:p>
+            <a:endParaRPr lang="en-US"/>
+          </a:p>
+        </p:txBody>
+      </p:sp>
+      <p:sp>
+        <p:nvSpPr>
+          <p:cNvPr id="7" name="Slide Number Placeholder 6"/>
+          <p:cNvSpPr>
+            <a:spLocks noGrp="1"/>
+          </p:cNvSpPr>
+          <p:nvPr>
+            <p:ph type="sldNum" sz="quarter" idx="5"/>
+          </p:nvPr>
+        </p:nvSpPr>
+        <p:spPr>
+          <a:xfrm>
+            <a:off x="3884613" y="8685213"/>
+            <a:ext cx="2971800" cy="457200"/>
+          </a:xfrm>
+          <a:prstGeom prst="rect">
+            <a:avLst/>
+          </a:prstGeom>
+        </p:spPr>
+        <p:txBody>
+          <a:bodyPr vert="horz" lIns="91440" tIns="45720" rIns="91440" bIns="45720" rtlCol="0" anchor="b"/>
+          <a:lstStyle>
+            <a:lvl1pPr algn="r">
+              <a:defRPr sz="1200"/>
+            </a:lvl1pPr>
+          </a:lstStyle>
+          <a:p>
+            <a:fld id="{BB5E49A5-4136-284D-997B-48E1D791AD67}" type="slidenum">
+              <a:rPr lang="en-US" smtClean="0"/>
+              <a:t>‹#›</a:t>
+            </a:fld>
+            <a:endParaRPr lang="en-US"/>
+          </a:p>
+        </p:txBody>
+      </p:sp>
+    </p:spTree>
+    <p:extLst>
+      <p:ext uri="{BB962C8B-B14F-4D97-AF65-F5344CB8AC3E}">
+        <p14:creationId xmlns:p14="http://schemas.microsoft.com/office/powerpoint/2010/main" val="2623252185"/>
+      </p:ext>
+    </p:extLst>
+  </p:cSld>
+  <p:clrMap bg1="lt1" tx1="dk1" bg2="lt2" tx2="dk2" accent1="accent1" accent2="accent2" accent3="accent3" accent4="accent4" accent5="accent5" accent6="accent6" hlink="hlink" folHlink="folHlink"/>
+  <p:notesStyle>
+    <a:lvl1pPr marL="0" algn="l" defTabSz="457200" rtl="0" eaLnBrk="1" latinLnBrk="0" hangingPunct="1">
+      <a:defRPr sz="1200" kern="1200">
+        <a:solidFill>
+          <a:schemeClr val="tx1"/>
+        </a:solidFill>
+        <a:latin typeface="+mn-lt"/>
+        <a:ea typeface="+mn-ea"/>
+        <a:cs typeface="+mn-cs"/>
+      </a:defRPr>
+    </a:lvl1pPr>
+    <a:lvl2pPr marL="457200" algn="l" defTabSz="457200" rtl="0" eaLnBrk="1" latinLnBrk="0" hangingPunct="1">
+      <a:defRPr sz="1200" kern="1200">
+        <a:solidFill>
+          <a:schemeClr val="tx1"/>
+        </a:solidFill>
+        <a:latin typeface="+mn-lt"/>
+        <a:ea typeface="+mn-ea"/>
+        <a:cs typeface="+mn-cs"/>
+      </a:defRPr>
+    </a:lvl2pPr>
+    <a:lvl3pPr marL="914400" algn="l" defTabSz="457200" rtl="0" eaLnBrk="1" latinLnBrk="0" hangingPunct="1">
+      <a:defRPr sz="1200" kern="1200">
+        <a:solidFill>
+          <a:schemeClr val="tx1"/>
+        </a:solidFill>
+        <a:latin typeface="+mn-lt"/>
+        <a:ea typeface="+mn-ea"/>
+        <a:cs typeface="+mn-cs"/>
+      </a:defRPr>
+    </a:lvl3pPr>
+    <a:lvl4pPr marL="1371600" algn="l" defTabSz="457200" rtl="0" eaLnBrk="1" latinLnBrk="0" hangingPunct="1">
+      <a:defRPr sz="1200" kern="1200">
+        <a:solidFill>
+          <a:schemeClr val="tx1"/>
+        </a:solidFill>
+        <a:latin typeface="+mn-lt"/>
+        <a:ea typeface="+mn-ea"/>
+        <a:cs typeface="+mn-cs"/>
+      </a:defRPr>
+    </a:lvl4pPr>
+    <a:lvl5pPr marL="1828800" algn="l" defTabSz="457200" rtl="0" eaLnBrk="1" latinLnBrk="0" hangingPunct="1">
+      <a:defRPr sz="1200" kern="1200">
+        <a:solidFill>
+          <a:schemeClr val="tx1"/>
+        </a:solidFill>
+        <a:latin typeface="+mn-lt"/>
+        <a:ea typeface="+mn-ea"/>
+        <a:cs typeface="+mn-cs"/>
+      </a:defRPr>
+    </a:lvl5pPr>
+    <a:lvl6pPr marL="2286000" algn="l" defTabSz="457200" rtl="0" eaLnBrk="1" latinLnBrk="0" hangingPunct="1">
+      <a:defRPr sz="1200" kern="1200">
+        <a:solidFill>
+          <a:schemeClr val="tx1"/>
+        </a:solidFill>
+        <a:latin typeface="+mn-lt"/>
+        <a:ea typeface="+mn-ea"/>
+        <a:cs typeface="+mn-cs"/>
+      </a:defRPr>
+    </a:lvl6pPr>
+    <a:lvl7pPr marL="2743200" algn="l" defTabSz="457200" rtl="0" eaLnBrk="1" latinLnBrk="0" hangingPunct="1">
+      <a:defRPr sz="1200" kern="1200">
+        <a:solidFill>
+          <a:schemeClr val="tx1"/>
+        </a:solidFill>
+        <a:latin typeface="+mn-lt"/>
+        <a:ea typeface="+mn-ea"/>
+        <a:cs typeface="+mn-cs"/>
+      </a:defRPr>
+    </a:lvl7pPr>
+    <a:lvl8pPr marL="3200400" algn="l" defTabSz="457200" rtl="0" eaLnBrk="1" latinLnBrk="0" hangingPunct="1">
+      <a:defRPr sz="1200" kern="1200">
+        <a:solidFill>
+          <a:schemeClr val="tx1"/>
+        </a:solidFill>
+        <a:latin typeface="+mn-lt"/>
+        <a:ea typeface="+mn-ea"/>
+        <a:cs typeface="+mn-cs"/>
+      </a:defRPr>
+    </a:lvl8pPr>
+    <a:lvl9pPr marL="3657600" algn="l" defTabSz="457200" rtl="0" eaLnBrk="1" latinLnBrk="0" hangingPunct="1">
+      <a:defRPr sz="1200" kern="1200">
+        <a:solidFill>
+          <a:schemeClr val="tx1"/>
+        </a:solidFill>
+        <a:latin typeface="+mn-lt"/>
+        <a:ea typeface="+mn-ea"/>
+        <a:cs typeface="+mn-cs"/>
+      </a:defRPr>
+    </a:lvl9pPr>
+  </p:notesStyle>
+</p:notesMaster>
+</file>
+
+<file path=ppt/notesSlides/notesSlide1.xml><?xml version="1.0" encoding="utf-8"?>
+<p:notes xmlns:a="http://schemas.openxmlformats.org/drawingml/2006/main" xmlns:p="http://schemas.openxmlformats.org/presentationml/2006/main" xmlns:r="http://schemas.openxmlformats.org/officeDocument/2006/relationships">
+  <p:cSld>
+    <p:spTree>
+      <p:nvGrpSpPr>
+        <p:cNvPr id="1" name=""/>
+        <p:cNvGrpSpPr/>
+        <p:nvPr/>
+      </p:nvGrpSpPr>
+      <p:grpSpPr>
+        <a:xfrm>
+          <a:off x="0" y="0"/>
+          <a:ext cx="0" cy="0"/>
+          <a:chOff x="0" y="0"/>
+          <a:chExt cx="0" cy="0"/>
+        </a:xfrm>
+      </p:grpSpPr>
+      <p:sp>
+        <p:nvSpPr>
+          <p:cNvPr id="2" name="Slide Image Placeholder 1"/>
+          <p:cNvSpPr>
+            <a:spLocks noGrp="1"/>
+          </p:cNvSpPr>
+          <p:nvPr>
+            <p:ph type="sldImg" idx="2"/>
+          </p:nvPr>
+        </p:nvSpPr>
+        <p:spPr/>
+      </p:sp>
+      <p:sp>
+        <p:nvSpPr>
+          <p:cNvPr id="3" name="Notes Placeholder 2"/>
+          <p:cNvSpPr>
+            <a:spLocks noGrp="1"/>
+          </p:cNvSpPr>
+          <p:nvPr>
+            <p:ph type="body" idx="3" sz="quarter"/>
+          </p:nvPr>
+        </p:nvSpPr>
+        <p:spPr/>
+        <p:txBody>
+          <a:bodyPr/>
+          <a:lstStyle/>
+          <a:p>
+            <a:r>
+              <a:t>Speaker notes here.</a:t>
+            </a:r>
+          </a:p>
+          <a:p>
+            <a:r>
+              <a:t>Second line of notes for testing.</a:t>
+            </a:r>
+          </a:p>
+        </p:txBody>
+      </p:sp>
+      <p:sp>
+        <p:nvSpPr>
+          <p:cNvPr id="4" name="Slide Number Placeholder 3"/>
+          <p:cNvSpPr>
+            <a:spLocks noGrp="1"/>
+          </p:cNvSpPr>
+          <p:nvPr>
+            <p:ph type="sldNum" idx="5" sz="quarter"/>
+          </p:nvPr>
+        </p:nvSpPr>
+        <p:spPr/>
+      </p:sp>
+    </p:spTree>
+  </p:cSld>
+  <p:clrMapOvr>
+    <a:masterClrMapping/>
+  </p:clrMapOvr>
+</p:notes>
 </file>
 
 <file path=ppt/slideLayouts/slideLayout1.xml><?xml version="1.0" encoding="utf-8"?>
@@ -4036,4 +4476,324 @@
   </a:objectDefaults>
   <a:extraClrSchemeLst/>
 </a:theme>
+</file>
+
+<file path=ppt/theme/theme2.xml><?xml version="1.0" encoding="utf-8"?>
+<a:theme xmlns:a="http://schemas.openxmlformats.org/drawingml/2006/main" name="Office Theme">
+  <a:themeElements>
+    <a:clrScheme name="Office">
+      <a:dk1>
+        <a:sysClr val="windowText" lastClr="000000"/>
+      </a:dk1>
+      <a:lt1>
+        <a:sysClr val="window" lastClr="FFFFFF"/>
+      </a:lt1>
+      <a:dk2>
+        <a:srgbClr val="1F497D"/>
+      </a:dk2>
+      <a:lt2>
+        <a:srgbClr val="EEECE1"/>
+      </a:lt2>
+      <a:accent1>
+        <a:srgbClr val="4F81BD"/>
+      </a:accent1>
+      <a:accent2>
+        <a:srgbClr val="C0504D"/>
+      </a:accent2>
+      <a:accent3>
+        <a:srgbClr val="9BBB59"/>
+      </a:accent3>
+      <a:accent4>
+        <a:srgbClr val="8064A2"/>
+      </a:accent4>
+      <a:accent5>
+        <a:srgbClr val="4BACC6"/>
+      </a:accent5>
+      <a:accent6>
+        <a:srgbClr val="F79646"/>
+      </a:accent6>
+      <a:hlink>
+        <a:srgbClr val="0000FF"/>
+      </a:hlink>
+      <a:folHlink>
+        <a:srgbClr val="800080"/>
+      </a:folHlink>
+    </a:clrScheme>
+    <a:fontScheme name="Office">
+      <a:majorFont>
+        <a:latin typeface="Calibri"/>
+        <a:ea typeface=""/>
+        <a:cs typeface=""/>
+        <a:font script="Jpan" typeface="ＭＳ Ｐゴシック"/>
+        <a:font script="Hang" typeface="맑은 고딕"/>
+        <a:font script="Hans" typeface="宋体"/>
+        <a:font script="Hant" typeface="新細明體"/>
+        <a:font script="Arab" typeface="Times New Roman"/>
+        <a:font script="Hebr" typeface="Times New Roman"/>
+        <a:font script="Thai" typeface="Angsana New"/>
+        <a:font script="Ethi" typeface="Nyala"/>
+        <a:font script="Beng" typeface="Vrinda"/>
+        <a:font script="Gujr" typeface="Shruti"/>
+        <a:font script="Khmr" typeface="MoolBoran"/>
+        <a:font script="Knda" typeface="Tunga"/>
+        <a:font script="Guru" typeface="Raavi"/>
+        <a:font script="Cans" typeface="Euphemia"/>
+        <a:font script="Cher" typeface="Plantagenet Cherokee"/>
+        <a:font script="Yiii" typeface="Microsoft Yi Baiti"/>
+        <a:font script="Tibt" typeface="Microsoft Himalaya"/>
+        <a:font script="Thaa" typeface="MV Boli"/>
+        <a:font script="Deva" typeface="Mangal"/>
+        <a:font script="Telu" typeface="Gautami"/>
+        <a:font script="Taml" typeface="Latha"/>
+        <a:font script="Syrc" typeface="Estrangelo Edessa"/>
+        <a:font script="Orya" typeface="Kalinga"/>
+        <a:font script="Mlym" typeface="Kartika"/>
+        <a:font script="Laoo" typeface="DokChampa"/>
+        <a:font script="Sinh" typeface="Iskoola Pota"/>
+        <a:font script="Mong" typeface="Mongolian Baiti"/>
+        <a:font script="Viet" typeface="Times New Roman"/>
+        <a:font script="Uigh" typeface="Microsoft Uighur"/>
+        <a:font script="Geor" typeface="Sylfaen"/>
+      </a:majorFont>
+      <a:minorFont>
+        <a:latin typeface="Calibri"/>
+        <a:ea typeface=""/>
+        <a:cs typeface=""/>
+        <a:font script="Jpan" typeface="ＭＳ Ｐゴシック"/>
+        <a:font script="Hang" typeface="맑은 고딕"/>
+        <a:font script="Hans" typeface="宋体"/>
+        <a:font script="Hant" typeface="新細明體"/>
+        <a:font script="Arab" typeface="Arial"/>
+        <a:font script="Hebr" typeface="Arial"/>
+        <a:font script="Thai" typeface="Cordia New"/>
+        <a:font script="Ethi" typeface="Nyala"/>
+        <a:font script="Beng" typeface="Vrinda"/>
+        <a:font script="Gujr" typeface="Shruti"/>
+        <a:font script="Khmr" typeface="DaunPenh"/>
+        <a:font script="Knda" typeface="Tunga"/>
+        <a:font script="Guru" typeface="Raavi"/>
+        <a:font script="Cans" typeface="Euphemia"/>
+        <a:font script="Cher" typeface="Plantagenet Cherokee"/>
+        <a:font script="Yiii" typeface="Microsoft Yi Baiti"/>
+        <a:font script="Tibt" typeface="Microsoft Himalaya"/>
+        <a:font script="Thaa" typeface="MV Boli"/>
+        <a:font script="Deva" typeface="Mangal"/>
+        <a:font script="Telu" typeface="Gautami"/>
+        <a:font script="Taml" typeface="Latha"/>
+        <a:font script="Syrc" typeface="Estrangelo Edessa"/>
+        <a:font script="Orya" typeface="Kalinga"/>
+        <a:font script="Mlym" typeface="Kartika"/>
+        <a:font script="Laoo" typeface="DokChampa"/>
+        <a:font script="Sinh" typeface="Iskoola Pota"/>
+        <a:font script="Mong" typeface="Mongolian Baiti"/>
+        <a:font script="Viet" typeface="Arial"/>
+        <a:font script="Uigh" typeface="Microsoft Uighur"/>
+        <a:font script="Geor" typeface="Sylfaen"/>
+      </a:minorFont>
+    </a:fontScheme>
+    <a:fmtScheme name="Office">
+      <a:fillStyleLst>
+        <a:solidFill>
+          <a:schemeClr val="phClr"/>
+        </a:solidFill>
+        <a:gradFill rotWithShape="1">
+          <a:gsLst>
+            <a:gs pos="0">
+              <a:schemeClr val="phClr">
+                <a:tint val="50000"/>
+                <a:satMod val="300000"/>
+              </a:schemeClr>
+            </a:gs>
+            <a:gs pos="35000">
+              <a:schemeClr val="phClr">
+                <a:tint val="37000"/>
+                <a:satMod val="300000"/>
+              </a:schemeClr>
+            </a:gs>
+            <a:gs pos="100000">
+              <a:schemeClr val="phClr">
+                <a:tint val="15000"/>
+                <a:satMod val="350000"/>
+              </a:schemeClr>
+            </a:gs>
+          </a:gsLst>
+          <a:lin ang="16200000" scaled="1"/>
+        </a:gradFill>
+        <a:gradFill rotWithShape="1">
+          <a:gsLst>
+            <a:gs pos="0">
+              <a:schemeClr val="phClr">
+                <a:tint val="100000"/>
+                <a:shade val="100000"/>
+                <a:satMod val="130000"/>
+              </a:schemeClr>
+            </a:gs>
+            <a:gs pos="100000">
+              <a:schemeClr val="phClr">
+                <a:tint val="50000"/>
+                <a:shade val="100000"/>
+                <a:satMod val="350000"/>
+              </a:schemeClr>
+            </a:gs>
+          </a:gsLst>
+          <a:lin ang="16200000" scaled="0"/>
+        </a:gradFill>
+      </a:fillStyleLst>
+      <a:lnStyleLst>
+        <a:ln w="9525" cap="flat" cmpd="sng" algn="ctr">
+          <a:solidFill>
+            <a:schemeClr val="phClr">
+              <a:shade val="95000"/>
+              <a:satMod val="105000"/>
+            </a:schemeClr>
+          </a:solidFill>
+          <a:prstDash val="solid"/>
+        </a:ln>
+        <a:ln w="25400" cap="flat" cmpd="sng" algn="ctr">
+          <a:solidFill>
+            <a:schemeClr val="phClr"/>
+          </a:solidFill>
+          <a:prstDash val="solid"/>
+        </a:ln>
+        <a:ln w="38100" cap="flat" cmpd="sng" algn="ctr">
+          <a:solidFill>
+            <a:schemeClr val="phClr"/>
+          </a:solidFill>
+          <a:prstDash val="solid"/>
+        </a:ln>
+      </a:lnStyleLst>
+      <a:effectStyleLst>
+        <a:effectStyle>
+          <a:effectLst>
+            <a:outerShdw blurRad="40000" dist="20000" dir="5400000" rotWithShape="0">
+              <a:srgbClr val="000000">
+                <a:alpha val="38000"/>
+              </a:srgbClr>
+            </a:outerShdw>
+          </a:effectLst>
+        </a:effectStyle>
+        <a:effectStyle>
+          <a:effectLst>
+            <a:outerShdw blurRad="40000" dist="23000" dir="5400000" rotWithShape="0">
+              <a:srgbClr val="000000">
+                <a:alpha val="35000"/>
+              </a:srgbClr>
+            </a:outerShdw>
+          </a:effectLst>
+        </a:effectStyle>
+        <a:effectStyle>
+          <a:effectLst>
+            <a:outerShdw blurRad="40000" dist="23000" dir="5400000" rotWithShape="0">
+              <a:srgbClr val="000000">
+                <a:alpha val="35000"/>
+              </a:srgbClr>
+            </a:outerShdw>
+          </a:effectLst>
+          <a:scene3d>
+            <a:camera prst="orthographicFront">
+              <a:rot lat="0" lon="0" rev="0"/>
+            </a:camera>
+            <a:lightRig rig="threePt" dir="t">
+              <a:rot lat="0" lon="0" rev="1200000"/>
+            </a:lightRig>
+          </a:scene3d>
+          <a:sp3d>
+            <a:bevelT w="63500" h="25400"/>
+          </a:sp3d>
+        </a:effectStyle>
+      </a:effectStyleLst>
+      <a:bgFillStyleLst>
+        <a:solidFill>
+          <a:schemeClr val="phClr"/>
+        </a:solidFill>
+        <a:gradFill rotWithShape="1">
+          <a:gsLst>
+            <a:gs pos="0">
+              <a:schemeClr val="phClr">
+                <a:tint val="40000"/>
+                <a:satMod val="350000"/>
+              </a:schemeClr>
+            </a:gs>
+            <a:gs pos="40000">
+              <a:schemeClr val="phClr">
+                <a:tint val="45000"/>
+                <a:shade val="99000"/>
+                <a:satMod val="350000"/>
+              </a:schemeClr>
+            </a:gs>
+            <a:gs pos="100000">
+              <a:schemeClr val="phClr">
+                <a:shade val="20000"/>
+                <a:satMod val="255000"/>
+              </a:schemeClr>
+            </a:gs>
+          </a:gsLst>
+          <a:path path="circle">
+            <a:fillToRect l="50000" t="-80000" r="50000" b="180000"/>
+          </a:path>
+        </a:gradFill>
+        <a:gradFill rotWithShape="1">
+          <a:gsLst>
+            <a:gs pos="0">
+              <a:schemeClr val="phClr">
+                <a:tint val="80000"/>
+                <a:satMod val="300000"/>
+              </a:schemeClr>
+            </a:gs>
+            <a:gs pos="100000">
+              <a:schemeClr val="phClr">
+                <a:shade val="30000"/>
+                <a:satMod val="200000"/>
+              </a:schemeClr>
+            </a:gs>
+          </a:gsLst>
+          <a:path path="circle">
+            <a:fillToRect l="50000" t="50000" r="50000" b="50000"/>
+          </a:path>
+        </a:gradFill>
+      </a:bgFillStyleLst>
+    </a:fmtScheme>
+  </a:themeElements>
+  <a:objectDefaults>
+    <a:spDef>
+      <a:spPr/>
+      <a:bodyPr/>
+      <a:lstStyle/>
+      <a:style>
+        <a:lnRef idx="1">
+          <a:schemeClr val="accent1"/>
+        </a:lnRef>
+        <a:fillRef idx="3">
+          <a:schemeClr val="accent1"/>
+        </a:fillRef>
+        <a:effectRef idx="2">
+          <a:schemeClr val="accent1"/>
+        </a:effectRef>
+        <a:fontRef idx="minor">
+          <a:schemeClr val="lt1"/>
+        </a:fontRef>
+      </a:style>
+    </a:spDef>
+    <a:lnDef>
+      <a:spPr/>
+      <a:bodyPr/>
+      <a:lstStyle/>
+      <a:style>
+        <a:lnRef idx="2">
+          <a:schemeClr val="accent1"/>
+        </a:lnRef>
+        <a:fillRef idx="0">
+          <a:schemeClr val="accent1"/>
+        </a:fillRef>
+        <a:effectRef idx="1">
+          <a:schemeClr val="accent1"/>
+        </a:effectRef>
+        <a:fontRef idx="minor">
+          <a:schemeClr val="tx1"/>
+        </a:fontRef>
+      </a:style>
+    </a:lnDef>
+  </a:objectDefaults>
+  <a:extraClrSchemeLst/>
+</a:theme>
 </file>
</xml_diff>

<commit_message>
feat(fields): substitute slidenum / datetime / footer / header fields
Resolves FieldRun variants at render time. slidenum reads first
slide number from presentation.xml; datetime uses locale-formatted
now(); ftr/hdr consume the slide's <p:hf> flags and placeholder
text. Hidden slides (<p:sldId show="0">) are filtered from the
render list unless the new `showHidden` option is on.

Co-Authored-By: Claude Opus 4.7 (1M context) <noreply@anthropic.com>
</commit_message>
<xml_diff>
--- a/tests/render-test/basic/presentation.pptx
+++ b/tests/render-test/basic/presentation.pptx
@@ -12,6 +12,7 @@
     <p:sldId id="260" r:id="rId11"/>
     <p:sldId id="261" r:id="rId12"/>
     <p:sldId id="262" r:id="rId13"/>
+    <p:sldId id="263" r:id="rId14" show="0"/>
   </p:sldIdLst>
   <p:sldSz cx="9144000" cy="6858000" type="screen4x3"/>
   <p:notesSz cx="6858000" cy="9144000"/>
@@ -3710,6 +3711,45 @@
           </a:graphicData>
         </a:graphic>
       </p:graphicFrame>
+    </p:spTree>
+  </p:cSld>
+  <p:clrMapOvr>
+    <a:masterClrMapping/>
+  </p:clrMapOvr>
+</p:sld>
+</file>
+
+<file path=ppt/slides/slide8.xml><?xml version="1.0" encoding="utf-8"?>
+<p:sld xmlns:a="http://schemas.openxmlformats.org/drawingml/2006/main" xmlns:p="http://schemas.openxmlformats.org/presentationml/2006/main" xmlns:r="http://schemas.openxmlformats.org/officeDocument/2006/relationships">
+  <p:cSld>
+    <p:spTree>
+      <p:nvGrpSpPr>
+        <p:cNvPr id="1" name=""/>
+        <p:cNvGrpSpPr/>
+        <p:nvPr/>
+      </p:nvGrpSpPr>
+      <p:grpSpPr/>
+      <p:sp>
+        <p:nvSpPr>
+          <p:cNvPr id="2" name="Title 1"/>
+          <p:cNvSpPr>
+            <a:spLocks noGrp="1"/>
+          </p:cNvSpPr>
+          <p:nvPr>
+            <p:ph type="title"/>
+          </p:nvPr>
+        </p:nvSpPr>
+        <p:spPr/>
+        <p:txBody>
+          <a:bodyPr/>
+          <a:lstStyle/>
+          <a:p>
+            <a:r>
+              <a:t>Hidden slide</a:t>
+            </a:r>
+          </a:p>
+        </p:txBody>
+      </p:sp>
     </p:spTree>
   </p:cSld>
   <p:clrMapOvr>

</xml_diff>

<commit_message>
feat(shapes): render preset geometries via SVG paths
Implements ~40 most-common OOXML prstGeom presets including rectangles,
ellipses, arrows, stars, callouts, and basic flowchart shapes. Adjust
values (avLst/adj1..adj3) honored where they meaningfully change the
silhouette (roundRect corner radius, star inner radius).

Co-Authored-By: Claude Opus 4.7 (1M context) <noreply@anthropic.com>
</commit_message>
<xml_diff>
--- a/tests/render-test/basic/presentation.pptx
+++ b/tests/render-test/basic/presentation.pptx
@@ -12,6 +12,7 @@
     <p:sldId id="260" r:id="rId11"/>
     <p:sldId id="261" r:id="rId12"/>
     <p:sldId id="262" r:id="rId13"/>
+    <p:sldId id="263" r:id="rId14"/>
   </p:sldIdLst>
   <p:sldSz cx="9144000" cy="6858000" type="screen4x3"/>
   <p:notesSz cx="6858000" cy="9144000"/>
@@ -3539,6 +3540,315 @@
 </file>
 
 <file path=ppt/slides/slide7.xml><?xml version="1.0" encoding="utf-8"?>
+<p:sld xmlns:a="http://schemas.openxmlformats.org/drawingml/2006/main" xmlns:p="http://schemas.openxmlformats.org/presentationml/2006/main" xmlns:r="http://schemas.openxmlformats.org/officeDocument/2006/relationships">
+  <p:cSld>
+    <p:spTree>
+      <p:nvGrpSpPr>
+        <p:cNvPr id="1" name=""/>
+        <p:cNvGrpSpPr/>
+        <p:nvPr/>
+      </p:nvGrpSpPr>
+      <p:grpSpPr/>
+      <p:sp>
+        <p:nvSpPr>
+          <p:cNvPr id="2" name="Title 1"/>
+          <p:cNvSpPr>
+            <a:spLocks noGrp="1"/>
+          </p:cNvSpPr>
+          <p:nvPr>
+            <p:ph type="title"/>
+          </p:nvPr>
+        </p:nvSpPr>
+        <p:spPr/>
+        <p:txBody>
+          <a:bodyPr/>
+          <a:lstStyle/>
+          <a:p>
+            <a:r>
+              <a:t>Preset shapes</a:t>
+            </a:r>
+          </a:p>
+        </p:txBody>
+      </p:sp>
+      <p:sp>
+        <p:nvSpPr>
+          <p:cNvPr id="3" name="Rounded Rectangle 2"/>
+          <p:cNvSpPr/>
+          <p:nvPr/>
+        </p:nvSpPr>
+        <p:spPr>
+          <a:xfrm>
+            <a:off x="685800" y="1645920"/>
+            <a:ext cx="1828800" cy="1371600"/>
+          </a:xfrm>
+          <a:prstGeom prst="roundRect">
+            <a:avLst/>
+          </a:prstGeom>
+          <a:solidFill>
+            <a:srgbClr val="4F81BD"/>
+          </a:solidFill>
+          <a:ln>
+            <a:solidFill>
+              <a:srgbClr val="1F497D"/>
+            </a:solidFill>
+          </a:ln>
+        </p:spPr>
+        <p:style>
+          <a:lnRef idx="1">
+            <a:schemeClr val="accent1"/>
+          </a:lnRef>
+          <a:fillRef idx="3">
+            <a:schemeClr val="accent1"/>
+          </a:fillRef>
+          <a:effectRef idx="2">
+            <a:schemeClr val="accent1"/>
+          </a:effectRef>
+          <a:fontRef idx="minor">
+            <a:schemeClr val="lt1"/>
+          </a:fontRef>
+        </p:style>
+        <p:txBody>
+          <a:bodyPr rtlCol="0" anchor="ctr"/>
+          <a:lstStyle/>
+          <a:p>
+            <a:pPr algn="ctr"/>
+          </a:p>
+        </p:txBody>
+      </p:sp>
+      <p:sp>
+        <p:nvSpPr>
+          <p:cNvPr id="4" name="Diamond 3"/>
+          <p:cNvSpPr/>
+          <p:nvPr/>
+        </p:nvSpPr>
+        <p:spPr>
+          <a:xfrm>
+            <a:off x="2971800" y="1645920"/>
+            <a:ext cx="1828800" cy="1371600"/>
+          </a:xfrm>
+          <a:prstGeom prst="diamond">
+            <a:avLst/>
+          </a:prstGeom>
+          <a:solidFill>
+            <a:srgbClr val="4F81BD"/>
+          </a:solidFill>
+          <a:ln>
+            <a:solidFill>
+              <a:srgbClr val="1F497D"/>
+            </a:solidFill>
+          </a:ln>
+        </p:spPr>
+        <p:style>
+          <a:lnRef idx="1">
+            <a:schemeClr val="accent1"/>
+          </a:lnRef>
+          <a:fillRef idx="3">
+            <a:schemeClr val="accent1"/>
+          </a:fillRef>
+          <a:effectRef idx="2">
+            <a:schemeClr val="accent1"/>
+          </a:effectRef>
+          <a:fontRef idx="minor">
+            <a:schemeClr val="lt1"/>
+          </a:fontRef>
+        </p:style>
+        <p:txBody>
+          <a:bodyPr rtlCol="0" anchor="ctr"/>
+          <a:lstStyle/>
+          <a:p>
+            <a:pPr algn="ctr"/>
+          </a:p>
+        </p:txBody>
+      </p:sp>
+      <p:sp>
+        <p:nvSpPr>
+          <p:cNvPr id="5" name="Oval 4"/>
+          <p:cNvSpPr/>
+          <p:nvPr/>
+        </p:nvSpPr>
+        <p:spPr>
+          <a:xfrm>
+            <a:off x="5257800" y="1645920"/>
+            <a:ext cx="1828800" cy="1371600"/>
+          </a:xfrm>
+          <a:prstGeom prst="ellipse">
+            <a:avLst/>
+          </a:prstGeom>
+          <a:solidFill>
+            <a:srgbClr val="4F81BD"/>
+          </a:solidFill>
+          <a:ln>
+            <a:solidFill>
+              <a:srgbClr val="1F497D"/>
+            </a:solidFill>
+          </a:ln>
+        </p:spPr>
+        <p:style>
+          <a:lnRef idx="1">
+            <a:schemeClr val="accent1"/>
+          </a:lnRef>
+          <a:fillRef idx="3">
+            <a:schemeClr val="accent1"/>
+          </a:fillRef>
+          <a:effectRef idx="2">
+            <a:schemeClr val="accent1"/>
+          </a:effectRef>
+          <a:fontRef idx="minor">
+            <a:schemeClr val="lt1"/>
+          </a:fontRef>
+        </p:style>
+        <p:txBody>
+          <a:bodyPr rtlCol="0" anchor="ctr"/>
+          <a:lstStyle/>
+          <a:p>
+            <a:pPr algn="ctr"/>
+          </a:p>
+        </p:txBody>
+      </p:sp>
+      <p:sp>
+        <p:nvSpPr>
+          <p:cNvPr id="6" name="Up Arrow 5"/>
+          <p:cNvSpPr/>
+          <p:nvPr/>
+        </p:nvSpPr>
+        <p:spPr>
+          <a:xfrm>
+            <a:off x="685800" y="3474720"/>
+            <a:ext cx="1828800" cy="1371600"/>
+          </a:xfrm>
+          <a:prstGeom prst="upArrow">
+            <a:avLst/>
+          </a:prstGeom>
+          <a:solidFill>
+            <a:srgbClr val="4F81BD"/>
+          </a:solidFill>
+          <a:ln>
+            <a:solidFill>
+              <a:srgbClr val="1F497D"/>
+            </a:solidFill>
+          </a:ln>
+        </p:spPr>
+        <p:style>
+          <a:lnRef idx="1">
+            <a:schemeClr val="accent1"/>
+          </a:lnRef>
+          <a:fillRef idx="3">
+            <a:schemeClr val="accent1"/>
+          </a:fillRef>
+          <a:effectRef idx="2">
+            <a:schemeClr val="accent1"/>
+          </a:effectRef>
+          <a:fontRef idx="minor">
+            <a:schemeClr val="lt1"/>
+          </a:fontRef>
+        </p:style>
+        <p:txBody>
+          <a:bodyPr rtlCol="0" anchor="ctr"/>
+          <a:lstStyle/>
+          <a:p>
+            <a:pPr algn="ctr"/>
+          </a:p>
+        </p:txBody>
+      </p:sp>
+      <p:sp>
+        <p:nvSpPr>
+          <p:cNvPr id="7" name="5-Point Star 6"/>
+          <p:cNvSpPr/>
+          <p:nvPr/>
+        </p:nvSpPr>
+        <p:spPr>
+          <a:xfrm>
+            <a:off x="2971800" y="3474720"/>
+            <a:ext cx="1828800" cy="1371600"/>
+          </a:xfrm>
+          <a:prstGeom prst="star5">
+            <a:avLst/>
+          </a:prstGeom>
+          <a:solidFill>
+            <a:srgbClr val="4F81BD"/>
+          </a:solidFill>
+          <a:ln>
+            <a:solidFill>
+              <a:srgbClr val="1F497D"/>
+            </a:solidFill>
+          </a:ln>
+        </p:spPr>
+        <p:style>
+          <a:lnRef idx="1">
+            <a:schemeClr val="accent1"/>
+          </a:lnRef>
+          <a:fillRef idx="3">
+            <a:schemeClr val="accent1"/>
+          </a:fillRef>
+          <a:effectRef idx="2">
+            <a:schemeClr val="accent1"/>
+          </a:effectRef>
+          <a:fontRef idx="minor">
+            <a:schemeClr val="lt1"/>
+          </a:fontRef>
+        </p:style>
+        <p:txBody>
+          <a:bodyPr rtlCol="0" anchor="ctr"/>
+          <a:lstStyle/>
+          <a:p>
+            <a:pPr algn="ctr"/>
+          </a:p>
+        </p:txBody>
+      </p:sp>
+      <p:sp>
+        <p:nvSpPr>
+          <p:cNvPr id="8" name="Pentagon 7"/>
+          <p:cNvSpPr/>
+          <p:nvPr/>
+        </p:nvSpPr>
+        <p:spPr>
+          <a:xfrm>
+            <a:off x="5257800" y="3474720"/>
+            <a:ext cx="1828800" cy="1371600"/>
+          </a:xfrm>
+          <a:prstGeom prst="homePlate">
+            <a:avLst/>
+          </a:prstGeom>
+          <a:solidFill>
+            <a:srgbClr val="4F81BD"/>
+          </a:solidFill>
+          <a:ln>
+            <a:solidFill>
+              <a:srgbClr val="1F497D"/>
+            </a:solidFill>
+          </a:ln>
+        </p:spPr>
+        <p:style>
+          <a:lnRef idx="1">
+            <a:schemeClr val="accent1"/>
+          </a:lnRef>
+          <a:fillRef idx="3">
+            <a:schemeClr val="accent1"/>
+          </a:fillRef>
+          <a:effectRef idx="2">
+            <a:schemeClr val="accent1"/>
+          </a:effectRef>
+          <a:fontRef idx="minor">
+            <a:schemeClr val="lt1"/>
+          </a:fontRef>
+        </p:style>
+        <p:txBody>
+          <a:bodyPr rtlCol="0" anchor="ctr"/>
+          <a:lstStyle/>
+          <a:p>
+            <a:pPr algn="ctr"/>
+          </a:p>
+        </p:txBody>
+      </p:sp>
+    </p:spTree>
+  </p:cSld>
+  <p:clrMapOvr>
+    <a:masterClrMapping/>
+  </p:clrMapOvr>
+</p:sld>
+</file>
+
+<file path=ppt/slides/slide8.xml><?xml version="1.0" encoding="utf-8"?>
 <p:sld xmlns:a="http://schemas.openxmlformats.org/drawingml/2006/main" xmlns:p="http://schemas.openxmlformats.org/presentationml/2006/main" xmlns:r="http://schemas.openxmlformats.org/officeDocument/2006/relationships">
   <p:cSld>
     <p:spTree>

</xml_diff>

<commit_message>
feat(render): render gradient / picture / pattern fills
Extends the solid-only fill path with linear/radial gradients (mapped
to CSS gradient functions), blipFill (via background-image with
embed-resolved blob URLs), and a subset of OOXML pattFill presets
via inline SVG data URLs. Line/stroke rendering remains solid-only
for now (TODO for non-solid strokes).

Co-Authored-By: Claude Opus 4.7 (1M context) <noreply@anthropic.com>
</commit_message>
<xml_diff>
--- a/tests/render-test/basic/presentation.pptx
+++ b/tests/render-test/basic/presentation.pptx
@@ -12,6 +12,8 @@
     <p:sldId id="260" r:id="rId11"/>
     <p:sldId id="261" r:id="rId12"/>
     <p:sldId id="262" r:id="rId13"/>
+    <p:sldId id="263" r:id="rId14"/>
+    <p:sldId id="264" r:id="rId15"/>
   </p:sldIdLst>
   <p:sldSz cx="9144000" cy="6858000" type="screen4x3"/>
   <p:notesSz cx="6858000" cy="9144000"/>
@@ -3710,6 +3712,182 @@
           </a:graphicData>
         </a:graphic>
       </p:graphicFrame>
+    </p:spTree>
+  </p:cSld>
+  <p:clrMapOvr>
+    <a:masterClrMapping/>
+  </p:clrMapOvr>
+</p:sld>
+</file>
+
+<file path=ppt/slides/slide8.xml><?xml version="1.0" encoding="utf-8"?>
+<p:sld xmlns:a="http://schemas.openxmlformats.org/drawingml/2006/main" xmlns:p="http://schemas.openxmlformats.org/presentationml/2006/main" xmlns:r="http://schemas.openxmlformats.org/officeDocument/2006/relationships">
+  <p:cSld>
+    <p:spTree>
+      <p:nvGrpSpPr>
+        <p:cNvPr id="1" name=""/>
+        <p:cNvGrpSpPr/>
+        <p:nvPr/>
+      </p:nvGrpSpPr>
+      <p:grpSpPr/>
+      <p:sp>
+        <p:nvSpPr>
+          <p:cNvPr id="2" name="Title 1"/>
+          <p:cNvSpPr>
+            <a:spLocks noGrp="1"/>
+          </p:cNvSpPr>
+          <p:nvPr>
+            <p:ph type="title"/>
+          </p:nvPr>
+        </p:nvSpPr>
+        <p:spPr/>
+        <p:txBody>
+          <a:bodyPr/>
+          <a:lstStyle/>
+          <a:p>
+            <a:r>
+              <a:t>Gradient fill</a:t>
+            </a:r>
+          </a:p>
+        </p:txBody>
+      </p:sp>
+      <p:sp>
+        <p:nvSpPr>
+          <p:cNvPr id="3" name="Rectangle 2"/>
+          <p:cNvSpPr/>
+          <p:nvPr/>
+        </p:nvSpPr>
+        <p:spPr>
+          <a:xfrm>
+            <a:off x="914400" y="1828800"/>
+            <a:ext cx="5486400" cy="1828800"/>
+          </a:xfrm>
+          <a:prstGeom prst="rect">
+            <a:avLst/>
+          </a:prstGeom>
+          <a:gradFill flip="none" rotWithShape="1">
+            <a:gsLst>
+              <a:gs pos="0">
+                <a:srgbClr val="4F81BD"/>
+              </a:gs>
+              <a:gs pos="100000">
+                <a:srgbClr val="C0504D"/>
+              </a:gs>
+            </a:gsLst>
+            <a:lin ang="2700000" scaled="1"/>
+          </a:gradFill>
+        </p:spPr>
+        <p:style>
+          <a:lnRef idx="1">
+            <a:schemeClr val="accent1"/>
+          </a:lnRef>
+          <a:fillRef idx="3">
+            <a:schemeClr val="accent1"/>
+          </a:fillRef>
+          <a:effectRef idx="2">
+            <a:schemeClr val="accent1"/>
+          </a:effectRef>
+          <a:fontRef idx="minor">
+            <a:schemeClr val="lt1"/>
+          </a:fontRef>
+        </p:style>
+        <p:txBody>
+          <a:bodyPr rtlCol="0" anchor="ctr"/>
+          <a:lstStyle/>
+          <a:p>
+            <a:r>
+              <a:rPr>
+                <a:solidFill>
+                  <a:srgbClr val="FFFFFF"/>
+                </a:solidFill>
+              </a:rPr>
+              <a:t>Linear gradient</a:t>
+            </a:r>
+          </a:p>
+        </p:txBody>
+      </p:sp>
+    </p:spTree>
+  </p:cSld>
+  <p:clrMapOvr>
+    <a:masterClrMapping/>
+  </p:clrMapOvr>
+</p:sld>
+</file>
+
+<file path=ppt/slides/slide9.xml><?xml version="1.0" encoding="utf-8"?>
+<p:sld xmlns:a="http://schemas.openxmlformats.org/drawingml/2006/main" xmlns:p="http://schemas.openxmlformats.org/presentationml/2006/main" xmlns:r="http://schemas.openxmlformats.org/officeDocument/2006/relationships">
+  <p:cSld>
+    <p:spTree>
+      <p:nvGrpSpPr>
+        <p:cNvPr id="1" name=""/>
+        <p:cNvGrpSpPr/>
+        <p:nvPr/>
+      </p:nvGrpSpPr>
+      <p:grpSpPr/>
+      <p:sp>
+        <p:nvSpPr>
+          <p:cNvPr id="2" name="Title 1"/>
+          <p:cNvSpPr>
+            <a:spLocks noGrp="1"/>
+          </p:cNvSpPr>
+          <p:nvPr>
+            <p:ph type="title"/>
+          </p:nvPr>
+        </p:nvSpPr>
+        <p:spPr/>
+        <p:txBody>
+          <a:bodyPr/>
+          <a:lstStyle/>
+          <a:p>
+            <a:r>
+              <a:t>Picture fill</a:t>
+            </a:r>
+          </a:p>
+        </p:txBody>
+      </p:sp>
+      <p:sp>
+        <p:nvSpPr>
+          <p:cNvPr id="3" name="Rectangle 2"/>
+          <p:cNvSpPr/>
+          <p:nvPr/>
+        </p:nvSpPr>
+        <p:spPr>
+          <a:xfrm>
+            <a:off x="1828800" y="1828800"/>
+            <a:ext cx="4572000" cy="2743200"/>
+          </a:xfrm>
+          <a:prstGeom prst="rect">
+            <a:avLst/>
+          </a:prstGeom>
+          <a:blipFill>
+            <a:blip r:embed="rId2"/>
+            <a:stretch>
+              <a:fillRect/>
+            </a:stretch>
+          </a:blipFill>
+        </p:spPr>
+        <p:style>
+          <a:lnRef idx="1">
+            <a:schemeClr val="accent1"/>
+          </a:lnRef>
+          <a:fillRef idx="3">
+            <a:schemeClr val="accent1"/>
+          </a:fillRef>
+          <a:effectRef idx="2">
+            <a:schemeClr val="accent1"/>
+          </a:effectRef>
+          <a:fontRef idx="minor">
+            <a:schemeClr val="lt1"/>
+          </a:fontRef>
+        </p:style>
+        <p:txBody>
+          <a:bodyPr rtlCol="0" anchor="ctr"/>
+          <a:lstStyle/>
+          <a:p>
+            <a:pPr algn="ctr"/>
+          </a:p>
+        </p:txBody>
+      </p:sp>
     </p:spTree>
   </p:cSld>
   <p:clrMapOvr>

</xml_diff>

<commit_message>
feat(graphic-frame): chart + SmartArt fallback rendering
Charts render as their cached image (or [Chart] placeholder). SmartArt
renders via the pre-existing DrawingML drawing sibling (data1.xml's
drawing1.xml) through the standard shape pipeline, falling back to a
[SmartArt] placeholder when that drawing is absent.

Co-Authored-By: Claude Opus 4.7 (1M context) <noreply@anthropic.com>
</commit_message>
<xml_diff>
--- a/tests/render-test/basic/presentation.pptx
+++ b/tests/render-test/basic/presentation.pptx
@@ -12,6 +12,7 @@
     <p:sldId id="260" r:id="rId11"/>
     <p:sldId id="261" r:id="rId12"/>
     <p:sldId id="262" r:id="rId13"/>
+    <p:sldId id="263" r:id="rId14"/>
   </p:sldIdLst>
   <p:sldSz cx="9144000" cy="6858000" type="screen4x3"/>
   <p:notesSz cx="6858000" cy="9144000"/>
@@ -111,6 +112,116 @@
     </a:lvl9pPr>
   </p:defaultTextStyle>
 </p:presentation>
+</file>
+
+<file path=ppt/charts/chart1.xml><?xml version="1.0" encoding="utf-8"?>
+<c:chartSpace xmlns:c="http://schemas.openxmlformats.org/drawingml/2006/chart" xmlns:a="http://schemas.openxmlformats.org/drawingml/2006/main" xmlns:r="http://schemas.openxmlformats.org/officeDocument/2006/relationships">
+  <c:date1904 val="0"/>
+  <c:chart>
+    <c:autoTitleDeleted val="0"/>
+    <c:plotArea>
+      <c:barChart>
+        <c:barDir val="col"/>
+        <c:grouping val="clustered"/>
+        <c:ser>
+          <c:idx val="0"/>
+          <c:order val="0"/>
+          <c:tx>
+            <c:strRef>
+              <c:f>Sheet1!$B$1</c:f>
+              <c:strCache>
+                <c:ptCount val="1"/>
+                <c:pt idx="0">
+                  <c:v>Series 1</c:v>
+                </c:pt>
+              </c:strCache>
+            </c:strRef>
+          </c:tx>
+          <c:cat>
+            <c:strRef>
+              <c:f>Sheet1!$A$2:$A$4</c:f>
+              <c:strCache>
+                <c:ptCount val="3"/>
+                <c:pt idx="0">
+                  <c:v>A</c:v>
+                </c:pt>
+                <c:pt idx="1">
+                  <c:v>B</c:v>
+                </c:pt>
+                <c:pt idx="2">
+                  <c:v>C</c:v>
+                </c:pt>
+              </c:strCache>
+            </c:strRef>
+          </c:cat>
+          <c:val>
+            <c:numRef>
+              <c:f>Sheet1!$B$2:$B$4</c:f>
+              <c:numCache>
+                <c:formatCode>General</c:formatCode>
+                <c:ptCount val="3"/>
+                <c:pt idx="0">
+                  <c:v>1</c:v>
+                </c:pt>
+                <c:pt idx="1">
+                  <c:v>2</c:v>
+                </c:pt>
+                <c:pt idx="2">
+                  <c:v>3</c:v>
+                </c:pt>
+              </c:numCache>
+            </c:numRef>
+          </c:val>
+        </c:ser>
+        <c:axId val="-2068027336"/>
+        <c:axId val="-2113994440"/>
+      </c:barChart>
+      <c:catAx>
+        <c:axId val="-2068027336"/>
+        <c:scaling>
+          <c:orientation val="minMax"/>
+        </c:scaling>
+        <c:delete val="0"/>
+        <c:axPos val="b"/>
+        <c:majorTickMark val="out"/>
+        <c:minorTickMark val="none"/>
+        <c:tickLblPos val="nextTo"/>
+        <c:crossAx val="-2113994440"/>
+        <c:crosses val="autoZero"/>
+        <c:auto val="1"/>
+        <c:lblAlgn val="ctr"/>
+        <c:lblOffset val="100"/>
+        <c:noMultiLvlLbl val="0"/>
+      </c:catAx>
+      <c:valAx>
+        <c:axId val="-2113994440"/>
+        <c:scaling/>
+        <c:delete val="0"/>
+        <c:axPos val="l"/>
+        <c:majorGridlines/>
+        <c:majorTickMark val="out"/>
+        <c:minorTickMark val="none"/>
+        <c:tickLblPos val="nextTo"/>
+        <c:crossAx val="-2068027336"/>
+        <c:crosses val="autoZero"/>
+      </c:valAx>
+    </c:plotArea>
+    <c:dispBlanksAs val="gap"/>
+  </c:chart>
+  <c:txPr>
+    <a:bodyPr/>
+    <a:lstStyle/>
+    <a:p>
+      <a:pPr>
+        <a:defRPr sz="1800"/>
+      </a:pPr>
+      <a:endParaRPr lang="en-US"/>
+    </a:p>
+  </c:txPr>
+  <c:externalData r:id="rId1">
+    <c:autoUpdate val="0"/>
+  </c:externalData>
+</c:chartSpace>
 </file>
 
 <file path=ppt/slideLayouts/slideLayout1.xml><?xml version="1.0" encoding="utf-8"?>
@@ -3707,6 +3818,63 @@
                 </a:tc>
               </a:tr>
             </a:tbl>
+          </a:graphicData>
+        </a:graphic>
+      </p:graphicFrame>
+    </p:spTree>
+  </p:cSld>
+  <p:clrMapOvr>
+    <a:masterClrMapping/>
+  </p:clrMapOvr>
+</p:sld>
+</file>
+
+<file path=ppt/slides/slide8.xml><?xml version="1.0" encoding="utf-8"?>
+<p:sld xmlns:a="http://schemas.openxmlformats.org/drawingml/2006/main" xmlns:p="http://schemas.openxmlformats.org/presentationml/2006/main" xmlns:r="http://schemas.openxmlformats.org/officeDocument/2006/relationships">
+  <p:cSld>
+    <p:spTree>
+      <p:nvGrpSpPr>
+        <p:cNvPr id="1" name=""/>
+        <p:cNvGrpSpPr/>
+        <p:nvPr/>
+      </p:nvGrpSpPr>
+      <p:grpSpPr/>
+      <p:sp>
+        <p:nvSpPr>
+          <p:cNvPr id="2" name="Title 1"/>
+          <p:cNvSpPr>
+            <a:spLocks noGrp="1"/>
+          </p:cNvSpPr>
+          <p:nvPr>
+            <p:ph type="title"/>
+          </p:nvPr>
+        </p:nvSpPr>
+        <p:spPr/>
+        <p:txBody>
+          <a:bodyPr/>
+          <a:lstStyle/>
+          <a:p>
+            <a:r>
+              <a:t>A chart</a:t>
+            </a:r>
+          </a:p>
+        </p:txBody>
+      </p:sp>
+      <p:graphicFrame>
+        <p:nvGraphicFramePr>
+          <p:cNvPr id="3" name="Chart 2"/>
+          <p:cNvGraphicFramePr>
+            <a:graphicFrameLocks noGrp="1"/>
+          </p:cNvGraphicFramePr>
+          <p:nvPr/>
+        </p:nvGraphicFramePr>
+        <p:xfrm>
+          <a:off x="914400" y="1828800"/>
+          <a:ext cx="5486400" cy="3657600"/>
+        </p:xfrm>
+        <a:graphic>
+          <a:graphicData uri="http://schemas.openxmlformats.org/drawingml/2006/chart">
+            <c:chart xmlns:c="http://schemas.openxmlformats.org/drawingml/2006/chart" r:id="rId2"/>
           </a:graphicData>
         </a:graphic>
       </p:graphicFrame>

</xml_diff>

<commit_message>
feat(custgeom): arcTo + multi-path + path fill mode
parseCustGeom now emits SVG A commands for <a:arcTo>, concatenates
all <a:path> entries inside <a:pathLst> into one d string, and
surfaces the <a:path fill="..."> attribute so path-level fill
overrides (notably "none") are respected at render time.

Co-Authored-By: Claude Opus 4.7 (1M context) <noreply@anthropic.com>
</commit_message>
<xml_diff>
--- a/tests/render-test/basic/presentation.pptx
+++ b/tests/render-test/basic/presentation.pptx
@@ -12,6 +12,16 @@
     <p:sldId id="260" r:id="rId12"/>
     <p:sldId id="261" r:id="rId13"/>
     <p:sldId id="262" r:id="rId14"/>
+    <p:sldId id="263" r:id="rId15"/>
+    <p:sldId id="264" r:id="rId16"/>
+    <p:sldId id="265" r:id="rId17"/>
+    <p:sldId id="266" r:id="rId18"/>
+    <p:sldId id="267" r:id="rId19"/>
+    <p:sldId id="268" r:id="rId20"/>
+    <p:sldId id="269" r:id="rId21"/>
+    <p:sldId id="270" r:id="rId22"/>
+    <p:sldId id="271" r:id="rId23"/>
+    <p:sldId id="272" r:id="rId24" show="0"/>
   </p:sldIdLst>
   <p:sldSz cx="9144000" cy="6858000" type="screen4x3"/>
   <p:notesSz cx="6858000" cy="9144000"/>
@@ -117,6 +127,116 @@
 <p:cmAuthorLst xmlns:p="http://schemas.openxmlformats.org/presentationml/2006/main">
   <p:cmAuthor id="0" name="Fixture Author" initials="FA" lastIdx="1" clrIdx="0"/>
 </p:cmAuthorLst>
+</file>
+
+<file path=ppt/charts/chart1.xml><?xml version="1.0" encoding="utf-8"?>
+<c:chartSpace xmlns:c="http://schemas.openxmlformats.org/drawingml/2006/chart" xmlns:a="http://schemas.openxmlformats.org/drawingml/2006/main" xmlns:r="http://schemas.openxmlformats.org/officeDocument/2006/relationships">
+  <c:date1904 val="0"/>
+  <c:chart>
+    <c:autoTitleDeleted val="0"/>
+    <c:plotArea>
+      <c:barChart>
+        <c:barDir val="col"/>
+        <c:grouping val="clustered"/>
+        <c:ser>
+          <c:idx val="0"/>
+          <c:order val="0"/>
+          <c:tx>
+            <c:strRef>
+              <c:f>Sheet1!$B$1</c:f>
+              <c:strCache>
+                <c:ptCount val="1"/>
+                <c:pt idx="0">
+                  <c:v>Series 1</c:v>
+                </c:pt>
+              </c:strCache>
+            </c:strRef>
+          </c:tx>
+          <c:cat>
+            <c:strRef>
+              <c:f>Sheet1!$A$2:$A$4</c:f>
+              <c:strCache>
+                <c:ptCount val="3"/>
+                <c:pt idx="0">
+                  <c:v>A</c:v>
+                </c:pt>
+                <c:pt idx="1">
+                  <c:v>B</c:v>
+                </c:pt>
+                <c:pt idx="2">
+                  <c:v>C</c:v>
+                </c:pt>
+              </c:strCache>
+            </c:strRef>
+          </c:cat>
+          <c:val>
+            <c:numRef>
+              <c:f>Sheet1!$B$2:$B$4</c:f>
+              <c:numCache>
+                <c:formatCode>General</c:formatCode>
+                <c:ptCount val="3"/>
+                <c:pt idx="0">
+                  <c:v>1</c:v>
+                </c:pt>
+                <c:pt idx="1">
+                  <c:v>2</c:v>
+                </c:pt>
+                <c:pt idx="2">
+                  <c:v>3</c:v>
+                </c:pt>
+              </c:numCache>
+            </c:numRef>
+          </c:val>
+        </c:ser>
+        <c:axId val="-2068027336"/>
+        <c:axId val="-2113994440"/>
+      </c:barChart>
+      <c:catAx>
+        <c:axId val="-2068027336"/>
+        <c:scaling>
+          <c:orientation val="minMax"/>
+        </c:scaling>
+        <c:delete val="0"/>
+        <c:axPos val="b"/>
+        <c:majorTickMark val="out"/>
+        <c:minorTickMark val="none"/>
+        <c:tickLblPos val="nextTo"/>
+        <c:crossAx val="-2113994440"/>
+        <c:crosses val="autoZero"/>
+        <c:auto val="1"/>
+        <c:lblAlgn val="ctr"/>
+        <c:lblOffset val="100"/>
+        <c:noMultiLvlLbl val="0"/>
+      </c:catAx>
+      <c:valAx>
+        <c:axId val="-2113994440"/>
+        <c:scaling/>
+        <c:delete val="0"/>
+        <c:axPos val="l"/>
+        <c:majorGridlines/>
+        <c:majorTickMark val="out"/>
+        <c:minorTickMark val="none"/>
+        <c:tickLblPos val="nextTo"/>
+        <c:crossAx val="-2068027336"/>
+        <c:crosses val="autoZero"/>
+      </c:valAx>
+    </c:plotArea>
+    <c:dispBlanksAs val="gap"/>
+  </c:chart>
+  <c:txPr>
+    <a:bodyPr/>
+    <a:lstStyle/>
+    <a:p>
+      <a:pPr>
+        <a:defRPr sz="1800"/>
+      </a:pPr>
+      <a:endParaRPr lang="en-US"/>
+    </a:p>
+  </c:txPr>
+  <c:externalData r:id="rId1">
+    <c:autoUpdate val="0"/>
+  </c:externalData>
+</c:chartSpace>
 </file>
 
 <file path=ppt/comments/comment1.xml><?xml version="1.0" encoding="utf-8"?>
@@ -3584,7 +3704,7 @@
 </p:sld>
 </file>
 
-<file path=ppt/slides/slide2.xml><?xml version="1.0" encoding="utf-8"?>
+<file path=ppt/slides/slide10.xml><?xml version="1.0" encoding="utf-8"?>
 <p:sld xmlns:a="http://schemas.openxmlformats.org/drawingml/2006/main" xmlns:p="http://schemas.openxmlformats.org/presentationml/2006/main" xmlns:r="http://schemas.openxmlformats.org/officeDocument/2006/relationships">
   <p:cSld>
     <p:spTree>
@@ -3610,155 +3730,7 @@
           <a:lstStyle/>
           <a:p>
             <a:r>
-              <a:t>Bullet points</a:t>
-            </a:r>
-          </a:p>
-        </p:txBody>
-      </p:sp>
-      <p:sp>
-        <p:nvSpPr>
-          <p:cNvPr id="3" name="Content Placeholder 2"/>
-          <p:cNvSpPr>
-            <a:spLocks noGrp="1"/>
-          </p:cNvSpPr>
-          <p:nvPr>
-            <p:ph idx="1"/>
-          </p:nvPr>
-        </p:nvSpPr>
-        <p:spPr/>
-        <p:txBody>
-          <a:bodyPr/>
-          <a:lstStyle/>
-          <a:p>
-            <a:r>
-              <a:t>First bullet</a:t>
-            </a:r>
-          </a:p>
-          <a:p>
-            <a:pPr>
-              <a:defRPr sz="1800"/>
-            </a:pPr>
-            <a:r>
-              <a:t>Second bullet</a:t>
-            </a:r>
-          </a:p>
-          <a:p>
-            <a:pPr>
-              <a:defRPr sz="1800"/>
-            </a:pPr>
-            <a:r>
-              <a:t>Third bullet</a:t>
-            </a:r>
-          </a:p>
-        </p:txBody>
-      </p:sp>
-    </p:spTree>
-  </p:cSld>
-  <p:clrMapOvr>
-    <a:masterClrMapping/>
-  </p:clrMapOvr>
-</p:sld>
-</file>
-
-<file path=ppt/slides/slide3.xml><?xml version="1.0" encoding="utf-8"?>
-<p:sld xmlns:a="http://schemas.openxmlformats.org/drawingml/2006/main" xmlns:p="http://schemas.openxmlformats.org/presentationml/2006/main" xmlns:r="http://schemas.openxmlformats.org/officeDocument/2006/relationships">
-  <p:cSld>
-    <p:spTree>
-      <p:nvGrpSpPr>
-        <p:cNvPr id="1" name=""/>
-        <p:cNvGrpSpPr/>
-        <p:nvPr/>
-      </p:nvGrpSpPr>
-      <p:grpSpPr/>
-      <p:sp>
-        <p:nvSpPr>
-          <p:cNvPr id="2" name="Title 1"/>
-          <p:cNvSpPr>
-            <a:spLocks noGrp="1"/>
-          </p:cNvSpPr>
-          <p:nvPr>
-            <p:ph type="title"/>
-          </p:nvPr>
-        </p:nvSpPr>
-        <p:spPr/>
-        <p:txBody>
-          <a:bodyPr/>
-          <a:lstStyle/>
-          <a:p>
-            <a:r>
-              <a:t>A shape</a:t>
-            </a:r>
-          </a:p>
-        </p:txBody>
-      </p:sp>
-      <p:sp>
-        <p:nvSpPr>
-          <p:cNvPr id="3" name="TextBox 2"/>
-          <p:cNvSpPr txBox="1"/>
-          <p:nvPr/>
-        </p:nvSpPr>
-        <p:spPr>
-          <a:xfrm>
-            <a:off x="914400" y="1828800"/>
-            <a:ext cx="3657600" cy="914400"/>
-          </a:xfrm>
-          <a:prstGeom prst="rect">
-            <a:avLst/>
-          </a:prstGeom>
-          <a:noFill/>
-        </p:spPr>
-        <p:txBody>
-          <a:bodyPr wrap="none">
-            <a:spAutoFit/>
-          </a:bodyPr>
-          <a:lstStyle/>
-          <a:p>
-            <a:r>
-              <a:rPr sz="2400" b="1">
-                <a:solidFill>
-                  <a:srgbClr val="C0392B"/>
-                </a:solidFill>
-              </a:rPr>
-              <a:t>Free-floating textbox</a:t>
-            </a:r>
-          </a:p>
-        </p:txBody>
-      </p:sp>
-    </p:spTree>
-  </p:cSld>
-  <p:clrMapOvr>
-    <a:masterClrMapping/>
-  </p:clrMapOvr>
-</p:sld>
-</file>
-
-<file path=ppt/slides/slide4.xml><?xml version="1.0" encoding="utf-8"?>
-<p:sld xmlns:a="http://schemas.openxmlformats.org/drawingml/2006/main" xmlns:p="http://schemas.openxmlformats.org/presentationml/2006/main" xmlns:r="http://schemas.openxmlformats.org/officeDocument/2006/relationships">
-  <p:cSld>
-    <p:spTree>
-      <p:nvGrpSpPr>
-        <p:cNvPr id="1" name=""/>
-        <p:cNvGrpSpPr/>
-        <p:nvPr/>
-      </p:nvGrpSpPr>
-      <p:grpSpPr/>
-      <p:sp>
-        <p:nvSpPr>
-          <p:cNvPr id="2" name="Title 1"/>
-          <p:cNvSpPr>
-            <a:spLocks noGrp="1"/>
-          </p:cNvSpPr>
-          <p:nvPr>
-            <p:ph type="title"/>
-          </p:nvPr>
-        </p:nvSpPr>
-        <p:spPr/>
-        <p:txBody>
-          <a:bodyPr/>
-          <a:lstStyle/>
-          <a:p>
-            <a:r>
-              <a:t>An image</a:t>
+              <a:t>Image adjustments</a:t>
             </a:r>
           </a:p>
         </p:txBody>
@@ -3772,6 +3744,7 @@
           <p:nvPr/>
         </p:nvPicPr>
         <p:blipFill>
+          <a:srcRect l="20000" t="10000" r="20000" b="10000"/>
           <a:blip r:embed="rId2"/>
           <a:stretch>
             <a:fillRect/>
@@ -3779,8 +3752,141 @@
         </p:blipFill>
         <p:spPr>
           <a:xfrm>
-            <a:off x="2743200" y="1828800"/>
-            <a:ext cx="3657600" cy="1828800"/>
+            <a:off x="457200" y="1645920"/>
+            <a:ext cx="2286000" cy="1645920"/>
+          </a:xfrm>
+          <a:prstGeom prst="rect">
+            <a:avLst/>
+          </a:prstGeom>
+        </p:spPr>
+      </p:pic>
+      <p:pic>
+        <p:nvPicPr>
+          <p:cNvPr id="4" name="Picture 3" descr="python-powered.png"/>
+          <p:cNvPicPr>
+            <a:picLocks noChangeAspect="1"/>
+          </p:cNvPicPr>
+          <p:nvPr/>
+        </p:nvPicPr>
+        <p:blipFill>
+          <a:blip r:embed="rId2">
+            <a:grayscl/>
+          </a:blip>
+          <a:stretch>
+            <a:fillRect/>
+          </a:stretch>
+        </p:blipFill>
+        <p:spPr>
+          <a:xfrm>
+            <a:off x="3017520" y="1645920"/>
+            <a:ext cx="2286000" cy="1645920"/>
+          </a:xfrm>
+          <a:prstGeom prst="rect">
+            <a:avLst/>
+          </a:prstGeom>
+        </p:spPr>
+      </p:pic>
+      <p:pic>
+        <p:nvPicPr>
+          <p:cNvPr id="5" name="Picture 4" descr="python-powered.png"/>
+          <p:cNvPicPr>
+            <a:picLocks noChangeAspect="1"/>
+          </p:cNvPicPr>
+          <p:nvPr/>
+        </p:nvPicPr>
+        <p:blipFill>
+          <a:blip r:embed="rId2">
+            <a:lum bright="20000" contrast="30000"/>
+          </a:blip>
+          <a:stretch>
+            <a:fillRect/>
+          </a:stretch>
+        </p:blipFill>
+        <p:spPr>
+          <a:xfrm>
+            <a:off x="5577840" y="1645920"/>
+            <a:ext cx="2286000" cy="1645920"/>
+          </a:xfrm>
+          <a:prstGeom prst="rect">
+            <a:avLst/>
+          </a:prstGeom>
+        </p:spPr>
+      </p:pic>
+      <p:pic>
+        <p:nvPicPr>
+          <p:cNvPr id="6" name="Picture 5" descr="python-powered.png"/>
+          <p:cNvPicPr>
+            <a:picLocks noChangeAspect="1"/>
+          </p:cNvPicPr>
+          <p:nvPr/>
+        </p:nvPicPr>
+        <p:blipFill>
+          <a:blip r:embed="rId2">
+            <a:alphaModFix amt="50000"/>
+          </a:blip>
+          <a:stretch>
+            <a:fillRect/>
+          </a:stretch>
+        </p:blipFill>
+        <p:spPr>
+          <a:xfrm>
+            <a:off x="457200" y="3840480"/>
+            <a:ext cx="2286000" cy="1645920"/>
+          </a:xfrm>
+          <a:prstGeom prst="rect">
+            <a:avLst/>
+          </a:prstGeom>
+        </p:spPr>
+      </p:pic>
+      <p:pic>
+        <p:nvPicPr>
+          <p:cNvPr id="7" name="Picture 6" descr="python-powered.png"/>
+          <p:cNvPicPr>
+            <a:picLocks noChangeAspect="1"/>
+          </p:cNvPicPr>
+          <p:nvPr/>
+        </p:nvPicPr>
+        <p:blipFill>
+          <a:blip r:embed="rId2">
+            <a:biLevel thresh="50000"/>
+          </a:blip>
+          <a:stretch>
+            <a:fillRect/>
+          </a:stretch>
+        </p:blipFill>
+        <p:spPr>
+          <a:xfrm>
+            <a:off x="3017520" y="3840480"/>
+            <a:ext cx="2286000" cy="1645920"/>
+          </a:xfrm>
+          <a:prstGeom prst="rect">
+            <a:avLst/>
+          </a:prstGeom>
+        </p:spPr>
+      </p:pic>
+      <p:pic>
+        <p:nvPicPr>
+          <p:cNvPr id="8" name="Picture 7" descr="python-powered.png"/>
+          <p:cNvPicPr>
+            <a:picLocks noChangeAspect="1"/>
+          </p:cNvPicPr>
+          <p:nvPr/>
+        </p:nvPicPr>
+        <p:blipFill>
+          <a:blip r:embed="rId2">
+            <a:duotone>
+              <a:srgbClr val="1F3A93"/>
+              <a:srgbClr val="FFD9B3"/>
+            </a:duotone>
+          </a:blip>
+          <a:stretch>
+            <a:fillRect/>
+          </a:stretch>
+        </p:blipFill>
+        <p:spPr>
+          <a:xfrm>
+            <a:off x="5577840" y="3840480"/>
+            <a:ext cx="2286000" cy="1645920"/>
           </a:xfrm>
           <a:prstGeom prst="rect">
             <a:avLst/>
@@ -3795,54 +3901,7 @@
 </p:sld>
 </file>
 
-<file path=ppt/slides/slide5.xml><?xml version="1.0" encoding="utf-8"?>
-<p:sld xmlns:a="http://schemas.openxmlformats.org/drawingml/2006/main" xmlns:p="http://schemas.openxmlformats.org/presentationml/2006/main" xmlns:r="http://schemas.openxmlformats.org/officeDocument/2006/relationships">
-  <p:cSld>
-    <p:bg>
-      <p:bgPr>
-        <a:solidFill>
-          <a:srgbClr val="FFF4E0"/>
-        </a:solidFill>
-        <a:effectLst/>
-      </p:bgPr>
-    </p:bg>
-    <p:spTree>
-      <p:nvGrpSpPr>
-        <p:cNvPr id="1" name=""/>
-        <p:cNvGrpSpPr/>
-        <p:nvPr/>
-      </p:nvGrpSpPr>
-      <p:grpSpPr/>
-      <p:sp>
-        <p:nvSpPr>
-          <p:cNvPr id="2" name="Title 1"/>
-          <p:cNvSpPr>
-            <a:spLocks noGrp="1"/>
-          </p:cNvSpPr>
-          <p:nvPr>
-            <p:ph type="title"/>
-          </p:nvPr>
-        </p:nvSpPr>
-        <p:spPr/>
-        <p:txBody>
-          <a:bodyPr/>
-          <a:lstStyle/>
-          <a:p>
-            <a:r>
-              <a:t>Tinted background</a:t>
-            </a:r>
-          </a:p>
-        </p:txBody>
-      </p:sp>
-    </p:spTree>
-  </p:cSld>
-  <p:clrMapOvr>
-    <a:masterClrMapping/>
-  </p:clrMapOvr>
-</p:sld>
-</file>
-
-<file path=ppt/slides/slide6.xml><?xml version="1.0" encoding="utf-8"?>
+<file path=ppt/slides/slide11.xml><?xml version="1.0" encoding="utf-8"?>
 <p:sld xmlns:a="http://schemas.openxmlformats.org/drawingml/2006/main" xmlns:p="http://schemas.openxmlformats.org/presentationml/2006/main" xmlns:r="http://schemas.openxmlformats.org/officeDocument/2006/relationships">
   <p:cSld>
     <p:spTree>
@@ -3868,7 +3927,7 @@
           <a:lstStyle/>
           <a:p>
             <a:r>
-              <a:t>Filled shapes</a:t>
+              <a:t>Custom geometry</a:t>
             </a:r>
           </a:p>
         </p:txBody>
@@ -3881,20 +3940,31 @@
         </p:nvSpPr>
         <p:spPr>
           <a:xfrm>
-            <a:off x="914400" y="1828800"/>
-            <a:ext cx="2743200" cy="1371600"/>
+            <a:off x="685800" y="1828800"/>
+            <a:ext cx="1828800" cy="1828800"/>
           </a:xfrm>
-          <a:prstGeom prst="rect">
-            <a:avLst/>
-          </a:prstGeom>
           <a:solidFill>
             <a:srgbClr val="4F81BD"/>
           </a:solidFill>
-          <a:ln w="38100">
-            <a:solidFill>
-              <a:srgbClr val="1F497D"/>
-            </a:solidFill>
-          </a:ln>
+          <a:custGeom>
+            <a:avLst/>
+            <a:gdLst/>
+            <a:ahLst/>
+            <a:cxnLst/>
+            <a:rect l="0" t="0" r="0" b="0"/>
+            <a:pathLst>
+              <a:path w="100000" h="100000">
+                <a:moveTo>
+                  <a:pt x="50000" y="50000"/>
+                </a:moveTo>
+                <a:lnTo>
+                  <a:pt x="100000" y="50000"/>
+                </a:lnTo>
+                <a:arcTo wR="50000" hR="50000" stAng="0" swAng="5400000"/>
+                <a:close/>
+              </a:path>
+            </a:pathLst>
+          </a:custGeom>
         </p:spPr>
         <p:style>
           <a:lnRef idx="1">
@@ -3914,14 +3984,7 @@
           <a:bodyPr rtlCol="0" anchor="ctr"/>
           <a:lstStyle/>
           <a:p>
-            <a:r>
-              <a:rPr>
-                <a:solidFill>
-                  <a:srgbClr val="FFFFFF"/>
-                </a:solidFill>
-              </a:rPr>
-              <a:t>Filled + bordered</a:t>
-            </a:r>
+            <a:pPr algn="ctr"/>
           </a:p>
         </p:txBody>
       </p:sp>
@@ -3933,18 +3996,51 @@
         </p:nvSpPr>
         <p:spPr>
           <a:xfrm>
-            <a:off x="4572000" y="1828800"/>
-            <a:ext cx="2743200" cy="1371600"/>
+            <a:off x="2971800" y="1828800"/>
+            <a:ext cx="1828800" cy="1828800"/>
           </a:xfrm>
-          <a:prstGeom prst="rect">
+          <a:solidFill>
+            <a:srgbClr val="C0504D"/>
+          </a:solidFill>
+          <a:custGeom>
             <a:avLst/>
-          </a:prstGeom>
-          <a:noFill/>
-          <a:ln w="19050">
-            <a:solidFill>
-              <a:srgbClr val="C0504D"/>
-            </a:solidFill>
-          </a:ln>
+            <a:gdLst/>
+            <a:ahLst/>
+            <a:cxnLst/>
+            <a:rect l="0" t="0" r="0" b="0"/>
+            <a:pathLst>
+              <a:path w="100000" h="100000">
+                <a:moveTo>
+                  <a:pt x="50000" y="0"/>
+                </a:moveTo>
+                <a:lnTo>
+                  <a:pt x="100000" y="50000"/>
+                </a:lnTo>
+                <a:lnTo>
+                  <a:pt x="50000" y="100000"/>
+                </a:lnTo>
+                <a:lnTo>
+                  <a:pt x="0" y="50000"/>
+                </a:lnTo>
+                <a:close/>
+              </a:path>
+              <a:path w="100000" h="100000">
+                <a:moveTo>
+                  <a:pt x="50000" y="25000"/>
+                </a:moveTo>
+                <a:lnTo>
+                  <a:pt x="75000" y="50000"/>
+                </a:lnTo>
+                <a:lnTo>
+                  <a:pt x="50000" y="75000"/>
+                </a:lnTo>
+                <a:lnTo>
+                  <a:pt x="25000" y="50000"/>
+                </a:lnTo>
+                <a:close/>
+              </a:path>
+            </a:pathLst>
+          </a:custGeom>
         </p:spPr>
         <p:style>
           <a:lnRef idx="1">
@@ -3964,9 +4060,68 @@
           <a:bodyPr rtlCol="0" anchor="ctr"/>
           <a:lstStyle/>
           <a:p>
-            <a:r>
-              <a:t>Border only</a:t>
-            </a:r>
+            <a:pPr algn="ctr"/>
+          </a:p>
+        </p:txBody>
+      </p:sp>
+      <p:sp>
+        <p:nvSpPr>
+          <p:cNvPr id="5" name="Rectangle 4"/>
+          <p:cNvSpPr/>
+          <p:nvPr/>
+        </p:nvSpPr>
+        <p:spPr>
+          <a:xfrm>
+            <a:off x="5257800" y="1828800"/>
+            <a:ext cx="2743200" cy="1828800"/>
+          </a:xfrm>
+          <a:solidFill>
+            <a:srgbClr val="4FBD81"/>
+          </a:solidFill>
+          <a:ln w="38100">
+            <a:solidFill>
+              <a:srgbClr val="1F497D"/>
+            </a:solidFill>
+          </a:ln>
+          <a:custGeom>
+            <a:avLst/>
+            <a:gdLst/>
+            <a:ahLst/>
+            <a:cxnLst/>
+            <a:rect l="0" t="0" r="0" b="0"/>
+            <a:pathLst>
+              <a:path w="100000" h="100000" fill="none">
+                <a:moveTo>
+                  <a:pt x="0" y="50000"/>
+                </a:moveTo>
+                <a:cubicBezTo>
+                  <a:pt x="25000" y="0"/>
+                  <a:pt x="75000" y="100000"/>
+                  <a:pt x="100000" y="50000"/>
+                </a:cubicBezTo>
+              </a:path>
+            </a:pathLst>
+          </a:custGeom>
+        </p:spPr>
+        <p:style>
+          <a:lnRef idx="1">
+            <a:schemeClr val="accent1"/>
+          </a:lnRef>
+          <a:fillRef idx="3">
+            <a:schemeClr val="accent1"/>
+          </a:fillRef>
+          <a:effectRef idx="2">
+            <a:schemeClr val="accent1"/>
+          </a:effectRef>
+          <a:fontRef idx="minor">
+            <a:schemeClr val="lt1"/>
+          </a:fontRef>
+        </p:style>
+        <p:txBody>
+          <a:bodyPr rtlCol="0" anchor="ctr"/>
+          <a:lstStyle/>
+          <a:p>
+            <a:pPr algn="ctr"/>
           </a:p>
         </p:txBody>
       </p:sp>
@@ -3978,7 +4133,7 @@
 </p:sld>
 </file>
 
-<file path=ppt/slides/slide7.xml><?xml version="1.0" encoding="utf-8"?>
+<file path=ppt/slides/slide12.xml><?xml version="1.0" encoding="utf-8"?>
 <p:sld xmlns:a="http://schemas.openxmlformats.org/drawingml/2006/main" xmlns:p="http://schemas.openxmlformats.org/presentationml/2006/main" xmlns:r="http://schemas.openxmlformats.org/officeDocument/2006/relationships">
   <p:cSld>
     <p:spTree>
@@ -4150,6 +4305,1568 @@
           </a:graphicData>
         </a:graphic>
       </p:graphicFrame>
+    </p:spTree>
+  </p:cSld>
+  <p:clrMapOvr>
+    <a:masterClrMapping/>
+  </p:clrMapOvr>
+</p:sld>
+</file>
+
+<file path=ppt/slides/slide13.xml><?xml version="1.0" encoding="utf-8"?>
+<p:sld xmlns:a="http://schemas.openxmlformats.org/drawingml/2006/main" xmlns:p="http://schemas.openxmlformats.org/presentationml/2006/main" xmlns:r="http://schemas.openxmlformats.org/officeDocument/2006/relationships">
+  <p:cSld>
+    <p:spTree>
+      <p:nvGrpSpPr>
+        <p:cNvPr id="1" name=""/>
+        <p:cNvGrpSpPr/>
+        <p:nvPr/>
+      </p:nvGrpSpPr>
+      <p:grpSpPr/>
+      <p:sp>
+        <p:nvSpPr>
+          <p:cNvPr id="2" name="Title 1"/>
+          <p:cNvSpPr>
+            <a:spLocks noGrp="1"/>
+          </p:cNvSpPr>
+          <p:nvPr>
+            <p:ph type="title"/>
+          </p:nvPr>
+        </p:nvSpPr>
+        <p:spPr/>
+        <p:txBody>
+          <a:bodyPr/>
+          <a:lstStyle/>
+          <a:p>
+            <a:r>
+              <a:t>Gradient fill</a:t>
+            </a:r>
+          </a:p>
+        </p:txBody>
+      </p:sp>
+      <p:sp>
+        <p:nvSpPr>
+          <p:cNvPr id="3" name="Rectangle 2"/>
+          <p:cNvSpPr/>
+          <p:nvPr/>
+        </p:nvSpPr>
+        <p:spPr>
+          <a:xfrm>
+            <a:off x="914400" y="1828800"/>
+            <a:ext cx="5486400" cy="1828800"/>
+          </a:xfrm>
+          <a:prstGeom prst="rect">
+            <a:avLst/>
+          </a:prstGeom>
+          <a:gradFill flip="none" rotWithShape="1">
+            <a:gsLst>
+              <a:gs pos="0">
+                <a:srgbClr val="4F81BD"/>
+              </a:gs>
+              <a:gs pos="100000">
+                <a:srgbClr val="C0504D"/>
+              </a:gs>
+            </a:gsLst>
+            <a:lin ang="2700000" scaled="1"/>
+          </a:gradFill>
+        </p:spPr>
+        <p:style>
+          <a:lnRef idx="1">
+            <a:schemeClr val="accent1"/>
+          </a:lnRef>
+          <a:fillRef idx="3">
+            <a:schemeClr val="accent1"/>
+          </a:fillRef>
+          <a:effectRef idx="2">
+            <a:schemeClr val="accent1"/>
+          </a:effectRef>
+          <a:fontRef idx="minor">
+            <a:schemeClr val="lt1"/>
+          </a:fontRef>
+        </p:style>
+        <p:txBody>
+          <a:bodyPr rtlCol="0" anchor="ctr"/>
+          <a:lstStyle/>
+          <a:p>
+            <a:r>
+              <a:rPr>
+                <a:solidFill>
+                  <a:srgbClr val="FFFFFF"/>
+                </a:solidFill>
+              </a:rPr>
+              <a:t>Linear gradient</a:t>
+            </a:r>
+          </a:p>
+        </p:txBody>
+      </p:sp>
+    </p:spTree>
+  </p:cSld>
+  <p:clrMapOvr>
+    <a:masterClrMapping/>
+  </p:clrMapOvr>
+</p:sld>
+</file>
+
+<file path=ppt/slides/slide14.xml><?xml version="1.0" encoding="utf-8"?>
+<p:sld xmlns:a="http://schemas.openxmlformats.org/drawingml/2006/main" xmlns:p="http://schemas.openxmlformats.org/presentationml/2006/main" xmlns:r="http://schemas.openxmlformats.org/officeDocument/2006/relationships">
+  <p:cSld>
+    <p:spTree>
+      <p:nvGrpSpPr>
+        <p:cNvPr id="1" name=""/>
+        <p:cNvGrpSpPr/>
+        <p:nvPr/>
+      </p:nvGrpSpPr>
+      <p:grpSpPr/>
+      <p:sp>
+        <p:nvSpPr>
+          <p:cNvPr id="2" name="Title 1"/>
+          <p:cNvSpPr>
+            <a:spLocks noGrp="1"/>
+          </p:cNvSpPr>
+          <p:nvPr>
+            <p:ph type="title"/>
+          </p:nvPr>
+        </p:nvSpPr>
+        <p:spPr/>
+        <p:txBody>
+          <a:bodyPr/>
+          <a:lstStyle/>
+          <a:p>
+            <a:r>
+              <a:t>Picture fill</a:t>
+            </a:r>
+          </a:p>
+        </p:txBody>
+      </p:sp>
+      <p:sp>
+        <p:nvSpPr>
+          <p:cNvPr id="3" name="Rectangle 2"/>
+          <p:cNvSpPr/>
+          <p:nvPr/>
+        </p:nvSpPr>
+        <p:spPr>
+          <a:xfrm>
+            <a:off x="1828800" y="1828800"/>
+            <a:ext cx="4572000" cy="2743200"/>
+          </a:xfrm>
+          <a:prstGeom prst="rect">
+            <a:avLst/>
+          </a:prstGeom>
+          <a:blipFill>
+            <a:blip r:embed="rId2"/>
+            <a:stretch>
+              <a:fillRect/>
+            </a:stretch>
+          </a:blipFill>
+        </p:spPr>
+        <p:style>
+          <a:lnRef idx="1">
+            <a:schemeClr val="accent1"/>
+          </a:lnRef>
+          <a:fillRef idx="3">
+            <a:schemeClr val="accent1"/>
+          </a:fillRef>
+          <a:effectRef idx="2">
+            <a:schemeClr val="accent1"/>
+          </a:effectRef>
+          <a:fontRef idx="minor">
+            <a:schemeClr val="lt1"/>
+          </a:fontRef>
+        </p:style>
+        <p:txBody>
+          <a:bodyPr rtlCol="0" anchor="ctr"/>
+          <a:lstStyle/>
+          <a:p>
+            <a:pPr algn="ctr"/>
+          </a:p>
+        </p:txBody>
+      </p:sp>
+    </p:spTree>
+  </p:cSld>
+  <p:clrMapOvr>
+    <a:masterClrMapping/>
+  </p:clrMapOvr>
+</p:sld>
+</file>
+
+<file path=ppt/slides/slide15.xml><?xml version="1.0" encoding="utf-8"?>
+<p:sld xmlns:a="http://schemas.openxmlformats.org/drawingml/2006/main" xmlns:p="http://schemas.openxmlformats.org/presentationml/2006/main" xmlns:r="http://schemas.openxmlformats.org/officeDocument/2006/relationships">
+  <p:cSld>
+    <p:spTree>
+      <p:nvGrpSpPr>
+        <p:cNvPr id="1" name=""/>
+        <p:cNvGrpSpPr/>
+        <p:nvPr/>
+      </p:nvGrpSpPr>
+      <p:grpSpPr/>
+      <p:sp>
+        <p:nvSpPr>
+          <p:cNvPr id="2" name="Title 1"/>
+          <p:cNvSpPr>
+            <a:spLocks noGrp="1"/>
+          </p:cNvSpPr>
+          <p:nvPr>
+            <p:ph type="title"/>
+          </p:nvPr>
+        </p:nvSpPr>
+        <p:spPr/>
+        <p:txBody>
+          <a:bodyPr/>
+          <a:lstStyle/>
+          <a:p>
+            <a:r>
+              <a:t>Typography</a:t>
+            </a:r>
+          </a:p>
+        </p:txBody>
+      </p:sp>
+      <p:sp>
+        <p:nvSpPr>
+          <p:cNvPr id="3" name="TextBox 2"/>
+          <p:cNvSpPr txBox="1"/>
+          <p:nvPr/>
+        </p:nvSpPr>
+        <p:spPr>
+          <a:xfrm>
+            <a:off x="914400" y="1371600"/>
+            <a:ext cx="7315200" cy="3657600"/>
+          </a:xfrm>
+          <a:prstGeom prst="rect">
+            <a:avLst/>
+          </a:prstGeom>
+          <a:noFill/>
+        </p:spPr>
+        <p:txBody>
+          <a:bodyPr wrap="square">
+            <a:spAutoFit/>
+          </a:bodyPr>
+          <a:lstStyle/>
+          <a:p>
+            <a:r>
+              <a:t>Plain then </a:t>
+            </a:r>
+            <a:r>
+              <a:rPr u="sng"/>
+              <a:t>underlined</a:t>
+            </a:r>
+            <a:r>
+              <a:t> then </a:t>
+            </a:r>
+            <a:r>
+              <a:rPr strike="sngStrike"/>
+              <a:t>strikethrough</a:t>
+            </a:r>
+            <a:r>
+              <a:t>.</a:t>
+            </a:r>
+          </a:p>
+          <a:p>
+            <a:r>
+              <a:t>E = mc</a:t>
+            </a:r>
+            <a:r>
+              <a:rPr baseline="30000"/>
+              <a:t>2</a:t>
+            </a:r>
+            <a:r>
+              <a:t>, H</a:t>
+            </a:r>
+            <a:r>
+              <a:rPr baseline="-25000"/>
+              <a:t>2</a:t>
+            </a:r>
+            <a:r>
+              <a:t>O, </a:t>
+            </a:r>
+            <a:r>
+              <a:rPr spc="200"/>
+              <a:t>l e t t e r   s p a c e d</a:t>
+            </a:r>
+          </a:p>
+          <a:p>
+            <a:pPr>
+              <a:lnSpc>
+                <a:spcPct val="150000"/>
+              </a:lnSpc>
+            </a:pPr>
+            <a:r>
+              <a:t>This paragraph uses 1.5x line spacing so you can see the extra vertical room between wrapped lines. Quick brown foxes and lazy dogs.</a:t>
+            </a:r>
+          </a:p>
+        </p:txBody>
+      </p:sp>
+    </p:spTree>
+  </p:cSld>
+  <p:clrMapOvr>
+    <a:masterClrMapping/>
+  </p:clrMapOvr>
+</p:sld>
+</file>
+
+<file path=ppt/slides/slide16.xml><?xml version="1.0" encoding="utf-8"?>
+<p:sld xmlns:a="http://schemas.openxmlformats.org/drawingml/2006/main" xmlns:p="http://schemas.openxmlformats.org/presentationml/2006/main" xmlns:r="http://schemas.openxmlformats.org/officeDocument/2006/relationships">
+  <p:cSld>
+    <p:spTree>
+      <p:nvGrpSpPr>
+        <p:cNvPr id="1" name=""/>
+        <p:cNvGrpSpPr/>
+        <p:nvPr/>
+      </p:nvGrpSpPr>
+      <p:grpSpPr/>
+      <p:sp>
+        <p:nvSpPr>
+          <p:cNvPr id="2" name="Title 1"/>
+          <p:cNvSpPr>
+            <a:spLocks noGrp="1"/>
+          </p:cNvSpPr>
+          <p:nvPr>
+            <p:ph type="title"/>
+          </p:nvPr>
+        </p:nvSpPr>
+        <p:spPr/>
+        <p:txBody>
+          <a:bodyPr/>
+          <a:lstStyle/>
+          <a:p>
+            <a:r>
+              <a:t>A chart</a:t>
+            </a:r>
+          </a:p>
+        </p:txBody>
+      </p:sp>
+      <p:graphicFrame>
+        <p:nvGraphicFramePr>
+          <p:cNvPr id="3" name="Chart 2"/>
+          <p:cNvGraphicFramePr>
+            <a:graphicFrameLocks noGrp="1"/>
+          </p:cNvGraphicFramePr>
+          <p:nvPr/>
+        </p:nvGraphicFramePr>
+        <p:xfrm>
+          <a:off x="914400" y="1828800"/>
+          <a:ext cx="5486400" cy="3657600"/>
+        </p:xfrm>
+        <a:graphic>
+          <a:graphicData uri="http://schemas.openxmlformats.org/drawingml/2006/chart">
+            <c:chart xmlns:c="http://schemas.openxmlformats.org/drawingml/2006/chart" r:id="rId2"/>
+          </a:graphicData>
+        </a:graphic>
+      </p:graphicFrame>
+    </p:spTree>
+  </p:cSld>
+  <p:clrMapOvr>
+    <a:masterClrMapping/>
+  </p:clrMapOvr>
+</p:sld>
+</file>
+
+<file path=ppt/slides/slide17.xml><?xml version="1.0" encoding="utf-8"?>
+<p:sld xmlns:a="http://schemas.openxmlformats.org/drawingml/2006/main" xmlns:p="http://schemas.openxmlformats.org/presentationml/2006/main" xmlns:r="http://schemas.openxmlformats.org/officeDocument/2006/relationships">
+  <p:cSld>
+    <p:spTree>
+      <p:nvGrpSpPr>
+        <p:cNvPr id="1" name=""/>
+        <p:cNvGrpSpPr/>
+        <p:nvPr/>
+      </p:nvGrpSpPr>
+      <p:grpSpPr/>
+      <p:sp>
+        <p:nvSpPr>
+          <p:cNvPr id="2" name="Title 1"/>
+          <p:cNvSpPr>
+            <a:spLocks noGrp="1"/>
+          </p:cNvSpPr>
+          <p:nvPr>
+            <p:ph type="title"/>
+          </p:nvPr>
+        </p:nvSpPr>
+        <p:spPr/>
+        <p:txBody>
+          <a:bodyPr/>
+          <a:lstStyle/>
+          <a:p>
+            <a:r>
+              <a:t>Hidden slide</a:t>
+            </a:r>
+          </a:p>
+        </p:txBody>
+      </p:sp>
+    </p:spTree>
+  </p:cSld>
+  <p:clrMapOvr>
+    <a:masterClrMapping/>
+  </p:clrMapOvr>
+</p:sld>
+</file>
+
+<file path=ppt/slides/slide2.xml><?xml version="1.0" encoding="utf-8"?>
+<p:sld xmlns:a="http://schemas.openxmlformats.org/drawingml/2006/main" xmlns:p="http://schemas.openxmlformats.org/presentationml/2006/main" xmlns:r="http://schemas.openxmlformats.org/officeDocument/2006/relationships">
+  <p:cSld>
+    <p:spTree>
+      <p:nvGrpSpPr>
+        <p:cNvPr id="1" name=""/>
+        <p:cNvGrpSpPr/>
+        <p:nvPr/>
+      </p:nvGrpSpPr>
+      <p:grpSpPr/>
+      <p:sp>
+        <p:nvSpPr>
+          <p:cNvPr id="2" name="Title 1"/>
+          <p:cNvSpPr>
+            <a:spLocks noGrp="1"/>
+          </p:cNvSpPr>
+          <p:nvPr>
+            <p:ph type="title"/>
+          </p:nvPr>
+        </p:nvSpPr>
+        <p:spPr/>
+        <p:txBody>
+          <a:bodyPr/>
+          <a:lstStyle/>
+          <a:p>
+            <a:r>
+              <a:t>Bullet points</a:t>
+            </a:r>
+          </a:p>
+        </p:txBody>
+      </p:sp>
+      <p:sp>
+        <p:nvSpPr>
+          <p:cNvPr id="3" name="Content Placeholder 2"/>
+          <p:cNvSpPr>
+            <a:spLocks noGrp="1"/>
+          </p:cNvSpPr>
+          <p:nvPr>
+            <p:ph idx="1"/>
+          </p:nvPr>
+        </p:nvSpPr>
+        <p:spPr/>
+        <p:txBody>
+          <a:bodyPr/>
+          <a:lstStyle/>
+          <a:p>
+            <a:r>
+              <a:t>First bullet</a:t>
+            </a:r>
+          </a:p>
+          <a:p>
+            <a:pPr>
+              <a:defRPr sz="1800"/>
+            </a:pPr>
+            <a:r>
+              <a:t>Second bullet</a:t>
+            </a:r>
+          </a:p>
+          <a:p>
+            <a:pPr>
+              <a:defRPr sz="1800"/>
+            </a:pPr>
+            <a:r>
+              <a:t>Third bullet</a:t>
+            </a:r>
+          </a:p>
+        </p:txBody>
+      </p:sp>
+    </p:spTree>
+  </p:cSld>
+  <p:clrMapOvr>
+    <a:masterClrMapping/>
+  </p:clrMapOvr>
+</p:sld>
+</file>
+
+<file path=ppt/slides/slide3.xml><?xml version="1.0" encoding="utf-8"?>
+<p:sld xmlns:a="http://schemas.openxmlformats.org/drawingml/2006/main" xmlns:p="http://schemas.openxmlformats.org/presentationml/2006/main" xmlns:r="http://schemas.openxmlformats.org/officeDocument/2006/relationships">
+  <p:cSld>
+    <p:spTree>
+      <p:nvGrpSpPr>
+        <p:cNvPr id="1" name=""/>
+        <p:cNvGrpSpPr/>
+        <p:nvPr/>
+      </p:nvGrpSpPr>
+      <p:grpSpPr/>
+      <p:sp>
+        <p:nvSpPr>
+          <p:cNvPr id="2" name="Title 1"/>
+          <p:cNvSpPr>
+            <a:spLocks noGrp="1"/>
+          </p:cNvSpPr>
+          <p:nvPr>
+            <p:ph type="title"/>
+          </p:nvPr>
+        </p:nvSpPr>
+        <p:spPr/>
+        <p:txBody>
+          <a:bodyPr/>
+          <a:lstStyle/>
+          <a:p>
+            <a:r>
+              <a:t>A shape</a:t>
+            </a:r>
+          </a:p>
+        </p:txBody>
+      </p:sp>
+      <p:sp>
+        <p:nvSpPr>
+          <p:cNvPr id="3" name="TextBox 2"/>
+          <p:cNvSpPr txBox="1"/>
+          <p:nvPr/>
+        </p:nvSpPr>
+        <p:spPr>
+          <a:xfrm>
+            <a:off x="914400" y="1828800"/>
+            <a:ext cx="3657600" cy="914400"/>
+          </a:xfrm>
+          <a:prstGeom prst="rect">
+            <a:avLst/>
+          </a:prstGeom>
+          <a:noFill/>
+        </p:spPr>
+        <p:txBody>
+          <a:bodyPr wrap="none">
+            <a:spAutoFit/>
+          </a:bodyPr>
+          <a:lstStyle/>
+          <a:p>
+            <a:r>
+              <a:rPr sz="2400" b="1">
+                <a:solidFill>
+                  <a:srgbClr val="C0392B"/>
+                </a:solidFill>
+              </a:rPr>
+              <a:t>Free-floating textbox</a:t>
+            </a:r>
+          </a:p>
+        </p:txBody>
+      </p:sp>
+    </p:spTree>
+  </p:cSld>
+  <p:clrMapOvr>
+    <a:masterClrMapping/>
+  </p:clrMapOvr>
+</p:sld>
+</file>
+
+<file path=ppt/slides/slide4.xml><?xml version="1.0" encoding="utf-8"?>
+<p:sld xmlns:a="http://schemas.openxmlformats.org/drawingml/2006/main" xmlns:p="http://schemas.openxmlformats.org/presentationml/2006/main" xmlns:r="http://schemas.openxmlformats.org/officeDocument/2006/relationships">
+  <p:cSld>
+    <p:spTree>
+      <p:nvGrpSpPr>
+        <p:cNvPr id="1" name=""/>
+        <p:cNvGrpSpPr/>
+        <p:nvPr/>
+      </p:nvGrpSpPr>
+      <p:grpSpPr/>
+      <p:sp>
+        <p:nvSpPr>
+          <p:cNvPr id="2" name="Title 1"/>
+          <p:cNvSpPr>
+            <a:spLocks noGrp="1"/>
+          </p:cNvSpPr>
+          <p:nvPr>
+            <p:ph type="title"/>
+          </p:nvPr>
+        </p:nvSpPr>
+        <p:spPr/>
+        <p:txBody>
+          <a:bodyPr/>
+          <a:lstStyle/>
+          <a:p>
+            <a:r>
+              <a:t>An image</a:t>
+            </a:r>
+          </a:p>
+        </p:txBody>
+      </p:sp>
+      <p:pic>
+        <p:nvPicPr>
+          <p:cNvPr id="3" name="Picture 2" descr="python-powered.png"/>
+          <p:cNvPicPr>
+            <a:picLocks noChangeAspect="1"/>
+          </p:cNvPicPr>
+          <p:nvPr/>
+        </p:nvPicPr>
+        <p:blipFill>
+          <a:blip r:embed="rId2"/>
+          <a:stretch>
+            <a:fillRect/>
+          </a:stretch>
+        </p:blipFill>
+        <p:spPr>
+          <a:xfrm>
+            <a:off x="2743200" y="1828800"/>
+            <a:ext cx="3657600" cy="1828800"/>
+          </a:xfrm>
+          <a:prstGeom prst="rect">
+            <a:avLst/>
+          </a:prstGeom>
+        </p:spPr>
+      </p:pic>
+    </p:spTree>
+  </p:cSld>
+  <p:clrMapOvr>
+    <a:masterClrMapping/>
+  </p:clrMapOvr>
+</p:sld>
+</file>
+
+<file path=ppt/slides/slide5.xml><?xml version="1.0" encoding="utf-8"?>
+<p:sld xmlns:a="http://schemas.openxmlformats.org/drawingml/2006/main" xmlns:p="http://schemas.openxmlformats.org/presentationml/2006/main" xmlns:r="http://schemas.openxmlformats.org/officeDocument/2006/relationships">
+  <p:cSld>
+    <p:bg>
+      <p:bgPr>
+        <a:solidFill>
+          <a:srgbClr val="FFF4E0"/>
+        </a:solidFill>
+        <a:effectLst/>
+      </p:bgPr>
+    </p:bg>
+    <p:spTree>
+      <p:nvGrpSpPr>
+        <p:cNvPr id="1" name=""/>
+        <p:cNvGrpSpPr/>
+        <p:nvPr/>
+      </p:nvGrpSpPr>
+      <p:grpSpPr/>
+      <p:sp>
+        <p:nvSpPr>
+          <p:cNvPr id="2" name="Title 1"/>
+          <p:cNvSpPr>
+            <a:spLocks noGrp="1"/>
+          </p:cNvSpPr>
+          <p:nvPr>
+            <p:ph type="title"/>
+          </p:nvPr>
+        </p:nvSpPr>
+        <p:spPr/>
+        <p:txBody>
+          <a:bodyPr/>
+          <a:lstStyle/>
+          <a:p>
+            <a:r>
+              <a:t>Tinted background</a:t>
+            </a:r>
+          </a:p>
+        </p:txBody>
+      </p:sp>
+    </p:spTree>
+  </p:cSld>
+  <p:clrMapOvr>
+    <a:masterClrMapping/>
+  </p:clrMapOvr>
+</p:sld>
+</file>
+
+<file path=ppt/slides/slide6.xml><?xml version="1.0" encoding="utf-8"?>
+<p:sld xmlns:a="http://schemas.openxmlformats.org/drawingml/2006/main" xmlns:p="http://schemas.openxmlformats.org/presentationml/2006/main" xmlns:r="http://schemas.openxmlformats.org/officeDocument/2006/relationships">
+  <p:cSld>
+    <p:spTree>
+      <p:nvGrpSpPr>
+        <p:cNvPr id="1" name=""/>
+        <p:cNvGrpSpPr/>
+        <p:nvPr/>
+      </p:nvGrpSpPr>
+      <p:grpSpPr/>
+      <p:sp>
+        <p:nvSpPr>
+          <p:cNvPr id="2" name="Title 1"/>
+          <p:cNvSpPr>
+            <a:spLocks noGrp="1"/>
+          </p:cNvSpPr>
+          <p:nvPr>
+            <p:ph type="title"/>
+          </p:nvPr>
+        </p:nvSpPr>
+        <p:spPr/>
+        <p:txBody>
+          <a:bodyPr/>
+          <a:lstStyle/>
+          <a:p>
+            <a:r>
+              <a:t>Filled shapes</a:t>
+            </a:r>
+          </a:p>
+        </p:txBody>
+      </p:sp>
+      <p:sp>
+        <p:nvSpPr>
+          <p:cNvPr id="3" name="Rectangle 2"/>
+          <p:cNvSpPr/>
+          <p:nvPr/>
+        </p:nvSpPr>
+        <p:spPr>
+          <a:xfrm>
+            <a:off x="914400" y="1828800"/>
+            <a:ext cx="2743200" cy="1371600"/>
+          </a:xfrm>
+          <a:prstGeom prst="rect">
+            <a:avLst/>
+          </a:prstGeom>
+          <a:solidFill>
+            <a:srgbClr val="4F81BD"/>
+          </a:solidFill>
+          <a:ln w="38100">
+            <a:solidFill>
+              <a:srgbClr val="1F497D"/>
+            </a:solidFill>
+          </a:ln>
+        </p:spPr>
+        <p:style>
+          <a:lnRef idx="1">
+            <a:schemeClr val="accent1"/>
+          </a:lnRef>
+          <a:fillRef idx="3">
+            <a:schemeClr val="accent1"/>
+          </a:fillRef>
+          <a:effectRef idx="2">
+            <a:schemeClr val="accent1"/>
+          </a:effectRef>
+          <a:fontRef idx="minor">
+            <a:schemeClr val="lt1"/>
+          </a:fontRef>
+        </p:style>
+        <p:txBody>
+          <a:bodyPr rtlCol="0" anchor="ctr"/>
+          <a:lstStyle/>
+          <a:p>
+            <a:r>
+              <a:rPr>
+                <a:solidFill>
+                  <a:srgbClr val="FFFFFF"/>
+                </a:solidFill>
+              </a:rPr>
+              <a:t>Filled + bordered</a:t>
+            </a:r>
+          </a:p>
+        </p:txBody>
+      </p:sp>
+      <p:sp>
+        <p:nvSpPr>
+          <p:cNvPr id="4" name="Rectangle 3"/>
+          <p:cNvSpPr/>
+          <p:nvPr/>
+        </p:nvSpPr>
+        <p:spPr>
+          <a:xfrm>
+            <a:off x="4572000" y="1828800"/>
+            <a:ext cx="2743200" cy="1371600"/>
+          </a:xfrm>
+          <a:prstGeom prst="rect">
+            <a:avLst/>
+          </a:prstGeom>
+          <a:noFill/>
+          <a:ln w="19050">
+            <a:solidFill>
+              <a:srgbClr val="C0504D"/>
+            </a:solidFill>
+          </a:ln>
+        </p:spPr>
+        <p:style>
+          <a:lnRef idx="1">
+            <a:schemeClr val="accent1"/>
+          </a:lnRef>
+          <a:fillRef idx="3">
+            <a:schemeClr val="accent1"/>
+          </a:fillRef>
+          <a:effectRef idx="2">
+            <a:schemeClr val="accent1"/>
+          </a:effectRef>
+          <a:fontRef idx="minor">
+            <a:schemeClr val="lt1"/>
+          </a:fontRef>
+        </p:style>
+        <p:txBody>
+          <a:bodyPr rtlCol="0" anchor="ctr"/>
+          <a:lstStyle/>
+          <a:p>
+            <a:r>
+              <a:t>Border only</a:t>
+            </a:r>
+          </a:p>
+        </p:txBody>
+      </p:sp>
+    </p:spTree>
+  </p:cSld>
+  <p:clrMapOvr>
+    <a:masterClrMapping/>
+  </p:clrMapOvr>
+</p:sld>
+</file>
+
+<file path=ppt/slides/slide7.xml><?xml version="1.0" encoding="utf-8"?>
+<p:sld xmlns:a="http://schemas.openxmlformats.org/drawingml/2006/main" xmlns:p="http://schemas.openxmlformats.org/presentationml/2006/main" xmlns:r="http://schemas.openxmlformats.org/officeDocument/2006/relationships">
+  <p:cSld>
+    <p:spTree>
+      <p:nvGrpSpPr>
+        <p:cNvPr id="1" name=""/>
+        <p:cNvGrpSpPr/>
+        <p:nvPr/>
+      </p:nvGrpSpPr>
+      <p:grpSpPr/>
+      <p:sp>
+        <p:nvSpPr>
+          <p:cNvPr id="2" name="Title 1"/>
+          <p:cNvSpPr>
+            <a:spLocks noGrp="1"/>
+          </p:cNvSpPr>
+          <p:nvPr>
+            <p:ph type="title"/>
+          </p:nvPr>
+        </p:nvSpPr>
+        <p:spPr/>
+        <p:txBody>
+          <a:bodyPr/>
+          <a:lstStyle/>
+          <a:p>
+            <a:r>
+              <a:t>Preset shapes</a:t>
+            </a:r>
+          </a:p>
+        </p:txBody>
+      </p:sp>
+      <p:sp>
+        <p:nvSpPr>
+          <p:cNvPr id="3" name="Rounded Rectangle 2"/>
+          <p:cNvSpPr/>
+          <p:nvPr/>
+        </p:nvSpPr>
+        <p:spPr>
+          <a:xfrm>
+            <a:off x="685800" y="1645920"/>
+            <a:ext cx="1828800" cy="1371600"/>
+          </a:xfrm>
+          <a:prstGeom prst="roundRect">
+            <a:avLst/>
+          </a:prstGeom>
+          <a:solidFill>
+            <a:srgbClr val="4F81BD"/>
+          </a:solidFill>
+          <a:ln>
+            <a:solidFill>
+              <a:srgbClr val="1F497D"/>
+            </a:solidFill>
+          </a:ln>
+        </p:spPr>
+        <p:style>
+          <a:lnRef idx="1">
+            <a:schemeClr val="accent1"/>
+          </a:lnRef>
+          <a:fillRef idx="3">
+            <a:schemeClr val="accent1"/>
+          </a:fillRef>
+          <a:effectRef idx="2">
+            <a:schemeClr val="accent1"/>
+          </a:effectRef>
+          <a:fontRef idx="minor">
+            <a:schemeClr val="lt1"/>
+          </a:fontRef>
+        </p:style>
+        <p:txBody>
+          <a:bodyPr rtlCol="0" anchor="ctr"/>
+          <a:lstStyle/>
+          <a:p>
+            <a:pPr algn="ctr"/>
+          </a:p>
+        </p:txBody>
+      </p:sp>
+      <p:sp>
+        <p:nvSpPr>
+          <p:cNvPr id="4" name="Diamond 3"/>
+          <p:cNvSpPr/>
+          <p:nvPr/>
+        </p:nvSpPr>
+        <p:spPr>
+          <a:xfrm>
+            <a:off x="2971800" y="1645920"/>
+            <a:ext cx="1828800" cy="1371600"/>
+          </a:xfrm>
+          <a:prstGeom prst="diamond">
+            <a:avLst/>
+          </a:prstGeom>
+          <a:solidFill>
+            <a:srgbClr val="4F81BD"/>
+          </a:solidFill>
+          <a:ln>
+            <a:solidFill>
+              <a:srgbClr val="1F497D"/>
+            </a:solidFill>
+          </a:ln>
+        </p:spPr>
+        <p:style>
+          <a:lnRef idx="1">
+            <a:schemeClr val="accent1"/>
+          </a:lnRef>
+          <a:fillRef idx="3">
+            <a:schemeClr val="accent1"/>
+          </a:fillRef>
+          <a:effectRef idx="2">
+            <a:schemeClr val="accent1"/>
+          </a:effectRef>
+          <a:fontRef idx="minor">
+            <a:schemeClr val="lt1"/>
+          </a:fontRef>
+        </p:style>
+        <p:txBody>
+          <a:bodyPr rtlCol="0" anchor="ctr"/>
+          <a:lstStyle/>
+          <a:p>
+            <a:pPr algn="ctr"/>
+          </a:p>
+        </p:txBody>
+      </p:sp>
+      <p:sp>
+        <p:nvSpPr>
+          <p:cNvPr id="5" name="Oval 4"/>
+          <p:cNvSpPr/>
+          <p:nvPr/>
+        </p:nvSpPr>
+        <p:spPr>
+          <a:xfrm>
+            <a:off x="5257800" y="1645920"/>
+            <a:ext cx="1828800" cy="1371600"/>
+          </a:xfrm>
+          <a:prstGeom prst="ellipse">
+            <a:avLst/>
+          </a:prstGeom>
+          <a:solidFill>
+            <a:srgbClr val="4F81BD"/>
+          </a:solidFill>
+          <a:ln>
+            <a:solidFill>
+              <a:srgbClr val="1F497D"/>
+            </a:solidFill>
+          </a:ln>
+        </p:spPr>
+        <p:style>
+          <a:lnRef idx="1">
+            <a:schemeClr val="accent1"/>
+          </a:lnRef>
+          <a:fillRef idx="3">
+            <a:schemeClr val="accent1"/>
+          </a:fillRef>
+          <a:effectRef idx="2">
+            <a:schemeClr val="accent1"/>
+          </a:effectRef>
+          <a:fontRef idx="minor">
+            <a:schemeClr val="lt1"/>
+          </a:fontRef>
+        </p:style>
+        <p:txBody>
+          <a:bodyPr rtlCol="0" anchor="ctr"/>
+          <a:lstStyle/>
+          <a:p>
+            <a:pPr algn="ctr"/>
+          </a:p>
+        </p:txBody>
+      </p:sp>
+      <p:sp>
+        <p:nvSpPr>
+          <p:cNvPr id="6" name="Up Arrow 5"/>
+          <p:cNvSpPr/>
+          <p:nvPr/>
+        </p:nvSpPr>
+        <p:spPr>
+          <a:xfrm>
+            <a:off x="685800" y="3474720"/>
+            <a:ext cx="1828800" cy="1371600"/>
+          </a:xfrm>
+          <a:prstGeom prst="upArrow">
+            <a:avLst/>
+          </a:prstGeom>
+          <a:solidFill>
+            <a:srgbClr val="4F81BD"/>
+          </a:solidFill>
+          <a:ln>
+            <a:solidFill>
+              <a:srgbClr val="1F497D"/>
+            </a:solidFill>
+          </a:ln>
+        </p:spPr>
+        <p:style>
+          <a:lnRef idx="1">
+            <a:schemeClr val="accent1"/>
+          </a:lnRef>
+          <a:fillRef idx="3">
+            <a:schemeClr val="accent1"/>
+          </a:fillRef>
+          <a:effectRef idx="2">
+            <a:schemeClr val="accent1"/>
+          </a:effectRef>
+          <a:fontRef idx="minor">
+            <a:schemeClr val="lt1"/>
+          </a:fontRef>
+        </p:style>
+        <p:txBody>
+          <a:bodyPr rtlCol="0" anchor="ctr"/>
+          <a:lstStyle/>
+          <a:p>
+            <a:pPr algn="ctr"/>
+          </a:p>
+        </p:txBody>
+      </p:sp>
+      <p:sp>
+        <p:nvSpPr>
+          <p:cNvPr id="7" name="5-Point Star 6"/>
+          <p:cNvSpPr/>
+          <p:nvPr/>
+        </p:nvSpPr>
+        <p:spPr>
+          <a:xfrm>
+            <a:off x="2971800" y="3474720"/>
+            <a:ext cx="1828800" cy="1371600"/>
+          </a:xfrm>
+          <a:prstGeom prst="star5">
+            <a:avLst/>
+          </a:prstGeom>
+          <a:solidFill>
+            <a:srgbClr val="4F81BD"/>
+          </a:solidFill>
+          <a:ln>
+            <a:solidFill>
+              <a:srgbClr val="1F497D"/>
+            </a:solidFill>
+          </a:ln>
+        </p:spPr>
+        <p:style>
+          <a:lnRef idx="1">
+            <a:schemeClr val="accent1"/>
+          </a:lnRef>
+          <a:fillRef idx="3">
+            <a:schemeClr val="accent1"/>
+          </a:fillRef>
+          <a:effectRef idx="2">
+            <a:schemeClr val="accent1"/>
+          </a:effectRef>
+          <a:fontRef idx="minor">
+            <a:schemeClr val="lt1"/>
+          </a:fontRef>
+        </p:style>
+        <p:txBody>
+          <a:bodyPr rtlCol="0" anchor="ctr"/>
+          <a:lstStyle/>
+          <a:p>
+            <a:pPr algn="ctr"/>
+          </a:p>
+        </p:txBody>
+      </p:sp>
+      <p:sp>
+        <p:nvSpPr>
+          <p:cNvPr id="8" name="Pentagon 7"/>
+          <p:cNvSpPr/>
+          <p:nvPr/>
+        </p:nvSpPr>
+        <p:spPr>
+          <a:xfrm>
+            <a:off x="5257800" y="3474720"/>
+            <a:ext cx="1828800" cy="1371600"/>
+          </a:xfrm>
+          <a:prstGeom prst="homePlate">
+            <a:avLst/>
+          </a:prstGeom>
+          <a:solidFill>
+            <a:srgbClr val="4F81BD"/>
+          </a:solidFill>
+          <a:ln>
+            <a:solidFill>
+              <a:srgbClr val="1F497D"/>
+            </a:solidFill>
+          </a:ln>
+        </p:spPr>
+        <p:style>
+          <a:lnRef idx="1">
+            <a:schemeClr val="accent1"/>
+          </a:lnRef>
+          <a:fillRef idx="3">
+            <a:schemeClr val="accent1"/>
+          </a:fillRef>
+          <a:effectRef idx="2">
+            <a:schemeClr val="accent1"/>
+          </a:effectRef>
+          <a:fontRef idx="minor">
+            <a:schemeClr val="lt1"/>
+          </a:fontRef>
+        </p:style>
+        <p:txBody>
+          <a:bodyPr rtlCol="0" anchor="ctr"/>
+          <a:lstStyle/>
+          <a:p>
+            <a:pPr algn="ctr"/>
+          </a:p>
+        </p:txBody>
+      </p:sp>
+    </p:spTree>
+  </p:cSld>
+  <p:clrMapOvr>
+    <a:masterClrMapping/>
+  </p:clrMapOvr>
+</p:sld>
+</file>
+
+<file path=ppt/slides/slide8.xml><?xml version="1.0" encoding="utf-8"?>
+<p:sld xmlns:a="http://schemas.openxmlformats.org/drawingml/2006/main" xmlns:p="http://schemas.openxmlformats.org/presentationml/2006/main" xmlns:r="http://schemas.openxmlformats.org/officeDocument/2006/relationships">
+  <p:cSld>
+    <p:spTree>
+      <p:nvGrpSpPr>
+        <p:cNvPr id="1" name=""/>
+        <p:cNvGrpSpPr/>
+        <p:nvPr/>
+      </p:nvGrpSpPr>
+      <p:grpSpPr/>
+      <p:sp>
+        <p:nvSpPr>
+          <p:cNvPr id="2" name="Title 1"/>
+          <p:cNvSpPr>
+            <a:spLocks noGrp="1"/>
+          </p:cNvSpPr>
+          <p:nvPr>
+            <p:ph type="title"/>
+          </p:nvPr>
+        </p:nvSpPr>
+        <p:spPr/>
+        <p:txBody>
+          <a:bodyPr/>
+          <a:lstStyle/>
+          <a:p>
+            <a:r>
+              <a:t>Rotated &amp; flipped</a:t>
+            </a:r>
+          </a:p>
+        </p:txBody>
+      </p:sp>
+      <p:sp>
+        <p:nvSpPr>
+          <p:cNvPr id="3" name="TextBox 2"/>
+          <p:cNvSpPr txBox="1"/>
+          <p:nvPr/>
+        </p:nvSpPr>
+        <p:spPr>
+          <a:xfrm rot="1800000">
+            <a:off x="914400" y="1828800"/>
+            <a:ext cx="2743200" cy="914400"/>
+          </a:xfrm>
+          <a:prstGeom prst="rect">
+            <a:avLst/>
+          </a:prstGeom>
+          <a:noFill/>
+        </p:spPr>
+        <p:txBody>
+          <a:bodyPr wrap="none">
+            <a:spAutoFit/>
+          </a:bodyPr>
+          <a:lstStyle/>
+          <a:p>
+            <a:r>
+              <a:rPr sz="2000"/>
+              <a:t>Rotated 30 degrees</a:t>
+            </a:r>
+          </a:p>
+        </p:txBody>
+      </p:sp>
+      <p:sp>
+        <p:nvSpPr>
+          <p:cNvPr id="4" name="Right Arrow 3"/>
+          <p:cNvSpPr/>
+          <p:nvPr/>
+        </p:nvSpPr>
+        <p:spPr>
+          <a:xfrm flipH="1">
+            <a:off x="4572000" y="1828800"/>
+            <a:ext cx="1828800" cy="914400"/>
+          </a:xfrm>
+          <a:prstGeom prst="rightArrow">
+            <a:avLst/>
+          </a:prstGeom>
+          <a:solidFill>
+            <a:srgbClr val="4F81BD"/>
+          </a:solidFill>
+        </p:spPr>
+        <p:style>
+          <a:lnRef idx="1">
+            <a:schemeClr val="accent1"/>
+          </a:lnRef>
+          <a:fillRef idx="3">
+            <a:schemeClr val="accent1"/>
+          </a:fillRef>
+          <a:effectRef idx="2">
+            <a:schemeClr val="accent1"/>
+          </a:effectRef>
+          <a:fontRef idx="minor">
+            <a:schemeClr val="lt1"/>
+          </a:fontRef>
+        </p:style>
+        <p:txBody>
+          <a:bodyPr rtlCol="0" anchor="ctr"/>
+          <a:lstStyle/>
+          <a:p>
+            <a:pPr algn="ctr"/>
+          </a:p>
+        </p:txBody>
+      </p:sp>
+      <p:pic>
+        <p:nvPicPr>
+          <p:cNvPr id="5" name="Picture 4" descr="python-powered.png"/>
+          <p:cNvPicPr>
+            <a:picLocks noChangeAspect="1"/>
+          </p:cNvPicPr>
+          <p:nvPr/>
+        </p:nvPicPr>
+        <p:blipFill>
+          <a:blip r:embed="rId2"/>
+          <a:stretch>
+            <a:fillRect/>
+          </a:stretch>
+        </p:blipFill>
+        <p:spPr>
+          <a:xfrm rot="2700000">
+            <a:off x="3657600" y="3657600"/>
+            <a:ext cx="1828800" cy="914400"/>
+          </a:xfrm>
+          <a:prstGeom prst="rect">
+            <a:avLst/>
+          </a:prstGeom>
+        </p:spPr>
+      </p:pic>
+    </p:spTree>
+  </p:cSld>
+  <p:clrMapOvr>
+    <a:masterClrMapping/>
+  </p:clrMapOvr>
+</p:sld>
+</file>
+
+<file path=ppt/slides/slide9.xml><?xml version="1.0" encoding="utf-8"?>
+<p:sld xmlns:a="http://schemas.openxmlformats.org/drawingml/2006/main" xmlns:p="http://schemas.openxmlformats.org/presentationml/2006/main" xmlns:r="http://schemas.openxmlformats.org/officeDocument/2006/relationships">
+  <p:cSld>
+    <p:spTree>
+      <p:nvGrpSpPr>
+        <p:cNvPr id="1" name=""/>
+        <p:cNvGrpSpPr/>
+        <p:nvPr/>
+      </p:nvGrpSpPr>
+      <p:grpSpPr/>
+      <p:sp>
+        <p:nvSpPr>
+          <p:cNvPr id="2" name="Title 1"/>
+          <p:cNvSpPr>
+            <a:spLocks noGrp="1"/>
+          </p:cNvSpPr>
+          <p:nvPr>
+            <p:ph type="title"/>
+          </p:nvPr>
+        </p:nvSpPr>
+        <p:spPr/>
+        <p:txBody>
+          <a:bodyPr/>
+          <a:lstStyle/>
+          <a:p>
+            <a:r>
+              <a:t>Effects</a:t>
+            </a:r>
+          </a:p>
+        </p:txBody>
+      </p:sp>
+      <p:sp>
+        <p:nvSpPr>
+          <p:cNvPr id="3" name="Rectangle 2"/>
+          <p:cNvSpPr/>
+          <p:nvPr/>
+        </p:nvSpPr>
+        <p:spPr>
+          <a:xfrm>
+            <a:off x="685800" y="1828800"/>
+            <a:ext cx="2286000" cy="1097280"/>
+          </a:xfrm>
+          <a:prstGeom prst="rect">
+            <a:avLst/>
+          </a:prstGeom>
+          <a:solidFill>
+            <a:srgbClr val="4F81BD"/>
+          </a:solidFill>
+          <a:effectLst>
+            <a:outerShdw blurRad="50800" dist="38100" dir="2700000" algn="tl" rotWithShape="0">
+              <a:srgbClr val="000000">
+                <a:alpha val="50000"/>
+              </a:srgbClr>
+            </a:outerShdw>
+          </a:effectLst>
+        </p:spPr>
+        <p:style>
+          <a:lnRef idx="1">
+            <a:schemeClr val="accent1"/>
+          </a:lnRef>
+          <a:fillRef idx="3">
+            <a:schemeClr val="accent1"/>
+          </a:fillRef>
+          <a:effectRef idx="2">
+            <a:schemeClr val="accent1"/>
+          </a:effectRef>
+          <a:fontRef idx="minor">
+            <a:schemeClr val="lt1"/>
+          </a:fontRef>
+        </p:style>
+        <p:txBody>
+          <a:bodyPr rtlCol="0" anchor="ctr"/>
+          <a:lstStyle/>
+          <a:p>
+            <a:r>
+              <a:rPr>
+                <a:solidFill>
+                  <a:srgbClr val="FFFFFF"/>
+                </a:solidFill>
+              </a:rPr>
+              <a:t>Outer shadow</a:t>
+            </a:r>
+          </a:p>
+        </p:txBody>
+      </p:sp>
+      <p:sp>
+        <p:nvSpPr>
+          <p:cNvPr id="4" name="Rectangle 3"/>
+          <p:cNvSpPr/>
+          <p:nvPr/>
+        </p:nvSpPr>
+        <p:spPr>
+          <a:xfrm>
+            <a:off x="3657600" y="1828800"/>
+            <a:ext cx="2286000" cy="1097280"/>
+          </a:xfrm>
+          <a:prstGeom prst="rect">
+            <a:avLst/>
+          </a:prstGeom>
+          <a:solidFill>
+            <a:srgbClr val="FFFFFF"/>
+          </a:solidFill>
+          <a:ln>
+            <a:solidFill>
+              <a:srgbClr val="009966"/>
+            </a:solidFill>
+          </a:ln>
+          <a:effectLst>
+            <a:glow rad="63500">
+              <a:srgbClr val="00CC66">
+                <a:alpha val="60000"/>
+              </a:srgbClr>
+            </a:glow>
+          </a:effectLst>
+        </p:spPr>
+        <p:style>
+          <a:lnRef idx="1">
+            <a:schemeClr val="accent1"/>
+          </a:lnRef>
+          <a:fillRef idx="3">
+            <a:schemeClr val="accent1"/>
+          </a:fillRef>
+          <a:effectRef idx="2">
+            <a:schemeClr val="accent1"/>
+          </a:effectRef>
+          <a:fontRef idx="minor">
+            <a:schemeClr val="lt1"/>
+          </a:fontRef>
+        </p:style>
+        <p:txBody>
+          <a:bodyPr rtlCol="0" anchor="ctr"/>
+          <a:lstStyle/>
+          <a:p>
+            <a:r>
+              <a:t>Glow</a:t>
+            </a:r>
+          </a:p>
+        </p:txBody>
+      </p:sp>
+      <p:sp>
+        <p:nvSpPr>
+          <p:cNvPr id="5" name="Rectangle 4"/>
+          <p:cNvSpPr/>
+          <p:nvPr/>
+        </p:nvSpPr>
+        <p:spPr>
+          <a:xfrm>
+            <a:off x="6629400" y="1828800"/>
+            <a:ext cx="2286000" cy="1097280"/>
+          </a:xfrm>
+          <a:prstGeom prst="rect">
+            <a:avLst/>
+          </a:prstGeom>
+          <a:solidFill>
+            <a:srgbClr val="D9436E"/>
+          </a:solidFill>
+          <a:effectLst>
+            <a:blur rad="38100" grow="1"/>
+          </a:effectLst>
+        </p:spPr>
+        <p:style>
+          <a:lnRef idx="1">
+            <a:schemeClr val="accent1"/>
+          </a:lnRef>
+          <a:fillRef idx="3">
+            <a:schemeClr val="accent1"/>
+          </a:fillRef>
+          <a:effectRef idx="2">
+            <a:schemeClr val="accent1"/>
+          </a:effectRef>
+          <a:fontRef idx="minor">
+            <a:schemeClr val="lt1"/>
+          </a:fontRef>
+        </p:style>
+        <p:txBody>
+          <a:bodyPr rtlCol="0" anchor="ctr"/>
+          <a:lstStyle/>
+          <a:p>
+            <a:r>
+              <a:rPr>
+                <a:solidFill>
+                  <a:srgbClr val="FFFFFF"/>
+                </a:solidFill>
+              </a:rPr>
+              <a:t>Blur</a:t>
+            </a:r>
+          </a:p>
+        </p:txBody>
+      </p:sp>
+      <p:sp>
+        <p:nvSpPr>
+          <p:cNvPr id="6" name="Rectangle 5"/>
+          <p:cNvSpPr/>
+          <p:nvPr/>
+        </p:nvSpPr>
+        <p:spPr>
+          <a:xfrm>
+            <a:off x="685800" y="3657600"/>
+            <a:ext cx="2286000" cy="1097280"/>
+          </a:xfrm>
+          <a:prstGeom prst="rect">
+            <a:avLst/>
+          </a:prstGeom>
+          <a:solidFill>
+            <a:srgbClr val="F2F2F2"/>
+          </a:solidFill>
+          <a:effectLst>
+            <a:innerShdw blurRad="63500" dist="25400" dir="13500000">
+              <a:srgbClr val="000000">
+                <a:alpha val="60000"/>
+              </a:srgbClr>
+            </a:innerShdw>
+          </a:effectLst>
+        </p:spPr>
+        <p:style>
+          <a:lnRef idx="1">
+            <a:schemeClr val="accent1"/>
+          </a:lnRef>
+          <a:fillRef idx="3">
+            <a:schemeClr val="accent1"/>
+          </a:fillRef>
+          <a:effectRef idx="2">
+            <a:schemeClr val="accent1"/>
+          </a:effectRef>
+          <a:fontRef idx="minor">
+            <a:schemeClr val="lt1"/>
+          </a:fontRef>
+        </p:style>
+        <p:txBody>
+          <a:bodyPr rtlCol="0" anchor="ctr"/>
+          <a:lstStyle/>
+          <a:p>
+            <a:r>
+              <a:t>Inner shadow</a:t>
+            </a:r>
+          </a:p>
+        </p:txBody>
+      </p:sp>
+      <p:sp>
+        <p:nvSpPr>
+          <p:cNvPr id="7" name="Rectangle 6"/>
+          <p:cNvSpPr/>
+          <p:nvPr/>
+        </p:nvSpPr>
+        <p:spPr>
+          <a:xfrm>
+            <a:off x="3657600" y="3657600"/>
+            <a:ext cx="2286000" cy="1097280"/>
+          </a:xfrm>
+          <a:prstGeom prst="rect">
+            <a:avLst/>
+          </a:prstGeom>
+          <a:solidFill>
+            <a:srgbClr val="F79646"/>
+          </a:solidFill>
+          <a:effectLst>
+            <a:softEdge rad="50800"/>
+          </a:effectLst>
+        </p:spPr>
+        <p:style>
+          <a:lnRef idx="1">
+            <a:schemeClr val="accent1"/>
+          </a:lnRef>
+          <a:fillRef idx="3">
+            <a:schemeClr val="accent1"/>
+          </a:fillRef>
+          <a:effectRef idx="2">
+            <a:schemeClr val="accent1"/>
+          </a:effectRef>
+          <a:fontRef idx="minor">
+            <a:schemeClr val="lt1"/>
+          </a:fontRef>
+        </p:style>
+        <p:txBody>
+          <a:bodyPr rtlCol="0" anchor="ctr"/>
+          <a:lstStyle/>
+          <a:p>
+            <a:r>
+              <a:t>Soft edge</a:t>
+            </a:r>
+          </a:p>
+        </p:txBody>
+      </p:sp>
+      <p:sp>
+        <p:nvSpPr>
+          <p:cNvPr id="8" name="Rectangle 7"/>
+          <p:cNvSpPr/>
+          <p:nvPr/>
+        </p:nvSpPr>
+        <p:spPr>
+          <a:xfrm>
+            <a:off x="6629400" y="3657600"/>
+            <a:ext cx="2286000" cy="1097280"/>
+          </a:xfrm>
+          <a:prstGeom prst="rect">
+            <a:avLst/>
+          </a:prstGeom>
+          <a:solidFill>
+            <a:srgbClr val="4F81BD"/>
+          </a:solidFill>
+          <a:effectLst>
+            <a:reflection blurRad="6350" stA="50000" stPos="0" endA="300" endPos="50000" dist="38100" dir="5400000" sy="-100000" algn="bl" rotWithShape="0"/>
+          </a:effectLst>
+        </p:spPr>
+        <p:style>
+          <a:lnRef idx="1">
+            <a:schemeClr val="accent1"/>
+          </a:lnRef>
+          <a:fillRef idx="3">
+            <a:schemeClr val="accent1"/>
+          </a:fillRef>
+          <a:effectRef idx="2">
+            <a:schemeClr val="accent1"/>
+          </a:effectRef>
+          <a:fontRef idx="minor">
+            <a:schemeClr val="lt1"/>
+          </a:fontRef>
+        </p:style>
+        <p:txBody>
+          <a:bodyPr rtlCol="0" anchor="ctr"/>
+          <a:lstStyle/>
+          <a:p>
+            <a:r>
+              <a:rPr>
+                <a:solidFill>
+                  <a:srgbClr val="FFFFFF"/>
+                </a:solidFill>
+              </a:rPr>
+              <a:t>Reflection</a:t>
+            </a:r>
+          </a:p>
+        </p:txBody>
+      </p:sp>
     </p:spTree>
   </p:cSld>
   <p:clrMapOvr>

</xml_diff>

<commit_message>
feat(text): apply body properties (insets, anchor, wrap, vert, autofit)
Wave 1 parsed <a:bodyPr> into BodyProperties. The renderer now wraps
each shape's paragraphs in a body div that carries padding (insets),
vertical anchor via flexbox, white-space for wrap="none", column-count
for multi-column text frames, and writing-mode for vertical text.
normAutofit fontScale + lnSpcReduction apply uniformly to run sizes
and line-heights.

Co-Authored-By: Claude Opus 4.7 (1M context) <noreply@anthropic.com>
</commit_message>
<xml_diff>
--- a/tests/render-test/basic/presentation.pptx
+++ b/tests/render-test/basic/presentation.pptx
@@ -12,6 +12,16 @@
     <p:sldId id="260" r:id="rId12"/>
     <p:sldId id="261" r:id="rId13"/>
     <p:sldId id="262" r:id="rId14"/>
+    <p:sldId id="263" r:id="rId15"/>
+    <p:sldId id="264" r:id="rId16"/>
+    <p:sldId id="265" r:id="rId17"/>
+    <p:sldId id="266" r:id="rId18"/>
+    <p:sldId id="267" r:id="rId19"/>
+    <p:sldId id="268" r:id="rId20"/>
+    <p:sldId id="269" r:id="rId21"/>
+    <p:sldId id="270" r:id="rId22"/>
+    <p:sldId id="271" r:id="rId23"/>
+    <p:sldId id="272" r:id="rId24" show="0"/>
   </p:sldIdLst>
   <p:sldSz cx="9144000" cy="6858000" type="screen4x3"/>
   <p:notesSz cx="6858000" cy="9144000"/>
@@ -117,6 +127,116 @@
 <p:cmAuthorLst xmlns:p="http://schemas.openxmlformats.org/presentationml/2006/main">
   <p:cmAuthor id="0" name="Fixture Author" initials="FA" lastIdx="1" clrIdx="0"/>
 </p:cmAuthorLst>
+</file>
+
+<file path=ppt/charts/chart1.xml><?xml version="1.0" encoding="utf-8"?>
+<c:chartSpace xmlns:c="http://schemas.openxmlformats.org/drawingml/2006/chart" xmlns:a="http://schemas.openxmlformats.org/drawingml/2006/main" xmlns:r="http://schemas.openxmlformats.org/officeDocument/2006/relationships">
+  <c:date1904 val="0"/>
+  <c:chart>
+    <c:autoTitleDeleted val="0"/>
+    <c:plotArea>
+      <c:barChart>
+        <c:barDir val="col"/>
+        <c:grouping val="clustered"/>
+        <c:ser>
+          <c:idx val="0"/>
+          <c:order val="0"/>
+          <c:tx>
+            <c:strRef>
+              <c:f>Sheet1!$B$1</c:f>
+              <c:strCache>
+                <c:ptCount val="1"/>
+                <c:pt idx="0">
+                  <c:v>Series 1</c:v>
+                </c:pt>
+              </c:strCache>
+            </c:strRef>
+          </c:tx>
+          <c:cat>
+            <c:strRef>
+              <c:f>Sheet1!$A$2:$A$4</c:f>
+              <c:strCache>
+                <c:ptCount val="3"/>
+                <c:pt idx="0">
+                  <c:v>A</c:v>
+                </c:pt>
+                <c:pt idx="1">
+                  <c:v>B</c:v>
+                </c:pt>
+                <c:pt idx="2">
+                  <c:v>C</c:v>
+                </c:pt>
+              </c:strCache>
+            </c:strRef>
+          </c:cat>
+          <c:val>
+            <c:numRef>
+              <c:f>Sheet1!$B$2:$B$4</c:f>
+              <c:numCache>
+                <c:formatCode>General</c:formatCode>
+                <c:ptCount val="3"/>
+                <c:pt idx="0">
+                  <c:v>1</c:v>
+                </c:pt>
+                <c:pt idx="1">
+                  <c:v>2</c:v>
+                </c:pt>
+                <c:pt idx="2">
+                  <c:v>3</c:v>
+                </c:pt>
+              </c:numCache>
+            </c:numRef>
+          </c:val>
+        </c:ser>
+        <c:axId val="-2068027336"/>
+        <c:axId val="-2113994440"/>
+      </c:barChart>
+      <c:catAx>
+        <c:axId val="-2068027336"/>
+        <c:scaling>
+          <c:orientation val="minMax"/>
+        </c:scaling>
+        <c:delete val="0"/>
+        <c:axPos val="b"/>
+        <c:majorTickMark val="out"/>
+        <c:minorTickMark val="none"/>
+        <c:tickLblPos val="nextTo"/>
+        <c:crossAx val="-2113994440"/>
+        <c:crosses val="autoZero"/>
+        <c:auto val="1"/>
+        <c:lblAlgn val="ctr"/>
+        <c:lblOffset val="100"/>
+        <c:noMultiLvlLbl val="0"/>
+      </c:catAx>
+      <c:valAx>
+        <c:axId val="-2113994440"/>
+        <c:scaling/>
+        <c:delete val="0"/>
+        <c:axPos val="l"/>
+        <c:majorGridlines/>
+        <c:majorTickMark val="out"/>
+        <c:minorTickMark val="none"/>
+        <c:tickLblPos val="nextTo"/>
+        <c:crossAx val="-2068027336"/>
+        <c:crosses val="autoZero"/>
+      </c:valAx>
+    </c:plotArea>
+    <c:dispBlanksAs val="gap"/>
+  </c:chart>
+  <c:txPr>
+    <a:bodyPr/>
+    <a:lstStyle/>
+    <a:p>
+      <a:pPr>
+        <a:defRPr sz="1800"/>
+      </a:pPr>
+      <a:endParaRPr lang="en-US"/>
+    </a:p>
+  </c:txPr>
+  <c:externalData r:id="rId1">
+    <c:autoUpdate val="0"/>
+  </c:externalData>
+</c:chartSpace>
 </file>
 
 <file path=ppt/comments/comment1.xml><?xml version="1.0" encoding="utf-8"?>
@@ -3584,7 +3704,7 @@
 </p:sld>
 </file>
 
-<file path=ppt/slides/slide2.xml><?xml version="1.0" encoding="utf-8"?>
+<file path=ppt/slides/slide10.xml><?xml version="1.0" encoding="utf-8"?>
 <p:sld xmlns:a="http://schemas.openxmlformats.org/drawingml/2006/main" xmlns:p="http://schemas.openxmlformats.org/presentationml/2006/main" xmlns:r="http://schemas.openxmlformats.org/officeDocument/2006/relationships">
   <p:cSld>
     <p:spTree>
@@ -3610,155 +3730,7 @@
           <a:lstStyle/>
           <a:p>
             <a:r>
-              <a:t>Bullet points</a:t>
-            </a:r>
-          </a:p>
-        </p:txBody>
-      </p:sp>
-      <p:sp>
-        <p:nvSpPr>
-          <p:cNvPr id="3" name="Content Placeholder 2"/>
-          <p:cNvSpPr>
-            <a:spLocks noGrp="1"/>
-          </p:cNvSpPr>
-          <p:nvPr>
-            <p:ph idx="1"/>
-          </p:nvPr>
-        </p:nvSpPr>
-        <p:spPr/>
-        <p:txBody>
-          <a:bodyPr/>
-          <a:lstStyle/>
-          <a:p>
-            <a:r>
-              <a:t>First bullet</a:t>
-            </a:r>
-          </a:p>
-          <a:p>
-            <a:pPr>
-              <a:defRPr sz="1800"/>
-            </a:pPr>
-            <a:r>
-              <a:t>Second bullet</a:t>
-            </a:r>
-          </a:p>
-          <a:p>
-            <a:pPr>
-              <a:defRPr sz="1800"/>
-            </a:pPr>
-            <a:r>
-              <a:t>Third bullet</a:t>
-            </a:r>
-          </a:p>
-        </p:txBody>
-      </p:sp>
-    </p:spTree>
-  </p:cSld>
-  <p:clrMapOvr>
-    <a:masterClrMapping/>
-  </p:clrMapOvr>
-</p:sld>
-</file>
-
-<file path=ppt/slides/slide3.xml><?xml version="1.0" encoding="utf-8"?>
-<p:sld xmlns:a="http://schemas.openxmlformats.org/drawingml/2006/main" xmlns:p="http://schemas.openxmlformats.org/presentationml/2006/main" xmlns:r="http://schemas.openxmlformats.org/officeDocument/2006/relationships">
-  <p:cSld>
-    <p:spTree>
-      <p:nvGrpSpPr>
-        <p:cNvPr id="1" name=""/>
-        <p:cNvGrpSpPr/>
-        <p:nvPr/>
-      </p:nvGrpSpPr>
-      <p:grpSpPr/>
-      <p:sp>
-        <p:nvSpPr>
-          <p:cNvPr id="2" name="Title 1"/>
-          <p:cNvSpPr>
-            <a:spLocks noGrp="1"/>
-          </p:cNvSpPr>
-          <p:nvPr>
-            <p:ph type="title"/>
-          </p:nvPr>
-        </p:nvSpPr>
-        <p:spPr/>
-        <p:txBody>
-          <a:bodyPr/>
-          <a:lstStyle/>
-          <a:p>
-            <a:r>
-              <a:t>A shape</a:t>
-            </a:r>
-          </a:p>
-        </p:txBody>
-      </p:sp>
-      <p:sp>
-        <p:nvSpPr>
-          <p:cNvPr id="3" name="TextBox 2"/>
-          <p:cNvSpPr txBox="1"/>
-          <p:nvPr/>
-        </p:nvSpPr>
-        <p:spPr>
-          <a:xfrm>
-            <a:off x="914400" y="1828800"/>
-            <a:ext cx="3657600" cy="914400"/>
-          </a:xfrm>
-          <a:prstGeom prst="rect">
-            <a:avLst/>
-          </a:prstGeom>
-          <a:noFill/>
-        </p:spPr>
-        <p:txBody>
-          <a:bodyPr wrap="none">
-            <a:spAutoFit/>
-          </a:bodyPr>
-          <a:lstStyle/>
-          <a:p>
-            <a:r>
-              <a:rPr sz="2400" b="1">
-                <a:solidFill>
-                  <a:srgbClr val="C0392B"/>
-                </a:solidFill>
-              </a:rPr>
-              <a:t>Free-floating textbox</a:t>
-            </a:r>
-          </a:p>
-        </p:txBody>
-      </p:sp>
-    </p:spTree>
-  </p:cSld>
-  <p:clrMapOvr>
-    <a:masterClrMapping/>
-  </p:clrMapOvr>
-</p:sld>
-</file>
-
-<file path=ppt/slides/slide4.xml><?xml version="1.0" encoding="utf-8"?>
-<p:sld xmlns:a="http://schemas.openxmlformats.org/drawingml/2006/main" xmlns:p="http://schemas.openxmlformats.org/presentationml/2006/main" xmlns:r="http://schemas.openxmlformats.org/officeDocument/2006/relationships">
-  <p:cSld>
-    <p:spTree>
-      <p:nvGrpSpPr>
-        <p:cNvPr id="1" name=""/>
-        <p:cNvGrpSpPr/>
-        <p:nvPr/>
-      </p:nvGrpSpPr>
-      <p:grpSpPr/>
-      <p:sp>
-        <p:nvSpPr>
-          <p:cNvPr id="2" name="Title 1"/>
-          <p:cNvSpPr>
-            <a:spLocks noGrp="1"/>
-          </p:cNvSpPr>
-          <p:nvPr>
-            <p:ph type="title"/>
-          </p:nvPr>
-        </p:nvSpPr>
-        <p:spPr/>
-        <p:txBody>
-          <a:bodyPr/>
-          <a:lstStyle/>
-          <a:p>
-            <a:r>
-              <a:t>An image</a:t>
+              <a:t>Image adjustments</a:t>
             </a:r>
           </a:p>
         </p:txBody>
@@ -3772,6 +3744,7 @@
           <p:nvPr/>
         </p:nvPicPr>
         <p:blipFill>
+          <a:srcRect l="20000" t="10000" r="20000" b="10000"/>
           <a:blip r:embed="rId2"/>
           <a:stretch>
             <a:fillRect/>
@@ -3779,8 +3752,141 @@
         </p:blipFill>
         <p:spPr>
           <a:xfrm>
-            <a:off x="2743200" y="1828800"/>
-            <a:ext cx="3657600" cy="1828800"/>
+            <a:off x="457200" y="1645920"/>
+            <a:ext cx="2286000" cy="1645920"/>
+          </a:xfrm>
+          <a:prstGeom prst="rect">
+            <a:avLst/>
+          </a:prstGeom>
+        </p:spPr>
+      </p:pic>
+      <p:pic>
+        <p:nvPicPr>
+          <p:cNvPr id="4" name="Picture 3" descr="python-powered.png"/>
+          <p:cNvPicPr>
+            <a:picLocks noChangeAspect="1"/>
+          </p:cNvPicPr>
+          <p:nvPr/>
+        </p:nvPicPr>
+        <p:blipFill>
+          <a:blip r:embed="rId2">
+            <a:grayscl/>
+          </a:blip>
+          <a:stretch>
+            <a:fillRect/>
+          </a:stretch>
+        </p:blipFill>
+        <p:spPr>
+          <a:xfrm>
+            <a:off x="3017520" y="1645920"/>
+            <a:ext cx="2286000" cy="1645920"/>
+          </a:xfrm>
+          <a:prstGeom prst="rect">
+            <a:avLst/>
+          </a:prstGeom>
+        </p:spPr>
+      </p:pic>
+      <p:pic>
+        <p:nvPicPr>
+          <p:cNvPr id="5" name="Picture 4" descr="python-powered.png"/>
+          <p:cNvPicPr>
+            <a:picLocks noChangeAspect="1"/>
+          </p:cNvPicPr>
+          <p:nvPr/>
+        </p:nvPicPr>
+        <p:blipFill>
+          <a:blip r:embed="rId2">
+            <a:lum bright="20000" contrast="30000"/>
+          </a:blip>
+          <a:stretch>
+            <a:fillRect/>
+          </a:stretch>
+        </p:blipFill>
+        <p:spPr>
+          <a:xfrm>
+            <a:off x="5577840" y="1645920"/>
+            <a:ext cx="2286000" cy="1645920"/>
+          </a:xfrm>
+          <a:prstGeom prst="rect">
+            <a:avLst/>
+          </a:prstGeom>
+        </p:spPr>
+      </p:pic>
+      <p:pic>
+        <p:nvPicPr>
+          <p:cNvPr id="6" name="Picture 5" descr="python-powered.png"/>
+          <p:cNvPicPr>
+            <a:picLocks noChangeAspect="1"/>
+          </p:cNvPicPr>
+          <p:nvPr/>
+        </p:nvPicPr>
+        <p:blipFill>
+          <a:blip r:embed="rId2">
+            <a:alphaModFix amt="50000"/>
+          </a:blip>
+          <a:stretch>
+            <a:fillRect/>
+          </a:stretch>
+        </p:blipFill>
+        <p:spPr>
+          <a:xfrm>
+            <a:off x="457200" y="3840480"/>
+            <a:ext cx="2286000" cy="1645920"/>
+          </a:xfrm>
+          <a:prstGeom prst="rect">
+            <a:avLst/>
+          </a:prstGeom>
+        </p:spPr>
+      </p:pic>
+      <p:pic>
+        <p:nvPicPr>
+          <p:cNvPr id="7" name="Picture 6" descr="python-powered.png"/>
+          <p:cNvPicPr>
+            <a:picLocks noChangeAspect="1"/>
+          </p:cNvPicPr>
+          <p:nvPr/>
+        </p:nvPicPr>
+        <p:blipFill>
+          <a:blip r:embed="rId2">
+            <a:biLevel thresh="50000"/>
+          </a:blip>
+          <a:stretch>
+            <a:fillRect/>
+          </a:stretch>
+        </p:blipFill>
+        <p:spPr>
+          <a:xfrm>
+            <a:off x="3017520" y="3840480"/>
+            <a:ext cx="2286000" cy="1645920"/>
+          </a:xfrm>
+          <a:prstGeom prst="rect">
+            <a:avLst/>
+          </a:prstGeom>
+        </p:spPr>
+      </p:pic>
+      <p:pic>
+        <p:nvPicPr>
+          <p:cNvPr id="8" name="Picture 7" descr="python-powered.png"/>
+          <p:cNvPicPr>
+            <a:picLocks noChangeAspect="1"/>
+          </p:cNvPicPr>
+          <p:nvPr/>
+        </p:nvPicPr>
+        <p:blipFill>
+          <a:blip r:embed="rId2">
+            <a:duotone>
+              <a:srgbClr val="1F3A93"/>
+              <a:srgbClr val="FFD9B3"/>
+            </a:duotone>
+          </a:blip>
+          <a:stretch>
+            <a:fillRect/>
+          </a:stretch>
+        </p:blipFill>
+        <p:spPr>
+          <a:xfrm>
+            <a:off x="5577840" y="3840480"/>
+            <a:ext cx="2286000" cy="1645920"/>
           </a:xfrm>
           <a:prstGeom prst="rect">
             <a:avLst/>
@@ -3795,190 +3901,7 @@
 </p:sld>
 </file>
 
-<file path=ppt/slides/slide5.xml><?xml version="1.0" encoding="utf-8"?>
-<p:sld xmlns:a="http://schemas.openxmlformats.org/drawingml/2006/main" xmlns:p="http://schemas.openxmlformats.org/presentationml/2006/main" xmlns:r="http://schemas.openxmlformats.org/officeDocument/2006/relationships">
-  <p:cSld>
-    <p:bg>
-      <p:bgPr>
-        <a:solidFill>
-          <a:srgbClr val="FFF4E0"/>
-        </a:solidFill>
-        <a:effectLst/>
-      </p:bgPr>
-    </p:bg>
-    <p:spTree>
-      <p:nvGrpSpPr>
-        <p:cNvPr id="1" name=""/>
-        <p:cNvGrpSpPr/>
-        <p:nvPr/>
-      </p:nvGrpSpPr>
-      <p:grpSpPr/>
-      <p:sp>
-        <p:nvSpPr>
-          <p:cNvPr id="2" name="Title 1"/>
-          <p:cNvSpPr>
-            <a:spLocks noGrp="1"/>
-          </p:cNvSpPr>
-          <p:nvPr>
-            <p:ph type="title"/>
-          </p:nvPr>
-        </p:nvSpPr>
-        <p:spPr/>
-        <p:txBody>
-          <a:bodyPr/>
-          <a:lstStyle/>
-          <a:p>
-            <a:r>
-              <a:t>Tinted background</a:t>
-            </a:r>
-          </a:p>
-        </p:txBody>
-      </p:sp>
-    </p:spTree>
-  </p:cSld>
-  <p:clrMapOvr>
-    <a:masterClrMapping/>
-  </p:clrMapOvr>
-</p:sld>
-</file>
-
-<file path=ppt/slides/slide6.xml><?xml version="1.0" encoding="utf-8"?>
-<p:sld xmlns:a="http://schemas.openxmlformats.org/drawingml/2006/main" xmlns:p="http://schemas.openxmlformats.org/presentationml/2006/main" xmlns:r="http://schemas.openxmlformats.org/officeDocument/2006/relationships">
-  <p:cSld>
-    <p:spTree>
-      <p:nvGrpSpPr>
-        <p:cNvPr id="1" name=""/>
-        <p:cNvGrpSpPr/>
-        <p:nvPr/>
-      </p:nvGrpSpPr>
-      <p:grpSpPr/>
-      <p:sp>
-        <p:nvSpPr>
-          <p:cNvPr id="2" name="Title 1"/>
-          <p:cNvSpPr>
-            <a:spLocks noGrp="1"/>
-          </p:cNvSpPr>
-          <p:nvPr>
-            <p:ph type="title"/>
-          </p:nvPr>
-        </p:nvSpPr>
-        <p:spPr/>
-        <p:txBody>
-          <a:bodyPr/>
-          <a:lstStyle/>
-          <a:p>
-            <a:r>
-              <a:t>Filled shapes</a:t>
-            </a:r>
-          </a:p>
-        </p:txBody>
-      </p:sp>
-      <p:sp>
-        <p:nvSpPr>
-          <p:cNvPr id="3" name="Rectangle 2"/>
-          <p:cNvSpPr/>
-          <p:nvPr/>
-        </p:nvSpPr>
-        <p:spPr>
-          <a:xfrm>
-            <a:off x="914400" y="1828800"/>
-            <a:ext cx="2743200" cy="1371600"/>
-          </a:xfrm>
-          <a:prstGeom prst="rect">
-            <a:avLst/>
-          </a:prstGeom>
-          <a:solidFill>
-            <a:srgbClr val="4F81BD"/>
-          </a:solidFill>
-          <a:ln w="38100">
-            <a:solidFill>
-              <a:srgbClr val="1F497D"/>
-            </a:solidFill>
-          </a:ln>
-        </p:spPr>
-        <p:style>
-          <a:lnRef idx="1">
-            <a:schemeClr val="accent1"/>
-          </a:lnRef>
-          <a:fillRef idx="3">
-            <a:schemeClr val="accent1"/>
-          </a:fillRef>
-          <a:effectRef idx="2">
-            <a:schemeClr val="accent1"/>
-          </a:effectRef>
-          <a:fontRef idx="minor">
-            <a:schemeClr val="lt1"/>
-          </a:fontRef>
-        </p:style>
-        <p:txBody>
-          <a:bodyPr rtlCol="0" anchor="ctr"/>
-          <a:lstStyle/>
-          <a:p>
-            <a:r>
-              <a:rPr>
-                <a:solidFill>
-                  <a:srgbClr val="FFFFFF"/>
-                </a:solidFill>
-              </a:rPr>
-              <a:t>Filled + bordered</a:t>
-            </a:r>
-          </a:p>
-        </p:txBody>
-      </p:sp>
-      <p:sp>
-        <p:nvSpPr>
-          <p:cNvPr id="4" name="Rectangle 3"/>
-          <p:cNvSpPr/>
-          <p:nvPr/>
-        </p:nvSpPr>
-        <p:spPr>
-          <a:xfrm>
-            <a:off x="4572000" y="1828800"/>
-            <a:ext cx="2743200" cy="1371600"/>
-          </a:xfrm>
-          <a:prstGeom prst="rect">
-            <a:avLst/>
-          </a:prstGeom>
-          <a:noFill/>
-          <a:ln w="19050">
-            <a:solidFill>
-              <a:srgbClr val="C0504D"/>
-            </a:solidFill>
-          </a:ln>
-        </p:spPr>
-        <p:style>
-          <a:lnRef idx="1">
-            <a:schemeClr val="accent1"/>
-          </a:lnRef>
-          <a:fillRef idx="3">
-            <a:schemeClr val="accent1"/>
-          </a:fillRef>
-          <a:effectRef idx="2">
-            <a:schemeClr val="accent1"/>
-          </a:effectRef>
-          <a:fontRef idx="minor">
-            <a:schemeClr val="lt1"/>
-          </a:fontRef>
-        </p:style>
-        <p:txBody>
-          <a:bodyPr rtlCol="0" anchor="ctr"/>
-          <a:lstStyle/>
-          <a:p>
-            <a:r>
-              <a:t>Border only</a:t>
-            </a:r>
-          </a:p>
-        </p:txBody>
-      </p:sp>
-    </p:spTree>
-  </p:cSld>
-  <p:clrMapOvr>
-    <a:masterClrMapping/>
-  </p:clrMapOvr>
-</p:sld>
-</file>
-
-<file path=ppt/slides/slide7.xml><?xml version="1.0" encoding="utf-8"?>
+<file path=ppt/slides/slide11.xml><?xml version="1.0" encoding="utf-8"?>
 <p:sld xmlns:a="http://schemas.openxmlformats.org/drawingml/2006/main" xmlns:p="http://schemas.openxmlformats.org/presentationml/2006/main" xmlns:r="http://schemas.openxmlformats.org/officeDocument/2006/relationships">
   <p:cSld>
     <p:spTree>
@@ -4150,6 +4073,1744 @@
           </a:graphicData>
         </a:graphic>
       </p:graphicFrame>
+    </p:spTree>
+  </p:cSld>
+  <p:clrMapOvr>
+    <a:masterClrMapping/>
+  </p:clrMapOvr>
+</p:sld>
+</file>
+
+<file path=ppt/slides/slide12.xml><?xml version="1.0" encoding="utf-8"?>
+<p:sld xmlns:a="http://schemas.openxmlformats.org/drawingml/2006/main" xmlns:p="http://schemas.openxmlformats.org/presentationml/2006/main" xmlns:r="http://schemas.openxmlformats.org/officeDocument/2006/relationships">
+  <p:cSld>
+    <p:spTree>
+      <p:nvGrpSpPr>
+        <p:cNvPr id="1" name=""/>
+        <p:cNvGrpSpPr/>
+        <p:nvPr/>
+      </p:nvGrpSpPr>
+      <p:grpSpPr/>
+      <p:sp>
+        <p:nvSpPr>
+          <p:cNvPr id="2" name="Title 1"/>
+          <p:cNvSpPr>
+            <a:spLocks noGrp="1"/>
+          </p:cNvSpPr>
+          <p:nvPr>
+            <p:ph type="title"/>
+          </p:nvPr>
+        </p:nvSpPr>
+        <p:spPr/>
+        <p:txBody>
+          <a:bodyPr/>
+          <a:lstStyle/>
+          <a:p>
+            <a:r>
+              <a:t>Gradient fill</a:t>
+            </a:r>
+          </a:p>
+        </p:txBody>
+      </p:sp>
+      <p:sp>
+        <p:nvSpPr>
+          <p:cNvPr id="3" name="Rectangle 2"/>
+          <p:cNvSpPr/>
+          <p:nvPr/>
+        </p:nvSpPr>
+        <p:spPr>
+          <a:xfrm>
+            <a:off x="914400" y="1828800"/>
+            <a:ext cx="5486400" cy="1828800"/>
+          </a:xfrm>
+          <a:prstGeom prst="rect">
+            <a:avLst/>
+          </a:prstGeom>
+          <a:gradFill flip="none" rotWithShape="1">
+            <a:gsLst>
+              <a:gs pos="0">
+                <a:srgbClr val="4F81BD"/>
+              </a:gs>
+              <a:gs pos="100000">
+                <a:srgbClr val="C0504D"/>
+              </a:gs>
+            </a:gsLst>
+            <a:lin ang="2700000" scaled="1"/>
+          </a:gradFill>
+        </p:spPr>
+        <p:style>
+          <a:lnRef idx="1">
+            <a:schemeClr val="accent1"/>
+          </a:lnRef>
+          <a:fillRef idx="3">
+            <a:schemeClr val="accent1"/>
+          </a:fillRef>
+          <a:effectRef idx="2">
+            <a:schemeClr val="accent1"/>
+          </a:effectRef>
+          <a:fontRef idx="minor">
+            <a:schemeClr val="lt1"/>
+          </a:fontRef>
+        </p:style>
+        <p:txBody>
+          <a:bodyPr rtlCol="0" anchor="ctr"/>
+          <a:lstStyle/>
+          <a:p>
+            <a:r>
+              <a:rPr>
+                <a:solidFill>
+                  <a:srgbClr val="FFFFFF"/>
+                </a:solidFill>
+              </a:rPr>
+              <a:t>Linear gradient</a:t>
+            </a:r>
+          </a:p>
+        </p:txBody>
+      </p:sp>
+    </p:spTree>
+  </p:cSld>
+  <p:clrMapOvr>
+    <a:masterClrMapping/>
+  </p:clrMapOvr>
+</p:sld>
+</file>
+
+<file path=ppt/slides/slide13.xml><?xml version="1.0" encoding="utf-8"?>
+<p:sld xmlns:a="http://schemas.openxmlformats.org/drawingml/2006/main" xmlns:p="http://schemas.openxmlformats.org/presentationml/2006/main" xmlns:r="http://schemas.openxmlformats.org/officeDocument/2006/relationships">
+  <p:cSld>
+    <p:spTree>
+      <p:nvGrpSpPr>
+        <p:cNvPr id="1" name=""/>
+        <p:cNvGrpSpPr/>
+        <p:nvPr/>
+      </p:nvGrpSpPr>
+      <p:grpSpPr/>
+      <p:sp>
+        <p:nvSpPr>
+          <p:cNvPr id="2" name="Title 1"/>
+          <p:cNvSpPr>
+            <a:spLocks noGrp="1"/>
+          </p:cNvSpPr>
+          <p:nvPr>
+            <p:ph type="title"/>
+          </p:nvPr>
+        </p:nvSpPr>
+        <p:spPr/>
+        <p:txBody>
+          <a:bodyPr/>
+          <a:lstStyle/>
+          <a:p>
+            <a:r>
+              <a:t>Picture fill</a:t>
+            </a:r>
+          </a:p>
+        </p:txBody>
+      </p:sp>
+      <p:sp>
+        <p:nvSpPr>
+          <p:cNvPr id="3" name="Rectangle 2"/>
+          <p:cNvSpPr/>
+          <p:nvPr/>
+        </p:nvSpPr>
+        <p:spPr>
+          <a:xfrm>
+            <a:off x="1828800" y="1828800"/>
+            <a:ext cx="4572000" cy="2743200"/>
+          </a:xfrm>
+          <a:prstGeom prst="rect">
+            <a:avLst/>
+          </a:prstGeom>
+          <a:blipFill>
+            <a:blip r:embed="rId2"/>
+            <a:stretch>
+              <a:fillRect/>
+            </a:stretch>
+          </a:blipFill>
+        </p:spPr>
+        <p:style>
+          <a:lnRef idx="1">
+            <a:schemeClr val="accent1"/>
+          </a:lnRef>
+          <a:fillRef idx="3">
+            <a:schemeClr val="accent1"/>
+          </a:fillRef>
+          <a:effectRef idx="2">
+            <a:schemeClr val="accent1"/>
+          </a:effectRef>
+          <a:fontRef idx="minor">
+            <a:schemeClr val="lt1"/>
+          </a:fontRef>
+        </p:style>
+        <p:txBody>
+          <a:bodyPr rtlCol="0" anchor="ctr"/>
+          <a:lstStyle/>
+          <a:p>
+            <a:pPr algn="ctr"/>
+          </a:p>
+        </p:txBody>
+      </p:sp>
+    </p:spTree>
+  </p:cSld>
+  <p:clrMapOvr>
+    <a:masterClrMapping/>
+  </p:clrMapOvr>
+</p:sld>
+</file>
+
+<file path=ppt/slides/slide14.xml><?xml version="1.0" encoding="utf-8"?>
+<p:sld xmlns:a="http://schemas.openxmlformats.org/drawingml/2006/main" xmlns:p="http://schemas.openxmlformats.org/presentationml/2006/main" xmlns:r="http://schemas.openxmlformats.org/officeDocument/2006/relationships">
+  <p:cSld>
+    <p:spTree>
+      <p:nvGrpSpPr>
+        <p:cNvPr id="1" name=""/>
+        <p:cNvGrpSpPr/>
+        <p:nvPr/>
+      </p:nvGrpSpPr>
+      <p:grpSpPr/>
+      <p:sp>
+        <p:nvSpPr>
+          <p:cNvPr id="2" name="Title 1"/>
+          <p:cNvSpPr>
+            <a:spLocks noGrp="1"/>
+          </p:cNvSpPr>
+          <p:nvPr>
+            <p:ph type="title"/>
+          </p:nvPr>
+        </p:nvSpPr>
+        <p:spPr/>
+        <p:txBody>
+          <a:bodyPr/>
+          <a:lstStyle/>
+          <a:p>
+            <a:r>
+              <a:t>Typography</a:t>
+            </a:r>
+          </a:p>
+        </p:txBody>
+      </p:sp>
+      <p:sp>
+        <p:nvSpPr>
+          <p:cNvPr id="3" name="TextBox 2"/>
+          <p:cNvSpPr txBox="1"/>
+          <p:nvPr/>
+        </p:nvSpPr>
+        <p:spPr>
+          <a:xfrm>
+            <a:off x="914400" y="1371600"/>
+            <a:ext cx="7315200" cy="3657600"/>
+          </a:xfrm>
+          <a:prstGeom prst="rect">
+            <a:avLst/>
+          </a:prstGeom>
+          <a:noFill/>
+        </p:spPr>
+        <p:txBody>
+          <a:bodyPr wrap="square">
+            <a:spAutoFit/>
+          </a:bodyPr>
+          <a:lstStyle/>
+          <a:p>
+            <a:r>
+              <a:t>Plain then </a:t>
+            </a:r>
+            <a:r>
+              <a:rPr u="sng"/>
+              <a:t>underlined</a:t>
+            </a:r>
+            <a:r>
+              <a:t> then </a:t>
+            </a:r>
+            <a:r>
+              <a:rPr strike="sngStrike"/>
+              <a:t>strikethrough</a:t>
+            </a:r>
+            <a:r>
+              <a:t>.</a:t>
+            </a:r>
+          </a:p>
+          <a:p>
+            <a:r>
+              <a:t>E = mc</a:t>
+            </a:r>
+            <a:r>
+              <a:rPr baseline="30000"/>
+              <a:t>2</a:t>
+            </a:r>
+            <a:r>
+              <a:t>, H</a:t>
+            </a:r>
+            <a:r>
+              <a:rPr baseline="-25000"/>
+              <a:t>2</a:t>
+            </a:r>
+            <a:r>
+              <a:t>O, </a:t>
+            </a:r>
+            <a:r>
+              <a:rPr spc="200"/>
+              <a:t>l e t t e r   s p a c e d</a:t>
+            </a:r>
+          </a:p>
+          <a:p>
+            <a:pPr>
+              <a:lnSpc>
+                <a:spcPct val="150000"/>
+              </a:lnSpc>
+            </a:pPr>
+            <a:r>
+              <a:t>This paragraph uses 1.5x line spacing so you can see the extra vertical room between wrapped lines. Quick brown foxes and lazy dogs.</a:t>
+            </a:r>
+          </a:p>
+        </p:txBody>
+      </p:sp>
+    </p:spTree>
+  </p:cSld>
+  <p:clrMapOvr>
+    <a:masterClrMapping/>
+  </p:clrMapOvr>
+</p:sld>
+</file>
+
+<file path=ppt/slides/slide15.xml><?xml version="1.0" encoding="utf-8"?>
+<p:sld xmlns:a="http://schemas.openxmlformats.org/drawingml/2006/main" xmlns:p="http://schemas.openxmlformats.org/presentationml/2006/main" xmlns:r="http://schemas.openxmlformats.org/officeDocument/2006/relationships">
+  <p:cSld>
+    <p:spTree>
+      <p:nvGrpSpPr>
+        <p:cNvPr id="1" name=""/>
+        <p:cNvGrpSpPr/>
+        <p:nvPr/>
+      </p:nvGrpSpPr>
+      <p:grpSpPr/>
+      <p:sp>
+        <p:nvSpPr>
+          <p:cNvPr id="2" name="Title 1"/>
+          <p:cNvSpPr>
+            <a:spLocks noGrp="1"/>
+          </p:cNvSpPr>
+          <p:nvPr>
+            <p:ph type="title"/>
+          </p:nvPr>
+        </p:nvSpPr>
+        <p:spPr/>
+        <p:txBody>
+          <a:bodyPr/>
+          <a:lstStyle/>
+          <a:p>
+            <a:r>
+              <a:t>Text frame</a:t>
+            </a:r>
+          </a:p>
+        </p:txBody>
+      </p:sp>
+      <p:sp>
+        <p:nvSpPr>
+          <p:cNvPr id="3" name="Rectangle 2"/>
+          <p:cNvSpPr/>
+          <p:nvPr/>
+        </p:nvSpPr>
+        <p:spPr>
+          <a:xfrm>
+            <a:off x="457200" y="1645920"/>
+            <a:ext cx="2743200" cy="2286000"/>
+          </a:xfrm>
+          <a:prstGeom prst="rect">
+            <a:avLst/>
+          </a:prstGeom>
+          <a:noFill/>
+          <a:ln>
+            <a:solidFill>
+              <a:srgbClr val="4F81BD"/>
+            </a:solidFill>
+          </a:ln>
+        </p:spPr>
+        <p:style>
+          <a:lnRef idx="1">
+            <a:schemeClr val="accent1"/>
+          </a:lnRef>
+          <a:fillRef idx="3">
+            <a:schemeClr val="accent1"/>
+          </a:fillRef>
+          <a:effectRef idx="2">
+            <a:schemeClr val="accent1"/>
+          </a:effectRef>
+          <a:fontRef idx="minor">
+            <a:schemeClr val="lt1"/>
+          </a:fontRef>
+        </p:style>
+        <p:txBody>
+          <a:bodyPr rtlCol="0" anchor="ctr"/>
+          <a:lstStyle/>
+          <a:p>
+            <a:r>
+              <a:t>Centered vertically</a:t>
+            </a:r>
+          </a:p>
+        </p:txBody>
+      </p:sp>
+      <p:sp>
+        <p:nvSpPr>
+          <p:cNvPr id="4" name="Rectangle 3"/>
+          <p:cNvSpPr/>
+          <p:nvPr/>
+        </p:nvSpPr>
+        <p:spPr>
+          <a:xfrm>
+            <a:off x="3657600" y="1645920"/>
+            <a:ext cx="2743200" cy="2286000"/>
+          </a:xfrm>
+          <a:prstGeom prst="rect">
+            <a:avLst/>
+          </a:prstGeom>
+          <a:solidFill>
+            <a:srgbClr val="E8EEF7"/>
+          </a:solidFill>
+          <a:ln>
+            <a:solidFill>
+              <a:srgbClr val="4F81BD"/>
+            </a:solidFill>
+          </a:ln>
+        </p:spPr>
+        <p:style>
+          <a:lnRef idx="1">
+            <a:schemeClr val="accent1"/>
+          </a:lnRef>
+          <a:fillRef idx="3">
+            <a:schemeClr val="accent1"/>
+          </a:fillRef>
+          <a:effectRef idx="2">
+            <a:schemeClr val="accent1"/>
+          </a:effectRef>
+          <a:fontRef idx="minor">
+            <a:schemeClr val="lt1"/>
+          </a:fontRef>
+        </p:style>
+        <p:txBody>
+          <a:bodyPr rtlCol="0" anchor="ctr" lIns="457200" tIns="457200" rIns="457200" bIns="457200"/>
+          <a:lstStyle/>
+          <a:p>
+            <a:r>
+              <a:t>Wide insets around this text.</a:t>
+            </a:r>
+          </a:p>
+        </p:txBody>
+      </p:sp>
+      <p:sp>
+        <p:nvSpPr>
+          <p:cNvPr id="5" name="Rectangle 4"/>
+          <p:cNvSpPr/>
+          <p:nvPr/>
+        </p:nvSpPr>
+        <p:spPr>
+          <a:xfrm>
+            <a:off x="457200" y="4114800"/>
+            <a:ext cx="2743200" cy="731520"/>
+          </a:xfrm>
+          <a:prstGeom prst="rect">
+            <a:avLst/>
+          </a:prstGeom>
+          <a:noFill/>
+          <a:ln>
+            <a:solidFill>
+              <a:srgbClr val="C0504D"/>
+            </a:solidFill>
+          </a:ln>
+        </p:spPr>
+        <p:style>
+          <a:lnRef idx="1">
+            <a:schemeClr val="accent1"/>
+          </a:lnRef>
+          <a:fillRef idx="3">
+            <a:schemeClr val="accent1"/>
+          </a:fillRef>
+          <a:effectRef idx="2">
+            <a:schemeClr val="accent1"/>
+          </a:effectRef>
+          <a:fontRef idx="minor">
+            <a:schemeClr val="lt1"/>
+          </a:fontRef>
+        </p:style>
+        <p:txBody>
+          <a:bodyPr rtlCol="0" anchor="ctr" wrap="none"/>
+          <a:lstStyle/>
+          <a:p>
+            <a:r>
+              <a:t>This line should not wrap even though it is long.</a:t>
+            </a:r>
+          </a:p>
+        </p:txBody>
+      </p:sp>
+    </p:spTree>
+  </p:cSld>
+  <p:clrMapOvr>
+    <a:masterClrMapping/>
+  </p:clrMapOvr>
+</p:sld>
+</file>
+
+<file path=ppt/slides/slide16.xml><?xml version="1.0" encoding="utf-8"?>
+<p:sld xmlns:a="http://schemas.openxmlformats.org/drawingml/2006/main" xmlns:p="http://schemas.openxmlformats.org/presentationml/2006/main" xmlns:r="http://schemas.openxmlformats.org/officeDocument/2006/relationships">
+  <p:cSld>
+    <p:spTree>
+      <p:nvGrpSpPr>
+        <p:cNvPr id="1" name=""/>
+        <p:cNvGrpSpPr/>
+        <p:nvPr/>
+      </p:nvGrpSpPr>
+      <p:grpSpPr/>
+      <p:sp>
+        <p:nvSpPr>
+          <p:cNvPr id="2" name="Title 1"/>
+          <p:cNvSpPr>
+            <a:spLocks noGrp="1"/>
+          </p:cNvSpPr>
+          <p:nvPr>
+            <p:ph type="title"/>
+          </p:nvPr>
+        </p:nvSpPr>
+        <p:spPr/>
+        <p:txBody>
+          <a:bodyPr/>
+          <a:lstStyle/>
+          <a:p>
+            <a:r>
+              <a:t>A chart</a:t>
+            </a:r>
+          </a:p>
+        </p:txBody>
+      </p:sp>
+      <p:graphicFrame>
+        <p:nvGraphicFramePr>
+          <p:cNvPr id="3" name="Chart 2"/>
+          <p:cNvGraphicFramePr>
+            <a:graphicFrameLocks noGrp="1"/>
+          </p:cNvGraphicFramePr>
+          <p:nvPr/>
+        </p:nvGraphicFramePr>
+        <p:xfrm>
+          <a:off x="914400" y="1828800"/>
+          <a:ext cx="5486400" cy="3657600"/>
+        </p:xfrm>
+        <a:graphic>
+          <a:graphicData uri="http://schemas.openxmlformats.org/drawingml/2006/chart">
+            <c:chart xmlns:c="http://schemas.openxmlformats.org/drawingml/2006/chart" r:id="rId2"/>
+          </a:graphicData>
+        </a:graphic>
+      </p:graphicFrame>
+    </p:spTree>
+  </p:cSld>
+  <p:clrMapOvr>
+    <a:masterClrMapping/>
+  </p:clrMapOvr>
+</p:sld>
+</file>
+
+<file path=ppt/slides/slide17.xml><?xml version="1.0" encoding="utf-8"?>
+<p:sld xmlns:a="http://schemas.openxmlformats.org/drawingml/2006/main" xmlns:p="http://schemas.openxmlformats.org/presentationml/2006/main" xmlns:r="http://schemas.openxmlformats.org/officeDocument/2006/relationships">
+  <p:cSld>
+    <p:spTree>
+      <p:nvGrpSpPr>
+        <p:cNvPr id="1" name=""/>
+        <p:cNvGrpSpPr/>
+        <p:nvPr/>
+      </p:nvGrpSpPr>
+      <p:grpSpPr/>
+      <p:sp>
+        <p:nvSpPr>
+          <p:cNvPr id="2" name="Title 1"/>
+          <p:cNvSpPr>
+            <a:spLocks noGrp="1"/>
+          </p:cNvSpPr>
+          <p:nvPr>
+            <p:ph type="title"/>
+          </p:nvPr>
+        </p:nvSpPr>
+        <p:spPr/>
+        <p:txBody>
+          <a:bodyPr/>
+          <a:lstStyle/>
+          <a:p>
+            <a:r>
+              <a:t>Hidden slide</a:t>
+            </a:r>
+          </a:p>
+        </p:txBody>
+      </p:sp>
+    </p:spTree>
+  </p:cSld>
+  <p:clrMapOvr>
+    <a:masterClrMapping/>
+  </p:clrMapOvr>
+</p:sld>
+</file>
+
+<file path=ppt/slides/slide2.xml><?xml version="1.0" encoding="utf-8"?>
+<p:sld xmlns:a="http://schemas.openxmlformats.org/drawingml/2006/main" xmlns:p="http://schemas.openxmlformats.org/presentationml/2006/main" xmlns:r="http://schemas.openxmlformats.org/officeDocument/2006/relationships">
+  <p:cSld>
+    <p:spTree>
+      <p:nvGrpSpPr>
+        <p:cNvPr id="1" name=""/>
+        <p:cNvGrpSpPr/>
+        <p:nvPr/>
+      </p:nvGrpSpPr>
+      <p:grpSpPr/>
+      <p:sp>
+        <p:nvSpPr>
+          <p:cNvPr id="2" name="Title 1"/>
+          <p:cNvSpPr>
+            <a:spLocks noGrp="1"/>
+          </p:cNvSpPr>
+          <p:nvPr>
+            <p:ph type="title"/>
+          </p:nvPr>
+        </p:nvSpPr>
+        <p:spPr/>
+        <p:txBody>
+          <a:bodyPr/>
+          <a:lstStyle/>
+          <a:p>
+            <a:r>
+              <a:t>Bullet points</a:t>
+            </a:r>
+          </a:p>
+        </p:txBody>
+      </p:sp>
+      <p:sp>
+        <p:nvSpPr>
+          <p:cNvPr id="3" name="Content Placeholder 2"/>
+          <p:cNvSpPr>
+            <a:spLocks noGrp="1"/>
+          </p:cNvSpPr>
+          <p:nvPr>
+            <p:ph idx="1"/>
+          </p:nvPr>
+        </p:nvSpPr>
+        <p:spPr/>
+        <p:txBody>
+          <a:bodyPr/>
+          <a:lstStyle/>
+          <a:p>
+            <a:r>
+              <a:t>First bullet</a:t>
+            </a:r>
+          </a:p>
+          <a:p>
+            <a:pPr>
+              <a:defRPr sz="1800"/>
+            </a:pPr>
+            <a:r>
+              <a:t>Second bullet</a:t>
+            </a:r>
+          </a:p>
+          <a:p>
+            <a:pPr>
+              <a:defRPr sz="1800"/>
+            </a:pPr>
+            <a:r>
+              <a:t>Third bullet</a:t>
+            </a:r>
+          </a:p>
+        </p:txBody>
+      </p:sp>
+    </p:spTree>
+  </p:cSld>
+  <p:clrMapOvr>
+    <a:masterClrMapping/>
+  </p:clrMapOvr>
+</p:sld>
+</file>
+
+<file path=ppt/slides/slide3.xml><?xml version="1.0" encoding="utf-8"?>
+<p:sld xmlns:a="http://schemas.openxmlformats.org/drawingml/2006/main" xmlns:p="http://schemas.openxmlformats.org/presentationml/2006/main" xmlns:r="http://schemas.openxmlformats.org/officeDocument/2006/relationships">
+  <p:cSld>
+    <p:spTree>
+      <p:nvGrpSpPr>
+        <p:cNvPr id="1" name=""/>
+        <p:cNvGrpSpPr/>
+        <p:nvPr/>
+      </p:nvGrpSpPr>
+      <p:grpSpPr/>
+      <p:sp>
+        <p:nvSpPr>
+          <p:cNvPr id="2" name="Title 1"/>
+          <p:cNvSpPr>
+            <a:spLocks noGrp="1"/>
+          </p:cNvSpPr>
+          <p:nvPr>
+            <p:ph type="title"/>
+          </p:nvPr>
+        </p:nvSpPr>
+        <p:spPr/>
+        <p:txBody>
+          <a:bodyPr/>
+          <a:lstStyle/>
+          <a:p>
+            <a:r>
+              <a:t>A shape</a:t>
+            </a:r>
+          </a:p>
+        </p:txBody>
+      </p:sp>
+      <p:sp>
+        <p:nvSpPr>
+          <p:cNvPr id="3" name="TextBox 2"/>
+          <p:cNvSpPr txBox="1"/>
+          <p:nvPr/>
+        </p:nvSpPr>
+        <p:spPr>
+          <a:xfrm>
+            <a:off x="914400" y="1828800"/>
+            <a:ext cx="3657600" cy="914400"/>
+          </a:xfrm>
+          <a:prstGeom prst="rect">
+            <a:avLst/>
+          </a:prstGeom>
+          <a:noFill/>
+        </p:spPr>
+        <p:txBody>
+          <a:bodyPr wrap="none">
+            <a:spAutoFit/>
+          </a:bodyPr>
+          <a:lstStyle/>
+          <a:p>
+            <a:r>
+              <a:rPr sz="2400" b="1">
+                <a:solidFill>
+                  <a:srgbClr val="C0392B"/>
+                </a:solidFill>
+              </a:rPr>
+              <a:t>Free-floating textbox</a:t>
+            </a:r>
+          </a:p>
+        </p:txBody>
+      </p:sp>
+    </p:spTree>
+  </p:cSld>
+  <p:clrMapOvr>
+    <a:masterClrMapping/>
+  </p:clrMapOvr>
+</p:sld>
+</file>
+
+<file path=ppt/slides/slide4.xml><?xml version="1.0" encoding="utf-8"?>
+<p:sld xmlns:a="http://schemas.openxmlformats.org/drawingml/2006/main" xmlns:p="http://schemas.openxmlformats.org/presentationml/2006/main" xmlns:r="http://schemas.openxmlformats.org/officeDocument/2006/relationships">
+  <p:cSld>
+    <p:spTree>
+      <p:nvGrpSpPr>
+        <p:cNvPr id="1" name=""/>
+        <p:cNvGrpSpPr/>
+        <p:nvPr/>
+      </p:nvGrpSpPr>
+      <p:grpSpPr/>
+      <p:sp>
+        <p:nvSpPr>
+          <p:cNvPr id="2" name="Title 1"/>
+          <p:cNvSpPr>
+            <a:spLocks noGrp="1"/>
+          </p:cNvSpPr>
+          <p:nvPr>
+            <p:ph type="title"/>
+          </p:nvPr>
+        </p:nvSpPr>
+        <p:spPr/>
+        <p:txBody>
+          <a:bodyPr/>
+          <a:lstStyle/>
+          <a:p>
+            <a:r>
+              <a:t>An image</a:t>
+            </a:r>
+          </a:p>
+        </p:txBody>
+      </p:sp>
+      <p:pic>
+        <p:nvPicPr>
+          <p:cNvPr id="3" name="Picture 2" descr="python-powered.png"/>
+          <p:cNvPicPr>
+            <a:picLocks noChangeAspect="1"/>
+          </p:cNvPicPr>
+          <p:nvPr/>
+        </p:nvPicPr>
+        <p:blipFill>
+          <a:blip r:embed="rId2"/>
+          <a:stretch>
+            <a:fillRect/>
+          </a:stretch>
+        </p:blipFill>
+        <p:spPr>
+          <a:xfrm>
+            <a:off x="2743200" y="1828800"/>
+            <a:ext cx="3657600" cy="1828800"/>
+          </a:xfrm>
+          <a:prstGeom prst="rect">
+            <a:avLst/>
+          </a:prstGeom>
+        </p:spPr>
+      </p:pic>
+    </p:spTree>
+  </p:cSld>
+  <p:clrMapOvr>
+    <a:masterClrMapping/>
+  </p:clrMapOvr>
+</p:sld>
+</file>
+
+<file path=ppt/slides/slide5.xml><?xml version="1.0" encoding="utf-8"?>
+<p:sld xmlns:a="http://schemas.openxmlformats.org/drawingml/2006/main" xmlns:p="http://schemas.openxmlformats.org/presentationml/2006/main" xmlns:r="http://schemas.openxmlformats.org/officeDocument/2006/relationships">
+  <p:cSld>
+    <p:bg>
+      <p:bgPr>
+        <a:solidFill>
+          <a:srgbClr val="FFF4E0"/>
+        </a:solidFill>
+        <a:effectLst/>
+      </p:bgPr>
+    </p:bg>
+    <p:spTree>
+      <p:nvGrpSpPr>
+        <p:cNvPr id="1" name=""/>
+        <p:cNvGrpSpPr/>
+        <p:nvPr/>
+      </p:nvGrpSpPr>
+      <p:grpSpPr/>
+      <p:sp>
+        <p:nvSpPr>
+          <p:cNvPr id="2" name="Title 1"/>
+          <p:cNvSpPr>
+            <a:spLocks noGrp="1"/>
+          </p:cNvSpPr>
+          <p:nvPr>
+            <p:ph type="title"/>
+          </p:nvPr>
+        </p:nvSpPr>
+        <p:spPr/>
+        <p:txBody>
+          <a:bodyPr/>
+          <a:lstStyle/>
+          <a:p>
+            <a:r>
+              <a:t>Tinted background</a:t>
+            </a:r>
+          </a:p>
+        </p:txBody>
+      </p:sp>
+    </p:spTree>
+  </p:cSld>
+  <p:clrMapOvr>
+    <a:masterClrMapping/>
+  </p:clrMapOvr>
+</p:sld>
+</file>
+
+<file path=ppt/slides/slide6.xml><?xml version="1.0" encoding="utf-8"?>
+<p:sld xmlns:a="http://schemas.openxmlformats.org/drawingml/2006/main" xmlns:p="http://schemas.openxmlformats.org/presentationml/2006/main" xmlns:r="http://schemas.openxmlformats.org/officeDocument/2006/relationships">
+  <p:cSld>
+    <p:spTree>
+      <p:nvGrpSpPr>
+        <p:cNvPr id="1" name=""/>
+        <p:cNvGrpSpPr/>
+        <p:nvPr/>
+      </p:nvGrpSpPr>
+      <p:grpSpPr/>
+      <p:sp>
+        <p:nvSpPr>
+          <p:cNvPr id="2" name="Title 1"/>
+          <p:cNvSpPr>
+            <a:spLocks noGrp="1"/>
+          </p:cNvSpPr>
+          <p:nvPr>
+            <p:ph type="title"/>
+          </p:nvPr>
+        </p:nvSpPr>
+        <p:spPr/>
+        <p:txBody>
+          <a:bodyPr/>
+          <a:lstStyle/>
+          <a:p>
+            <a:r>
+              <a:t>Filled shapes</a:t>
+            </a:r>
+          </a:p>
+        </p:txBody>
+      </p:sp>
+      <p:sp>
+        <p:nvSpPr>
+          <p:cNvPr id="3" name="Rectangle 2"/>
+          <p:cNvSpPr/>
+          <p:nvPr/>
+        </p:nvSpPr>
+        <p:spPr>
+          <a:xfrm>
+            <a:off x="914400" y="1828800"/>
+            <a:ext cx="2743200" cy="1371600"/>
+          </a:xfrm>
+          <a:prstGeom prst="rect">
+            <a:avLst/>
+          </a:prstGeom>
+          <a:solidFill>
+            <a:srgbClr val="4F81BD"/>
+          </a:solidFill>
+          <a:ln w="38100">
+            <a:solidFill>
+              <a:srgbClr val="1F497D"/>
+            </a:solidFill>
+          </a:ln>
+        </p:spPr>
+        <p:style>
+          <a:lnRef idx="1">
+            <a:schemeClr val="accent1"/>
+          </a:lnRef>
+          <a:fillRef idx="3">
+            <a:schemeClr val="accent1"/>
+          </a:fillRef>
+          <a:effectRef idx="2">
+            <a:schemeClr val="accent1"/>
+          </a:effectRef>
+          <a:fontRef idx="minor">
+            <a:schemeClr val="lt1"/>
+          </a:fontRef>
+        </p:style>
+        <p:txBody>
+          <a:bodyPr rtlCol="0" anchor="ctr"/>
+          <a:lstStyle/>
+          <a:p>
+            <a:r>
+              <a:rPr>
+                <a:solidFill>
+                  <a:srgbClr val="FFFFFF"/>
+                </a:solidFill>
+              </a:rPr>
+              <a:t>Filled + bordered</a:t>
+            </a:r>
+          </a:p>
+        </p:txBody>
+      </p:sp>
+      <p:sp>
+        <p:nvSpPr>
+          <p:cNvPr id="4" name="Rectangle 3"/>
+          <p:cNvSpPr/>
+          <p:nvPr/>
+        </p:nvSpPr>
+        <p:spPr>
+          <a:xfrm>
+            <a:off x="4572000" y="1828800"/>
+            <a:ext cx="2743200" cy="1371600"/>
+          </a:xfrm>
+          <a:prstGeom prst="rect">
+            <a:avLst/>
+          </a:prstGeom>
+          <a:noFill/>
+          <a:ln w="19050">
+            <a:solidFill>
+              <a:srgbClr val="C0504D"/>
+            </a:solidFill>
+          </a:ln>
+        </p:spPr>
+        <p:style>
+          <a:lnRef idx="1">
+            <a:schemeClr val="accent1"/>
+          </a:lnRef>
+          <a:fillRef idx="3">
+            <a:schemeClr val="accent1"/>
+          </a:fillRef>
+          <a:effectRef idx="2">
+            <a:schemeClr val="accent1"/>
+          </a:effectRef>
+          <a:fontRef idx="minor">
+            <a:schemeClr val="lt1"/>
+          </a:fontRef>
+        </p:style>
+        <p:txBody>
+          <a:bodyPr rtlCol="0" anchor="ctr"/>
+          <a:lstStyle/>
+          <a:p>
+            <a:r>
+              <a:t>Border only</a:t>
+            </a:r>
+          </a:p>
+        </p:txBody>
+      </p:sp>
+    </p:spTree>
+  </p:cSld>
+  <p:clrMapOvr>
+    <a:masterClrMapping/>
+  </p:clrMapOvr>
+</p:sld>
+</file>
+
+<file path=ppt/slides/slide7.xml><?xml version="1.0" encoding="utf-8"?>
+<p:sld xmlns:a="http://schemas.openxmlformats.org/drawingml/2006/main" xmlns:p="http://schemas.openxmlformats.org/presentationml/2006/main" xmlns:r="http://schemas.openxmlformats.org/officeDocument/2006/relationships">
+  <p:cSld>
+    <p:spTree>
+      <p:nvGrpSpPr>
+        <p:cNvPr id="1" name=""/>
+        <p:cNvGrpSpPr/>
+        <p:nvPr/>
+      </p:nvGrpSpPr>
+      <p:grpSpPr/>
+      <p:sp>
+        <p:nvSpPr>
+          <p:cNvPr id="2" name="Title 1"/>
+          <p:cNvSpPr>
+            <a:spLocks noGrp="1"/>
+          </p:cNvSpPr>
+          <p:nvPr>
+            <p:ph type="title"/>
+          </p:nvPr>
+        </p:nvSpPr>
+        <p:spPr/>
+        <p:txBody>
+          <a:bodyPr/>
+          <a:lstStyle/>
+          <a:p>
+            <a:r>
+              <a:t>Preset shapes</a:t>
+            </a:r>
+          </a:p>
+        </p:txBody>
+      </p:sp>
+      <p:sp>
+        <p:nvSpPr>
+          <p:cNvPr id="3" name="Rounded Rectangle 2"/>
+          <p:cNvSpPr/>
+          <p:nvPr/>
+        </p:nvSpPr>
+        <p:spPr>
+          <a:xfrm>
+            <a:off x="685800" y="1645920"/>
+            <a:ext cx="1828800" cy="1371600"/>
+          </a:xfrm>
+          <a:prstGeom prst="roundRect">
+            <a:avLst/>
+          </a:prstGeom>
+          <a:solidFill>
+            <a:srgbClr val="4F81BD"/>
+          </a:solidFill>
+          <a:ln>
+            <a:solidFill>
+              <a:srgbClr val="1F497D"/>
+            </a:solidFill>
+          </a:ln>
+        </p:spPr>
+        <p:style>
+          <a:lnRef idx="1">
+            <a:schemeClr val="accent1"/>
+          </a:lnRef>
+          <a:fillRef idx="3">
+            <a:schemeClr val="accent1"/>
+          </a:fillRef>
+          <a:effectRef idx="2">
+            <a:schemeClr val="accent1"/>
+          </a:effectRef>
+          <a:fontRef idx="minor">
+            <a:schemeClr val="lt1"/>
+          </a:fontRef>
+        </p:style>
+        <p:txBody>
+          <a:bodyPr rtlCol="0" anchor="ctr"/>
+          <a:lstStyle/>
+          <a:p>
+            <a:pPr algn="ctr"/>
+          </a:p>
+        </p:txBody>
+      </p:sp>
+      <p:sp>
+        <p:nvSpPr>
+          <p:cNvPr id="4" name="Diamond 3"/>
+          <p:cNvSpPr/>
+          <p:nvPr/>
+        </p:nvSpPr>
+        <p:spPr>
+          <a:xfrm>
+            <a:off x="2971800" y="1645920"/>
+            <a:ext cx="1828800" cy="1371600"/>
+          </a:xfrm>
+          <a:prstGeom prst="diamond">
+            <a:avLst/>
+          </a:prstGeom>
+          <a:solidFill>
+            <a:srgbClr val="4F81BD"/>
+          </a:solidFill>
+          <a:ln>
+            <a:solidFill>
+              <a:srgbClr val="1F497D"/>
+            </a:solidFill>
+          </a:ln>
+        </p:spPr>
+        <p:style>
+          <a:lnRef idx="1">
+            <a:schemeClr val="accent1"/>
+          </a:lnRef>
+          <a:fillRef idx="3">
+            <a:schemeClr val="accent1"/>
+          </a:fillRef>
+          <a:effectRef idx="2">
+            <a:schemeClr val="accent1"/>
+          </a:effectRef>
+          <a:fontRef idx="minor">
+            <a:schemeClr val="lt1"/>
+          </a:fontRef>
+        </p:style>
+        <p:txBody>
+          <a:bodyPr rtlCol="0" anchor="ctr"/>
+          <a:lstStyle/>
+          <a:p>
+            <a:pPr algn="ctr"/>
+          </a:p>
+        </p:txBody>
+      </p:sp>
+      <p:sp>
+        <p:nvSpPr>
+          <p:cNvPr id="5" name="Oval 4"/>
+          <p:cNvSpPr/>
+          <p:nvPr/>
+        </p:nvSpPr>
+        <p:spPr>
+          <a:xfrm>
+            <a:off x="5257800" y="1645920"/>
+            <a:ext cx="1828800" cy="1371600"/>
+          </a:xfrm>
+          <a:prstGeom prst="ellipse">
+            <a:avLst/>
+          </a:prstGeom>
+          <a:solidFill>
+            <a:srgbClr val="4F81BD"/>
+          </a:solidFill>
+          <a:ln>
+            <a:solidFill>
+              <a:srgbClr val="1F497D"/>
+            </a:solidFill>
+          </a:ln>
+        </p:spPr>
+        <p:style>
+          <a:lnRef idx="1">
+            <a:schemeClr val="accent1"/>
+          </a:lnRef>
+          <a:fillRef idx="3">
+            <a:schemeClr val="accent1"/>
+          </a:fillRef>
+          <a:effectRef idx="2">
+            <a:schemeClr val="accent1"/>
+          </a:effectRef>
+          <a:fontRef idx="minor">
+            <a:schemeClr val="lt1"/>
+          </a:fontRef>
+        </p:style>
+        <p:txBody>
+          <a:bodyPr rtlCol="0" anchor="ctr"/>
+          <a:lstStyle/>
+          <a:p>
+            <a:pPr algn="ctr"/>
+          </a:p>
+        </p:txBody>
+      </p:sp>
+      <p:sp>
+        <p:nvSpPr>
+          <p:cNvPr id="6" name="Up Arrow 5"/>
+          <p:cNvSpPr/>
+          <p:nvPr/>
+        </p:nvSpPr>
+        <p:spPr>
+          <a:xfrm>
+            <a:off x="685800" y="3474720"/>
+            <a:ext cx="1828800" cy="1371600"/>
+          </a:xfrm>
+          <a:prstGeom prst="upArrow">
+            <a:avLst/>
+          </a:prstGeom>
+          <a:solidFill>
+            <a:srgbClr val="4F81BD"/>
+          </a:solidFill>
+          <a:ln>
+            <a:solidFill>
+              <a:srgbClr val="1F497D"/>
+            </a:solidFill>
+          </a:ln>
+        </p:spPr>
+        <p:style>
+          <a:lnRef idx="1">
+            <a:schemeClr val="accent1"/>
+          </a:lnRef>
+          <a:fillRef idx="3">
+            <a:schemeClr val="accent1"/>
+          </a:fillRef>
+          <a:effectRef idx="2">
+            <a:schemeClr val="accent1"/>
+          </a:effectRef>
+          <a:fontRef idx="minor">
+            <a:schemeClr val="lt1"/>
+          </a:fontRef>
+        </p:style>
+        <p:txBody>
+          <a:bodyPr rtlCol="0" anchor="ctr"/>
+          <a:lstStyle/>
+          <a:p>
+            <a:pPr algn="ctr"/>
+          </a:p>
+        </p:txBody>
+      </p:sp>
+      <p:sp>
+        <p:nvSpPr>
+          <p:cNvPr id="7" name="5-Point Star 6"/>
+          <p:cNvSpPr/>
+          <p:nvPr/>
+        </p:nvSpPr>
+        <p:spPr>
+          <a:xfrm>
+            <a:off x="2971800" y="3474720"/>
+            <a:ext cx="1828800" cy="1371600"/>
+          </a:xfrm>
+          <a:prstGeom prst="star5">
+            <a:avLst/>
+          </a:prstGeom>
+          <a:solidFill>
+            <a:srgbClr val="4F81BD"/>
+          </a:solidFill>
+          <a:ln>
+            <a:solidFill>
+              <a:srgbClr val="1F497D"/>
+            </a:solidFill>
+          </a:ln>
+        </p:spPr>
+        <p:style>
+          <a:lnRef idx="1">
+            <a:schemeClr val="accent1"/>
+          </a:lnRef>
+          <a:fillRef idx="3">
+            <a:schemeClr val="accent1"/>
+          </a:fillRef>
+          <a:effectRef idx="2">
+            <a:schemeClr val="accent1"/>
+          </a:effectRef>
+          <a:fontRef idx="minor">
+            <a:schemeClr val="lt1"/>
+          </a:fontRef>
+        </p:style>
+        <p:txBody>
+          <a:bodyPr rtlCol="0" anchor="ctr"/>
+          <a:lstStyle/>
+          <a:p>
+            <a:pPr algn="ctr"/>
+          </a:p>
+        </p:txBody>
+      </p:sp>
+      <p:sp>
+        <p:nvSpPr>
+          <p:cNvPr id="8" name="Pentagon 7"/>
+          <p:cNvSpPr/>
+          <p:nvPr/>
+        </p:nvSpPr>
+        <p:spPr>
+          <a:xfrm>
+            <a:off x="5257800" y="3474720"/>
+            <a:ext cx="1828800" cy="1371600"/>
+          </a:xfrm>
+          <a:prstGeom prst="homePlate">
+            <a:avLst/>
+          </a:prstGeom>
+          <a:solidFill>
+            <a:srgbClr val="4F81BD"/>
+          </a:solidFill>
+          <a:ln>
+            <a:solidFill>
+              <a:srgbClr val="1F497D"/>
+            </a:solidFill>
+          </a:ln>
+        </p:spPr>
+        <p:style>
+          <a:lnRef idx="1">
+            <a:schemeClr val="accent1"/>
+          </a:lnRef>
+          <a:fillRef idx="3">
+            <a:schemeClr val="accent1"/>
+          </a:fillRef>
+          <a:effectRef idx="2">
+            <a:schemeClr val="accent1"/>
+          </a:effectRef>
+          <a:fontRef idx="minor">
+            <a:schemeClr val="lt1"/>
+          </a:fontRef>
+        </p:style>
+        <p:txBody>
+          <a:bodyPr rtlCol="0" anchor="ctr"/>
+          <a:lstStyle/>
+          <a:p>
+            <a:pPr algn="ctr"/>
+          </a:p>
+        </p:txBody>
+      </p:sp>
+    </p:spTree>
+  </p:cSld>
+  <p:clrMapOvr>
+    <a:masterClrMapping/>
+  </p:clrMapOvr>
+</p:sld>
+</file>
+
+<file path=ppt/slides/slide8.xml><?xml version="1.0" encoding="utf-8"?>
+<p:sld xmlns:a="http://schemas.openxmlformats.org/drawingml/2006/main" xmlns:p="http://schemas.openxmlformats.org/presentationml/2006/main" xmlns:r="http://schemas.openxmlformats.org/officeDocument/2006/relationships">
+  <p:cSld>
+    <p:spTree>
+      <p:nvGrpSpPr>
+        <p:cNvPr id="1" name=""/>
+        <p:cNvGrpSpPr/>
+        <p:nvPr/>
+      </p:nvGrpSpPr>
+      <p:grpSpPr/>
+      <p:sp>
+        <p:nvSpPr>
+          <p:cNvPr id="2" name="Title 1"/>
+          <p:cNvSpPr>
+            <a:spLocks noGrp="1"/>
+          </p:cNvSpPr>
+          <p:nvPr>
+            <p:ph type="title"/>
+          </p:nvPr>
+        </p:nvSpPr>
+        <p:spPr/>
+        <p:txBody>
+          <a:bodyPr/>
+          <a:lstStyle/>
+          <a:p>
+            <a:r>
+              <a:t>Rotated &amp; flipped</a:t>
+            </a:r>
+          </a:p>
+        </p:txBody>
+      </p:sp>
+      <p:sp>
+        <p:nvSpPr>
+          <p:cNvPr id="3" name="TextBox 2"/>
+          <p:cNvSpPr txBox="1"/>
+          <p:nvPr/>
+        </p:nvSpPr>
+        <p:spPr>
+          <a:xfrm rot="1800000">
+            <a:off x="914400" y="1828800"/>
+            <a:ext cx="2743200" cy="914400"/>
+          </a:xfrm>
+          <a:prstGeom prst="rect">
+            <a:avLst/>
+          </a:prstGeom>
+          <a:noFill/>
+        </p:spPr>
+        <p:txBody>
+          <a:bodyPr wrap="none">
+            <a:spAutoFit/>
+          </a:bodyPr>
+          <a:lstStyle/>
+          <a:p>
+            <a:r>
+              <a:rPr sz="2000"/>
+              <a:t>Rotated 30 degrees</a:t>
+            </a:r>
+          </a:p>
+        </p:txBody>
+      </p:sp>
+      <p:sp>
+        <p:nvSpPr>
+          <p:cNvPr id="4" name="Right Arrow 3"/>
+          <p:cNvSpPr/>
+          <p:nvPr/>
+        </p:nvSpPr>
+        <p:spPr>
+          <a:xfrm flipH="1">
+            <a:off x="4572000" y="1828800"/>
+            <a:ext cx="1828800" cy="914400"/>
+          </a:xfrm>
+          <a:prstGeom prst="rightArrow">
+            <a:avLst/>
+          </a:prstGeom>
+          <a:solidFill>
+            <a:srgbClr val="4F81BD"/>
+          </a:solidFill>
+        </p:spPr>
+        <p:style>
+          <a:lnRef idx="1">
+            <a:schemeClr val="accent1"/>
+          </a:lnRef>
+          <a:fillRef idx="3">
+            <a:schemeClr val="accent1"/>
+          </a:fillRef>
+          <a:effectRef idx="2">
+            <a:schemeClr val="accent1"/>
+          </a:effectRef>
+          <a:fontRef idx="minor">
+            <a:schemeClr val="lt1"/>
+          </a:fontRef>
+        </p:style>
+        <p:txBody>
+          <a:bodyPr rtlCol="0" anchor="ctr"/>
+          <a:lstStyle/>
+          <a:p>
+            <a:pPr algn="ctr"/>
+          </a:p>
+        </p:txBody>
+      </p:sp>
+      <p:pic>
+        <p:nvPicPr>
+          <p:cNvPr id="5" name="Picture 4" descr="python-powered.png"/>
+          <p:cNvPicPr>
+            <a:picLocks noChangeAspect="1"/>
+          </p:cNvPicPr>
+          <p:nvPr/>
+        </p:nvPicPr>
+        <p:blipFill>
+          <a:blip r:embed="rId2"/>
+          <a:stretch>
+            <a:fillRect/>
+          </a:stretch>
+        </p:blipFill>
+        <p:spPr>
+          <a:xfrm rot="2700000">
+            <a:off x="3657600" y="3657600"/>
+            <a:ext cx="1828800" cy="914400"/>
+          </a:xfrm>
+          <a:prstGeom prst="rect">
+            <a:avLst/>
+          </a:prstGeom>
+        </p:spPr>
+      </p:pic>
+    </p:spTree>
+  </p:cSld>
+  <p:clrMapOvr>
+    <a:masterClrMapping/>
+  </p:clrMapOvr>
+</p:sld>
+</file>
+
+<file path=ppt/slides/slide9.xml><?xml version="1.0" encoding="utf-8"?>
+<p:sld xmlns:a="http://schemas.openxmlformats.org/drawingml/2006/main" xmlns:p="http://schemas.openxmlformats.org/presentationml/2006/main" xmlns:r="http://schemas.openxmlformats.org/officeDocument/2006/relationships">
+  <p:cSld>
+    <p:spTree>
+      <p:nvGrpSpPr>
+        <p:cNvPr id="1" name=""/>
+        <p:cNvGrpSpPr/>
+        <p:nvPr/>
+      </p:nvGrpSpPr>
+      <p:grpSpPr/>
+      <p:sp>
+        <p:nvSpPr>
+          <p:cNvPr id="2" name="Title 1"/>
+          <p:cNvSpPr>
+            <a:spLocks noGrp="1"/>
+          </p:cNvSpPr>
+          <p:nvPr>
+            <p:ph type="title"/>
+          </p:nvPr>
+        </p:nvSpPr>
+        <p:spPr/>
+        <p:txBody>
+          <a:bodyPr/>
+          <a:lstStyle/>
+          <a:p>
+            <a:r>
+              <a:t>Effects</a:t>
+            </a:r>
+          </a:p>
+        </p:txBody>
+      </p:sp>
+      <p:sp>
+        <p:nvSpPr>
+          <p:cNvPr id="3" name="Rectangle 2"/>
+          <p:cNvSpPr/>
+          <p:nvPr/>
+        </p:nvSpPr>
+        <p:spPr>
+          <a:xfrm>
+            <a:off x="685800" y="1828800"/>
+            <a:ext cx="2286000" cy="1097280"/>
+          </a:xfrm>
+          <a:prstGeom prst="rect">
+            <a:avLst/>
+          </a:prstGeom>
+          <a:solidFill>
+            <a:srgbClr val="4F81BD"/>
+          </a:solidFill>
+          <a:effectLst>
+            <a:outerShdw blurRad="50800" dist="38100" dir="2700000" algn="tl" rotWithShape="0">
+              <a:srgbClr val="000000">
+                <a:alpha val="50000"/>
+              </a:srgbClr>
+            </a:outerShdw>
+          </a:effectLst>
+        </p:spPr>
+        <p:style>
+          <a:lnRef idx="1">
+            <a:schemeClr val="accent1"/>
+          </a:lnRef>
+          <a:fillRef idx="3">
+            <a:schemeClr val="accent1"/>
+          </a:fillRef>
+          <a:effectRef idx="2">
+            <a:schemeClr val="accent1"/>
+          </a:effectRef>
+          <a:fontRef idx="minor">
+            <a:schemeClr val="lt1"/>
+          </a:fontRef>
+        </p:style>
+        <p:txBody>
+          <a:bodyPr rtlCol="0" anchor="ctr"/>
+          <a:lstStyle/>
+          <a:p>
+            <a:r>
+              <a:rPr>
+                <a:solidFill>
+                  <a:srgbClr val="FFFFFF"/>
+                </a:solidFill>
+              </a:rPr>
+              <a:t>Outer shadow</a:t>
+            </a:r>
+          </a:p>
+        </p:txBody>
+      </p:sp>
+      <p:sp>
+        <p:nvSpPr>
+          <p:cNvPr id="4" name="Rectangle 3"/>
+          <p:cNvSpPr/>
+          <p:nvPr/>
+        </p:nvSpPr>
+        <p:spPr>
+          <a:xfrm>
+            <a:off x="3657600" y="1828800"/>
+            <a:ext cx="2286000" cy="1097280"/>
+          </a:xfrm>
+          <a:prstGeom prst="rect">
+            <a:avLst/>
+          </a:prstGeom>
+          <a:solidFill>
+            <a:srgbClr val="FFFFFF"/>
+          </a:solidFill>
+          <a:ln>
+            <a:solidFill>
+              <a:srgbClr val="009966"/>
+            </a:solidFill>
+          </a:ln>
+          <a:effectLst>
+            <a:glow rad="63500">
+              <a:srgbClr val="00CC66">
+                <a:alpha val="60000"/>
+              </a:srgbClr>
+            </a:glow>
+          </a:effectLst>
+        </p:spPr>
+        <p:style>
+          <a:lnRef idx="1">
+            <a:schemeClr val="accent1"/>
+          </a:lnRef>
+          <a:fillRef idx="3">
+            <a:schemeClr val="accent1"/>
+          </a:fillRef>
+          <a:effectRef idx="2">
+            <a:schemeClr val="accent1"/>
+          </a:effectRef>
+          <a:fontRef idx="minor">
+            <a:schemeClr val="lt1"/>
+          </a:fontRef>
+        </p:style>
+        <p:txBody>
+          <a:bodyPr rtlCol="0" anchor="ctr"/>
+          <a:lstStyle/>
+          <a:p>
+            <a:r>
+              <a:t>Glow</a:t>
+            </a:r>
+          </a:p>
+        </p:txBody>
+      </p:sp>
+      <p:sp>
+        <p:nvSpPr>
+          <p:cNvPr id="5" name="Rectangle 4"/>
+          <p:cNvSpPr/>
+          <p:nvPr/>
+        </p:nvSpPr>
+        <p:spPr>
+          <a:xfrm>
+            <a:off x="6629400" y="1828800"/>
+            <a:ext cx="2286000" cy="1097280"/>
+          </a:xfrm>
+          <a:prstGeom prst="rect">
+            <a:avLst/>
+          </a:prstGeom>
+          <a:solidFill>
+            <a:srgbClr val="D9436E"/>
+          </a:solidFill>
+          <a:effectLst>
+            <a:blur rad="38100" grow="1"/>
+          </a:effectLst>
+        </p:spPr>
+        <p:style>
+          <a:lnRef idx="1">
+            <a:schemeClr val="accent1"/>
+          </a:lnRef>
+          <a:fillRef idx="3">
+            <a:schemeClr val="accent1"/>
+          </a:fillRef>
+          <a:effectRef idx="2">
+            <a:schemeClr val="accent1"/>
+          </a:effectRef>
+          <a:fontRef idx="minor">
+            <a:schemeClr val="lt1"/>
+          </a:fontRef>
+        </p:style>
+        <p:txBody>
+          <a:bodyPr rtlCol="0" anchor="ctr"/>
+          <a:lstStyle/>
+          <a:p>
+            <a:r>
+              <a:rPr>
+                <a:solidFill>
+                  <a:srgbClr val="FFFFFF"/>
+                </a:solidFill>
+              </a:rPr>
+              <a:t>Blur</a:t>
+            </a:r>
+          </a:p>
+        </p:txBody>
+      </p:sp>
+      <p:sp>
+        <p:nvSpPr>
+          <p:cNvPr id="6" name="Rectangle 5"/>
+          <p:cNvSpPr/>
+          <p:nvPr/>
+        </p:nvSpPr>
+        <p:spPr>
+          <a:xfrm>
+            <a:off x="685800" y="3657600"/>
+            <a:ext cx="2286000" cy="1097280"/>
+          </a:xfrm>
+          <a:prstGeom prst="rect">
+            <a:avLst/>
+          </a:prstGeom>
+          <a:solidFill>
+            <a:srgbClr val="F2F2F2"/>
+          </a:solidFill>
+          <a:effectLst>
+            <a:innerShdw blurRad="63500" dist="25400" dir="13500000">
+              <a:srgbClr val="000000">
+                <a:alpha val="60000"/>
+              </a:srgbClr>
+            </a:innerShdw>
+          </a:effectLst>
+        </p:spPr>
+        <p:style>
+          <a:lnRef idx="1">
+            <a:schemeClr val="accent1"/>
+          </a:lnRef>
+          <a:fillRef idx="3">
+            <a:schemeClr val="accent1"/>
+          </a:fillRef>
+          <a:effectRef idx="2">
+            <a:schemeClr val="accent1"/>
+          </a:effectRef>
+          <a:fontRef idx="minor">
+            <a:schemeClr val="lt1"/>
+          </a:fontRef>
+        </p:style>
+        <p:txBody>
+          <a:bodyPr rtlCol="0" anchor="ctr"/>
+          <a:lstStyle/>
+          <a:p>
+            <a:r>
+              <a:t>Inner shadow</a:t>
+            </a:r>
+          </a:p>
+        </p:txBody>
+      </p:sp>
+      <p:sp>
+        <p:nvSpPr>
+          <p:cNvPr id="7" name="Rectangle 6"/>
+          <p:cNvSpPr/>
+          <p:nvPr/>
+        </p:nvSpPr>
+        <p:spPr>
+          <a:xfrm>
+            <a:off x="3657600" y="3657600"/>
+            <a:ext cx="2286000" cy="1097280"/>
+          </a:xfrm>
+          <a:prstGeom prst="rect">
+            <a:avLst/>
+          </a:prstGeom>
+          <a:solidFill>
+            <a:srgbClr val="F79646"/>
+          </a:solidFill>
+          <a:effectLst>
+            <a:softEdge rad="50800"/>
+          </a:effectLst>
+        </p:spPr>
+        <p:style>
+          <a:lnRef idx="1">
+            <a:schemeClr val="accent1"/>
+          </a:lnRef>
+          <a:fillRef idx="3">
+            <a:schemeClr val="accent1"/>
+          </a:fillRef>
+          <a:effectRef idx="2">
+            <a:schemeClr val="accent1"/>
+          </a:effectRef>
+          <a:fontRef idx="minor">
+            <a:schemeClr val="lt1"/>
+          </a:fontRef>
+        </p:style>
+        <p:txBody>
+          <a:bodyPr rtlCol="0" anchor="ctr"/>
+          <a:lstStyle/>
+          <a:p>
+            <a:r>
+              <a:t>Soft edge</a:t>
+            </a:r>
+          </a:p>
+        </p:txBody>
+      </p:sp>
+      <p:sp>
+        <p:nvSpPr>
+          <p:cNvPr id="8" name="Rectangle 7"/>
+          <p:cNvSpPr/>
+          <p:nvPr/>
+        </p:nvSpPr>
+        <p:spPr>
+          <a:xfrm>
+            <a:off x="6629400" y="3657600"/>
+            <a:ext cx="2286000" cy="1097280"/>
+          </a:xfrm>
+          <a:prstGeom prst="rect">
+            <a:avLst/>
+          </a:prstGeom>
+          <a:solidFill>
+            <a:srgbClr val="4F81BD"/>
+          </a:solidFill>
+          <a:effectLst>
+            <a:reflection blurRad="6350" stA="50000" stPos="0" endA="300" endPos="50000" dist="38100" dir="5400000" sy="-100000" algn="bl" rotWithShape="0"/>
+          </a:effectLst>
+        </p:spPr>
+        <p:style>
+          <a:lnRef idx="1">
+            <a:schemeClr val="accent1"/>
+          </a:lnRef>
+          <a:fillRef idx="3">
+            <a:schemeClr val="accent1"/>
+          </a:fillRef>
+          <a:effectRef idx="2">
+            <a:schemeClr val="accent1"/>
+          </a:effectRef>
+          <a:fontRef idx="minor">
+            <a:schemeClr val="lt1"/>
+          </a:fontRef>
+        </p:style>
+        <p:txBody>
+          <a:bodyPr rtlCol="0" anchor="ctr"/>
+          <a:lstStyle/>
+          <a:p>
+            <a:r>
+              <a:rPr>
+                <a:solidFill>
+                  <a:srgbClr val="FFFFFF"/>
+                </a:solidFill>
+              </a:rPr>
+              <a:t>Reflection</a:t>
+            </a:r>
+          </a:p>
+        </p:txBody>
+      </p:sp>
     </p:spTree>
   </p:cSld>
   <p:clrMapOvr>

</xml_diff>

<commit_message>
feat(line): dash styles + caps/joins + arrow heads on shape strokes
Shape borders now honour <a:prstDash> (mapped to CSS border-style or
SVG stroke-dasharray). SVG paths emit stroke-linecap/linejoin from
<a:ln cap=...>. <a:headEnd>/<a:tailEnd> produce inline SVG markers
scaled per the w/len hints. Connector lines with arrow heads now
render via SVG instead of the background-band fallback so markers
survive.

Co-Authored-By: Claude Opus 4.7 (1M context) <noreply@anthropic.com>
</commit_message>
<xml_diff>
--- a/tests/render-test/basic/presentation.pptx
+++ b/tests/render-test/basic/presentation.pptx
@@ -12,6 +12,16 @@
     <p:sldId id="260" r:id="rId12"/>
     <p:sldId id="261" r:id="rId13"/>
     <p:sldId id="262" r:id="rId14"/>
+    <p:sldId id="263" r:id="rId15"/>
+    <p:sldId id="264" r:id="rId16"/>
+    <p:sldId id="265" r:id="rId17"/>
+    <p:sldId id="266" r:id="rId18"/>
+    <p:sldId id="267" r:id="rId19"/>
+    <p:sldId id="268" r:id="rId20"/>
+    <p:sldId id="269" r:id="rId21"/>
+    <p:sldId id="270" r:id="rId22"/>
+    <p:sldId id="271" r:id="rId23"/>
+    <p:sldId id="272" r:id="rId24" show="0"/>
   </p:sldIdLst>
   <p:sldSz cx="9144000" cy="6858000" type="screen4x3"/>
   <p:notesSz cx="6858000" cy="9144000"/>
@@ -117,6 +127,116 @@
 <p:cmAuthorLst xmlns:p="http://schemas.openxmlformats.org/presentationml/2006/main">
   <p:cmAuthor id="0" name="Fixture Author" initials="FA" lastIdx="1" clrIdx="0"/>
 </p:cmAuthorLst>
+</file>
+
+<file path=ppt/charts/chart1.xml><?xml version="1.0" encoding="utf-8"?>
+<c:chartSpace xmlns:c="http://schemas.openxmlformats.org/drawingml/2006/chart" xmlns:a="http://schemas.openxmlformats.org/drawingml/2006/main" xmlns:r="http://schemas.openxmlformats.org/officeDocument/2006/relationships">
+  <c:date1904 val="0"/>
+  <c:chart>
+    <c:autoTitleDeleted val="0"/>
+    <c:plotArea>
+      <c:barChart>
+        <c:barDir val="col"/>
+        <c:grouping val="clustered"/>
+        <c:ser>
+          <c:idx val="0"/>
+          <c:order val="0"/>
+          <c:tx>
+            <c:strRef>
+              <c:f>Sheet1!$B$1</c:f>
+              <c:strCache>
+                <c:ptCount val="1"/>
+                <c:pt idx="0">
+                  <c:v>Series 1</c:v>
+                </c:pt>
+              </c:strCache>
+            </c:strRef>
+          </c:tx>
+          <c:cat>
+            <c:strRef>
+              <c:f>Sheet1!$A$2:$A$4</c:f>
+              <c:strCache>
+                <c:ptCount val="3"/>
+                <c:pt idx="0">
+                  <c:v>A</c:v>
+                </c:pt>
+                <c:pt idx="1">
+                  <c:v>B</c:v>
+                </c:pt>
+                <c:pt idx="2">
+                  <c:v>C</c:v>
+                </c:pt>
+              </c:strCache>
+            </c:strRef>
+          </c:cat>
+          <c:val>
+            <c:numRef>
+              <c:f>Sheet1!$B$2:$B$4</c:f>
+              <c:numCache>
+                <c:formatCode>General</c:formatCode>
+                <c:ptCount val="3"/>
+                <c:pt idx="0">
+                  <c:v>1</c:v>
+                </c:pt>
+                <c:pt idx="1">
+                  <c:v>2</c:v>
+                </c:pt>
+                <c:pt idx="2">
+                  <c:v>3</c:v>
+                </c:pt>
+              </c:numCache>
+            </c:numRef>
+          </c:val>
+        </c:ser>
+        <c:axId val="-2068027336"/>
+        <c:axId val="-2113994440"/>
+      </c:barChart>
+      <c:catAx>
+        <c:axId val="-2068027336"/>
+        <c:scaling>
+          <c:orientation val="minMax"/>
+        </c:scaling>
+        <c:delete val="0"/>
+        <c:axPos val="b"/>
+        <c:majorTickMark val="out"/>
+        <c:minorTickMark val="none"/>
+        <c:tickLblPos val="nextTo"/>
+        <c:crossAx val="-2113994440"/>
+        <c:crosses val="autoZero"/>
+        <c:auto val="1"/>
+        <c:lblAlgn val="ctr"/>
+        <c:lblOffset val="100"/>
+        <c:noMultiLvlLbl val="0"/>
+      </c:catAx>
+      <c:valAx>
+        <c:axId val="-2113994440"/>
+        <c:scaling/>
+        <c:delete val="0"/>
+        <c:axPos val="l"/>
+        <c:majorGridlines/>
+        <c:majorTickMark val="out"/>
+        <c:minorTickMark val="none"/>
+        <c:tickLblPos val="nextTo"/>
+        <c:crossAx val="-2068027336"/>
+        <c:crosses val="autoZero"/>
+      </c:valAx>
+    </c:plotArea>
+    <c:dispBlanksAs val="gap"/>
+  </c:chart>
+  <c:txPr>
+    <a:bodyPr/>
+    <a:lstStyle/>
+    <a:p>
+      <a:pPr>
+        <a:defRPr sz="1800"/>
+      </a:pPr>
+      <a:endParaRPr lang="en-US"/>
+    </a:p>
+  </c:txPr>
+  <c:externalData r:id="rId1">
+    <c:autoUpdate val="0"/>
+  </c:externalData>
+</c:chartSpace>
 </file>
 
 <file path=ppt/comments/comment1.xml><?xml version="1.0" encoding="utf-8"?>
@@ -3584,7 +3704,7 @@
 </p:sld>
 </file>
 
-<file path=ppt/slides/slide2.xml><?xml version="1.0" encoding="utf-8"?>
+<file path=ppt/slides/slide10.xml><?xml version="1.0" encoding="utf-8"?>
 <p:sld xmlns:a="http://schemas.openxmlformats.org/drawingml/2006/main" xmlns:p="http://schemas.openxmlformats.org/presentationml/2006/main" xmlns:r="http://schemas.openxmlformats.org/officeDocument/2006/relationships">
   <p:cSld>
     <p:spTree>
@@ -3610,155 +3730,7 @@
           <a:lstStyle/>
           <a:p>
             <a:r>
-              <a:t>Bullet points</a:t>
-            </a:r>
-          </a:p>
-        </p:txBody>
-      </p:sp>
-      <p:sp>
-        <p:nvSpPr>
-          <p:cNvPr id="3" name="Content Placeholder 2"/>
-          <p:cNvSpPr>
-            <a:spLocks noGrp="1"/>
-          </p:cNvSpPr>
-          <p:nvPr>
-            <p:ph idx="1"/>
-          </p:nvPr>
-        </p:nvSpPr>
-        <p:spPr/>
-        <p:txBody>
-          <a:bodyPr/>
-          <a:lstStyle/>
-          <a:p>
-            <a:r>
-              <a:t>First bullet</a:t>
-            </a:r>
-          </a:p>
-          <a:p>
-            <a:pPr>
-              <a:defRPr sz="1800"/>
-            </a:pPr>
-            <a:r>
-              <a:t>Second bullet</a:t>
-            </a:r>
-          </a:p>
-          <a:p>
-            <a:pPr>
-              <a:defRPr sz="1800"/>
-            </a:pPr>
-            <a:r>
-              <a:t>Third bullet</a:t>
-            </a:r>
-          </a:p>
-        </p:txBody>
-      </p:sp>
-    </p:spTree>
-  </p:cSld>
-  <p:clrMapOvr>
-    <a:masterClrMapping/>
-  </p:clrMapOvr>
-</p:sld>
-</file>
-
-<file path=ppt/slides/slide3.xml><?xml version="1.0" encoding="utf-8"?>
-<p:sld xmlns:a="http://schemas.openxmlformats.org/drawingml/2006/main" xmlns:p="http://schemas.openxmlformats.org/presentationml/2006/main" xmlns:r="http://schemas.openxmlformats.org/officeDocument/2006/relationships">
-  <p:cSld>
-    <p:spTree>
-      <p:nvGrpSpPr>
-        <p:cNvPr id="1" name=""/>
-        <p:cNvGrpSpPr/>
-        <p:nvPr/>
-      </p:nvGrpSpPr>
-      <p:grpSpPr/>
-      <p:sp>
-        <p:nvSpPr>
-          <p:cNvPr id="2" name="Title 1"/>
-          <p:cNvSpPr>
-            <a:spLocks noGrp="1"/>
-          </p:cNvSpPr>
-          <p:nvPr>
-            <p:ph type="title"/>
-          </p:nvPr>
-        </p:nvSpPr>
-        <p:spPr/>
-        <p:txBody>
-          <a:bodyPr/>
-          <a:lstStyle/>
-          <a:p>
-            <a:r>
-              <a:t>A shape</a:t>
-            </a:r>
-          </a:p>
-        </p:txBody>
-      </p:sp>
-      <p:sp>
-        <p:nvSpPr>
-          <p:cNvPr id="3" name="TextBox 2"/>
-          <p:cNvSpPr txBox="1"/>
-          <p:nvPr/>
-        </p:nvSpPr>
-        <p:spPr>
-          <a:xfrm>
-            <a:off x="914400" y="1828800"/>
-            <a:ext cx="3657600" cy="914400"/>
-          </a:xfrm>
-          <a:prstGeom prst="rect">
-            <a:avLst/>
-          </a:prstGeom>
-          <a:noFill/>
-        </p:spPr>
-        <p:txBody>
-          <a:bodyPr wrap="none">
-            <a:spAutoFit/>
-          </a:bodyPr>
-          <a:lstStyle/>
-          <a:p>
-            <a:r>
-              <a:rPr sz="2400" b="1">
-                <a:solidFill>
-                  <a:srgbClr val="C0392B"/>
-                </a:solidFill>
-              </a:rPr>
-              <a:t>Free-floating textbox</a:t>
-            </a:r>
-          </a:p>
-        </p:txBody>
-      </p:sp>
-    </p:spTree>
-  </p:cSld>
-  <p:clrMapOvr>
-    <a:masterClrMapping/>
-  </p:clrMapOvr>
-</p:sld>
-</file>
-
-<file path=ppt/slides/slide4.xml><?xml version="1.0" encoding="utf-8"?>
-<p:sld xmlns:a="http://schemas.openxmlformats.org/drawingml/2006/main" xmlns:p="http://schemas.openxmlformats.org/presentationml/2006/main" xmlns:r="http://schemas.openxmlformats.org/officeDocument/2006/relationships">
-  <p:cSld>
-    <p:spTree>
-      <p:nvGrpSpPr>
-        <p:cNvPr id="1" name=""/>
-        <p:cNvGrpSpPr/>
-        <p:nvPr/>
-      </p:nvGrpSpPr>
-      <p:grpSpPr/>
-      <p:sp>
-        <p:nvSpPr>
-          <p:cNvPr id="2" name="Title 1"/>
-          <p:cNvSpPr>
-            <a:spLocks noGrp="1"/>
-          </p:cNvSpPr>
-          <p:nvPr>
-            <p:ph type="title"/>
-          </p:nvPr>
-        </p:nvSpPr>
-        <p:spPr/>
-        <p:txBody>
-          <a:bodyPr/>
-          <a:lstStyle/>
-          <a:p>
-            <a:r>
-              <a:t>An image</a:t>
+              <a:t>Image adjustments</a:t>
             </a:r>
           </a:p>
         </p:txBody>
@@ -3772,6 +3744,7 @@
           <p:nvPr/>
         </p:nvPicPr>
         <p:blipFill>
+          <a:srcRect l="20000" t="10000" r="20000" b="10000"/>
           <a:blip r:embed="rId2"/>
           <a:stretch>
             <a:fillRect/>
@@ -3779,8 +3752,141 @@
         </p:blipFill>
         <p:spPr>
           <a:xfrm>
-            <a:off x="2743200" y="1828800"/>
-            <a:ext cx="3657600" cy="1828800"/>
+            <a:off x="457200" y="1645920"/>
+            <a:ext cx="2286000" cy="1645920"/>
+          </a:xfrm>
+          <a:prstGeom prst="rect">
+            <a:avLst/>
+          </a:prstGeom>
+        </p:spPr>
+      </p:pic>
+      <p:pic>
+        <p:nvPicPr>
+          <p:cNvPr id="4" name="Picture 3" descr="python-powered.png"/>
+          <p:cNvPicPr>
+            <a:picLocks noChangeAspect="1"/>
+          </p:cNvPicPr>
+          <p:nvPr/>
+        </p:nvPicPr>
+        <p:blipFill>
+          <a:blip r:embed="rId2">
+            <a:grayscl/>
+          </a:blip>
+          <a:stretch>
+            <a:fillRect/>
+          </a:stretch>
+        </p:blipFill>
+        <p:spPr>
+          <a:xfrm>
+            <a:off x="3017520" y="1645920"/>
+            <a:ext cx="2286000" cy="1645920"/>
+          </a:xfrm>
+          <a:prstGeom prst="rect">
+            <a:avLst/>
+          </a:prstGeom>
+        </p:spPr>
+      </p:pic>
+      <p:pic>
+        <p:nvPicPr>
+          <p:cNvPr id="5" name="Picture 4" descr="python-powered.png"/>
+          <p:cNvPicPr>
+            <a:picLocks noChangeAspect="1"/>
+          </p:cNvPicPr>
+          <p:nvPr/>
+        </p:nvPicPr>
+        <p:blipFill>
+          <a:blip r:embed="rId2">
+            <a:lum bright="20000" contrast="30000"/>
+          </a:blip>
+          <a:stretch>
+            <a:fillRect/>
+          </a:stretch>
+        </p:blipFill>
+        <p:spPr>
+          <a:xfrm>
+            <a:off x="5577840" y="1645920"/>
+            <a:ext cx="2286000" cy="1645920"/>
+          </a:xfrm>
+          <a:prstGeom prst="rect">
+            <a:avLst/>
+          </a:prstGeom>
+        </p:spPr>
+      </p:pic>
+      <p:pic>
+        <p:nvPicPr>
+          <p:cNvPr id="6" name="Picture 5" descr="python-powered.png"/>
+          <p:cNvPicPr>
+            <a:picLocks noChangeAspect="1"/>
+          </p:cNvPicPr>
+          <p:nvPr/>
+        </p:nvPicPr>
+        <p:blipFill>
+          <a:blip r:embed="rId2">
+            <a:alphaModFix amt="50000"/>
+          </a:blip>
+          <a:stretch>
+            <a:fillRect/>
+          </a:stretch>
+        </p:blipFill>
+        <p:spPr>
+          <a:xfrm>
+            <a:off x="457200" y="3840480"/>
+            <a:ext cx="2286000" cy="1645920"/>
+          </a:xfrm>
+          <a:prstGeom prst="rect">
+            <a:avLst/>
+          </a:prstGeom>
+        </p:spPr>
+      </p:pic>
+      <p:pic>
+        <p:nvPicPr>
+          <p:cNvPr id="7" name="Picture 6" descr="python-powered.png"/>
+          <p:cNvPicPr>
+            <a:picLocks noChangeAspect="1"/>
+          </p:cNvPicPr>
+          <p:nvPr/>
+        </p:nvPicPr>
+        <p:blipFill>
+          <a:blip r:embed="rId2">
+            <a:biLevel thresh="50000"/>
+          </a:blip>
+          <a:stretch>
+            <a:fillRect/>
+          </a:stretch>
+        </p:blipFill>
+        <p:spPr>
+          <a:xfrm>
+            <a:off x="3017520" y="3840480"/>
+            <a:ext cx="2286000" cy="1645920"/>
+          </a:xfrm>
+          <a:prstGeom prst="rect">
+            <a:avLst/>
+          </a:prstGeom>
+        </p:spPr>
+      </p:pic>
+      <p:pic>
+        <p:nvPicPr>
+          <p:cNvPr id="8" name="Picture 7" descr="python-powered.png"/>
+          <p:cNvPicPr>
+            <a:picLocks noChangeAspect="1"/>
+          </p:cNvPicPr>
+          <p:nvPr/>
+        </p:nvPicPr>
+        <p:blipFill>
+          <a:blip r:embed="rId2">
+            <a:duotone>
+              <a:srgbClr val="1F3A93"/>
+              <a:srgbClr val="FFD9B3"/>
+            </a:duotone>
+          </a:blip>
+          <a:stretch>
+            <a:fillRect/>
+          </a:stretch>
+        </p:blipFill>
+        <p:spPr>
+          <a:xfrm>
+            <a:off x="5577840" y="3840480"/>
+            <a:ext cx="2286000" cy="1645920"/>
           </a:xfrm>
           <a:prstGeom prst="rect">
             <a:avLst/>
@@ -3795,190 +3901,7 @@
 </p:sld>
 </file>
 
-<file path=ppt/slides/slide5.xml><?xml version="1.0" encoding="utf-8"?>
-<p:sld xmlns:a="http://schemas.openxmlformats.org/drawingml/2006/main" xmlns:p="http://schemas.openxmlformats.org/presentationml/2006/main" xmlns:r="http://schemas.openxmlformats.org/officeDocument/2006/relationships">
-  <p:cSld>
-    <p:bg>
-      <p:bgPr>
-        <a:solidFill>
-          <a:srgbClr val="FFF4E0"/>
-        </a:solidFill>
-        <a:effectLst/>
-      </p:bgPr>
-    </p:bg>
-    <p:spTree>
-      <p:nvGrpSpPr>
-        <p:cNvPr id="1" name=""/>
-        <p:cNvGrpSpPr/>
-        <p:nvPr/>
-      </p:nvGrpSpPr>
-      <p:grpSpPr/>
-      <p:sp>
-        <p:nvSpPr>
-          <p:cNvPr id="2" name="Title 1"/>
-          <p:cNvSpPr>
-            <a:spLocks noGrp="1"/>
-          </p:cNvSpPr>
-          <p:nvPr>
-            <p:ph type="title"/>
-          </p:nvPr>
-        </p:nvSpPr>
-        <p:spPr/>
-        <p:txBody>
-          <a:bodyPr/>
-          <a:lstStyle/>
-          <a:p>
-            <a:r>
-              <a:t>Tinted background</a:t>
-            </a:r>
-          </a:p>
-        </p:txBody>
-      </p:sp>
-    </p:spTree>
-  </p:cSld>
-  <p:clrMapOvr>
-    <a:masterClrMapping/>
-  </p:clrMapOvr>
-</p:sld>
-</file>
-
-<file path=ppt/slides/slide6.xml><?xml version="1.0" encoding="utf-8"?>
-<p:sld xmlns:a="http://schemas.openxmlformats.org/drawingml/2006/main" xmlns:p="http://schemas.openxmlformats.org/presentationml/2006/main" xmlns:r="http://schemas.openxmlformats.org/officeDocument/2006/relationships">
-  <p:cSld>
-    <p:spTree>
-      <p:nvGrpSpPr>
-        <p:cNvPr id="1" name=""/>
-        <p:cNvGrpSpPr/>
-        <p:nvPr/>
-      </p:nvGrpSpPr>
-      <p:grpSpPr/>
-      <p:sp>
-        <p:nvSpPr>
-          <p:cNvPr id="2" name="Title 1"/>
-          <p:cNvSpPr>
-            <a:spLocks noGrp="1"/>
-          </p:cNvSpPr>
-          <p:nvPr>
-            <p:ph type="title"/>
-          </p:nvPr>
-        </p:nvSpPr>
-        <p:spPr/>
-        <p:txBody>
-          <a:bodyPr/>
-          <a:lstStyle/>
-          <a:p>
-            <a:r>
-              <a:t>Filled shapes</a:t>
-            </a:r>
-          </a:p>
-        </p:txBody>
-      </p:sp>
-      <p:sp>
-        <p:nvSpPr>
-          <p:cNvPr id="3" name="Rectangle 2"/>
-          <p:cNvSpPr/>
-          <p:nvPr/>
-        </p:nvSpPr>
-        <p:spPr>
-          <a:xfrm>
-            <a:off x="914400" y="1828800"/>
-            <a:ext cx="2743200" cy="1371600"/>
-          </a:xfrm>
-          <a:prstGeom prst="rect">
-            <a:avLst/>
-          </a:prstGeom>
-          <a:solidFill>
-            <a:srgbClr val="4F81BD"/>
-          </a:solidFill>
-          <a:ln w="38100">
-            <a:solidFill>
-              <a:srgbClr val="1F497D"/>
-            </a:solidFill>
-          </a:ln>
-        </p:spPr>
-        <p:style>
-          <a:lnRef idx="1">
-            <a:schemeClr val="accent1"/>
-          </a:lnRef>
-          <a:fillRef idx="3">
-            <a:schemeClr val="accent1"/>
-          </a:fillRef>
-          <a:effectRef idx="2">
-            <a:schemeClr val="accent1"/>
-          </a:effectRef>
-          <a:fontRef idx="minor">
-            <a:schemeClr val="lt1"/>
-          </a:fontRef>
-        </p:style>
-        <p:txBody>
-          <a:bodyPr rtlCol="0" anchor="ctr"/>
-          <a:lstStyle/>
-          <a:p>
-            <a:r>
-              <a:rPr>
-                <a:solidFill>
-                  <a:srgbClr val="FFFFFF"/>
-                </a:solidFill>
-              </a:rPr>
-              <a:t>Filled + bordered</a:t>
-            </a:r>
-          </a:p>
-        </p:txBody>
-      </p:sp>
-      <p:sp>
-        <p:nvSpPr>
-          <p:cNvPr id="4" name="Rectangle 3"/>
-          <p:cNvSpPr/>
-          <p:nvPr/>
-        </p:nvSpPr>
-        <p:spPr>
-          <a:xfrm>
-            <a:off x="4572000" y="1828800"/>
-            <a:ext cx="2743200" cy="1371600"/>
-          </a:xfrm>
-          <a:prstGeom prst="rect">
-            <a:avLst/>
-          </a:prstGeom>
-          <a:noFill/>
-          <a:ln w="19050">
-            <a:solidFill>
-              <a:srgbClr val="C0504D"/>
-            </a:solidFill>
-          </a:ln>
-        </p:spPr>
-        <p:style>
-          <a:lnRef idx="1">
-            <a:schemeClr val="accent1"/>
-          </a:lnRef>
-          <a:fillRef idx="3">
-            <a:schemeClr val="accent1"/>
-          </a:fillRef>
-          <a:effectRef idx="2">
-            <a:schemeClr val="accent1"/>
-          </a:effectRef>
-          <a:fontRef idx="minor">
-            <a:schemeClr val="lt1"/>
-          </a:fontRef>
-        </p:style>
-        <p:txBody>
-          <a:bodyPr rtlCol="0" anchor="ctr"/>
-          <a:lstStyle/>
-          <a:p>
-            <a:r>
-              <a:t>Border only</a:t>
-            </a:r>
-          </a:p>
-        </p:txBody>
-      </p:sp>
-    </p:spTree>
-  </p:cSld>
-  <p:clrMapOvr>
-    <a:masterClrMapping/>
-  </p:clrMapOvr>
-</p:sld>
-</file>
-
-<file path=ppt/slides/slide7.xml><?xml version="1.0" encoding="utf-8"?>
+<file path=ppt/slides/slide11.xml><?xml version="1.0" encoding="utf-8"?>
 <p:sld xmlns:a="http://schemas.openxmlformats.org/drawingml/2006/main" xmlns:p="http://schemas.openxmlformats.org/presentationml/2006/main" xmlns:r="http://schemas.openxmlformats.org/officeDocument/2006/relationships">
   <p:cSld>
     <p:spTree>
@@ -4150,6 +4073,1953 @@
           </a:graphicData>
         </a:graphic>
       </p:graphicFrame>
+    </p:spTree>
+  </p:cSld>
+  <p:clrMapOvr>
+    <a:masterClrMapping/>
+  </p:clrMapOvr>
+</p:sld>
+</file>
+
+<file path=ppt/slides/slide12.xml><?xml version="1.0" encoding="utf-8"?>
+<p:sld xmlns:a="http://schemas.openxmlformats.org/drawingml/2006/main" xmlns:p="http://schemas.openxmlformats.org/presentationml/2006/main" xmlns:r="http://schemas.openxmlformats.org/officeDocument/2006/relationships">
+  <p:cSld>
+    <p:spTree>
+      <p:nvGrpSpPr>
+        <p:cNvPr id="1" name=""/>
+        <p:cNvGrpSpPr/>
+        <p:nvPr/>
+      </p:nvGrpSpPr>
+      <p:grpSpPr/>
+      <p:sp>
+        <p:nvSpPr>
+          <p:cNvPr id="2" name="Title 1"/>
+          <p:cNvSpPr>
+            <a:spLocks noGrp="1"/>
+          </p:cNvSpPr>
+          <p:nvPr>
+            <p:ph type="title"/>
+          </p:nvPr>
+        </p:nvSpPr>
+        <p:spPr/>
+        <p:txBody>
+          <a:bodyPr/>
+          <a:lstStyle/>
+          <a:p>
+            <a:r>
+              <a:t>Gradient fill</a:t>
+            </a:r>
+          </a:p>
+        </p:txBody>
+      </p:sp>
+      <p:sp>
+        <p:nvSpPr>
+          <p:cNvPr id="3" name="Rectangle 2"/>
+          <p:cNvSpPr/>
+          <p:nvPr/>
+        </p:nvSpPr>
+        <p:spPr>
+          <a:xfrm>
+            <a:off x="914400" y="1828800"/>
+            <a:ext cx="5486400" cy="1828800"/>
+          </a:xfrm>
+          <a:prstGeom prst="rect">
+            <a:avLst/>
+          </a:prstGeom>
+          <a:gradFill flip="none" rotWithShape="1">
+            <a:gsLst>
+              <a:gs pos="0">
+                <a:srgbClr val="4F81BD"/>
+              </a:gs>
+              <a:gs pos="100000">
+                <a:srgbClr val="C0504D"/>
+              </a:gs>
+            </a:gsLst>
+            <a:lin ang="2700000" scaled="1"/>
+          </a:gradFill>
+        </p:spPr>
+        <p:style>
+          <a:lnRef idx="1">
+            <a:schemeClr val="accent1"/>
+          </a:lnRef>
+          <a:fillRef idx="3">
+            <a:schemeClr val="accent1"/>
+          </a:fillRef>
+          <a:effectRef idx="2">
+            <a:schemeClr val="accent1"/>
+          </a:effectRef>
+          <a:fontRef idx="minor">
+            <a:schemeClr val="lt1"/>
+          </a:fontRef>
+        </p:style>
+        <p:txBody>
+          <a:bodyPr rtlCol="0" anchor="ctr"/>
+          <a:lstStyle/>
+          <a:p>
+            <a:r>
+              <a:rPr>
+                <a:solidFill>
+                  <a:srgbClr val="FFFFFF"/>
+                </a:solidFill>
+              </a:rPr>
+              <a:t>Linear gradient</a:t>
+            </a:r>
+          </a:p>
+        </p:txBody>
+      </p:sp>
+    </p:spTree>
+  </p:cSld>
+  <p:clrMapOvr>
+    <a:masterClrMapping/>
+  </p:clrMapOvr>
+</p:sld>
+</file>
+
+<file path=ppt/slides/slide13.xml><?xml version="1.0" encoding="utf-8"?>
+<p:sld xmlns:a="http://schemas.openxmlformats.org/drawingml/2006/main" xmlns:p="http://schemas.openxmlformats.org/presentationml/2006/main" xmlns:r="http://schemas.openxmlformats.org/officeDocument/2006/relationships">
+  <p:cSld>
+    <p:spTree>
+      <p:nvGrpSpPr>
+        <p:cNvPr id="1" name=""/>
+        <p:cNvGrpSpPr/>
+        <p:nvPr/>
+      </p:nvGrpSpPr>
+      <p:grpSpPr/>
+      <p:sp>
+        <p:nvSpPr>
+          <p:cNvPr id="2" name="Title 1"/>
+          <p:cNvSpPr>
+            <a:spLocks noGrp="1"/>
+          </p:cNvSpPr>
+          <p:nvPr>
+            <p:ph type="title"/>
+          </p:nvPr>
+        </p:nvSpPr>
+        <p:spPr/>
+        <p:txBody>
+          <a:bodyPr/>
+          <a:lstStyle/>
+          <a:p>
+            <a:r>
+              <a:t>Picture fill</a:t>
+            </a:r>
+          </a:p>
+        </p:txBody>
+      </p:sp>
+      <p:sp>
+        <p:nvSpPr>
+          <p:cNvPr id="3" name="Rectangle 2"/>
+          <p:cNvSpPr/>
+          <p:nvPr/>
+        </p:nvSpPr>
+        <p:spPr>
+          <a:xfrm>
+            <a:off x="1828800" y="1828800"/>
+            <a:ext cx="4572000" cy="2743200"/>
+          </a:xfrm>
+          <a:prstGeom prst="rect">
+            <a:avLst/>
+          </a:prstGeom>
+          <a:blipFill>
+            <a:blip r:embed="rId2"/>
+            <a:stretch>
+              <a:fillRect/>
+            </a:stretch>
+          </a:blipFill>
+        </p:spPr>
+        <p:style>
+          <a:lnRef idx="1">
+            <a:schemeClr val="accent1"/>
+          </a:lnRef>
+          <a:fillRef idx="3">
+            <a:schemeClr val="accent1"/>
+          </a:fillRef>
+          <a:effectRef idx="2">
+            <a:schemeClr val="accent1"/>
+          </a:effectRef>
+          <a:fontRef idx="minor">
+            <a:schemeClr val="lt1"/>
+          </a:fontRef>
+        </p:style>
+        <p:txBody>
+          <a:bodyPr rtlCol="0" anchor="ctr"/>
+          <a:lstStyle/>
+          <a:p>
+            <a:pPr algn="ctr"/>
+          </a:p>
+        </p:txBody>
+      </p:sp>
+    </p:spTree>
+  </p:cSld>
+  <p:clrMapOvr>
+    <a:masterClrMapping/>
+  </p:clrMapOvr>
+</p:sld>
+</file>
+
+<file path=ppt/slides/slide14.xml><?xml version="1.0" encoding="utf-8"?>
+<p:sld xmlns:a="http://schemas.openxmlformats.org/drawingml/2006/main" xmlns:p="http://schemas.openxmlformats.org/presentationml/2006/main" xmlns:r="http://schemas.openxmlformats.org/officeDocument/2006/relationships">
+  <p:cSld>
+    <p:spTree>
+      <p:nvGrpSpPr>
+        <p:cNvPr id="1" name=""/>
+        <p:cNvGrpSpPr/>
+        <p:nvPr/>
+      </p:nvGrpSpPr>
+      <p:grpSpPr/>
+      <p:sp>
+        <p:nvSpPr>
+          <p:cNvPr id="2" name="Title 1"/>
+          <p:cNvSpPr>
+            <a:spLocks noGrp="1"/>
+          </p:cNvSpPr>
+          <p:nvPr>
+            <p:ph type="title"/>
+          </p:nvPr>
+        </p:nvSpPr>
+        <p:spPr/>
+        <p:txBody>
+          <a:bodyPr/>
+          <a:lstStyle/>
+          <a:p>
+            <a:r>
+              <a:t>Lines</a:t>
+            </a:r>
+          </a:p>
+        </p:txBody>
+      </p:sp>
+      <p:cxnSp>
+        <p:nvCxnSpPr>
+          <p:cNvPr id="3" name="Connector 2"/>
+          <p:cNvCxnSpPr/>
+          <p:nvPr/>
+        </p:nvCxnSpPr>
+        <p:spPr>
+          <a:xfrm>
+            <a:off x="914400" y="1828800"/>
+            <a:ext cx="2743200" cy="0"/>
+          </a:xfrm>
+          <a:prstGeom prst="line">
+            <a:avLst/>
+          </a:prstGeom>
+          <a:ln w="19050">
+            <a:solidFill>
+              <a:srgbClr val="1F497D"/>
+            </a:solidFill>
+          </a:ln>
+        </p:spPr>
+        <p:style>
+          <a:lnRef idx="2">
+            <a:schemeClr val="accent1"/>
+          </a:lnRef>
+          <a:fillRef idx="0">
+            <a:schemeClr val="accent1"/>
+          </a:fillRef>
+          <a:effectRef idx="1">
+            <a:schemeClr val="accent1"/>
+          </a:effectRef>
+          <a:fontRef idx="minor">
+            <a:schemeClr val="tx1"/>
+          </a:fontRef>
+        </p:style>
+      </p:cxnSp>
+      <p:cxnSp>
+        <p:nvCxnSpPr>
+          <p:cNvPr id="4" name="Connector 3"/>
+          <p:cNvCxnSpPr/>
+          <p:nvPr/>
+        </p:nvCxnSpPr>
+        <p:spPr>
+          <a:xfrm>
+            <a:off x="914400" y="2286000"/>
+            <a:ext cx="2743200" cy="0"/>
+          </a:xfrm>
+          <a:prstGeom prst="line">
+            <a:avLst/>
+          </a:prstGeom>
+          <a:ln w="19050">
+            <a:solidFill>
+              <a:srgbClr val="C0504D"/>
+            </a:solidFill>
+            <a:prstDash val="dash"/>
+          </a:ln>
+        </p:spPr>
+        <p:style>
+          <a:lnRef idx="2">
+            <a:schemeClr val="accent1"/>
+          </a:lnRef>
+          <a:fillRef idx="0">
+            <a:schemeClr val="accent1"/>
+          </a:fillRef>
+          <a:effectRef idx="1">
+            <a:schemeClr val="accent1"/>
+          </a:effectRef>
+          <a:fontRef idx="minor">
+            <a:schemeClr val="tx1"/>
+          </a:fontRef>
+        </p:style>
+      </p:cxnSp>
+      <p:cxnSp>
+        <p:nvCxnSpPr>
+          <p:cNvPr id="5" name="Connector 4"/>
+          <p:cNvCxnSpPr/>
+          <p:nvPr/>
+        </p:nvCxnSpPr>
+        <p:spPr>
+          <a:xfrm>
+            <a:off x="914400" y="2743200"/>
+            <a:ext cx="2743200" cy="0"/>
+          </a:xfrm>
+          <a:prstGeom prst="line">
+            <a:avLst/>
+          </a:prstGeom>
+          <a:ln w="19050">
+            <a:solidFill>
+              <a:srgbClr val="4F81BD"/>
+            </a:solidFill>
+            <a:prstDash val="dot"/>
+          </a:ln>
+        </p:spPr>
+        <p:style>
+          <a:lnRef idx="2">
+            <a:schemeClr val="accent1"/>
+          </a:lnRef>
+          <a:fillRef idx="0">
+            <a:schemeClr val="accent1"/>
+          </a:fillRef>
+          <a:effectRef idx="1">
+            <a:schemeClr val="accent1"/>
+          </a:effectRef>
+          <a:fontRef idx="minor">
+            <a:schemeClr val="tx1"/>
+          </a:fontRef>
+        </p:style>
+      </p:cxnSp>
+      <p:cxnSp>
+        <p:nvCxnSpPr>
+          <p:cNvPr id="6" name="Connector 5"/>
+          <p:cNvCxnSpPr/>
+          <p:nvPr/>
+        </p:nvCxnSpPr>
+        <p:spPr>
+          <a:xfrm>
+            <a:off x="914400" y="3200400"/>
+            <a:ext cx="2743200" cy="0"/>
+          </a:xfrm>
+          <a:prstGeom prst="line">
+            <a:avLst/>
+          </a:prstGeom>
+          <a:ln w="19050">
+            <a:solidFill>
+              <a:srgbClr val="5A7A3B"/>
+            </a:solidFill>
+            <a:prstDash val="lgDashDot"/>
+          </a:ln>
+        </p:spPr>
+        <p:style>
+          <a:lnRef idx="2">
+            <a:schemeClr val="accent1"/>
+          </a:lnRef>
+          <a:fillRef idx="0">
+            <a:schemeClr val="accent1"/>
+          </a:fillRef>
+          <a:effectRef idx="1">
+            <a:schemeClr val="accent1"/>
+          </a:effectRef>
+          <a:fontRef idx="minor">
+            <a:schemeClr val="tx1"/>
+          </a:fontRef>
+        </p:style>
+      </p:cxnSp>
+      <p:cxnSp>
+        <p:nvCxnSpPr>
+          <p:cNvPr id="7" name="Connector 6"/>
+          <p:cNvCxnSpPr/>
+          <p:nvPr/>
+        </p:nvCxnSpPr>
+        <p:spPr>
+          <a:xfrm>
+            <a:off x="5029200" y="1828800"/>
+            <a:ext cx="2743200" cy="0"/>
+          </a:xfrm>
+          <a:prstGeom prst="line">
+            <a:avLst/>
+          </a:prstGeom>
+          <a:ln w="19050">
+            <a:solidFill>
+              <a:srgbClr val="1F497D"/>
+            </a:solidFill>
+            <a:tailEnd type="triangle" w="med" len="med"/>
+          </a:ln>
+        </p:spPr>
+        <p:style>
+          <a:lnRef idx="2">
+            <a:schemeClr val="accent1"/>
+          </a:lnRef>
+          <a:fillRef idx="0">
+            <a:schemeClr val="accent1"/>
+          </a:fillRef>
+          <a:effectRef idx="1">
+            <a:schemeClr val="accent1"/>
+          </a:effectRef>
+          <a:fontRef idx="minor">
+            <a:schemeClr val="tx1"/>
+          </a:fontRef>
+        </p:style>
+      </p:cxnSp>
+      <p:cxnSp>
+        <p:nvCxnSpPr>
+          <p:cNvPr id="8" name="Connector 7"/>
+          <p:cNvCxnSpPr/>
+          <p:nvPr/>
+        </p:nvCxnSpPr>
+        <p:spPr>
+          <a:xfrm>
+            <a:off x="5029200" y="2286000"/>
+            <a:ext cx="2743200" cy="0"/>
+          </a:xfrm>
+          <a:prstGeom prst="line">
+            <a:avLst/>
+          </a:prstGeom>
+          <a:ln w="19050">
+            <a:solidFill>
+              <a:srgbClr val="C0504D"/>
+            </a:solidFill>
+            <a:headEnd type="stealth" w="lg" len="lg"/>
+            <a:tailEnd type="stealth" w="lg" len="lg"/>
+          </a:ln>
+        </p:spPr>
+        <p:style>
+          <a:lnRef idx="2">
+            <a:schemeClr val="accent1"/>
+          </a:lnRef>
+          <a:fillRef idx="0">
+            <a:schemeClr val="accent1"/>
+          </a:fillRef>
+          <a:effectRef idx="1">
+            <a:schemeClr val="accent1"/>
+          </a:effectRef>
+          <a:fontRef idx="minor">
+            <a:schemeClr val="tx1"/>
+          </a:fontRef>
+        </p:style>
+      </p:cxnSp>
+      <p:cxnSp>
+        <p:nvCxnSpPr>
+          <p:cNvPr id="9" name="Connector 8"/>
+          <p:cNvCxnSpPr/>
+          <p:nvPr/>
+        </p:nvCxnSpPr>
+        <p:spPr>
+          <a:xfrm>
+            <a:off x="5029200" y="2743200"/>
+            <a:ext cx="2743200" cy="0"/>
+          </a:xfrm>
+          <a:prstGeom prst="line">
+            <a:avLst/>
+          </a:prstGeom>
+          <a:ln w="19050">
+            <a:solidFill>
+              <a:srgbClr val="4F81BD"/>
+            </a:solidFill>
+            <a:prstDash val="dash"/>
+            <a:headEnd type="diamond" w="med" len="med"/>
+            <a:tailEnd type="oval" w="med" len="med"/>
+          </a:ln>
+        </p:spPr>
+        <p:style>
+          <a:lnRef idx="2">
+            <a:schemeClr val="accent1"/>
+          </a:lnRef>
+          <a:fillRef idx="0">
+            <a:schemeClr val="accent1"/>
+          </a:fillRef>
+          <a:effectRef idx="1">
+            <a:schemeClr val="accent1"/>
+          </a:effectRef>
+          <a:fontRef idx="minor">
+            <a:schemeClr val="tx1"/>
+          </a:fontRef>
+        </p:style>
+      </p:cxnSp>
+      <p:sp>
+        <p:nvSpPr>
+          <p:cNvPr id="10" name="Rectangle 9"/>
+          <p:cNvSpPr/>
+          <p:nvPr/>
+        </p:nvSpPr>
+        <p:spPr>
+          <a:xfrm>
+            <a:off x="914400" y="4114800"/>
+            <a:ext cx="2743200" cy="1371600"/>
+          </a:xfrm>
+          <a:prstGeom prst="rect">
+            <a:avLst/>
+          </a:prstGeom>
+          <a:noFill/>
+          <a:ln w="28575" cap="rnd">
+            <a:solidFill>
+              <a:srgbClr val="C0504D"/>
+            </a:solidFill>
+            <a:prstDash val="dot"/>
+            <a:bevel/>
+          </a:ln>
+        </p:spPr>
+        <p:style>
+          <a:lnRef idx="1">
+            <a:schemeClr val="accent1"/>
+          </a:lnRef>
+          <a:fillRef idx="3">
+            <a:schemeClr val="accent1"/>
+          </a:fillRef>
+          <a:effectRef idx="2">
+            <a:schemeClr val="accent1"/>
+          </a:effectRef>
+          <a:fontRef idx="minor">
+            <a:schemeClr val="lt1"/>
+          </a:fontRef>
+        </p:style>
+        <p:txBody>
+          <a:bodyPr rtlCol="0" anchor="ctr"/>
+          <a:lstStyle/>
+          <a:p>
+            <a:r>
+              <a:t>Dotted border</a:t>
+            </a:r>
+          </a:p>
+        </p:txBody>
+      </p:sp>
+      <p:sp>
+        <p:nvSpPr>
+          <p:cNvPr id="11" name="Rectangle 10"/>
+          <p:cNvSpPr/>
+          <p:nvPr/>
+        </p:nvSpPr>
+        <p:spPr>
+          <a:xfrm>
+            <a:off x="4572000" y="4114800"/>
+            <a:ext cx="2743200" cy="1371600"/>
+          </a:xfrm>
+          <a:prstGeom prst="rect">
+            <a:avLst/>
+          </a:prstGeom>
+          <a:noFill/>
+          <a:ln w="38100" cmpd="dbl">
+            <a:solidFill>
+              <a:srgbClr val="1F497D"/>
+            </a:solidFill>
+          </a:ln>
+        </p:spPr>
+        <p:style>
+          <a:lnRef idx="1">
+            <a:schemeClr val="accent1"/>
+          </a:lnRef>
+          <a:fillRef idx="3">
+            <a:schemeClr val="accent1"/>
+          </a:fillRef>
+          <a:effectRef idx="2">
+            <a:schemeClr val="accent1"/>
+          </a:effectRef>
+          <a:fontRef idx="minor">
+            <a:schemeClr val="lt1"/>
+          </a:fontRef>
+        </p:style>
+        <p:txBody>
+          <a:bodyPr rtlCol="0" anchor="ctr"/>
+          <a:lstStyle/>
+          <a:p>
+            <a:r>
+              <a:t>Double border</a:t>
+            </a:r>
+          </a:p>
+        </p:txBody>
+      </p:sp>
+    </p:spTree>
+  </p:cSld>
+  <p:clrMapOvr>
+    <a:masterClrMapping/>
+  </p:clrMapOvr>
+</p:sld>
+</file>
+
+<file path=ppt/slides/slide15.xml><?xml version="1.0" encoding="utf-8"?>
+<p:sld xmlns:a="http://schemas.openxmlformats.org/drawingml/2006/main" xmlns:p="http://schemas.openxmlformats.org/presentationml/2006/main" xmlns:r="http://schemas.openxmlformats.org/officeDocument/2006/relationships">
+  <p:cSld>
+    <p:spTree>
+      <p:nvGrpSpPr>
+        <p:cNvPr id="1" name=""/>
+        <p:cNvGrpSpPr/>
+        <p:nvPr/>
+      </p:nvGrpSpPr>
+      <p:grpSpPr/>
+      <p:sp>
+        <p:nvSpPr>
+          <p:cNvPr id="2" name="Title 1"/>
+          <p:cNvSpPr>
+            <a:spLocks noGrp="1"/>
+          </p:cNvSpPr>
+          <p:nvPr>
+            <p:ph type="title"/>
+          </p:nvPr>
+        </p:nvSpPr>
+        <p:spPr/>
+        <p:txBody>
+          <a:bodyPr/>
+          <a:lstStyle/>
+          <a:p>
+            <a:r>
+              <a:t>Typography</a:t>
+            </a:r>
+          </a:p>
+        </p:txBody>
+      </p:sp>
+      <p:sp>
+        <p:nvSpPr>
+          <p:cNvPr id="3" name="TextBox 2"/>
+          <p:cNvSpPr txBox="1"/>
+          <p:nvPr/>
+        </p:nvSpPr>
+        <p:spPr>
+          <a:xfrm>
+            <a:off x="914400" y="1371600"/>
+            <a:ext cx="7315200" cy="3657600"/>
+          </a:xfrm>
+          <a:prstGeom prst="rect">
+            <a:avLst/>
+          </a:prstGeom>
+          <a:noFill/>
+        </p:spPr>
+        <p:txBody>
+          <a:bodyPr wrap="square">
+            <a:spAutoFit/>
+          </a:bodyPr>
+          <a:lstStyle/>
+          <a:p>
+            <a:r>
+              <a:t>Plain then </a:t>
+            </a:r>
+            <a:r>
+              <a:rPr u="sng"/>
+              <a:t>underlined</a:t>
+            </a:r>
+            <a:r>
+              <a:t> then </a:t>
+            </a:r>
+            <a:r>
+              <a:rPr strike="sngStrike"/>
+              <a:t>strikethrough</a:t>
+            </a:r>
+            <a:r>
+              <a:t>.</a:t>
+            </a:r>
+          </a:p>
+          <a:p>
+            <a:r>
+              <a:t>E = mc</a:t>
+            </a:r>
+            <a:r>
+              <a:rPr baseline="30000"/>
+              <a:t>2</a:t>
+            </a:r>
+            <a:r>
+              <a:t>, H</a:t>
+            </a:r>
+            <a:r>
+              <a:rPr baseline="-25000"/>
+              <a:t>2</a:t>
+            </a:r>
+            <a:r>
+              <a:t>O, </a:t>
+            </a:r>
+            <a:r>
+              <a:rPr spc="200"/>
+              <a:t>l e t t e r   s p a c e d</a:t>
+            </a:r>
+          </a:p>
+          <a:p>
+            <a:pPr>
+              <a:lnSpc>
+                <a:spcPct val="150000"/>
+              </a:lnSpc>
+            </a:pPr>
+            <a:r>
+              <a:t>This paragraph uses 1.5x line spacing so you can see the extra vertical room between wrapped lines. Quick brown foxes and lazy dogs.</a:t>
+            </a:r>
+          </a:p>
+        </p:txBody>
+      </p:sp>
+    </p:spTree>
+  </p:cSld>
+  <p:clrMapOvr>
+    <a:masterClrMapping/>
+  </p:clrMapOvr>
+</p:sld>
+</file>
+
+<file path=ppt/slides/slide16.xml><?xml version="1.0" encoding="utf-8"?>
+<p:sld xmlns:a="http://schemas.openxmlformats.org/drawingml/2006/main" xmlns:p="http://schemas.openxmlformats.org/presentationml/2006/main" xmlns:r="http://schemas.openxmlformats.org/officeDocument/2006/relationships">
+  <p:cSld>
+    <p:spTree>
+      <p:nvGrpSpPr>
+        <p:cNvPr id="1" name=""/>
+        <p:cNvGrpSpPr/>
+        <p:nvPr/>
+      </p:nvGrpSpPr>
+      <p:grpSpPr/>
+      <p:sp>
+        <p:nvSpPr>
+          <p:cNvPr id="2" name="Title 1"/>
+          <p:cNvSpPr>
+            <a:spLocks noGrp="1"/>
+          </p:cNvSpPr>
+          <p:nvPr>
+            <p:ph type="title"/>
+          </p:nvPr>
+        </p:nvSpPr>
+        <p:spPr/>
+        <p:txBody>
+          <a:bodyPr/>
+          <a:lstStyle/>
+          <a:p>
+            <a:r>
+              <a:t>A chart</a:t>
+            </a:r>
+          </a:p>
+        </p:txBody>
+      </p:sp>
+      <p:graphicFrame>
+        <p:nvGraphicFramePr>
+          <p:cNvPr id="3" name="Chart 2"/>
+          <p:cNvGraphicFramePr>
+            <a:graphicFrameLocks noGrp="1"/>
+          </p:cNvGraphicFramePr>
+          <p:nvPr/>
+        </p:nvGraphicFramePr>
+        <p:xfrm>
+          <a:off x="914400" y="1828800"/>
+          <a:ext cx="5486400" cy="3657600"/>
+        </p:xfrm>
+        <a:graphic>
+          <a:graphicData uri="http://schemas.openxmlformats.org/drawingml/2006/chart">
+            <c:chart xmlns:c="http://schemas.openxmlformats.org/drawingml/2006/chart" r:id="rId2"/>
+          </a:graphicData>
+        </a:graphic>
+      </p:graphicFrame>
+    </p:spTree>
+  </p:cSld>
+  <p:clrMapOvr>
+    <a:masterClrMapping/>
+  </p:clrMapOvr>
+</p:sld>
+</file>
+
+<file path=ppt/slides/slide17.xml><?xml version="1.0" encoding="utf-8"?>
+<p:sld xmlns:a="http://schemas.openxmlformats.org/drawingml/2006/main" xmlns:p="http://schemas.openxmlformats.org/presentationml/2006/main" xmlns:r="http://schemas.openxmlformats.org/officeDocument/2006/relationships">
+  <p:cSld>
+    <p:spTree>
+      <p:nvGrpSpPr>
+        <p:cNvPr id="1" name=""/>
+        <p:cNvGrpSpPr/>
+        <p:nvPr/>
+      </p:nvGrpSpPr>
+      <p:grpSpPr/>
+      <p:sp>
+        <p:nvSpPr>
+          <p:cNvPr id="2" name="Title 1"/>
+          <p:cNvSpPr>
+            <a:spLocks noGrp="1"/>
+          </p:cNvSpPr>
+          <p:nvPr>
+            <p:ph type="title"/>
+          </p:nvPr>
+        </p:nvSpPr>
+        <p:spPr/>
+        <p:txBody>
+          <a:bodyPr/>
+          <a:lstStyle/>
+          <a:p>
+            <a:r>
+              <a:t>Hidden slide</a:t>
+            </a:r>
+          </a:p>
+        </p:txBody>
+      </p:sp>
+    </p:spTree>
+  </p:cSld>
+  <p:clrMapOvr>
+    <a:masterClrMapping/>
+  </p:clrMapOvr>
+</p:sld>
+</file>
+
+<file path=ppt/slides/slide2.xml><?xml version="1.0" encoding="utf-8"?>
+<p:sld xmlns:a="http://schemas.openxmlformats.org/drawingml/2006/main" xmlns:p="http://schemas.openxmlformats.org/presentationml/2006/main" xmlns:r="http://schemas.openxmlformats.org/officeDocument/2006/relationships">
+  <p:cSld>
+    <p:spTree>
+      <p:nvGrpSpPr>
+        <p:cNvPr id="1" name=""/>
+        <p:cNvGrpSpPr/>
+        <p:nvPr/>
+      </p:nvGrpSpPr>
+      <p:grpSpPr/>
+      <p:sp>
+        <p:nvSpPr>
+          <p:cNvPr id="2" name="Title 1"/>
+          <p:cNvSpPr>
+            <a:spLocks noGrp="1"/>
+          </p:cNvSpPr>
+          <p:nvPr>
+            <p:ph type="title"/>
+          </p:nvPr>
+        </p:nvSpPr>
+        <p:spPr/>
+        <p:txBody>
+          <a:bodyPr/>
+          <a:lstStyle/>
+          <a:p>
+            <a:r>
+              <a:t>Bullet points</a:t>
+            </a:r>
+          </a:p>
+        </p:txBody>
+      </p:sp>
+      <p:sp>
+        <p:nvSpPr>
+          <p:cNvPr id="3" name="Content Placeholder 2"/>
+          <p:cNvSpPr>
+            <a:spLocks noGrp="1"/>
+          </p:cNvSpPr>
+          <p:nvPr>
+            <p:ph idx="1"/>
+          </p:nvPr>
+        </p:nvSpPr>
+        <p:spPr/>
+        <p:txBody>
+          <a:bodyPr/>
+          <a:lstStyle/>
+          <a:p>
+            <a:r>
+              <a:t>First bullet</a:t>
+            </a:r>
+          </a:p>
+          <a:p>
+            <a:pPr>
+              <a:defRPr sz="1800"/>
+            </a:pPr>
+            <a:r>
+              <a:t>Second bullet</a:t>
+            </a:r>
+          </a:p>
+          <a:p>
+            <a:pPr>
+              <a:defRPr sz="1800"/>
+            </a:pPr>
+            <a:r>
+              <a:t>Third bullet</a:t>
+            </a:r>
+          </a:p>
+        </p:txBody>
+      </p:sp>
+    </p:spTree>
+  </p:cSld>
+  <p:clrMapOvr>
+    <a:masterClrMapping/>
+  </p:clrMapOvr>
+</p:sld>
+</file>
+
+<file path=ppt/slides/slide3.xml><?xml version="1.0" encoding="utf-8"?>
+<p:sld xmlns:a="http://schemas.openxmlformats.org/drawingml/2006/main" xmlns:p="http://schemas.openxmlformats.org/presentationml/2006/main" xmlns:r="http://schemas.openxmlformats.org/officeDocument/2006/relationships">
+  <p:cSld>
+    <p:spTree>
+      <p:nvGrpSpPr>
+        <p:cNvPr id="1" name=""/>
+        <p:cNvGrpSpPr/>
+        <p:nvPr/>
+      </p:nvGrpSpPr>
+      <p:grpSpPr/>
+      <p:sp>
+        <p:nvSpPr>
+          <p:cNvPr id="2" name="Title 1"/>
+          <p:cNvSpPr>
+            <a:spLocks noGrp="1"/>
+          </p:cNvSpPr>
+          <p:nvPr>
+            <p:ph type="title"/>
+          </p:nvPr>
+        </p:nvSpPr>
+        <p:spPr/>
+        <p:txBody>
+          <a:bodyPr/>
+          <a:lstStyle/>
+          <a:p>
+            <a:r>
+              <a:t>A shape</a:t>
+            </a:r>
+          </a:p>
+        </p:txBody>
+      </p:sp>
+      <p:sp>
+        <p:nvSpPr>
+          <p:cNvPr id="3" name="TextBox 2"/>
+          <p:cNvSpPr txBox="1"/>
+          <p:nvPr/>
+        </p:nvSpPr>
+        <p:spPr>
+          <a:xfrm>
+            <a:off x="914400" y="1828800"/>
+            <a:ext cx="3657600" cy="914400"/>
+          </a:xfrm>
+          <a:prstGeom prst="rect">
+            <a:avLst/>
+          </a:prstGeom>
+          <a:noFill/>
+        </p:spPr>
+        <p:txBody>
+          <a:bodyPr wrap="none">
+            <a:spAutoFit/>
+          </a:bodyPr>
+          <a:lstStyle/>
+          <a:p>
+            <a:r>
+              <a:rPr sz="2400" b="1">
+                <a:solidFill>
+                  <a:srgbClr val="C0392B"/>
+                </a:solidFill>
+              </a:rPr>
+              <a:t>Free-floating textbox</a:t>
+            </a:r>
+          </a:p>
+        </p:txBody>
+      </p:sp>
+    </p:spTree>
+  </p:cSld>
+  <p:clrMapOvr>
+    <a:masterClrMapping/>
+  </p:clrMapOvr>
+</p:sld>
+</file>
+
+<file path=ppt/slides/slide4.xml><?xml version="1.0" encoding="utf-8"?>
+<p:sld xmlns:a="http://schemas.openxmlformats.org/drawingml/2006/main" xmlns:p="http://schemas.openxmlformats.org/presentationml/2006/main" xmlns:r="http://schemas.openxmlformats.org/officeDocument/2006/relationships">
+  <p:cSld>
+    <p:spTree>
+      <p:nvGrpSpPr>
+        <p:cNvPr id="1" name=""/>
+        <p:cNvGrpSpPr/>
+        <p:nvPr/>
+      </p:nvGrpSpPr>
+      <p:grpSpPr/>
+      <p:sp>
+        <p:nvSpPr>
+          <p:cNvPr id="2" name="Title 1"/>
+          <p:cNvSpPr>
+            <a:spLocks noGrp="1"/>
+          </p:cNvSpPr>
+          <p:nvPr>
+            <p:ph type="title"/>
+          </p:nvPr>
+        </p:nvSpPr>
+        <p:spPr/>
+        <p:txBody>
+          <a:bodyPr/>
+          <a:lstStyle/>
+          <a:p>
+            <a:r>
+              <a:t>An image</a:t>
+            </a:r>
+          </a:p>
+        </p:txBody>
+      </p:sp>
+      <p:pic>
+        <p:nvPicPr>
+          <p:cNvPr id="3" name="Picture 2" descr="python-powered.png"/>
+          <p:cNvPicPr>
+            <a:picLocks noChangeAspect="1"/>
+          </p:cNvPicPr>
+          <p:nvPr/>
+        </p:nvPicPr>
+        <p:blipFill>
+          <a:blip r:embed="rId2"/>
+          <a:stretch>
+            <a:fillRect/>
+          </a:stretch>
+        </p:blipFill>
+        <p:spPr>
+          <a:xfrm>
+            <a:off x="2743200" y="1828800"/>
+            <a:ext cx="3657600" cy="1828800"/>
+          </a:xfrm>
+          <a:prstGeom prst="rect">
+            <a:avLst/>
+          </a:prstGeom>
+        </p:spPr>
+      </p:pic>
+    </p:spTree>
+  </p:cSld>
+  <p:clrMapOvr>
+    <a:masterClrMapping/>
+  </p:clrMapOvr>
+</p:sld>
+</file>
+
+<file path=ppt/slides/slide5.xml><?xml version="1.0" encoding="utf-8"?>
+<p:sld xmlns:a="http://schemas.openxmlformats.org/drawingml/2006/main" xmlns:p="http://schemas.openxmlformats.org/presentationml/2006/main" xmlns:r="http://schemas.openxmlformats.org/officeDocument/2006/relationships">
+  <p:cSld>
+    <p:bg>
+      <p:bgPr>
+        <a:solidFill>
+          <a:srgbClr val="FFF4E0"/>
+        </a:solidFill>
+        <a:effectLst/>
+      </p:bgPr>
+    </p:bg>
+    <p:spTree>
+      <p:nvGrpSpPr>
+        <p:cNvPr id="1" name=""/>
+        <p:cNvGrpSpPr/>
+        <p:nvPr/>
+      </p:nvGrpSpPr>
+      <p:grpSpPr/>
+      <p:sp>
+        <p:nvSpPr>
+          <p:cNvPr id="2" name="Title 1"/>
+          <p:cNvSpPr>
+            <a:spLocks noGrp="1"/>
+          </p:cNvSpPr>
+          <p:nvPr>
+            <p:ph type="title"/>
+          </p:nvPr>
+        </p:nvSpPr>
+        <p:spPr/>
+        <p:txBody>
+          <a:bodyPr/>
+          <a:lstStyle/>
+          <a:p>
+            <a:r>
+              <a:t>Tinted background</a:t>
+            </a:r>
+          </a:p>
+        </p:txBody>
+      </p:sp>
+    </p:spTree>
+  </p:cSld>
+  <p:clrMapOvr>
+    <a:masterClrMapping/>
+  </p:clrMapOvr>
+</p:sld>
+</file>
+
+<file path=ppt/slides/slide6.xml><?xml version="1.0" encoding="utf-8"?>
+<p:sld xmlns:a="http://schemas.openxmlformats.org/drawingml/2006/main" xmlns:p="http://schemas.openxmlformats.org/presentationml/2006/main" xmlns:r="http://schemas.openxmlformats.org/officeDocument/2006/relationships">
+  <p:cSld>
+    <p:spTree>
+      <p:nvGrpSpPr>
+        <p:cNvPr id="1" name=""/>
+        <p:cNvGrpSpPr/>
+        <p:nvPr/>
+      </p:nvGrpSpPr>
+      <p:grpSpPr/>
+      <p:sp>
+        <p:nvSpPr>
+          <p:cNvPr id="2" name="Title 1"/>
+          <p:cNvSpPr>
+            <a:spLocks noGrp="1"/>
+          </p:cNvSpPr>
+          <p:nvPr>
+            <p:ph type="title"/>
+          </p:nvPr>
+        </p:nvSpPr>
+        <p:spPr/>
+        <p:txBody>
+          <a:bodyPr/>
+          <a:lstStyle/>
+          <a:p>
+            <a:r>
+              <a:t>Filled shapes</a:t>
+            </a:r>
+          </a:p>
+        </p:txBody>
+      </p:sp>
+      <p:sp>
+        <p:nvSpPr>
+          <p:cNvPr id="3" name="Rectangle 2"/>
+          <p:cNvSpPr/>
+          <p:nvPr/>
+        </p:nvSpPr>
+        <p:spPr>
+          <a:xfrm>
+            <a:off x="914400" y="1828800"/>
+            <a:ext cx="2743200" cy="1371600"/>
+          </a:xfrm>
+          <a:prstGeom prst="rect">
+            <a:avLst/>
+          </a:prstGeom>
+          <a:solidFill>
+            <a:srgbClr val="4F81BD"/>
+          </a:solidFill>
+          <a:ln w="38100">
+            <a:solidFill>
+              <a:srgbClr val="1F497D"/>
+            </a:solidFill>
+          </a:ln>
+        </p:spPr>
+        <p:style>
+          <a:lnRef idx="1">
+            <a:schemeClr val="accent1"/>
+          </a:lnRef>
+          <a:fillRef idx="3">
+            <a:schemeClr val="accent1"/>
+          </a:fillRef>
+          <a:effectRef idx="2">
+            <a:schemeClr val="accent1"/>
+          </a:effectRef>
+          <a:fontRef idx="minor">
+            <a:schemeClr val="lt1"/>
+          </a:fontRef>
+        </p:style>
+        <p:txBody>
+          <a:bodyPr rtlCol="0" anchor="ctr"/>
+          <a:lstStyle/>
+          <a:p>
+            <a:r>
+              <a:rPr>
+                <a:solidFill>
+                  <a:srgbClr val="FFFFFF"/>
+                </a:solidFill>
+              </a:rPr>
+              <a:t>Filled + bordered</a:t>
+            </a:r>
+          </a:p>
+        </p:txBody>
+      </p:sp>
+      <p:sp>
+        <p:nvSpPr>
+          <p:cNvPr id="4" name="Rectangle 3"/>
+          <p:cNvSpPr/>
+          <p:nvPr/>
+        </p:nvSpPr>
+        <p:spPr>
+          <a:xfrm>
+            <a:off x="4572000" y="1828800"/>
+            <a:ext cx="2743200" cy="1371600"/>
+          </a:xfrm>
+          <a:prstGeom prst="rect">
+            <a:avLst/>
+          </a:prstGeom>
+          <a:noFill/>
+          <a:ln w="19050">
+            <a:solidFill>
+              <a:srgbClr val="C0504D"/>
+            </a:solidFill>
+          </a:ln>
+        </p:spPr>
+        <p:style>
+          <a:lnRef idx="1">
+            <a:schemeClr val="accent1"/>
+          </a:lnRef>
+          <a:fillRef idx="3">
+            <a:schemeClr val="accent1"/>
+          </a:fillRef>
+          <a:effectRef idx="2">
+            <a:schemeClr val="accent1"/>
+          </a:effectRef>
+          <a:fontRef idx="minor">
+            <a:schemeClr val="lt1"/>
+          </a:fontRef>
+        </p:style>
+        <p:txBody>
+          <a:bodyPr rtlCol="0" anchor="ctr"/>
+          <a:lstStyle/>
+          <a:p>
+            <a:r>
+              <a:t>Border only</a:t>
+            </a:r>
+          </a:p>
+        </p:txBody>
+      </p:sp>
+    </p:spTree>
+  </p:cSld>
+  <p:clrMapOvr>
+    <a:masterClrMapping/>
+  </p:clrMapOvr>
+</p:sld>
+</file>
+
+<file path=ppt/slides/slide7.xml><?xml version="1.0" encoding="utf-8"?>
+<p:sld xmlns:a="http://schemas.openxmlformats.org/drawingml/2006/main" xmlns:p="http://schemas.openxmlformats.org/presentationml/2006/main" xmlns:r="http://schemas.openxmlformats.org/officeDocument/2006/relationships">
+  <p:cSld>
+    <p:spTree>
+      <p:nvGrpSpPr>
+        <p:cNvPr id="1" name=""/>
+        <p:cNvGrpSpPr/>
+        <p:nvPr/>
+      </p:nvGrpSpPr>
+      <p:grpSpPr/>
+      <p:sp>
+        <p:nvSpPr>
+          <p:cNvPr id="2" name="Title 1"/>
+          <p:cNvSpPr>
+            <a:spLocks noGrp="1"/>
+          </p:cNvSpPr>
+          <p:nvPr>
+            <p:ph type="title"/>
+          </p:nvPr>
+        </p:nvSpPr>
+        <p:spPr/>
+        <p:txBody>
+          <a:bodyPr/>
+          <a:lstStyle/>
+          <a:p>
+            <a:r>
+              <a:t>Preset shapes</a:t>
+            </a:r>
+          </a:p>
+        </p:txBody>
+      </p:sp>
+      <p:sp>
+        <p:nvSpPr>
+          <p:cNvPr id="3" name="Rounded Rectangle 2"/>
+          <p:cNvSpPr/>
+          <p:nvPr/>
+        </p:nvSpPr>
+        <p:spPr>
+          <a:xfrm>
+            <a:off x="685800" y="1645920"/>
+            <a:ext cx="1828800" cy="1371600"/>
+          </a:xfrm>
+          <a:prstGeom prst="roundRect">
+            <a:avLst/>
+          </a:prstGeom>
+          <a:solidFill>
+            <a:srgbClr val="4F81BD"/>
+          </a:solidFill>
+          <a:ln>
+            <a:solidFill>
+              <a:srgbClr val="1F497D"/>
+            </a:solidFill>
+          </a:ln>
+        </p:spPr>
+        <p:style>
+          <a:lnRef idx="1">
+            <a:schemeClr val="accent1"/>
+          </a:lnRef>
+          <a:fillRef idx="3">
+            <a:schemeClr val="accent1"/>
+          </a:fillRef>
+          <a:effectRef idx="2">
+            <a:schemeClr val="accent1"/>
+          </a:effectRef>
+          <a:fontRef idx="minor">
+            <a:schemeClr val="lt1"/>
+          </a:fontRef>
+        </p:style>
+        <p:txBody>
+          <a:bodyPr rtlCol="0" anchor="ctr"/>
+          <a:lstStyle/>
+          <a:p>
+            <a:pPr algn="ctr"/>
+          </a:p>
+        </p:txBody>
+      </p:sp>
+      <p:sp>
+        <p:nvSpPr>
+          <p:cNvPr id="4" name="Diamond 3"/>
+          <p:cNvSpPr/>
+          <p:nvPr/>
+        </p:nvSpPr>
+        <p:spPr>
+          <a:xfrm>
+            <a:off x="2971800" y="1645920"/>
+            <a:ext cx="1828800" cy="1371600"/>
+          </a:xfrm>
+          <a:prstGeom prst="diamond">
+            <a:avLst/>
+          </a:prstGeom>
+          <a:solidFill>
+            <a:srgbClr val="4F81BD"/>
+          </a:solidFill>
+          <a:ln>
+            <a:solidFill>
+              <a:srgbClr val="1F497D"/>
+            </a:solidFill>
+          </a:ln>
+        </p:spPr>
+        <p:style>
+          <a:lnRef idx="1">
+            <a:schemeClr val="accent1"/>
+          </a:lnRef>
+          <a:fillRef idx="3">
+            <a:schemeClr val="accent1"/>
+          </a:fillRef>
+          <a:effectRef idx="2">
+            <a:schemeClr val="accent1"/>
+          </a:effectRef>
+          <a:fontRef idx="minor">
+            <a:schemeClr val="lt1"/>
+          </a:fontRef>
+        </p:style>
+        <p:txBody>
+          <a:bodyPr rtlCol="0" anchor="ctr"/>
+          <a:lstStyle/>
+          <a:p>
+            <a:pPr algn="ctr"/>
+          </a:p>
+        </p:txBody>
+      </p:sp>
+      <p:sp>
+        <p:nvSpPr>
+          <p:cNvPr id="5" name="Oval 4"/>
+          <p:cNvSpPr/>
+          <p:nvPr/>
+        </p:nvSpPr>
+        <p:spPr>
+          <a:xfrm>
+            <a:off x="5257800" y="1645920"/>
+            <a:ext cx="1828800" cy="1371600"/>
+          </a:xfrm>
+          <a:prstGeom prst="ellipse">
+            <a:avLst/>
+          </a:prstGeom>
+          <a:solidFill>
+            <a:srgbClr val="4F81BD"/>
+          </a:solidFill>
+          <a:ln>
+            <a:solidFill>
+              <a:srgbClr val="1F497D"/>
+            </a:solidFill>
+          </a:ln>
+        </p:spPr>
+        <p:style>
+          <a:lnRef idx="1">
+            <a:schemeClr val="accent1"/>
+          </a:lnRef>
+          <a:fillRef idx="3">
+            <a:schemeClr val="accent1"/>
+          </a:fillRef>
+          <a:effectRef idx="2">
+            <a:schemeClr val="accent1"/>
+          </a:effectRef>
+          <a:fontRef idx="minor">
+            <a:schemeClr val="lt1"/>
+          </a:fontRef>
+        </p:style>
+        <p:txBody>
+          <a:bodyPr rtlCol="0" anchor="ctr"/>
+          <a:lstStyle/>
+          <a:p>
+            <a:pPr algn="ctr"/>
+          </a:p>
+        </p:txBody>
+      </p:sp>
+      <p:sp>
+        <p:nvSpPr>
+          <p:cNvPr id="6" name="Up Arrow 5"/>
+          <p:cNvSpPr/>
+          <p:nvPr/>
+        </p:nvSpPr>
+        <p:spPr>
+          <a:xfrm>
+            <a:off x="685800" y="3474720"/>
+            <a:ext cx="1828800" cy="1371600"/>
+          </a:xfrm>
+          <a:prstGeom prst="upArrow">
+            <a:avLst/>
+          </a:prstGeom>
+          <a:solidFill>
+            <a:srgbClr val="4F81BD"/>
+          </a:solidFill>
+          <a:ln>
+            <a:solidFill>
+              <a:srgbClr val="1F497D"/>
+            </a:solidFill>
+          </a:ln>
+        </p:spPr>
+        <p:style>
+          <a:lnRef idx="1">
+            <a:schemeClr val="accent1"/>
+          </a:lnRef>
+          <a:fillRef idx="3">
+            <a:schemeClr val="accent1"/>
+          </a:fillRef>
+          <a:effectRef idx="2">
+            <a:schemeClr val="accent1"/>
+          </a:effectRef>
+          <a:fontRef idx="minor">
+            <a:schemeClr val="lt1"/>
+          </a:fontRef>
+        </p:style>
+        <p:txBody>
+          <a:bodyPr rtlCol="0" anchor="ctr"/>
+          <a:lstStyle/>
+          <a:p>
+            <a:pPr algn="ctr"/>
+          </a:p>
+        </p:txBody>
+      </p:sp>
+      <p:sp>
+        <p:nvSpPr>
+          <p:cNvPr id="7" name="5-Point Star 6"/>
+          <p:cNvSpPr/>
+          <p:nvPr/>
+        </p:nvSpPr>
+        <p:spPr>
+          <a:xfrm>
+            <a:off x="2971800" y="3474720"/>
+            <a:ext cx="1828800" cy="1371600"/>
+          </a:xfrm>
+          <a:prstGeom prst="star5">
+            <a:avLst/>
+          </a:prstGeom>
+          <a:solidFill>
+            <a:srgbClr val="4F81BD"/>
+          </a:solidFill>
+          <a:ln>
+            <a:solidFill>
+              <a:srgbClr val="1F497D"/>
+            </a:solidFill>
+          </a:ln>
+        </p:spPr>
+        <p:style>
+          <a:lnRef idx="1">
+            <a:schemeClr val="accent1"/>
+          </a:lnRef>
+          <a:fillRef idx="3">
+            <a:schemeClr val="accent1"/>
+          </a:fillRef>
+          <a:effectRef idx="2">
+            <a:schemeClr val="accent1"/>
+          </a:effectRef>
+          <a:fontRef idx="minor">
+            <a:schemeClr val="lt1"/>
+          </a:fontRef>
+        </p:style>
+        <p:txBody>
+          <a:bodyPr rtlCol="0" anchor="ctr"/>
+          <a:lstStyle/>
+          <a:p>
+            <a:pPr algn="ctr"/>
+          </a:p>
+        </p:txBody>
+      </p:sp>
+      <p:sp>
+        <p:nvSpPr>
+          <p:cNvPr id="8" name="Pentagon 7"/>
+          <p:cNvSpPr/>
+          <p:nvPr/>
+        </p:nvSpPr>
+        <p:spPr>
+          <a:xfrm>
+            <a:off x="5257800" y="3474720"/>
+            <a:ext cx="1828800" cy="1371600"/>
+          </a:xfrm>
+          <a:prstGeom prst="homePlate">
+            <a:avLst/>
+          </a:prstGeom>
+          <a:solidFill>
+            <a:srgbClr val="4F81BD"/>
+          </a:solidFill>
+          <a:ln>
+            <a:solidFill>
+              <a:srgbClr val="1F497D"/>
+            </a:solidFill>
+          </a:ln>
+        </p:spPr>
+        <p:style>
+          <a:lnRef idx="1">
+            <a:schemeClr val="accent1"/>
+          </a:lnRef>
+          <a:fillRef idx="3">
+            <a:schemeClr val="accent1"/>
+          </a:fillRef>
+          <a:effectRef idx="2">
+            <a:schemeClr val="accent1"/>
+          </a:effectRef>
+          <a:fontRef idx="minor">
+            <a:schemeClr val="lt1"/>
+          </a:fontRef>
+        </p:style>
+        <p:txBody>
+          <a:bodyPr rtlCol="0" anchor="ctr"/>
+          <a:lstStyle/>
+          <a:p>
+            <a:pPr algn="ctr"/>
+          </a:p>
+        </p:txBody>
+      </p:sp>
+    </p:spTree>
+  </p:cSld>
+  <p:clrMapOvr>
+    <a:masterClrMapping/>
+  </p:clrMapOvr>
+</p:sld>
+</file>
+
+<file path=ppt/slides/slide8.xml><?xml version="1.0" encoding="utf-8"?>
+<p:sld xmlns:a="http://schemas.openxmlformats.org/drawingml/2006/main" xmlns:p="http://schemas.openxmlformats.org/presentationml/2006/main" xmlns:r="http://schemas.openxmlformats.org/officeDocument/2006/relationships">
+  <p:cSld>
+    <p:spTree>
+      <p:nvGrpSpPr>
+        <p:cNvPr id="1" name=""/>
+        <p:cNvGrpSpPr/>
+        <p:nvPr/>
+      </p:nvGrpSpPr>
+      <p:grpSpPr/>
+      <p:sp>
+        <p:nvSpPr>
+          <p:cNvPr id="2" name="Title 1"/>
+          <p:cNvSpPr>
+            <a:spLocks noGrp="1"/>
+          </p:cNvSpPr>
+          <p:nvPr>
+            <p:ph type="title"/>
+          </p:nvPr>
+        </p:nvSpPr>
+        <p:spPr/>
+        <p:txBody>
+          <a:bodyPr/>
+          <a:lstStyle/>
+          <a:p>
+            <a:r>
+              <a:t>Rotated &amp; flipped</a:t>
+            </a:r>
+          </a:p>
+        </p:txBody>
+      </p:sp>
+      <p:sp>
+        <p:nvSpPr>
+          <p:cNvPr id="3" name="TextBox 2"/>
+          <p:cNvSpPr txBox="1"/>
+          <p:nvPr/>
+        </p:nvSpPr>
+        <p:spPr>
+          <a:xfrm rot="1800000">
+            <a:off x="914400" y="1828800"/>
+            <a:ext cx="2743200" cy="914400"/>
+          </a:xfrm>
+          <a:prstGeom prst="rect">
+            <a:avLst/>
+          </a:prstGeom>
+          <a:noFill/>
+        </p:spPr>
+        <p:txBody>
+          <a:bodyPr wrap="none">
+            <a:spAutoFit/>
+          </a:bodyPr>
+          <a:lstStyle/>
+          <a:p>
+            <a:r>
+              <a:rPr sz="2000"/>
+              <a:t>Rotated 30 degrees</a:t>
+            </a:r>
+          </a:p>
+        </p:txBody>
+      </p:sp>
+      <p:sp>
+        <p:nvSpPr>
+          <p:cNvPr id="4" name="Right Arrow 3"/>
+          <p:cNvSpPr/>
+          <p:nvPr/>
+        </p:nvSpPr>
+        <p:spPr>
+          <a:xfrm flipH="1">
+            <a:off x="4572000" y="1828800"/>
+            <a:ext cx="1828800" cy="914400"/>
+          </a:xfrm>
+          <a:prstGeom prst="rightArrow">
+            <a:avLst/>
+          </a:prstGeom>
+          <a:solidFill>
+            <a:srgbClr val="4F81BD"/>
+          </a:solidFill>
+        </p:spPr>
+        <p:style>
+          <a:lnRef idx="1">
+            <a:schemeClr val="accent1"/>
+          </a:lnRef>
+          <a:fillRef idx="3">
+            <a:schemeClr val="accent1"/>
+          </a:fillRef>
+          <a:effectRef idx="2">
+            <a:schemeClr val="accent1"/>
+          </a:effectRef>
+          <a:fontRef idx="minor">
+            <a:schemeClr val="lt1"/>
+          </a:fontRef>
+        </p:style>
+        <p:txBody>
+          <a:bodyPr rtlCol="0" anchor="ctr"/>
+          <a:lstStyle/>
+          <a:p>
+            <a:pPr algn="ctr"/>
+          </a:p>
+        </p:txBody>
+      </p:sp>
+      <p:pic>
+        <p:nvPicPr>
+          <p:cNvPr id="5" name="Picture 4" descr="python-powered.png"/>
+          <p:cNvPicPr>
+            <a:picLocks noChangeAspect="1"/>
+          </p:cNvPicPr>
+          <p:nvPr/>
+        </p:nvPicPr>
+        <p:blipFill>
+          <a:blip r:embed="rId2"/>
+          <a:stretch>
+            <a:fillRect/>
+          </a:stretch>
+        </p:blipFill>
+        <p:spPr>
+          <a:xfrm rot="2700000">
+            <a:off x="3657600" y="3657600"/>
+            <a:ext cx="1828800" cy="914400"/>
+          </a:xfrm>
+          <a:prstGeom prst="rect">
+            <a:avLst/>
+          </a:prstGeom>
+        </p:spPr>
+      </p:pic>
+    </p:spTree>
+  </p:cSld>
+  <p:clrMapOvr>
+    <a:masterClrMapping/>
+  </p:clrMapOvr>
+</p:sld>
+</file>
+
+<file path=ppt/slides/slide9.xml><?xml version="1.0" encoding="utf-8"?>
+<p:sld xmlns:a="http://schemas.openxmlformats.org/drawingml/2006/main" xmlns:p="http://schemas.openxmlformats.org/presentationml/2006/main" xmlns:r="http://schemas.openxmlformats.org/officeDocument/2006/relationships">
+  <p:cSld>
+    <p:spTree>
+      <p:nvGrpSpPr>
+        <p:cNvPr id="1" name=""/>
+        <p:cNvGrpSpPr/>
+        <p:nvPr/>
+      </p:nvGrpSpPr>
+      <p:grpSpPr/>
+      <p:sp>
+        <p:nvSpPr>
+          <p:cNvPr id="2" name="Title 1"/>
+          <p:cNvSpPr>
+            <a:spLocks noGrp="1"/>
+          </p:cNvSpPr>
+          <p:nvPr>
+            <p:ph type="title"/>
+          </p:nvPr>
+        </p:nvSpPr>
+        <p:spPr/>
+        <p:txBody>
+          <a:bodyPr/>
+          <a:lstStyle/>
+          <a:p>
+            <a:r>
+              <a:t>Effects</a:t>
+            </a:r>
+          </a:p>
+        </p:txBody>
+      </p:sp>
+      <p:sp>
+        <p:nvSpPr>
+          <p:cNvPr id="3" name="Rectangle 2"/>
+          <p:cNvSpPr/>
+          <p:nvPr/>
+        </p:nvSpPr>
+        <p:spPr>
+          <a:xfrm>
+            <a:off x="685800" y="1828800"/>
+            <a:ext cx="2286000" cy="1097280"/>
+          </a:xfrm>
+          <a:prstGeom prst="rect">
+            <a:avLst/>
+          </a:prstGeom>
+          <a:solidFill>
+            <a:srgbClr val="4F81BD"/>
+          </a:solidFill>
+          <a:effectLst>
+            <a:outerShdw blurRad="50800" dist="38100" dir="2700000" algn="tl" rotWithShape="0">
+              <a:srgbClr val="000000">
+                <a:alpha val="50000"/>
+              </a:srgbClr>
+            </a:outerShdw>
+          </a:effectLst>
+        </p:spPr>
+        <p:style>
+          <a:lnRef idx="1">
+            <a:schemeClr val="accent1"/>
+          </a:lnRef>
+          <a:fillRef idx="3">
+            <a:schemeClr val="accent1"/>
+          </a:fillRef>
+          <a:effectRef idx="2">
+            <a:schemeClr val="accent1"/>
+          </a:effectRef>
+          <a:fontRef idx="minor">
+            <a:schemeClr val="lt1"/>
+          </a:fontRef>
+        </p:style>
+        <p:txBody>
+          <a:bodyPr rtlCol="0" anchor="ctr"/>
+          <a:lstStyle/>
+          <a:p>
+            <a:r>
+              <a:rPr>
+                <a:solidFill>
+                  <a:srgbClr val="FFFFFF"/>
+                </a:solidFill>
+              </a:rPr>
+              <a:t>Outer shadow</a:t>
+            </a:r>
+          </a:p>
+        </p:txBody>
+      </p:sp>
+      <p:sp>
+        <p:nvSpPr>
+          <p:cNvPr id="4" name="Rectangle 3"/>
+          <p:cNvSpPr/>
+          <p:nvPr/>
+        </p:nvSpPr>
+        <p:spPr>
+          <a:xfrm>
+            <a:off x="3657600" y="1828800"/>
+            <a:ext cx="2286000" cy="1097280"/>
+          </a:xfrm>
+          <a:prstGeom prst="rect">
+            <a:avLst/>
+          </a:prstGeom>
+          <a:solidFill>
+            <a:srgbClr val="FFFFFF"/>
+          </a:solidFill>
+          <a:ln>
+            <a:solidFill>
+              <a:srgbClr val="009966"/>
+            </a:solidFill>
+          </a:ln>
+          <a:effectLst>
+            <a:glow rad="63500">
+              <a:srgbClr val="00CC66">
+                <a:alpha val="60000"/>
+              </a:srgbClr>
+            </a:glow>
+          </a:effectLst>
+        </p:spPr>
+        <p:style>
+          <a:lnRef idx="1">
+            <a:schemeClr val="accent1"/>
+          </a:lnRef>
+          <a:fillRef idx="3">
+            <a:schemeClr val="accent1"/>
+          </a:fillRef>
+          <a:effectRef idx="2">
+            <a:schemeClr val="accent1"/>
+          </a:effectRef>
+          <a:fontRef idx="minor">
+            <a:schemeClr val="lt1"/>
+          </a:fontRef>
+        </p:style>
+        <p:txBody>
+          <a:bodyPr rtlCol="0" anchor="ctr"/>
+          <a:lstStyle/>
+          <a:p>
+            <a:r>
+              <a:t>Glow</a:t>
+            </a:r>
+          </a:p>
+        </p:txBody>
+      </p:sp>
+      <p:sp>
+        <p:nvSpPr>
+          <p:cNvPr id="5" name="Rectangle 4"/>
+          <p:cNvSpPr/>
+          <p:nvPr/>
+        </p:nvSpPr>
+        <p:spPr>
+          <a:xfrm>
+            <a:off x="6629400" y="1828800"/>
+            <a:ext cx="2286000" cy="1097280"/>
+          </a:xfrm>
+          <a:prstGeom prst="rect">
+            <a:avLst/>
+          </a:prstGeom>
+          <a:solidFill>
+            <a:srgbClr val="D9436E"/>
+          </a:solidFill>
+          <a:effectLst>
+            <a:blur rad="38100" grow="1"/>
+          </a:effectLst>
+        </p:spPr>
+        <p:style>
+          <a:lnRef idx="1">
+            <a:schemeClr val="accent1"/>
+          </a:lnRef>
+          <a:fillRef idx="3">
+            <a:schemeClr val="accent1"/>
+          </a:fillRef>
+          <a:effectRef idx="2">
+            <a:schemeClr val="accent1"/>
+          </a:effectRef>
+          <a:fontRef idx="minor">
+            <a:schemeClr val="lt1"/>
+          </a:fontRef>
+        </p:style>
+        <p:txBody>
+          <a:bodyPr rtlCol="0" anchor="ctr"/>
+          <a:lstStyle/>
+          <a:p>
+            <a:r>
+              <a:rPr>
+                <a:solidFill>
+                  <a:srgbClr val="FFFFFF"/>
+                </a:solidFill>
+              </a:rPr>
+              <a:t>Blur</a:t>
+            </a:r>
+          </a:p>
+        </p:txBody>
+      </p:sp>
+      <p:sp>
+        <p:nvSpPr>
+          <p:cNvPr id="6" name="Rectangle 5"/>
+          <p:cNvSpPr/>
+          <p:nvPr/>
+        </p:nvSpPr>
+        <p:spPr>
+          <a:xfrm>
+            <a:off x="685800" y="3657600"/>
+            <a:ext cx="2286000" cy="1097280"/>
+          </a:xfrm>
+          <a:prstGeom prst="rect">
+            <a:avLst/>
+          </a:prstGeom>
+          <a:solidFill>
+            <a:srgbClr val="F2F2F2"/>
+          </a:solidFill>
+          <a:effectLst>
+            <a:innerShdw blurRad="63500" dist="25400" dir="13500000">
+              <a:srgbClr val="000000">
+                <a:alpha val="60000"/>
+              </a:srgbClr>
+            </a:innerShdw>
+          </a:effectLst>
+        </p:spPr>
+        <p:style>
+          <a:lnRef idx="1">
+            <a:schemeClr val="accent1"/>
+          </a:lnRef>
+          <a:fillRef idx="3">
+            <a:schemeClr val="accent1"/>
+          </a:fillRef>
+          <a:effectRef idx="2">
+            <a:schemeClr val="accent1"/>
+          </a:effectRef>
+          <a:fontRef idx="minor">
+            <a:schemeClr val="lt1"/>
+          </a:fontRef>
+        </p:style>
+        <p:txBody>
+          <a:bodyPr rtlCol="0" anchor="ctr"/>
+          <a:lstStyle/>
+          <a:p>
+            <a:r>
+              <a:t>Inner shadow</a:t>
+            </a:r>
+          </a:p>
+        </p:txBody>
+      </p:sp>
+      <p:sp>
+        <p:nvSpPr>
+          <p:cNvPr id="7" name="Rectangle 6"/>
+          <p:cNvSpPr/>
+          <p:nvPr/>
+        </p:nvSpPr>
+        <p:spPr>
+          <a:xfrm>
+            <a:off x="3657600" y="3657600"/>
+            <a:ext cx="2286000" cy="1097280"/>
+          </a:xfrm>
+          <a:prstGeom prst="rect">
+            <a:avLst/>
+          </a:prstGeom>
+          <a:solidFill>
+            <a:srgbClr val="F79646"/>
+          </a:solidFill>
+          <a:effectLst>
+            <a:softEdge rad="50800"/>
+          </a:effectLst>
+        </p:spPr>
+        <p:style>
+          <a:lnRef idx="1">
+            <a:schemeClr val="accent1"/>
+          </a:lnRef>
+          <a:fillRef idx="3">
+            <a:schemeClr val="accent1"/>
+          </a:fillRef>
+          <a:effectRef idx="2">
+            <a:schemeClr val="accent1"/>
+          </a:effectRef>
+          <a:fontRef idx="minor">
+            <a:schemeClr val="lt1"/>
+          </a:fontRef>
+        </p:style>
+        <p:txBody>
+          <a:bodyPr rtlCol="0" anchor="ctr"/>
+          <a:lstStyle/>
+          <a:p>
+            <a:r>
+              <a:t>Soft edge</a:t>
+            </a:r>
+          </a:p>
+        </p:txBody>
+      </p:sp>
+      <p:sp>
+        <p:nvSpPr>
+          <p:cNvPr id="8" name="Rectangle 7"/>
+          <p:cNvSpPr/>
+          <p:nvPr/>
+        </p:nvSpPr>
+        <p:spPr>
+          <a:xfrm>
+            <a:off x="6629400" y="3657600"/>
+            <a:ext cx="2286000" cy="1097280"/>
+          </a:xfrm>
+          <a:prstGeom prst="rect">
+            <a:avLst/>
+          </a:prstGeom>
+          <a:solidFill>
+            <a:srgbClr val="4F81BD"/>
+          </a:solidFill>
+          <a:effectLst>
+            <a:reflection blurRad="6350" stA="50000" stPos="0" endA="300" endPos="50000" dist="38100" dir="5400000" sy="-100000" algn="bl" rotWithShape="0"/>
+          </a:effectLst>
+        </p:spPr>
+        <p:style>
+          <a:lnRef idx="1">
+            <a:schemeClr val="accent1"/>
+          </a:lnRef>
+          <a:fillRef idx="3">
+            <a:schemeClr val="accent1"/>
+          </a:fillRef>
+          <a:effectRef idx="2">
+            <a:schemeClr val="accent1"/>
+          </a:effectRef>
+          <a:fontRef idx="minor">
+            <a:schemeClr val="lt1"/>
+          </a:fontRef>
+        </p:style>
+        <p:txBody>
+          <a:bodyPr rtlCol="0" anchor="ctr"/>
+          <a:lstStyle/>
+          <a:p>
+            <a:r>
+              <a:rPr>
+                <a:solidFill>
+                  <a:srgbClr val="FFFFFF"/>
+                </a:solidFill>
+              </a:rPr>
+              <a:t>Reflection</a:t>
+            </a:r>
+          </a:p>
+        </p:txBody>
+      </p:sp>
     </p:spTree>
   </p:cSld>
   <p:clrMapOvr>

</xml_diff>

<commit_message>
chore: regenerate basic fixture for wave 4
</commit_message>
<xml_diff>
--- a/tests/render-test/basic/presentation.pptx
+++ b/tests/render-test/basic/presentation.pptx
@@ -21,7 +21,9 @@
     <p:sldId id="269" r:id="rId21"/>
     <p:sldId id="270" r:id="rId22"/>
     <p:sldId id="271" r:id="rId23"/>
-    <p:sldId id="272" r:id="rId24" show="0"/>
+    <p:sldId id="272" r:id="rId24"/>
+    <p:sldId id="273" r:id="rId25"/>
+    <p:sldId id="274" r:id="rId26" show="0"/>
   </p:sldIdLst>
   <p:sldSz cx="9144000" cy="6858000" type="screen4x3"/>
   <p:notesSz cx="6858000" cy="9144000"/>
@@ -4515,82 +4517,353 @@
           <a:lstStyle/>
           <a:p>
             <a:r>
-              <a:t>Typography</a:t>
-            </a:r>
-          </a:p>
-        </p:txBody>
-      </p:sp>
-      <p:sp>
-        <p:nvSpPr>
-          <p:cNvPr id="3" name="TextBox 2"/>
-          <p:cNvSpPr txBox="1"/>
+              <a:t>Lines</a:t>
+            </a:r>
+          </a:p>
+        </p:txBody>
+      </p:sp>
+      <p:cxnSp>
+        <p:nvCxnSpPr>
+          <p:cNvPr id="3" name="Connector 2"/>
+          <p:cNvCxnSpPr/>
           <p:nvPr/>
-        </p:nvSpPr>
+        </p:nvCxnSpPr>
         <p:spPr>
           <a:xfrm>
-            <a:off x="914400" y="1371600"/>
-            <a:ext cx="7315200" cy="3657600"/>
+            <a:off x="914400" y="1828800"/>
+            <a:ext cx="2743200" cy="0"/>
+          </a:xfrm>
+          <a:prstGeom prst="line">
+            <a:avLst/>
+          </a:prstGeom>
+          <a:ln w="19050">
+            <a:solidFill>
+              <a:srgbClr val="1F497D"/>
+            </a:solidFill>
+          </a:ln>
+        </p:spPr>
+        <p:style>
+          <a:lnRef idx="2">
+            <a:schemeClr val="accent1"/>
+          </a:lnRef>
+          <a:fillRef idx="0">
+            <a:schemeClr val="accent1"/>
+          </a:fillRef>
+          <a:effectRef idx="1">
+            <a:schemeClr val="accent1"/>
+          </a:effectRef>
+          <a:fontRef idx="minor">
+            <a:schemeClr val="tx1"/>
+          </a:fontRef>
+        </p:style>
+      </p:cxnSp>
+      <p:cxnSp>
+        <p:nvCxnSpPr>
+          <p:cNvPr id="4" name="Connector 3"/>
+          <p:cNvCxnSpPr/>
+          <p:nvPr/>
+        </p:nvCxnSpPr>
+        <p:spPr>
+          <a:xfrm>
+            <a:off x="914400" y="2286000"/>
+            <a:ext cx="2743200" cy="0"/>
+          </a:xfrm>
+          <a:prstGeom prst="line">
+            <a:avLst/>
+          </a:prstGeom>
+          <a:ln w="19050">
+            <a:solidFill>
+              <a:srgbClr val="C0504D"/>
+            </a:solidFill>
+            <a:prstDash val="dash"/>
+          </a:ln>
+        </p:spPr>
+        <p:style>
+          <a:lnRef idx="2">
+            <a:schemeClr val="accent1"/>
+          </a:lnRef>
+          <a:fillRef idx="0">
+            <a:schemeClr val="accent1"/>
+          </a:fillRef>
+          <a:effectRef idx="1">
+            <a:schemeClr val="accent1"/>
+          </a:effectRef>
+          <a:fontRef idx="minor">
+            <a:schemeClr val="tx1"/>
+          </a:fontRef>
+        </p:style>
+      </p:cxnSp>
+      <p:cxnSp>
+        <p:nvCxnSpPr>
+          <p:cNvPr id="5" name="Connector 4"/>
+          <p:cNvCxnSpPr/>
+          <p:nvPr/>
+        </p:nvCxnSpPr>
+        <p:spPr>
+          <a:xfrm>
+            <a:off x="914400" y="2743200"/>
+            <a:ext cx="2743200" cy="0"/>
+          </a:xfrm>
+          <a:prstGeom prst="line">
+            <a:avLst/>
+          </a:prstGeom>
+          <a:ln w="19050">
+            <a:solidFill>
+              <a:srgbClr val="4F81BD"/>
+            </a:solidFill>
+            <a:prstDash val="dot"/>
+          </a:ln>
+        </p:spPr>
+        <p:style>
+          <a:lnRef idx="2">
+            <a:schemeClr val="accent1"/>
+          </a:lnRef>
+          <a:fillRef idx="0">
+            <a:schemeClr val="accent1"/>
+          </a:fillRef>
+          <a:effectRef idx="1">
+            <a:schemeClr val="accent1"/>
+          </a:effectRef>
+          <a:fontRef idx="minor">
+            <a:schemeClr val="tx1"/>
+          </a:fontRef>
+        </p:style>
+      </p:cxnSp>
+      <p:cxnSp>
+        <p:nvCxnSpPr>
+          <p:cNvPr id="6" name="Connector 5"/>
+          <p:cNvCxnSpPr/>
+          <p:nvPr/>
+        </p:nvCxnSpPr>
+        <p:spPr>
+          <a:xfrm>
+            <a:off x="914400" y="3200400"/>
+            <a:ext cx="2743200" cy="0"/>
+          </a:xfrm>
+          <a:prstGeom prst="line">
+            <a:avLst/>
+          </a:prstGeom>
+          <a:ln w="19050">
+            <a:solidFill>
+              <a:srgbClr val="5A7A3B"/>
+            </a:solidFill>
+            <a:prstDash val="lgDashDot"/>
+          </a:ln>
+        </p:spPr>
+        <p:style>
+          <a:lnRef idx="2">
+            <a:schemeClr val="accent1"/>
+          </a:lnRef>
+          <a:fillRef idx="0">
+            <a:schemeClr val="accent1"/>
+          </a:fillRef>
+          <a:effectRef idx="1">
+            <a:schemeClr val="accent1"/>
+          </a:effectRef>
+          <a:fontRef idx="minor">
+            <a:schemeClr val="tx1"/>
+          </a:fontRef>
+        </p:style>
+      </p:cxnSp>
+      <p:cxnSp>
+        <p:nvCxnSpPr>
+          <p:cNvPr id="7" name="Connector 6"/>
+          <p:cNvCxnSpPr/>
+          <p:nvPr/>
+        </p:nvCxnSpPr>
+        <p:spPr>
+          <a:xfrm>
+            <a:off x="5029200" y="1828800"/>
+            <a:ext cx="2743200" cy="0"/>
+          </a:xfrm>
+          <a:prstGeom prst="line">
+            <a:avLst/>
+          </a:prstGeom>
+          <a:ln w="19050">
+            <a:solidFill>
+              <a:srgbClr val="1F497D"/>
+            </a:solidFill>
+            <a:tailEnd type="triangle" w="med" len="med"/>
+          </a:ln>
+        </p:spPr>
+        <p:style>
+          <a:lnRef idx="2">
+            <a:schemeClr val="accent1"/>
+          </a:lnRef>
+          <a:fillRef idx="0">
+            <a:schemeClr val="accent1"/>
+          </a:fillRef>
+          <a:effectRef idx="1">
+            <a:schemeClr val="accent1"/>
+          </a:effectRef>
+          <a:fontRef idx="minor">
+            <a:schemeClr val="tx1"/>
+          </a:fontRef>
+        </p:style>
+      </p:cxnSp>
+      <p:cxnSp>
+        <p:nvCxnSpPr>
+          <p:cNvPr id="8" name="Connector 7"/>
+          <p:cNvCxnSpPr/>
+          <p:nvPr/>
+        </p:nvCxnSpPr>
+        <p:spPr>
+          <a:xfrm>
+            <a:off x="5029200" y="2286000"/>
+            <a:ext cx="2743200" cy="0"/>
+          </a:xfrm>
+          <a:prstGeom prst="line">
+            <a:avLst/>
+          </a:prstGeom>
+          <a:ln w="19050">
+            <a:solidFill>
+              <a:srgbClr val="C0504D"/>
+            </a:solidFill>
+            <a:headEnd type="stealth" w="lg" len="lg"/>
+            <a:tailEnd type="stealth" w="lg" len="lg"/>
+          </a:ln>
+        </p:spPr>
+        <p:style>
+          <a:lnRef idx="2">
+            <a:schemeClr val="accent1"/>
+          </a:lnRef>
+          <a:fillRef idx="0">
+            <a:schemeClr val="accent1"/>
+          </a:fillRef>
+          <a:effectRef idx="1">
+            <a:schemeClr val="accent1"/>
+          </a:effectRef>
+          <a:fontRef idx="minor">
+            <a:schemeClr val="tx1"/>
+          </a:fontRef>
+        </p:style>
+      </p:cxnSp>
+      <p:cxnSp>
+        <p:nvCxnSpPr>
+          <p:cNvPr id="9" name="Connector 8"/>
+          <p:cNvCxnSpPr/>
+          <p:nvPr/>
+        </p:nvCxnSpPr>
+        <p:spPr>
+          <a:xfrm>
+            <a:off x="5029200" y="2743200"/>
+            <a:ext cx="2743200" cy="0"/>
+          </a:xfrm>
+          <a:prstGeom prst="line">
+            <a:avLst/>
+          </a:prstGeom>
+          <a:ln w="19050">
+            <a:solidFill>
+              <a:srgbClr val="4F81BD"/>
+            </a:solidFill>
+            <a:prstDash val="dash"/>
+            <a:headEnd type="diamond" w="med" len="med"/>
+            <a:tailEnd type="oval" w="med" len="med"/>
+          </a:ln>
+        </p:spPr>
+        <p:style>
+          <a:lnRef idx="2">
+            <a:schemeClr val="accent1"/>
+          </a:lnRef>
+          <a:fillRef idx="0">
+            <a:schemeClr val="accent1"/>
+          </a:fillRef>
+          <a:effectRef idx="1">
+            <a:schemeClr val="accent1"/>
+          </a:effectRef>
+          <a:fontRef idx="minor">
+            <a:schemeClr val="tx1"/>
+          </a:fontRef>
+        </p:style>
+      </p:cxnSp>
+      <p:sp>
+        <p:nvSpPr>
+          <p:cNvPr id="10" name="Rectangle 9"/>
+          <p:cNvSpPr/>
+          <p:nvPr/>
+        </p:nvSpPr>
+        <p:spPr>
+          <a:xfrm>
+            <a:off x="914400" y="4114800"/>
+            <a:ext cx="2743200" cy="1371600"/>
           </a:xfrm>
           <a:prstGeom prst="rect">
             <a:avLst/>
           </a:prstGeom>
           <a:noFill/>
-        </p:spPr>
-        <p:txBody>
-          <a:bodyPr wrap="square">
-            <a:spAutoFit/>
-          </a:bodyPr>
-          <a:lstStyle/>
-          <a:p>
-            <a:r>
-              <a:t>Plain then </a:t>
-            </a:r>
-            <a:r>
-              <a:rPr u="sng"/>
-              <a:t>underlined</a:t>
-            </a:r>
-            <a:r>
-              <a:t> then </a:t>
-            </a:r>
-            <a:r>
-              <a:rPr strike="sngStrike"/>
-              <a:t>strikethrough</a:t>
-            </a:r>
-            <a:r>
-              <a:t>.</a:t>
-            </a:r>
-          </a:p>
-          <a:p>
-            <a:r>
-              <a:t>E = mc</a:t>
-            </a:r>
-            <a:r>
-              <a:rPr baseline="30000"/>
-              <a:t>2</a:t>
-            </a:r>
-            <a:r>
-              <a:t>, H</a:t>
-            </a:r>
-            <a:r>
-              <a:rPr baseline="-25000"/>
-              <a:t>2</a:t>
-            </a:r>
-            <a:r>
-              <a:t>O, </a:t>
-            </a:r>
-            <a:r>
-              <a:rPr spc="200"/>
-              <a:t>l e t t e r   s p a c e d</a:t>
-            </a:r>
-          </a:p>
-          <a:p>
-            <a:pPr>
-              <a:lnSpc>
-                <a:spcPct val="150000"/>
-              </a:lnSpc>
-            </a:pPr>
-            <a:r>
-              <a:t>This paragraph uses 1.5x line spacing so you can see the extra vertical room between wrapped lines. Quick brown foxes and lazy dogs.</a:t>
+          <a:ln w="28575" cap="rnd">
+            <a:solidFill>
+              <a:srgbClr val="C0504D"/>
+            </a:solidFill>
+            <a:prstDash val="dot"/>
+            <a:bevel/>
+          </a:ln>
+        </p:spPr>
+        <p:style>
+          <a:lnRef idx="1">
+            <a:schemeClr val="accent1"/>
+          </a:lnRef>
+          <a:fillRef idx="3">
+            <a:schemeClr val="accent1"/>
+          </a:fillRef>
+          <a:effectRef idx="2">
+            <a:schemeClr val="accent1"/>
+          </a:effectRef>
+          <a:fontRef idx="minor">
+            <a:schemeClr val="lt1"/>
+          </a:fontRef>
+        </p:style>
+        <p:txBody>
+          <a:bodyPr rtlCol="0" anchor="ctr"/>
+          <a:lstStyle/>
+          <a:p>
+            <a:r>
+              <a:t>Dotted border</a:t>
+            </a:r>
+          </a:p>
+        </p:txBody>
+      </p:sp>
+      <p:sp>
+        <p:nvSpPr>
+          <p:cNvPr id="11" name="Rectangle 10"/>
+          <p:cNvSpPr/>
+          <p:nvPr/>
+        </p:nvSpPr>
+        <p:spPr>
+          <a:xfrm>
+            <a:off x="4572000" y="4114800"/>
+            <a:ext cx="2743200" cy="1371600"/>
+          </a:xfrm>
+          <a:prstGeom prst="rect">
+            <a:avLst/>
+          </a:prstGeom>
+          <a:noFill/>
+          <a:ln w="38100" cmpd="dbl">
+            <a:solidFill>
+              <a:srgbClr val="1F497D"/>
+            </a:solidFill>
+          </a:ln>
+        </p:spPr>
+        <p:style>
+          <a:lnRef idx="1">
+            <a:schemeClr val="accent1"/>
+          </a:lnRef>
+          <a:fillRef idx="3">
+            <a:schemeClr val="accent1"/>
+          </a:fillRef>
+          <a:effectRef idx="2">
+            <a:schemeClr val="accent1"/>
+          </a:effectRef>
+          <a:fontRef idx="minor">
+            <a:schemeClr val="lt1"/>
+          </a:fontRef>
+        </p:style>
+        <p:txBody>
+          <a:bodyPr rtlCol="0" anchor="ctr"/>
+          <a:lstStyle/>
+          <a:p>
+            <a:r>
+              <a:t>Double border</a:t>
             </a:r>
           </a:p>
         </p:txBody>
@@ -4604,6 +4877,296 @@
 </file>
 
 <file path=ppt/slides/slide16.xml><?xml version="1.0" encoding="utf-8"?>
+<p:sld xmlns:a="http://schemas.openxmlformats.org/drawingml/2006/main" xmlns:p="http://schemas.openxmlformats.org/presentationml/2006/main" xmlns:r="http://schemas.openxmlformats.org/officeDocument/2006/relationships">
+  <p:cSld>
+    <p:spTree>
+      <p:nvGrpSpPr>
+        <p:cNvPr id="1" name=""/>
+        <p:cNvGrpSpPr/>
+        <p:nvPr/>
+      </p:nvGrpSpPr>
+      <p:grpSpPr/>
+      <p:sp>
+        <p:nvSpPr>
+          <p:cNvPr id="2" name="Title 1"/>
+          <p:cNvSpPr>
+            <a:spLocks noGrp="1"/>
+          </p:cNvSpPr>
+          <p:nvPr>
+            <p:ph type="title"/>
+          </p:nvPr>
+        </p:nvSpPr>
+        <p:spPr/>
+        <p:txBody>
+          <a:bodyPr/>
+          <a:lstStyle/>
+          <a:p>
+            <a:r>
+              <a:t>Typography</a:t>
+            </a:r>
+          </a:p>
+        </p:txBody>
+      </p:sp>
+      <p:sp>
+        <p:nvSpPr>
+          <p:cNvPr id="3" name="TextBox 2"/>
+          <p:cNvSpPr txBox="1"/>
+          <p:nvPr/>
+        </p:nvSpPr>
+        <p:spPr>
+          <a:xfrm>
+            <a:off x="914400" y="1371600"/>
+            <a:ext cx="7315200" cy="3657600"/>
+          </a:xfrm>
+          <a:prstGeom prst="rect">
+            <a:avLst/>
+          </a:prstGeom>
+          <a:noFill/>
+        </p:spPr>
+        <p:txBody>
+          <a:bodyPr wrap="square">
+            <a:spAutoFit/>
+          </a:bodyPr>
+          <a:lstStyle/>
+          <a:p>
+            <a:r>
+              <a:t>Plain then </a:t>
+            </a:r>
+            <a:r>
+              <a:rPr u="sng"/>
+              <a:t>underlined</a:t>
+            </a:r>
+            <a:r>
+              <a:t> then </a:t>
+            </a:r>
+            <a:r>
+              <a:rPr strike="sngStrike"/>
+              <a:t>strikethrough</a:t>
+            </a:r>
+            <a:r>
+              <a:t>.</a:t>
+            </a:r>
+          </a:p>
+          <a:p>
+            <a:r>
+              <a:t>E = mc</a:t>
+            </a:r>
+            <a:r>
+              <a:rPr baseline="30000"/>
+              <a:t>2</a:t>
+            </a:r>
+            <a:r>
+              <a:t>, H</a:t>
+            </a:r>
+            <a:r>
+              <a:rPr baseline="-25000"/>
+              <a:t>2</a:t>
+            </a:r>
+            <a:r>
+              <a:t>O, </a:t>
+            </a:r>
+            <a:r>
+              <a:rPr spc="200"/>
+              <a:t>l e t t e r   s p a c e d</a:t>
+            </a:r>
+          </a:p>
+          <a:p>
+            <a:pPr>
+              <a:lnSpc>
+                <a:spcPct val="150000"/>
+              </a:lnSpc>
+            </a:pPr>
+            <a:r>
+              <a:t>This paragraph uses 1.5x line spacing so you can see the extra vertical room between wrapped lines. Quick brown foxes and lazy dogs.</a:t>
+            </a:r>
+          </a:p>
+        </p:txBody>
+      </p:sp>
+    </p:spTree>
+  </p:cSld>
+  <p:clrMapOvr>
+    <a:masterClrMapping/>
+  </p:clrMapOvr>
+</p:sld>
+</file>
+
+<file path=ppt/slides/slide17.xml><?xml version="1.0" encoding="utf-8"?>
+<p:sld xmlns:a="http://schemas.openxmlformats.org/drawingml/2006/main" xmlns:p="http://schemas.openxmlformats.org/presentationml/2006/main" xmlns:r="http://schemas.openxmlformats.org/officeDocument/2006/relationships">
+  <p:cSld>
+    <p:spTree>
+      <p:nvGrpSpPr>
+        <p:cNvPr id="1" name=""/>
+        <p:cNvGrpSpPr/>
+        <p:nvPr/>
+      </p:nvGrpSpPr>
+      <p:grpSpPr/>
+      <p:sp>
+        <p:nvSpPr>
+          <p:cNvPr id="2" name="Title 1"/>
+          <p:cNvSpPr>
+            <a:spLocks noGrp="1"/>
+          </p:cNvSpPr>
+          <p:nvPr>
+            <p:ph type="title"/>
+          </p:nvPr>
+        </p:nvSpPr>
+        <p:spPr/>
+        <p:txBody>
+          <a:bodyPr/>
+          <a:lstStyle/>
+          <a:p>
+            <a:r>
+              <a:t>Text frame</a:t>
+            </a:r>
+          </a:p>
+        </p:txBody>
+      </p:sp>
+      <p:sp>
+        <p:nvSpPr>
+          <p:cNvPr id="3" name="Rectangle 2"/>
+          <p:cNvSpPr/>
+          <p:nvPr/>
+        </p:nvSpPr>
+        <p:spPr>
+          <a:xfrm>
+            <a:off x="457200" y="1645920"/>
+            <a:ext cx="2743200" cy="2286000"/>
+          </a:xfrm>
+          <a:prstGeom prst="rect">
+            <a:avLst/>
+          </a:prstGeom>
+          <a:noFill/>
+          <a:ln>
+            <a:solidFill>
+              <a:srgbClr val="4F81BD"/>
+            </a:solidFill>
+          </a:ln>
+        </p:spPr>
+        <p:style>
+          <a:lnRef idx="1">
+            <a:schemeClr val="accent1"/>
+          </a:lnRef>
+          <a:fillRef idx="3">
+            <a:schemeClr val="accent1"/>
+          </a:fillRef>
+          <a:effectRef idx="2">
+            <a:schemeClr val="accent1"/>
+          </a:effectRef>
+          <a:fontRef idx="minor">
+            <a:schemeClr val="lt1"/>
+          </a:fontRef>
+        </p:style>
+        <p:txBody>
+          <a:bodyPr rtlCol="0" anchor="ctr"/>
+          <a:lstStyle/>
+          <a:p>
+            <a:r>
+              <a:t>Centered vertically</a:t>
+            </a:r>
+          </a:p>
+        </p:txBody>
+      </p:sp>
+      <p:sp>
+        <p:nvSpPr>
+          <p:cNvPr id="4" name="Rectangle 3"/>
+          <p:cNvSpPr/>
+          <p:nvPr/>
+        </p:nvSpPr>
+        <p:spPr>
+          <a:xfrm>
+            <a:off x="3657600" y="1645920"/>
+            <a:ext cx="2743200" cy="2286000"/>
+          </a:xfrm>
+          <a:prstGeom prst="rect">
+            <a:avLst/>
+          </a:prstGeom>
+          <a:solidFill>
+            <a:srgbClr val="E8EEF7"/>
+          </a:solidFill>
+          <a:ln>
+            <a:solidFill>
+              <a:srgbClr val="4F81BD"/>
+            </a:solidFill>
+          </a:ln>
+        </p:spPr>
+        <p:style>
+          <a:lnRef idx="1">
+            <a:schemeClr val="accent1"/>
+          </a:lnRef>
+          <a:fillRef idx="3">
+            <a:schemeClr val="accent1"/>
+          </a:fillRef>
+          <a:effectRef idx="2">
+            <a:schemeClr val="accent1"/>
+          </a:effectRef>
+          <a:fontRef idx="minor">
+            <a:schemeClr val="lt1"/>
+          </a:fontRef>
+        </p:style>
+        <p:txBody>
+          <a:bodyPr rtlCol="0" anchor="ctr" lIns="457200" tIns="457200" rIns="457200" bIns="457200"/>
+          <a:lstStyle/>
+          <a:p>
+            <a:r>
+              <a:t>Wide insets around this text.</a:t>
+            </a:r>
+          </a:p>
+        </p:txBody>
+      </p:sp>
+      <p:sp>
+        <p:nvSpPr>
+          <p:cNvPr id="5" name="Rectangle 4"/>
+          <p:cNvSpPr/>
+          <p:nvPr/>
+        </p:nvSpPr>
+        <p:spPr>
+          <a:xfrm>
+            <a:off x="457200" y="4114800"/>
+            <a:ext cx="2743200" cy="731520"/>
+          </a:xfrm>
+          <a:prstGeom prst="rect">
+            <a:avLst/>
+          </a:prstGeom>
+          <a:noFill/>
+          <a:ln>
+            <a:solidFill>
+              <a:srgbClr val="C0504D"/>
+            </a:solidFill>
+          </a:ln>
+        </p:spPr>
+        <p:style>
+          <a:lnRef idx="1">
+            <a:schemeClr val="accent1"/>
+          </a:lnRef>
+          <a:fillRef idx="3">
+            <a:schemeClr val="accent1"/>
+          </a:fillRef>
+          <a:effectRef idx="2">
+            <a:schemeClr val="accent1"/>
+          </a:effectRef>
+          <a:fontRef idx="minor">
+            <a:schemeClr val="lt1"/>
+          </a:fontRef>
+        </p:style>
+        <p:txBody>
+          <a:bodyPr rtlCol="0" anchor="ctr" wrap="none"/>
+          <a:lstStyle/>
+          <a:p>
+            <a:r>
+              <a:t>This line should not wrap even though it is long.</a:t>
+            </a:r>
+          </a:p>
+        </p:txBody>
+      </p:sp>
+    </p:spTree>
+  </p:cSld>
+  <p:clrMapOvr>
+    <a:masterClrMapping/>
+  </p:clrMapOvr>
+</p:sld>
+</file>
+
+<file path=ppt/slides/slide18.xml><?xml version="1.0" encoding="utf-8"?>
 <p:sld xmlns:a="http://schemas.openxmlformats.org/drawingml/2006/main" xmlns:p="http://schemas.openxmlformats.org/presentationml/2006/main" xmlns:r="http://schemas.openxmlformats.org/officeDocument/2006/relationships">
   <p:cSld>
     <p:spTree>
@@ -4660,7 +5223,7 @@
 </p:sld>
 </file>
 
-<file path=ppt/slides/slide17.xml><?xml version="1.0" encoding="utf-8"?>
+<file path=ppt/slides/slide19.xml><?xml version="1.0" encoding="utf-8"?>
 <p:sld xmlns:a="http://schemas.openxmlformats.org/drawingml/2006/main" xmlns:p="http://schemas.openxmlformats.org/presentationml/2006/main" xmlns:r="http://schemas.openxmlformats.org/officeDocument/2006/relationships">
   <p:cSld>
     <p:spTree>

</xml_diff>

<commit_message>
feat(text): extended auto-num enum + image bullets + accurate indent math
Adds ~20 auto-number variants (circled, CJK Chs/Cht, Japanese, Korean,
Thai, Hebrew, arabic double-byte) to formatAutoNum — fall-through to
default for truly exotic formats. BulletDef gains a 'blip' kind;
<a:buBlip> renders as an <img> marker resolved through the embedUrls
map. marL/indent EMU values now drive padding-left/text-indent
directly instead of the hard-coded level*24px fallback.

Co-Authored-By: Claude Opus 4.7 (1M context) <noreply@anthropic.com>
</commit_message>
<xml_diff>
--- a/tests/render-test/basic/presentation.pptx
+++ b/tests/render-test/basic/presentation.pptx
@@ -23,7 +23,8 @@
     <p:sldId id="271" r:id="rId23"/>
     <p:sldId id="272" r:id="rId24"/>
     <p:sldId id="273" r:id="rId25"/>
-    <p:sldId id="274" r:id="rId26" show="0"/>
+    <p:sldId id="274" r:id="rId26"/>
+    <p:sldId id="275" r:id="rId27" show="0"/>
   </p:sldIdLst>
   <p:sldSz cx="9144000" cy="6858000" type="screen4x3"/>
   <p:notesSz cx="6858000" cy="9144000"/>
@@ -5192,6 +5193,134 @@
           <a:lstStyle/>
           <a:p>
             <a:r>
+              <a:t>Numbering formats</a:t>
+            </a:r>
+          </a:p>
+        </p:txBody>
+      </p:sp>
+      <p:sp>
+        <p:nvSpPr>
+          <p:cNvPr id="3" name="TextBox 2"/>
+          <p:cNvSpPr txBox="1"/>
+          <p:nvPr/>
+        </p:nvSpPr>
+        <p:spPr>
+          <a:xfrm>
+            <a:off x="914400" y="1371600"/>
+            <a:ext cx="7315200" cy="4572000"/>
+          </a:xfrm>
+          <a:prstGeom prst="rect">
+            <a:avLst/>
+          </a:prstGeom>
+          <a:noFill/>
+        </p:spPr>
+        <p:txBody>
+          <a:bodyPr wrap="square">
+            <a:spAutoFit/>
+          </a:bodyPr>
+          <a:lstStyle/>
+          <a:p>
+            <a:pPr>
+              <a:buAutoNum type="arabicPeriod"/>
+            </a:pPr>
+            <a:r>
+              <a:t>Arabic period</a:t>
+            </a:r>
+          </a:p>
+          <a:p>
+            <a:pPr>
+              <a:buAutoNum type="arabic1Minus"/>
+            </a:pPr>
+            <a:r>
+              <a:t>Arabic minus</a:t>
+            </a:r>
+          </a:p>
+          <a:p>
+            <a:pPr>
+              <a:buAutoNum type="circleNumDbPlain"/>
+            </a:pPr>
+            <a:r>
+              <a:t>Circled number</a:t>
+            </a:r>
+          </a:p>
+          <a:p>
+            <a:pPr>
+              <a:buAutoNum type="ea1ChsPeriod"/>
+            </a:pPr>
+            <a:r>
+              <a:t>Chinese Simplified</a:t>
+            </a:r>
+          </a:p>
+          <a:p>
+            <a:pPr>
+              <a:buAutoNum type="ea1JpnKorPlain"/>
+            </a:pPr>
+            <a:r>
+              <a:t>Korean hangul</a:t>
+            </a:r>
+          </a:p>
+          <a:p>
+            <a:pPr>
+              <a:buAutoNum type="thaiNumPeriod"/>
+            </a:pPr>
+            <a:r>
+              <a:t>Thai digits</a:t>
+            </a:r>
+          </a:p>
+          <a:p>
+            <a:pPr>
+              <a:buAutoNum type="hebrew2Minus"/>
+            </a:pPr>
+            <a:r>
+              <a:t>Hebrew letter</a:t>
+            </a:r>
+          </a:p>
+          <a:p>
+            <a:pPr>
+              <a:buBlip>
+                <a:blip r:embed="rId2"/>
+              </a:buBlip>
+            </a:pPr>
+            <a:r>
+              <a:t>Image bullet</a:t>
+            </a:r>
+          </a:p>
+        </p:txBody>
+      </p:sp>
+    </p:spTree>
+  </p:cSld>
+  <p:clrMapOvr>
+    <a:masterClrMapping/>
+  </p:clrMapOvr>
+</p:sld>
+</file>
+
+<file path=ppt/slides/slide19.xml><?xml version="1.0" encoding="utf-8"?>
+<p:sld xmlns:a="http://schemas.openxmlformats.org/drawingml/2006/main" xmlns:p="http://schemas.openxmlformats.org/presentationml/2006/main" xmlns:r="http://schemas.openxmlformats.org/officeDocument/2006/relationships">
+  <p:cSld>
+    <p:spTree>
+      <p:nvGrpSpPr>
+        <p:cNvPr id="1" name=""/>
+        <p:cNvGrpSpPr/>
+        <p:nvPr/>
+      </p:nvGrpSpPr>
+      <p:grpSpPr/>
+      <p:sp>
+        <p:nvSpPr>
+          <p:cNvPr id="2" name="Title 1"/>
+          <p:cNvSpPr>
+            <a:spLocks noGrp="1"/>
+          </p:cNvSpPr>
+          <p:nvPr>
+            <p:ph type="title"/>
+          </p:nvPr>
+        </p:nvSpPr>
+        <p:spPr/>
+        <p:txBody>
+          <a:bodyPr/>
+          <a:lstStyle/>
+          <a:p>
+            <a:r>
               <a:t>A chart</a:t>
             </a:r>
           </a:p>
@@ -5223,45 +5352,6 @@
 </p:sld>
 </file>
 
-<file path=ppt/slides/slide19.xml><?xml version="1.0" encoding="utf-8"?>
-<p:sld xmlns:a="http://schemas.openxmlformats.org/drawingml/2006/main" xmlns:p="http://schemas.openxmlformats.org/presentationml/2006/main" xmlns:r="http://schemas.openxmlformats.org/officeDocument/2006/relationships">
-  <p:cSld>
-    <p:spTree>
-      <p:nvGrpSpPr>
-        <p:cNvPr id="1" name=""/>
-        <p:cNvGrpSpPr/>
-        <p:nvPr/>
-      </p:nvGrpSpPr>
-      <p:grpSpPr/>
-      <p:sp>
-        <p:nvSpPr>
-          <p:cNvPr id="2" name="Title 1"/>
-          <p:cNvSpPr>
-            <a:spLocks noGrp="1"/>
-          </p:cNvSpPr>
-          <p:nvPr>
-            <p:ph type="title"/>
-          </p:nvPr>
-        </p:nvSpPr>
-        <p:spPr/>
-        <p:txBody>
-          <a:bodyPr/>
-          <a:lstStyle/>
-          <a:p>
-            <a:r>
-              <a:t>Hidden slide</a:t>
-            </a:r>
-          </a:p>
-        </p:txBody>
-      </p:sp>
-    </p:spTree>
-  </p:cSld>
-  <p:clrMapOvr>
-    <a:masterClrMapping/>
-  </p:clrMapOvr>
-</p:sld>
-</file>
-
 <file path=ppt/slides/slide2.xml><?xml version="1.0" encoding="utf-8"?>
 <p:sld xmlns:a="http://schemas.openxmlformats.org/drawingml/2006/main" xmlns:p="http://schemas.openxmlformats.org/presentationml/2006/main" xmlns:r="http://schemas.openxmlformats.org/officeDocument/2006/relationships">
   <p:cSld>
@@ -5326,6 +5416,45 @@
             </a:pPr>
             <a:r>
               <a:t>Third bullet</a:t>
+            </a:r>
+          </a:p>
+        </p:txBody>
+      </p:sp>
+    </p:spTree>
+  </p:cSld>
+  <p:clrMapOvr>
+    <a:masterClrMapping/>
+  </p:clrMapOvr>
+</p:sld>
+</file>
+
+<file path=ppt/slides/slide20.xml><?xml version="1.0" encoding="utf-8"?>
+<p:sld xmlns:a="http://schemas.openxmlformats.org/drawingml/2006/main" xmlns:p="http://schemas.openxmlformats.org/presentationml/2006/main" xmlns:r="http://schemas.openxmlformats.org/officeDocument/2006/relationships">
+  <p:cSld>
+    <p:spTree>
+      <p:nvGrpSpPr>
+        <p:cNvPr id="1" name=""/>
+        <p:cNvGrpSpPr/>
+        <p:nvPr/>
+      </p:nvGrpSpPr>
+      <p:grpSpPr/>
+      <p:sp>
+        <p:nvSpPr>
+          <p:cNvPr id="2" name="Title 1"/>
+          <p:cNvSpPr>
+            <a:spLocks noGrp="1"/>
+          </p:cNvSpPr>
+          <p:nvPr>
+            <p:ph type="title"/>
+          </p:nvPr>
+        </p:nvSpPr>
+        <p:spPr/>
+        <p:txBody>
+          <a:bodyPr/>
+          <a:lstStyle/>
+          <a:p>
+            <a:r>
+              <a:t>Hidden slide</a:t>
             </a:r>
           </a:p>
         </p:txBody>

</xml_diff>

<commit_message>
test(tables): verify diagonals span merged cells correctly
Adds a 2-col spanning cell with <a:lnTlToBr> to the fixture. Inspection
confirms the SVG overlay stretches across the full colspan via
preserveAspectRatio="none" — no code change needed. Documents this in
renderCell so future readers don't re-relitigate the merged-cell case.

Browser verification (dev server): <td colspan="2"> renders 512x144 px,
the inner <svg viewBox="0 0 100 100" preserveAspectRatio="none"> fills
the td, and the line endpoints map via getScreenCTM to exactly the td's
top-left (239, 9136) and bottom-right (751, 9280) — i.e. the diagonal
traces the full merged rectangle, not just the first column.

Co-Authored-By: Claude Opus 4.7 (1M context) <noreply@anthropic.com>
</commit_message>
<xml_diff>
--- a/tests/render-test/basic/presentation.pptx
+++ b/tests/render-test/basic/presentation.pptx
@@ -24,7 +24,8 @@
     <p:sldId id="272" r:id="rId24"/>
     <p:sldId id="273" r:id="rId25"/>
     <p:sldId id="274" r:id="rId26"/>
-    <p:sldId id="275" r:id="rId27" show="0"/>
+    <p:sldId id="275" r:id="rId27"/>
+    <p:sldId id="276" r:id="rId28" show="0"/>
   </p:sldIdLst>
   <p:sldSz cx="9144000" cy="6858000" type="screen4x3"/>
   <p:notesSz cx="6858000" cy="9144000"/>
@@ -4342,6 +4343,150 @@
           <a:lstStyle/>
           <a:p>
             <a:r>
+              <a:t>Merged-cell diagonals</a:t>
+            </a:r>
+          </a:p>
+        </p:txBody>
+      </p:sp>
+      <p:graphicFrame>
+        <p:nvGraphicFramePr>
+          <p:cNvPr id="3" name="Table 2"/>
+          <p:cNvGraphicFramePr>
+            <a:graphicFrameLocks noGrp="1"/>
+          </p:cNvGraphicFramePr>
+          <p:nvPr/>
+        </p:nvGraphicFramePr>
+        <p:xfrm>
+          <a:off x="914400" y="1828800"/>
+          <a:ext cx="7315200" cy="2743200"/>
+        </p:xfrm>
+        <a:graphic>
+          <a:graphicData uri="http://schemas.openxmlformats.org/drawingml/2006/table">
+            <a:tbl>
+              <a:tblPr firstRow="1" bandRow="1">
+                <a:tableStyleId>{5C22544A-7EE6-4342-B048-85BDC9FD1C3A}</a:tableStyleId>
+              </a:tblPr>
+              <a:tblGrid>
+                <a:gridCol w="2438400"/>
+                <a:gridCol w="2438400"/>
+                <a:gridCol w="2438400"/>
+              </a:tblGrid>
+              <a:tr h="1371600">
+                <a:tc gridSpan="2">
+                  <a:txBody>
+                    <a:bodyPr/>
+                    <a:lstStyle/>
+                    <a:p>
+                      <a:r>
+                        <a:t>spans 2 cols + diagonal</a:t>
+                      </a:r>
+                    </a:p>
+                  </a:txBody>
+                  <a:tcPr>
+                    <a:lnTlToBr w="38100">
+                      <a:solidFill>
+                        <a:srgbClr val="C0392B"/>
+                      </a:solidFill>
+                    </a:lnTlToBr>
+                  </a:tcPr>
+                </a:tc>
+                <a:tc hMerge="1">
+                  <a:txBody>
+                    <a:bodyPr/>
+                    <a:lstStyle/>
+                    <a:p/>
+                  </a:txBody>
+                  <a:tcPr/>
+                </a:tc>
+                <a:tc>
+                  <a:txBody>
+                    <a:bodyPr/>
+                    <a:lstStyle/>
+                    <a:p>
+                      <a:r>
+                        <a:t>right</a:t>
+                      </a:r>
+                    </a:p>
+                  </a:txBody>
+                  <a:tcPr/>
+                </a:tc>
+              </a:tr>
+              <a:tr h="1371600">
+                <a:tc>
+                  <a:txBody>
+                    <a:bodyPr/>
+                    <a:lstStyle/>
+                    <a:p>
+                      <a:r>
+                        <a:t>a</a:t>
+                      </a:r>
+                    </a:p>
+                  </a:txBody>
+                  <a:tcPr/>
+                </a:tc>
+                <a:tc>
+                  <a:txBody>
+                    <a:bodyPr/>
+                    <a:lstStyle/>
+                    <a:p>
+                      <a:r>
+                        <a:t>b</a:t>
+                      </a:r>
+                    </a:p>
+                  </a:txBody>
+                  <a:tcPr/>
+                </a:tc>
+                <a:tc>
+                  <a:txBody>
+                    <a:bodyPr/>
+                    <a:lstStyle/>
+                    <a:p>
+                      <a:r>
+                        <a:t>c</a:t>
+                      </a:r>
+                    </a:p>
+                  </a:txBody>
+                  <a:tcPr/>
+                </a:tc>
+              </a:tr>
+            </a:tbl>
+          </a:graphicData>
+        </a:graphic>
+      </p:graphicFrame>
+    </p:spTree>
+  </p:cSld>
+  <p:clrMapOvr>
+    <a:masterClrMapping/>
+  </p:clrMapOvr>
+</p:sld>
+</file>
+
+<file path=ppt/slides/slide14.xml><?xml version="1.0" encoding="utf-8"?>
+<p:sld xmlns:a="http://schemas.openxmlformats.org/drawingml/2006/main" xmlns:p="http://schemas.openxmlformats.org/presentationml/2006/main" xmlns:r="http://schemas.openxmlformats.org/officeDocument/2006/relationships">
+  <p:cSld>
+    <p:spTree>
+      <p:nvGrpSpPr>
+        <p:cNvPr id="1" name=""/>
+        <p:cNvGrpSpPr/>
+        <p:nvPr/>
+      </p:nvGrpSpPr>
+      <p:grpSpPr/>
+      <p:sp>
+        <p:nvSpPr>
+          <p:cNvPr id="2" name="Title 1"/>
+          <p:cNvSpPr>
+            <a:spLocks noGrp="1"/>
+          </p:cNvSpPr>
+          <p:nvPr>
+            <p:ph type="title"/>
+          </p:nvPr>
+        </p:nvSpPr>
+        <p:spPr/>
+        <p:txBody>
+          <a:bodyPr/>
+          <a:lstStyle/>
+          <a:p>
+            <a:r>
               <a:t>Gradient fill</a:t>
             </a:r>
           </a:p>
@@ -4410,7 +4555,7 @@
 </p:sld>
 </file>
 
-<file path=ppt/slides/slide14.xml><?xml version="1.0" encoding="utf-8"?>
+<file path=ppt/slides/slide15.xml><?xml version="1.0" encoding="utf-8"?>
 <p:sld xmlns:a="http://schemas.openxmlformats.org/drawingml/2006/main" xmlns:p="http://schemas.openxmlformats.org/presentationml/2006/main" xmlns:r="http://schemas.openxmlformats.org/officeDocument/2006/relationships">
   <p:cSld>
     <p:spTree>
@@ -4492,7 +4637,7 @@
 </p:sld>
 </file>
 
-<file path=ppt/slides/slide15.xml><?xml version="1.0" encoding="utf-8"?>
+<file path=ppt/slides/slide16.xml><?xml version="1.0" encoding="utf-8"?>
 <p:sld xmlns:a="http://schemas.openxmlformats.org/drawingml/2006/main" xmlns:p="http://schemas.openxmlformats.org/presentationml/2006/main" xmlns:r="http://schemas.openxmlformats.org/officeDocument/2006/relationships">
   <p:cSld>
     <p:spTree>
@@ -4877,7 +5022,7 @@
 </p:sld>
 </file>
 
-<file path=ppt/slides/slide16.xml><?xml version="1.0" encoding="utf-8"?>
+<file path=ppt/slides/slide17.xml><?xml version="1.0" encoding="utf-8"?>
 <p:sld xmlns:a="http://schemas.openxmlformats.org/drawingml/2006/main" xmlns:p="http://schemas.openxmlformats.org/presentationml/2006/main" xmlns:r="http://schemas.openxmlformats.org/officeDocument/2006/relationships">
   <p:cSld>
     <p:spTree>
@@ -4991,7 +5136,7 @@
 </p:sld>
 </file>
 
-<file path=ppt/slides/slide17.xml><?xml version="1.0" encoding="utf-8"?>
+<file path=ppt/slides/slide18.xml><?xml version="1.0" encoding="utf-8"?>
 <p:sld xmlns:a="http://schemas.openxmlformats.org/drawingml/2006/main" xmlns:p="http://schemas.openxmlformats.org/presentationml/2006/main" xmlns:r="http://schemas.openxmlformats.org/officeDocument/2006/relationships">
   <p:cSld>
     <p:spTree>
@@ -5167,7 +5312,7 @@
 </p:sld>
 </file>
 
-<file path=ppt/slides/slide18.xml><?xml version="1.0" encoding="utf-8"?>
+<file path=ppt/slides/slide19.xml><?xml version="1.0" encoding="utf-8"?>
 <p:sld xmlns:a="http://schemas.openxmlformats.org/drawingml/2006/main" xmlns:p="http://schemas.openxmlformats.org/presentationml/2006/main" xmlns:r="http://schemas.openxmlformats.org/officeDocument/2006/relationships">
   <p:cSld>
     <p:spTree>
@@ -5295,7 +5440,83 @@
 </p:sld>
 </file>
 
-<file path=ppt/slides/slide19.xml><?xml version="1.0" encoding="utf-8"?>
+<file path=ppt/slides/slide2.xml><?xml version="1.0" encoding="utf-8"?>
+<p:sld xmlns:a="http://schemas.openxmlformats.org/drawingml/2006/main" xmlns:p="http://schemas.openxmlformats.org/presentationml/2006/main" xmlns:r="http://schemas.openxmlformats.org/officeDocument/2006/relationships">
+  <p:cSld>
+    <p:spTree>
+      <p:nvGrpSpPr>
+        <p:cNvPr id="1" name=""/>
+        <p:cNvGrpSpPr/>
+        <p:nvPr/>
+      </p:nvGrpSpPr>
+      <p:grpSpPr/>
+      <p:sp>
+        <p:nvSpPr>
+          <p:cNvPr id="2" name="Title 1"/>
+          <p:cNvSpPr>
+            <a:spLocks noGrp="1"/>
+          </p:cNvSpPr>
+          <p:nvPr>
+            <p:ph type="title"/>
+          </p:nvPr>
+        </p:nvSpPr>
+        <p:spPr/>
+        <p:txBody>
+          <a:bodyPr/>
+          <a:lstStyle/>
+          <a:p>
+            <a:r>
+              <a:t>Bullet points</a:t>
+            </a:r>
+          </a:p>
+        </p:txBody>
+      </p:sp>
+      <p:sp>
+        <p:nvSpPr>
+          <p:cNvPr id="3" name="Content Placeholder 2"/>
+          <p:cNvSpPr>
+            <a:spLocks noGrp="1"/>
+          </p:cNvSpPr>
+          <p:nvPr>
+            <p:ph idx="1"/>
+          </p:nvPr>
+        </p:nvSpPr>
+        <p:spPr/>
+        <p:txBody>
+          <a:bodyPr/>
+          <a:lstStyle/>
+          <a:p>
+            <a:r>
+              <a:t>First bullet</a:t>
+            </a:r>
+          </a:p>
+          <a:p>
+            <a:pPr>
+              <a:defRPr sz="1800"/>
+            </a:pPr>
+            <a:r>
+              <a:t>Second bullet</a:t>
+            </a:r>
+          </a:p>
+          <a:p>
+            <a:pPr>
+              <a:defRPr sz="1800"/>
+            </a:pPr>
+            <a:r>
+              <a:t>Third bullet</a:t>
+            </a:r>
+          </a:p>
+        </p:txBody>
+      </p:sp>
+    </p:spTree>
+  </p:cSld>
+  <p:clrMapOvr>
+    <a:masterClrMapping/>
+  </p:clrMapOvr>
+</p:sld>
+</file>
+
+<file path=ppt/slides/slide20.xml><?xml version="1.0" encoding="utf-8"?>
 <p:sld xmlns:a="http://schemas.openxmlformats.org/drawingml/2006/main" xmlns:p="http://schemas.openxmlformats.org/presentationml/2006/main" xmlns:r="http://schemas.openxmlformats.org/officeDocument/2006/relationships">
   <p:cSld>
     <p:spTree>
@@ -5352,83 +5573,7 @@
 </p:sld>
 </file>
 
-<file path=ppt/slides/slide2.xml><?xml version="1.0" encoding="utf-8"?>
-<p:sld xmlns:a="http://schemas.openxmlformats.org/drawingml/2006/main" xmlns:p="http://schemas.openxmlformats.org/presentationml/2006/main" xmlns:r="http://schemas.openxmlformats.org/officeDocument/2006/relationships">
-  <p:cSld>
-    <p:spTree>
-      <p:nvGrpSpPr>
-        <p:cNvPr id="1" name=""/>
-        <p:cNvGrpSpPr/>
-        <p:nvPr/>
-      </p:nvGrpSpPr>
-      <p:grpSpPr/>
-      <p:sp>
-        <p:nvSpPr>
-          <p:cNvPr id="2" name="Title 1"/>
-          <p:cNvSpPr>
-            <a:spLocks noGrp="1"/>
-          </p:cNvSpPr>
-          <p:nvPr>
-            <p:ph type="title"/>
-          </p:nvPr>
-        </p:nvSpPr>
-        <p:spPr/>
-        <p:txBody>
-          <a:bodyPr/>
-          <a:lstStyle/>
-          <a:p>
-            <a:r>
-              <a:t>Bullet points</a:t>
-            </a:r>
-          </a:p>
-        </p:txBody>
-      </p:sp>
-      <p:sp>
-        <p:nvSpPr>
-          <p:cNvPr id="3" name="Content Placeholder 2"/>
-          <p:cNvSpPr>
-            <a:spLocks noGrp="1"/>
-          </p:cNvSpPr>
-          <p:nvPr>
-            <p:ph idx="1"/>
-          </p:nvPr>
-        </p:nvSpPr>
-        <p:spPr/>
-        <p:txBody>
-          <a:bodyPr/>
-          <a:lstStyle/>
-          <a:p>
-            <a:r>
-              <a:t>First bullet</a:t>
-            </a:r>
-          </a:p>
-          <a:p>
-            <a:pPr>
-              <a:defRPr sz="1800"/>
-            </a:pPr>
-            <a:r>
-              <a:t>Second bullet</a:t>
-            </a:r>
-          </a:p>
-          <a:p>
-            <a:pPr>
-              <a:defRPr sz="1800"/>
-            </a:pPr>
-            <a:r>
-              <a:t>Third bullet</a:t>
-            </a:r>
-          </a:p>
-        </p:txBody>
-      </p:sp>
-    </p:spTree>
-  </p:cSld>
-  <p:clrMapOvr>
-    <a:masterClrMapping/>
-  </p:clrMapOvr>
-</p:sld>
-</file>
-
-<file path=ppt/slides/slide20.xml><?xml version="1.0" encoding="utf-8"?>
+<file path=ppt/slides/slide21.xml><?xml version="1.0" encoding="utf-8"?>
 <p:sld xmlns:a="http://schemas.openxmlformats.org/drawingml/2006/main" xmlns:p="http://schemas.openxmlformats.org/presentationml/2006/main" xmlns:r="http://schemas.openxmlformats.org/officeDocument/2006/relationships">
   <p:cSld>
     <p:spTree>

</xml_diff>

<commit_message>
feat(demo): sections drawer populated from presentation.sections
The demo page gains a collapsible left drawer showing each section
and its slide range. Clicking a section scrolls the corresponding
slide into view. A header shows the total slide / section counts.
Hidden when the deck has no sections. No source changes; demo-only.

Co-Authored-By: Claude Opus 4.7 (1M context) <noreply@anthropic.com>
</commit_message>
<xml_diff>
--- a/tests/render-test/basic/presentation.pptx
+++ b/tests/render-test/basic/presentation.pptx
@@ -123,6 +123,48 @@
       </a:defRPr>
     </a:lvl9pPr>
   </p:defaultTextStyle>
+  <p:extLst>
+    <p:ext uri="{521415D9-36F7-43E2-AB2F-B90AF26B5E84}">
+      <p14:sectionLst xmlns:p14="http://schemas.microsoft.com/office/powerpoint/2010/main">
+        <p14:section name="Introduction" id="{00000000-0000-0000-0000-000000000000}">
+          <p14:sldIdLst>
+            <p14:sldId id="256"/>
+            <p14:sldId id="257"/>
+          </p14:sldIdLst>
+        </p14:section>
+        <p14:section name="Visuals &amp; Effects" id="{00000000-0000-0000-0000-000000000001}">
+          <p14:sldIdLst>
+            <p14:sldId id="258"/>
+            <p14:sldId id="259"/>
+            <p14:sldId id="260"/>
+            <p14:sldId id="261"/>
+            <p14:sldId id="262"/>
+            <p14:sldId id="263"/>
+            <p14:sldId id="264"/>
+            <p14:sldId id="265"/>
+          </p14:sldIdLst>
+        </p14:section>
+        <p14:section name="Typography &amp; Text" id="{00000000-0000-0000-0000-000000000002}">
+          <p14:sldIdLst>
+            <p14:sldId id="266"/>
+            <p14:sldId id="267"/>
+            <p14:sldId id="268"/>
+            <p14:sldId id="269"/>
+          </p14:sldIdLst>
+        </p14:section>
+        <p14:section name="Tables, Charts &amp; Extras" id="{00000000-0000-0000-0000-000000000003}">
+          <p14:sldIdLst>
+            <p14:sldId id="270"/>
+            <p14:sldId id="271"/>
+            <p14:sldId id="272"/>
+            <p14:sldId id="273"/>
+            <p14:sldId id="274"/>
+            <p14:sldId id="275"/>
+          </p14:sldIdLst>
+        </p14:section>
+      </p14:sectionLst>
+    </p:ext>
+  </p:extLst>
 </p:presentation>
 </file>
 

</xml_diff>

<commit_message>
docs(todo): mark sections drawer as done (shipped in Wave 6 A5)
The Wave 6 A5 commit (commit 97bf6c2 "feat(demo): sections drawer
populated from presentation.sections") implemented this but the TODO
entry was never moved. Moving it + the existing basic fixture's
<p14:sectionLst> splice confirmed.

While auditing, found the committed basic fixture had drifted — an
intermediate fixture regeneration (commit 54050bb) silently dropped
the section splice from the binary even though the generator script
still produces it. Regenerated via `python3 scripts/make-fixture-basic.py`
and added tests/render-test/basic/sections.spec.js as a regression
guard (asserts 4 sections with expected names, 0-based indices, and
full coverage of the visible slides).

Co-Authored-By: Claude Opus 4.7 (1M context) <noreply@anthropic.com>
</commit_message>
<xml_diff>
--- a/tests/render-test/basic/presentation.pptx
+++ b/tests/render-test/basic/presentation.pptx
@@ -24,7 +24,8 @@
     <p:sldId id="272" r:id="rId24"/>
     <p:sldId id="273" r:id="rId25"/>
     <p:sldId id="274" r:id="rId26"/>
-    <p:sldId id="275" r:id="rId27" show="0"/>
+    <p:sldId id="275" r:id="rId27"/>
+    <p:sldId id="276" r:id="rId28" show="0"/>
   </p:sldIdLst>
   <p:sldSz cx="9144000" cy="6858000" type="screen4x3"/>
   <p:notesSz cx="6858000" cy="9144000"/>
@@ -123,6 +124,49 @@
       </a:defRPr>
     </a:lvl9pPr>
   </p:defaultTextStyle>
+  <p:extLst>
+    <p:ext uri="{521415D9-36F7-43E2-AB2F-B90AF26B5E84}">
+      <p14:sectionLst xmlns:p14="http://schemas.microsoft.com/office/powerpoint/2010/main">
+        <p14:section name="Introduction" id="{00000000-0000-0000-0000-000000000000}">
+          <p14:sldIdLst>
+            <p14:sldId id="256"/>
+            <p14:sldId id="257"/>
+          </p14:sldIdLst>
+        </p14:section>
+        <p14:section name="Visuals &amp; Effects" id="{00000000-0000-0000-0000-000000000001}">
+          <p14:sldIdLst>
+            <p14:sldId id="258"/>
+            <p14:sldId id="259"/>
+            <p14:sldId id="260"/>
+            <p14:sldId id="261"/>
+            <p14:sldId id="262"/>
+            <p14:sldId id="263"/>
+            <p14:sldId id="264"/>
+            <p14:sldId id="265"/>
+          </p14:sldIdLst>
+        </p14:section>
+        <p14:section name="Typography &amp; Text" id="{00000000-0000-0000-0000-000000000002}">
+          <p14:sldIdLst>
+            <p14:sldId id="266"/>
+            <p14:sldId id="267"/>
+            <p14:sldId id="268"/>
+            <p14:sldId id="269"/>
+          </p14:sldIdLst>
+        </p14:section>
+        <p14:section name="Tables, Charts &amp; Extras" id="{00000000-0000-0000-0000-000000000003}">
+          <p14:sldIdLst>
+            <p14:sldId id="270"/>
+            <p14:sldId id="271"/>
+            <p14:sldId id="272"/>
+            <p14:sldId id="273"/>
+            <p14:sldId id="274"/>
+            <p14:sldId id="275"/>
+            <p14:sldId id="276"/>
+          </p14:sldIdLst>
+        </p14:section>
+      </p14:sectionLst>
+    </p:ext>
+  </p:extLst>
 </p:presentation>
 </file>
 
@@ -4342,6 +4386,150 @@
           <a:lstStyle/>
           <a:p>
             <a:r>
+              <a:t>Merged-cell diagonals</a:t>
+            </a:r>
+          </a:p>
+        </p:txBody>
+      </p:sp>
+      <p:graphicFrame>
+        <p:nvGraphicFramePr>
+          <p:cNvPr id="3" name="Table 2"/>
+          <p:cNvGraphicFramePr>
+            <a:graphicFrameLocks noGrp="1"/>
+          </p:cNvGraphicFramePr>
+          <p:nvPr/>
+        </p:nvGraphicFramePr>
+        <p:xfrm>
+          <a:off x="914400" y="1828800"/>
+          <a:ext cx="7315200" cy="2743200"/>
+        </p:xfrm>
+        <a:graphic>
+          <a:graphicData uri="http://schemas.openxmlformats.org/drawingml/2006/table">
+            <a:tbl>
+              <a:tblPr firstRow="1" bandRow="1">
+                <a:tableStyleId>{5C22544A-7EE6-4342-B048-85BDC9FD1C3A}</a:tableStyleId>
+              </a:tblPr>
+              <a:tblGrid>
+                <a:gridCol w="2438400"/>
+                <a:gridCol w="2438400"/>
+                <a:gridCol w="2438400"/>
+              </a:tblGrid>
+              <a:tr h="1371600">
+                <a:tc gridSpan="2">
+                  <a:txBody>
+                    <a:bodyPr/>
+                    <a:lstStyle/>
+                    <a:p>
+                      <a:r>
+                        <a:t>spans 2 cols + diagonal</a:t>
+                      </a:r>
+                    </a:p>
+                  </a:txBody>
+                  <a:tcPr>
+                    <a:lnTlToBr w="38100">
+                      <a:solidFill>
+                        <a:srgbClr val="C0392B"/>
+                      </a:solidFill>
+                    </a:lnTlToBr>
+                  </a:tcPr>
+                </a:tc>
+                <a:tc hMerge="1">
+                  <a:txBody>
+                    <a:bodyPr/>
+                    <a:lstStyle/>
+                    <a:p/>
+                  </a:txBody>
+                  <a:tcPr/>
+                </a:tc>
+                <a:tc>
+                  <a:txBody>
+                    <a:bodyPr/>
+                    <a:lstStyle/>
+                    <a:p>
+                      <a:r>
+                        <a:t>right</a:t>
+                      </a:r>
+                    </a:p>
+                  </a:txBody>
+                  <a:tcPr/>
+                </a:tc>
+              </a:tr>
+              <a:tr h="1371600">
+                <a:tc>
+                  <a:txBody>
+                    <a:bodyPr/>
+                    <a:lstStyle/>
+                    <a:p>
+                      <a:r>
+                        <a:t>a</a:t>
+                      </a:r>
+                    </a:p>
+                  </a:txBody>
+                  <a:tcPr/>
+                </a:tc>
+                <a:tc>
+                  <a:txBody>
+                    <a:bodyPr/>
+                    <a:lstStyle/>
+                    <a:p>
+                      <a:r>
+                        <a:t>b</a:t>
+                      </a:r>
+                    </a:p>
+                  </a:txBody>
+                  <a:tcPr/>
+                </a:tc>
+                <a:tc>
+                  <a:txBody>
+                    <a:bodyPr/>
+                    <a:lstStyle/>
+                    <a:p>
+                      <a:r>
+                        <a:t>c</a:t>
+                      </a:r>
+                    </a:p>
+                  </a:txBody>
+                  <a:tcPr/>
+                </a:tc>
+              </a:tr>
+            </a:tbl>
+          </a:graphicData>
+        </a:graphic>
+      </p:graphicFrame>
+    </p:spTree>
+  </p:cSld>
+  <p:clrMapOvr>
+    <a:masterClrMapping/>
+  </p:clrMapOvr>
+</p:sld>
+</file>
+
+<file path=ppt/slides/slide14.xml><?xml version="1.0" encoding="utf-8"?>
+<p:sld xmlns:a="http://schemas.openxmlformats.org/drawingml/2006/main" xmlns:p="http://schemas.openxmlformats.org/presentationml/2006/main" xmlns:r="http://schemas.openxmlformats.org/officeDocument/2006/relationships">
+  <p:cSld>
+    <p:spTree>
+      <p:nvGrpSpPr>
+        <p:cNvPr id="1" name=""/>
+        <p:cNvGrpSpPr/>
+        <p:nvPr/>
+      </p:nvGrpSpPr>
+      <p:grpSpPr/>
+      <p:sp>
+        <p:nvSpPr>
+          <p:cNvPr id="2" name="Title 1"/>
+          <p:cNvSpPr>
+            <a:spLocks noGrp="1"/>
+          </p:cNvSpPr>
+          <p:nvPr>
+            <p:ph type="title"/>
+          </p:nvPr>
+        </p:nvSpPr>
+        <p:spPr/>
+        <p:txBody>
+          <a:bodyPr/>
+          <a:lstStyle/>
+          <a:p>
+            <a:r>
               <a:t>Gradient fill</a:t>
             </a:r>
           </a:p>
@@ -4410,7 +4598,7 @@
 </p:sld>
 </file>
 
-<file path=ppt/slides/slide14.xml><?xml version="1.0" encoding="utf-8"?>
+<file path=ppt/slides/slide15.xml><?xml version="1.0" encoding="utf-8"?>
 <p:sld xmlns:a="http://schemas.openxmlformats.org/drawingml/2006/main" xmlns:p="http://schemas.openxmlformats.org/presentationml/2006/main" xmlns:r="http://schemas.openxmlformats.org/officeDocument/2006/relationships">
   <p:cSld>
     <p:spTree>
@@ -4492,7 +4680,7 @@
 </p:sld>
 </file>
 
-<file path=ppt/slides/slide15.xml><?xml version="1.0" encoding="utf-8"?>
+<file path=ppt/slides/slide16.xml><?xml version="1.0" encoding="utf-8"?>
 <p:sld xmlns:a="http://schemas.openxmlformats.org/drawingml/2006/main" xmlns:p="http://schemas.openxmlformats.org/presentationml/2006/main" xmlns:r="http://schemas.openxmlformats.org/officeDocument/2006/relationships">
   <p:cSld>
     <p:spTree>
@@ -4877,7 +5065,7 @@
 </p:sld>
 </file>
 
-<file path=ppt/slides/slide16.xml><?xml version="1.0" encoding="utf-8"?>
+<file path=ppt/slides/slide17.xml><?xml version="1.0" encoding="utf-8"?>
 <p:sld xmlns:a="http://schemas.openxmlformats.org/drawingml/2006/main" xmlns:p="http://schemas.openxmlformats.org/presentationml/2006/main" xmlns:r="http://schemas.openxmlformats.org/officeDocument/2006/relationships">
   <p:cSld>
     <p:spTree>
@@ -4991,7 +5179,7 @@
 </p:sld>
 </file>
 
-<file path=ppt/slides/slide17.xml><?xml version="1.0" encoding="utf-8"?>
+<file path=ppt/slides/slide18.xml><?xml version="1.0" encoding="utf-8"?>
 <p:sld xmlns:a="http://schemas.openxmlformats.org/drawingml/2006/main" xmlns:p="http://schemas.openxmlformats.org/presentationml/2006/main" xmlns:r="http://schemas.openxmlformats.org/officeDocument/2006/relationships">
   <p:cSld>
     <p:spTree>
@@ -5167,7 +5355,7 @@
 </p:sld>
 </file>
 
-<file path=ppt/slides/slide18.xml><?xml version="1.0" encoding="utf-8"?>
+<file path=ppt/slides/slide19.xml><?xml version="1.0" encoding="utf-8"?>
 <p:sld xmlns:a="http://schemas.openxmlformats.org/drawingml/2006/main" xmlns:p="http://schemas.openxmlformats.org/presentationml/2006/main" xmlns:r="http://schemas.openxmlformats.org/officeDocument/2006/relationships">
   <p:cSld>
     <p:spTree>
@@ -5295,7 +5483,83 @@
 </p:sld>
 </file>
 
-<file path=ppt/slides/slide19.xml><?xml version="1.0" encoding="utf-8"?>
+<file path=ppt/slides/slide2.xml><?xml version="1.0" encoding="utf-8"?>
+<p:sld xmlns:a="http://schemas.openxmlformats.org/drawingml/2006/main" xmlns:p="http://schemas.openxmlformats.org/presentationml/2006/main" xmlns:r="http://schemas.openxmlformats.org/officeDocument/2006/relationships">
+  <p:cSld>
+    <p:spTree>
+      <p:nvGrpSpPr>
+        <p:cNvPr id="1" name=""/>
+        <p:cNvGrpSpPr/>
+        <p:nvPr/>
+      </p:nvGrpSpPr>
+      <p:grpSpPr/>
+      <p:sp>
+        <p:nvSpPr>
+          <p:cNvPr id="2" name="Title 1"/>
+          <p:cNvSpPr>
+            <a:spLocks noGrp="1"/>
+          </p:cNvSpPr>
+          <p:nvPr>
+            <p:ph type="title"/>
+          </p:nvPr>
+        </p:nvSpPr>
+        <p:spPr/>
+        <p:txBody>
+          <a:bodyPr/>
+          <a:lstStyle/>
+          <a:p>
+            <a:r>
+              <a:t>Bullet points</a:t>
+            </a:r>
+          </a:p>
+        </p:txBody>
+      </p:sp>
+      <p:sp>
+        <p:nvSpPr>
+          <p:cNvPr id="3" name="Content Placeholder 2"/>
+          <p:cNvSpPr>
+            <a:spLocks noGrp="1"/>
+          </p:cNvSpPr>
+          <p:nvPr>
+            <p:ph idx="1"/>
+          </p:nvPr>
+        </p:nvSpPr>
+        <p:spPr/>
+        <p:txBody>
+          <a:bodyPr/>
+          <a:lstStyle/>
+          <a:p>
+            <a:r>
+              <a:t>First bullet</a:t>
+            </a:r>
+          </a:p>
+          <a:p>
+            <a:pPr>
+              <a:defRPr sz="1800"/>
+            </a:pPr>
+            <a:r>
+              <a:t>Second bullet</a:t>
+            </a:r>
+          </a:p>
+          <a:p>
+            <a:pPr>
+              <a:defRPr sz="1800"/>
+            </a:pPr>
+            <a:r>
+              <a:t>Third bullet</a:t>
+            </a:r>
+          </a:p>
+        </p:txBody>
+      </p:sp>
+    </p:spTree>
+  </p:cSld>
+  <p:clrMapOvr>
+    <a:masterClrMapping/>
+  </p:clrMapOvr>
+</p:sld>
+</file>
+
+<file path=ppt/slides/slide20.xml><?xml version="1.0" encoding="utf-8"?>
 <p:sld xmlns:a="http://schemas.openxmlformats.org/drawingml/2006/main" xmlns:p="http://schemas.openxmlformats.org/presentationml/2006/main" xmlns:r="http://schemas.openxmlformats.org/officeDocument/2006/relationships">
   <p:cSld>
     <p:spTree>
@@ -5352,83 +5616,7 @@
 </p:sld>
 </file>
 
-<file path=ppt/slides/slide2.xml><?xml version="1.0" encoding="utf-8"?>
-<p:sld xmlns:a="http://schemas.openxmlformats.org/drawingml/2006/main" xmlns:p="http://schemas.openxmlformats.org/presentationml/2006/main" xmlns:r="http://schemas.openxmlformats.org/officeDocument/2006/relationships">
-  <p:cSld>
-    <p:spTree>
-      <p:nvGrpSpPr>
-        <p:cNvPr id="1" name=""/>
-        <p:cNvGrpSpPr/>
-        <p:nvPr/>
-      </p:nvGrpSpPr>
-      <p:grpSpPr/>
-      <p:sp>
-        <p:nvSpPr>
-          <p:cNvPr id="2" name="Title 1"/>
-          <p:cNvSpPr>
-            <a:spLocks noGrp="1"/>
-          </p:cNvSpPr>
-          <p:nvPr>
-            <p:ph type="title"/>
-          </p:nvPr>
-        </p:nvSpPr>
-        <p:spPr/>
-        <p:txBody>
-          <a:bodyPr/>
-          <a:lstStyle/>
-          <a:p>
-            <a:r>
-              <a:t>Bullet points</a:t>
-            </a:r>
-          </a:p>
-        </p:txBody>
-      </p:sp>
-      <p:sp>
-        <p:nvSpPr>
-          <p:cNvPr id="3" name="Content Placeholder 2"/>
-          <p:cNvSpPr>
-            <a:spLocks noGrp="1"/>
-          </p:cNvSpPr>
-          <p:nvPr>
-            <p:ph idx="1"/>
-          </p:nvPr>
-        </p:nvSpPr>
-        <p:spPr/>
-        <p:txBody>
-          <a:bodyPr/>
-          <a:lstStyle/>
-          <a:p>
-            <a:r>
-              <a:t>First bullet</a:t>
-            </a:r>
-          </a:p>
-          <a:p>
-            <a:pPr>
-              <a:defRPr sz="1800"/>
-            </a:pPr>
-            <a:r>
-              <a:t>Second bullet</a:t>
-            </a:r>
-          </a:p>
-          <a:p>
-            <a:pPr>
-              <a:defRPr sz="1800"/>
-            </a:pPr>
-            <a:r>
-              <a:t>Third bullet</a:t>
-            </a:r>
-          </a:p>
-        </p:txBody>
-      </p:sp>
-    </p:spTree>
-  </p:cSld>
-  <p:clrMapOvr>
-    <a:masterClrMapping/>
-  </p:clrMapOvr>
-</p:sld>
-</file>
-
-<file path=ppt/slides/slide20.xml><?xml version="1.0" encoding="utf-8"?>
+<file path=ppt/slides/slide21.xml><?xml version="1.0" encoding="utf-8"?>
 <p:sld xmlns:a="http://schemas.openxmlformats.org/drawingml/2006/main" xmlns:p="http://schemas.openxmlformats.org/presentationml/2006/main" xmlns:r="http://schemas.openxmlformats.org/officeDocument/2006/relationships">
   <p:cSld>
     <p:spTree>

</xml_diff>

<commit_message>
feat(tables): verify diagonals on merged cells; tableStyles is presentation-level
Task 1: Verified that <a:lnTlToBr>/<a:lnBlToTr> diagonals on a
spanning cell stretch correctly across the merged rectangle via the
existing per-cell SVG overlay + preserveAspectRatio="none". Added a
regression fixture with a colspan=2 diagonal.

Task 2: Closed the "per-master tableStyles" TODO — ppt/tableStyles.xml
is a presentation-level part in OOXML, not per-master. Added a
clarifying comment in Presentation.load and moved the entry to the
TODO Done list.

Co-Authored-By: Claude Opus 4.7 (1M context) <noreply@anthropic.com>
</commit_message>
<xml_diff>
--- a/tests/render-test/basic/presentation.pptx
+++ b/tests/render-test/basic/presentation.pptx
@@ -24,7 +24,8 @@
     <p:sldId id="272" r:id="rId24"/>
     <p:sldId id="273" r:id="rId25"/>
     <p:sldId id="274" r:id="rId26"/>
-    <p:sldId id="275" r:id="rId27" show="0"/>
+    <p:sldId id="275" r:id="rId27"/>
+    <p:sldId id="276" r:id="rId28" show="0"/>
   </p:sldIdLst>
   <p:sldSz cx="9144000" cy="6858000" type="screen4x3"/>
   <p:notesSz cx="6858000" cy="9144000"/>
@@ -123,6 +124,49 @@
       </a:defRPr>
     </a:lvl9pPr>
   </p:defaultTextStyle>
+  <p:extLst>
+    <p:ext uri="{521415D9-36F7-43E2-AB2F-B90AF26B5E84}">
+      <p14:sectionLst xmlns:p14="http://schemas.microsoft.com/office/powerpoint/2010/main">
+        <p14:section name="Introduction" id="{00000000-0000-0000-0000-000000000000}">
+          <p14:sldIdLst>
+            <p14:sldId id="256"/>
+            <p14:sldId id="257"/>
+          </p14:sldIdLst>
+        </p14:section>
+        <p14:section name="Visuals &amp; Effects" id="{00000000-0000-0000-0000-000000000001}">
+          <p14:sldIdLst>
+            <p14:sldId id="258"/>
+            <p14:sldId id="259"/>
+            <p14:sldId id="260"/>
+            <p14:sldId id="261"/>
+            <p14:sldId id="262"/>
+            <p14:sldId id="263"/>
+            <p14:sldId id="264"/>
+            <p14:sldId id="265"/>
+          </p14:sldIdLst>
+        </p14:section>
+        <p14:section name="Typography &amp; Text" id="{00000000-0000-0000-0000-000000000002}">
+          <p14:sldIdLst>
+            <p14:sldId id="266"/>
+            <p14:sldId id="267"/>
+            <p14:sldId id="268"/>
+            <p14:sldId id="269"/>
+          </p14:sldIdLst>
+        </p14:section>
+        <p14:section name="Tables, Charts &amp; Extras" id="{00000000-0000-0000-0000-000000000003}">
+          <p14:sldIdLst>
+            <p14:sldId id="270"/>
+            <p14:sldId id="271"/>
+            <p14:sldId id="272"/>
+            <p14:sldId id="273"/>
+            <p14:sldId id="274"/>
+            <p14:sldId id="275"/>
+            <p14:sldId id="276"/>
+          </p14:sldIdLst>
+        </p14:section>
+      </p14:sectionLst>
+    </p:ext>
+  </p:extLst>
 </p:presentation>
 </file>
 
@@ -4342,6 +4386,150 @@
           <a:lstStyle/>
           <a:p>
             <a:r>
+              <a:t>Merged-cell diagonals</a:t>
+            </a:r>
+          </a:p>
+        </p:txBody>
+      </p:sp>
+      <p:graphicFrame>
+        <p:nvGraphicFramePr>
+          <p:cNvPr id="3" name="Table 2"/>
+          <p:cNvGraphicFramePr>
+            <a:graphicFrameLocks noGrp="1"/>
+          </p:cNvGraphicFramePr>
+          <p:nvPr/>
+        </p:nvGraphicFramePr>
+        <p:xfrm>
+          <a:off x="914400" y="1828800"/>
+          <a:ext cx="7315200" cy="2743200"/>
+        </p:xfrm>
+        <a:graphic>
+          <a:graphicData uri="http://schemas.openxmlformats.org/drawingml/2006/table">
+            <a:tbl>
+              <a:tblPr firstRow="1" bandRow="1">
+                <a:tableStyleId>{5C22544A-7EE6-4342-B048-85BDC9FD1C3A}</a:tableStyleId>
+              </a:tblPr>
+              <a:tblGrid>
+                <a:gridCol w="2438400"/>
+                <a:gridCol w="2438400"/>
+                <a:gridCol w="2438400"/>
+              </a:tblGrid>
+              <a:tr h="1371600">
+                <a:tc gridSpan="2">
+                  <a:txBody>
+                    <a:bodyPr/>
+                    <a:lstStyle/>
+                    <a:p>
+                      <a:r>
+                        <a:t>spans 2 cols + diagonal</a:t>
+                      </a:r>
+                    </a:p>
+                  </a:txBody>
+                  <a:tcPr>
+                    <a:lnTlToBr w="38100">
+                      <a:solidFill>
+                        <a:srgbClr val="C0392B"/>
+                      </a:solidFill>
+                    </a:lnTlToBr>
+                  </a:tcPr>
+                </a:tc>
+                <a:tc hMerge="1">
+                  <a:txBody>
+                    <a:bodyPr/>
+                    <a:lstStyle/>
+                    <a:p/>
+                  </a:txBody>
+                  <a:tcPr/>
+                </a:tc>
+                <a:tc>
+                  <a:txBody>
+                    <a:bodyPr/>
+                    <a:lstStyle/>
+                    <a:p>
+                      <a:r>
+                        <a:t>right</a:t>
+                      </a:r>
+                    </a:p>
+                  </a:txBody>
+                  <a:tcPr/>
+                </a:tc>
+              </a:tr>
+              <a:tr h="1371600">
+                <a:tc>
+                  <a:txBody>
+                    <a:bodyPr/>
+                    <a:lstStyle/>
+                    <a:p>
+                      <a:r>
+                        <a:t>a</a:t>
+                      </a:r>
+                    </a:p>
+                  </a:txBody>
+                  <a:tcPr/>
+                </a:tc>
+                <a:tc>
+                  <a:txBody>
+                    <a:bodyPr/>
+                    <a:lstStyle/>
+                    <a:p>
+                      <a:r>
+                        <a:t>b</a:t>
+                      </a:r>
+                    </a:p>
+                  </a:txBody>
+                  <a:tcPr/>
+                </a:tc>
+                <a:tc>
+                  <a:txBody>
+                    <a:bodyPr/>
+                    <a:lstStyle/>
+                    <a:p>
+                      <a:r>
+                        <a:t>c</a:t>
+                      </a:r>
+                    </a:p>
+                  </a:txBody>
+                  <a:tcPr/>
+                </a:tc>
+              </a:tr>
+            </a:tbl>
+          </a:graphicData>
+        </a:graphic>
+      </p:graphicFrame>
+    </p:spTree>
+  </p:cSld>
+  <p:clrMapOvr>
+    <a:masterClrMapping/>
+  </p:clrMapOvr>
+</p:sld>
+</file>
+
+<file path=ppt/slides/slide14.xml><?xml version="1.0" encoding="utf-8"?>
+<p:sld xmlns:a="http://schemas.openxmlformats.org/drawingml/2006/main" xmlns:p="http://schemas.openxmlformats.org/presentationml/2006/main" xmlns:r="http://schemas.openxmlformats.org/officeDocument/2006/relationships">
+  <p:cSld>
+    <p:spTree>
+      <p:nvGrpSpPr>
+        <p:cNvPr id="1" name=""/>
+        <p:cNvGrpSpPr/>
+        <p:nvPr/>
+      </p:nvGrpSpPr>
+      <p:grpSpPr/>
+      <p:sp>
+        <p:nvSpPr>
+          <p:cNvPr id="2" name="Title 1"/>
+          <p:cNvSpPr>
+            <a:spLocks noGrp="1"/>
+          </p:cNvSpPr>
+          <p:nvPr>
+            <p:ph type="title"/>
+          </p:nvPr>
+        </p:nvSpPr>
+        <p:spPr/>
+        <p:txBody>
+          <a:bodyPr/>
+          <a:lstStyle/>
+          <a:p>
+            <a:r>
               <a:t>Gradient fill</a:t>
             </a:r>
           </a:p>
@@ -4410,7 +4598,7 @@
 </p:sld>
 </file>
 
-<file path=ppt/slides/slide14.xml><?xml version="1.0" encoding="utf-8"?>
+<file path=ppt/slides/slide15.xml><?xml version="1.0" encoding="utf-8"?>
 <p:sld xmlns:a="http://schemas.openxmlformats.org/drawingml/2006/main" xmlns:p="http://schemas.openxmlformats.org/presentationml/2006/main" xmlns:r="http://schemas.openxmlformats.org/officeDocument/2006/relationships">
   <p:cSld>
     <p:spTree>
@@ -4492,7 +4680,7 @@
 </p:sld>
 </file>
 
-<file path=ppt/slides/slide15.xml><?xml version="1.0" encoding="utf-8"?>
+<file path=ppt/slides/slide16.xml><?xml version="1.0" encoding="utf-8"?>
 <p:sld xmlns:a="http://schemas.openxmlformats.org/drawingml/2006/main" xmlns:p="http://schemas.openxmlformats.org/presentationml/2006/main" xmlns:r="http://schemas.openxmlformats.org/officeDocument/2006/relationships">
   <p:cSld>
     <p:spTree>
@@ -4877,7 +5065,7 @@
 </p:sld>
 </file>
 
-<file path=ppt/slides/slide16.xml><?xml version="1.0" encoding="utf-8"?>
+<file path=ppt/slides/slide17.xml><?xml version="1.0" encoding="utf-8"?>
 <p:sld xmlns:a="http://schemas.openxmlformats.org/drawingml/2006/main" xmlns:p="http://schemas.openxmlformats.org/presentationml/2006/main" xmlns:r="http://schemas.openxmlformats.org/officeDocument/2006/relationships">
   <p:cSld>
     <p:spTree>
@@ -4991,7 +5179,7 @@
 </p:sld>
 </file>
 
-<file path=ppt/slides/slide17.xml><?xml version="1.0" encoding="utf-8"?>
+<file path=ppt/slides/slide18.xml><?xml version="1.0" encoding="utf-8"?>
 <p:sld xmlns:a="http://schemas.openxmlformats.org/drawingml/2006/main" xmlns:p="http://schemas.openxmlformats.org/presentationml/2006/main" xmlns:r="http://schemas.openxmlformats.org/officeDocument/2006/relationships">
   <p:cSld>
     <p:spTree>
@@ -5167,7 +5355,7 @@
 </p:sld>
 </file>
 
-<file path=ppt/slides/slide18.xml><?xml version="1.0" encoding="utf-8"?>
+<file path=ppt/slides/slide19.xml><?xml version="1.0" encoding="utf-8"?>
 <p:sld xmlns:a="http://schemas.openxmlformats.org/drawingml/2006/main" xmlns:p="http://schemas.openxmlformats.org/presentationml/2006/main" xmlns:r="http://schemas.openxmlformats.org/officeDocument/2006/relationships">
   <p:cSld>
     <p:spTree>
@@ -5295,7 +5483,83 @@
 </p:sld>
 </file>
 
-<file path=ppt/slides/slide19.xml><?xml version="1.0" encoding="utf-8"?>
+<file path=ppt/slides/slide2.xml><?xml version="1.0" encoding="utf-8"?>
+<p:sld xmlns:a="http://schemas.openxmlformats.org/drawingml/2006/main" xmlns:p="http://schemas.openxmlformats.org/presentationml/2006/main" xmlns:r="http://schemas.openxmlformats.org/officeDocument/2006/relationships">
+  <p:cSld>
+    <p:spTree>
+      <p:nvGrpSpPr>
+        <p:cNvPr id="1" name=""/>
+        <p:cNvGrpSpPr/>
+        <p:nvPr/>
+      </p:nvGrpSpPr>
+      <p:grpSpPr/>
+      <p:sp>
+        <p:nvSpPr>
+          <p:cNvPr id="2" name="Title 1"/>
+          <p:cNvSpPr>
+            <a:spLocks noGrp="1"/>
+          </p:cNvSpPr>
+          <p:nvPr>
+            <p:ph type="title"/>
+          </p:nvPr>
+        </p:nvSpPr>
+        <p:spPr/>
+        <p:txBody>
+          <a:bodyPr/>
+          <a:lstStyle/>
+          <a:p>
+            <a:r>
+              <a:t>Bullet points</a:t>
+            </a:r>
+          </a:p>
+        </p:txBody>
+      </p:sp>
+      <p:sp>
+        <p:nvSpPr>
+          <p:cNvPr id="3" name="Content Placeholder 2"/>
+          <p:cNvSpPr>
+            <a:spLocks noGrp="1"/>
+          </p:cNvSpPr>
+          <p:nvPr>
+            <p:ph idx="1"/>
+          </p:nvPr>
+        </p:nvSpPr>
+        <p:spPr/>
+        <p:txBody>
+          <a:bodyPr/>
+          <a:lstStyle/>
+          <a:p>
+            <a:r>
+              <a:t>First bullet</a:t>
+            </a:r>
+          </a:p>
+          <a:p>
+            <a:pPr>
+              <a:defRPr sz="1800"/>
+            </a:pPr>
+            <a:r>
+              <a:t>Second bullet</a:t>
+            </a:r>
+          </a:p>
+          <a:p>
+            <a:pPr>
+              <a:defRPr sz="1800"/>
+            </a:pPr>
+            <a:r>
+              <a:t>Third bullet</a:t>
+            </a:r>
+          </a:p>
+        </p:txBody>
+      </p:sp>
+    </p:spTree>
+  </p:cSld>
+  <p:clrMapOvr>
+    <a:masterClrMapping/>
+  </p:clrMapOvr>
+</p:sld>
+</file>
+
+<file path=ppt/slides/slide20.xml><?xml version="1.0" encoding="utf-8"?>
 <p:sld xmlns:a="http://schemas.openxmlformats.org/drawingml/2006/main" xmlns:p="http://schemas.openxmlformats.org/presentationml/2006/main" xmlns:r="http://schemas.openxmlformats.org/officeDocument/2006/relationships">
   <p:cSld>
     <p:spTree>
@@ -5352,83 +5616,7 @@
 </p:sld>
 </file>
 
-<file path=ppt/slides/slide2.xml><?xml version="1.0" encoding="utf-8"?>
-<p:sld xmlns:a="http://schemas.openxmlformats.org/drawingml/2006/main" xmlns:p="http://schemas.openxmlformats.org/presentationml/2006/main" xmlns:r="http://schemas.openxmlformats.org/officeDocument/2006/relationships">
-  <p:cSld>
-    <p:spTree>
-      <p:nvGrpSpPr>
-        <p:cNvPr id="1" name=""/>
-        <p:cNvGrpSpPr/>
-        <p:nvPr/>
-      </p:nvGrpSpPr>
-      <p:grpSpPr/>
-      <p:sp>
-        <p:nvSpPr>
-          <p:cNvPr id="2" name="Title 1"/>
-          <p:cNvSpPr>
-            <a:spLocks noGrp="1"/>
-          </p:cNvSpPr>
-          <p:nvPr>
-            <p:ph type="title"/>
-          </p:nvPr>
-        </p:nvSpPr>
-        <p:spPr/>
-        <p:txBody>
-          <a:bodyPr/>
-          <a:lstStyle/>
-          <a:p>
-            <a:r>
-              <a:t>Bullet points</a:t>
-            </a:r>
-          </a:p>
-        </p:txBody>
-      </p:sp>
-      <p:sp>
-        <p:nvSpPr>
-          <p:cNvPr id="3" name="Content Placeholder 2"/>
-          <p:cNvSpPr>
-            <a:spLocks noGrp="1"/>
-          </p:cNvSpPr>
-          <p:nvPr>
-            <p:ph idx="1"/>
-          </p:nvPr>
-        </p:nvSpPr>
-        <p:spPr/>
-        <p:txBody>
-          <a:bodyPr/>
-          <a:lstStyle/>
-          <a:p>
-            <a:r>
-              <a:t>First bullet</a:t>
-            </a:r>
-          </a:p>
-          <a:p>
-            <a:pPr>
-              <a:defRPr sz="1800"/>
-            </a:pPr>
-            <a:r>
-              <a:t>Second bullet</a:t>
-            </a:r>
-          </a:p>
-          <a:p>
-            <a:pPr>
-              <a:defRPr sz="1800"/>
-            </a:pPr>
-            <a:r>
-              <a:t>Third bullet</a:t>
-            </a:r>
-          </a:p>
-        </p:txBody>
-      </p:sp>
-    </p:spTree>
-  </p:cSld>
-  <p:clrMapOvr>
-    <a:masterClrMapping/>
-  </p:clrMapOvr>
-</p:sld>
-</file>
-
-<file path=ppt/slides/slide20.xml><?xml version="1.0" encoding="utf-8"?>
+<file path=ppt/slides/slide21.xml><?xml version="1.0" encoding="utf-8"?>
 <p:sld xmlns:a="http://schemas.openxmlformats.org/drawingml/2006/main" xmlns:p="http://schemas.openxmlformats.org/presentationml/2006/main" xmlns:r="http://schemas.openxmlformats.org/officeDocument/2006/relationships">
   <p:cSld>
     <p:spTree>

</xml_diff>